<commit_message>
update : update le Readme js et rename html/css
</commit_message>
<xml_diff>
--- a/annexe/Presentation.pptx
+++ b/annexe/Presentation.pptx
@@ -13,7 +13,9 @@
     <p:sldId id="257" r:id="rId7"/>
     <p:sldId id="263" r:id="rId8"/>
     <p:sldId id="264" r:id="rId9"/>
-    <p:sldId id="258" r:id="rId10"/>
+    <p:sldId id="265" r:id="rId10"/>
+    <p:sldId id="258" r:id="rId11"/>
+    <p:sldId id="266" r:id="rId12"/>
   </p:sldIdLst>
   <p:sldSz cx="12192000" cy="6858000"/>
   <p:notesSz cx="6858000" cy="9144000"/>
@@ -3808,7 +3810,7 @@
         <p:spPr>
           <a:xfrm>
             <a:off x="517870" y="978407"/>
-            <a:ext cx="5021182" cy="3290107"/>
+            <a:ext cx="9055898" cy="3290107"/>
           </a:xfrm>
         </p:spPr>
         <p:txBody>
@@ -3818,7 +3820,7 @@
           <a:lstStyle/>
           <a:p>
             <a:r>
-              <a:rPr lang="fr-CH" sz="4700" b="1">
+              <a:rPr lang="fr-CH" sz="4700" b="1" dirty="0">
                 <a:solidFill>
                   <a:srgbClr val="FFFFFF"/>
                 </a:solidFill>
@@ -3826,7 +3828,7 @@
               <a:t>DemoMot</a:t>
             </a:r>
             <a:r>
-              <a:rPr lang="fr-CH" sz="4700">
+              <a:rPr lang="fr-CH" sz="4700" dirty="0">
                 <a:solidFill>
                   <a:srgbClr val="FFFFFF"/>
                 </a:solidFill>
@@ -3834,14 +3836,14 @@
               <a:t>/Portes Ouvertes</a:t>
             </a:r>
             <a:r>
-              <a:rPr lang="fr-CH" sz="4700" b="1">
+              <a:rPr lang="fr-CH" sz="4700" b="1" dirty="0">
                 <a:solidFill>
                   <a:srgbClr val="FFFFFF"/>
                 </a:solidFill>
               </a:rPr>
               <a:t> 2025-2026</a:t>
             </a:r>
-            <a:endParaRPr lang="fr-CH" sz="4700">
+            <a:endParaRPr lang="fr-CH" sz="4700" dirty="0">
               <a:solidFill>
                 <a:srgbClr val="FFFFFF"/>
               </a:solidFill>
@@ -4177,381 +4179,7 @@
 </p:sld>
 </file>
 
-<file path=ppt/slides/slide2.xml><?xml version="1.0" encoding="utf-8"?>
-<p:sld xmlns:a="http://schemas.openxmlformats.org/drawingml/2006/main" xmlns:r="http://schemas.openxmlformats.org/officeDocument/2006/relationships" xmlns:p="http://schemas.openxmlformats.org/presentationml/2006/main">
-  <p:cSld>
-    <p:spTree>
-      <p:nvGrpSpPr>
-        <p:cNvPr id="1" name=""/>
-        <p:cNvGrpSpPr/>
-        <p:nvPr/>
-      </p:nvGrpSpPr>
-      <p:grpSpPr>
-        <a:xfrm>
-          <a:off x="0" y="0"/>
-          <a:ext cx="0" cy="0"/>
-          <a:chOff x="0" y="0"/>
-          <a:chExt cx="0" cy="0"/>
-        </a:xfrm>
-      </p:grpSpPr>
-      <p:sp>
-        <p:nvSpPr>
-          <p:cNvPr id="2" name="Titre 1">
-            <a:extLst>
-              <a:ext uri="{FF2B5EF4-FFF2-40B4-BE49-F238E27FC236}">
-                <a16:creationId xmlns:a16="http://schemas.microsoft.com/office/drawing/2014/main" id="{BD894843-3D1F-45BD-DF89-B0EE380FC91E}"/>
-              </a:ext>
-            </a:extLst>
-          </p:cNvPr>
-          <p:cNvSpPr>
-            <a:spLocks noGrp="1"/>
-          </p:cNvSpPr>
-          <p:nvPr>
-            <p:ph type="title"/>
-          </p:nvPr>
-        </p:nvSpPr>
-        <p:spPr/>
-        <p:txBody>
-          <a:bodyPr/>
-          <a:lstStyle/>
-          <a:p>
-            <a:r>
-              <a:rPr lang="fr-CH" dirty="0"/>
-              <a:t>Buzzer</a:t>
-            </a:r>
-          </a:p>
-        </p:txBody>
-      </p:sp>
-      <p:sp>
-        <p:nvSpPr>
-          <p:cNvPr id="3" name="Espace réservé du contenu 2">
-            <a:extLst>
-              <a:ext uri="{FF2B5EF4-FFF2-40B4-BE49-F238E27FC236}">
-                <a16:creationId xmlns:a16="http://schemas.microsoft.com/office/drawing/2014/main" id="{02FC0054-0C20-4F7D-DF95-8DDE257CBAFB}"/>
-              </a:ext>
-            </a:extLst>
-          </p:cNvPr>
-          <p:cNvSpPr>
-            <a:spLocks noGrp="1"/>
-          </p:cNvSpPr>
-          <p:nvPr>
-            <p:ph idx="1"/>
-          </p:nvPr>
-        </p:nvSpPr>
-        <p:spPr/>
-        <p:txBody>
-          <a:bodyPr/>
-          <a:lstStyle/>
-          <a:p>
-            <a:r>
-              <a:rPr lang="fr-CH" dirty="0"/>
-              <a:t>Aider à la création du </a:t>
-            </a:r>
-            <a:r>
-              <a:rPr lang="fr-CH" dirty="0" err="1"/>
-              <a:t>Kahoot</a:t>
-            </a:r>
-            <a:r>
-              <a:rPr lang="fr-CH" dirty="0"/>
-              <a:t> avec Liam Bauchard : </a:t>
-            </a:r>
-            <a:r>
-              <a:rPr lang="fr-CH" dirty="0">
-                <a:hlinkClick r:id="rId2"/>
-              </a:rPr>
-              <a:t>https://create.kahoot.it/share/x-portesouvertes-bauchard-buzzer-quiz/13bce810-5c9e-422c-8d9d-d6591684c67d</a:t>
-            </a:r>
-            <a:endParaRPr lang="fr-CH" dirty="0"/>
-          </a:p>
-          <a:p>
-            <a:endParaRPr lang="fr-CH" dirty="0"/>
-          </a:p>
-        </p:txBody>
-      </p:sp>
-    </p:spTree>
-    <p:extLst>
-      <p:ext uri="{BB962C8B-B14F-4D97-AF65-F5344CB8AC3E}">
-        <p14:creationId xmlns:p14="http://schemas.microsoft.com/office/powerpoint/2010/main" val="317335013"/>
-      </p:ext>
-    </p:extLst>
-  </p:cSld>
-  <p:clrMapOvr>
-    <a:masterClrMapping/>
-  </p:clrMapOvr>
-</p:sld>
-</file>
-
-<file path=ppt/slides/slide3.xml><?xml version="1.0" encoding="utf-8"?>
-<p:sld xmlns:a="http://schemas.openxmlformats.org/drawingml/2006/main" xmlns:r="http://schemas.openxmlformats.org/officeDocument/2006/relationships" xmlns:p="http://schemas.openxmlformats.org/presentationml/2006/main">
-  <p:cSld>
-    <p:spTree>
-      <p:nvGrpSpPr>
-        <p:cNvPr id="1" name=""/>
-        <p:cNvGrpSpPr/>
-        <p:nvPr/>
-      </p:nvGrpSpPr>
-      <p:grpSpPr>
-        <a:xfrm>
-          <a:off x="0" y="0"/>
-          <a:ext cx="0" cy="0"/>
-          <a:chOff x="0" y="0"/>
-          <a:chExt cx="0" cy="0"/>
-        </a:xfrm>
-      </p:grpSpPr>
-      <p:sp>
-        <p:nvSpPr>
-          <p:cNvPr id="2" name="Titre 1">
-            <a:extLst>
-              <a:ext uri="{FF2B5EF4-FFF2-40B4-BE49-F238E27FC236}">
-                <a16:creationId xmlns:a16="http://schemas.microsoft.com/office/drawing/2014/main" id="{F6DAD9EE-4B23-643B-4DC1-F77898C6BF8C}"/>
-              </a:ext>
-            </a:extLst>
-          </p:cNvPr>
-          <p:cNvSpPr>
-            <a:spLocks noGrp="1"/>
-          </p:cNvSpPr>
-          <p:nvPr>
-            <p:ph type="title"/>
-          </p:nvPr>
-        </p:nvSpPr>
-        <p:spPr/>
-        <p:txBody>
-          <a:bodyPr/>
-          <a:lstStyle/>
-          <a:p>
-            <a:r>
-              <a:rPr lang="fr-CH" dirty="0"/>
-              <a:t>Cadavre Exquis</a:t>
-            </a:r>
-          </a:p>
-        </p:txBody>
-      </p:sp>
-      <p:sp>
-        <p:nvSpPr>
-          <p:cNvPr id="3" name="Espace réservé du contenu 2">
-            <a:extLst>
-              <a:ext uri="{FF2B5EF4-FFF2-40B4-BE49-F238E27FC236}">
-                <a16:creationId xmlns:a16="http://schemas.microsoft.com/office/drawing/2014/main" id="{B85C1AD1-F3F2-AE6A-95A3-A307D8511D15}"/>
-              </a:ext>
-            </a:extLst>
-          </p:cNvPr>
-          <p:cNvSpPr>
-            <a:spLocks noGrp="1"/>
-          </p:cNvSpPr>
-          <p:nvPr>
-            <p:ph idx="1"/>
-          </p:nvPr>
-        </p:nvSpPr>
-        <p:spPr/>
-        <p:txBody>
-          <a:bodyPr/>
-          <a:lstStyle/>
-          <a:p>
-            <a:r>
-              <a:rPr lang="fr-CH" dirty="0"/>
-              <a:t>Aider à la création du fichier Word d’aide au code avec Noah</a:t>
-            </a:r>
-          </a:p>
-        </p:txBody>
-      </p:sp>
-    </p:spTree>
-    <p:extLst>
-      <p:ext uri="{BB962C8B-B14F-4D97-AF65-F5344CB8AC3E}">
-        <p14:creationId xmlns:p14="http://schemas.microsoft.com/office/powerpoint/2010/main" val="261395948"/>
-      </p:ext>
-    </p:extLst>
-  </p:cSld>
-  <p:clrMapOvr>
-    <a:masterClrMapping/>
-  </p:clrMapOvr>
-</p:sld>
-</file>
-
-<file path=ppt/slides/slide4.xml><?xml version="1.0" encoding="utf-8"?>
-<p:sld xmlns:a="http://schemas.openxmlformats.org/drawingml/2006/main" xmlns:r="http://schemas.openxmlformats.org/officeDocument/2006/relationships" xmlns:p="http://schemas.openxmlformats.org/presentationml/2006/main">
-  <p:cSld>
-    <p:spTree>
-      <p:nvGrpSpPr>
-        <p:cNvPr id="1" name=""/>
-        <p:cNvGrpSpPr/>
-        <p:nvPr/>
-      </p:nvGrpSpPr>
-      <p:grpSpPr>
-        <a:xfrm>
-          <a:off x="0" y="0"/>
-          <a:ext cx="0" cy="0"/>
-          <a:chOff x="0" y="0"/>
-          <a:chExt cx="0" cy="0"/>
-        </a:xfrm>
-      </p:grpSpPr>
-      <p:sp>
-        <p:nvSpPr>
-          <p:cNvPr id="2" name="Titre 1">
-            <a:extLst>
-              <a:ext uri="{FF2B5EF4-FFF2-40B4-BE49-F238E27FC236}">
-                <a16:creationId xmlns:a16="http://schemas.microsoft.com/office/drawing/2014/main" id="{969C35A0-150C-6CDA-942E-F691CBDACD33}"/>
-              </a:ext>
-            </a:extLst>
-          </p:cNvPr>
-          <p:cNvSpPr>
-            <a:spLocks noGrp="1"/>
-          </p:cNvSpPr>
-          <p:nvPr>
-            <p:ph type="title"/>
-          </p:nvPr>
-        </p:nvSpPr>
-        <p:spPr/>
-        <p:txBody>
-          <a:bodyPr/>
-          <a:lstStyle/>
-          <a:p>
-            <a:r>
-              <a:rPr lang="fr-CH" dirty="0"/>
-              <a:t>Imposteur</a:t>
-            </a:r>
-          </a:p>
-        </p:txBody>
-      </p:sp>
-      <p:sp>
-        <p:nvSpPr>
-          <p:cNvPr id="3" name="Espace réservé du contenu 2">
-            <a:extLst>
-              <a:ext uri="{FF2B5EF4-FFF2-40B4-BE49-F238E27FC236}">
-                <a16:creationId xmlns:a16="http://schemas.microsoft.com/office/drawing/2014/main" id="{2FA53BE3-7655-4799-6A30-70C3111FC1E1}"/>
-              </a:ext>
-            </a:extLst>
-          </p:cNvPr>
-          <p:cNvSpPr>
-            <a:spLocks noGrp="1"/>
-          </p:cNvSpPr>
-          <p:nvPr>
-            <p:ph idx="1"/>
-          </p:nvPr>
-        </p:nvSpPr>
-        <p:spPr/>
-        <p:txBody>
-          <a:bodyPr/>
-          <a:lstStyle/>
-          <a:p>
-            <a:r>
-              <a:rPr lang="fr-CH" dirty="0"/>
-              <a:t>Création du CdC </a:t>
-            </a:r>
-          </a:p>
-          <a:p>
-            <a:r>
-              <a:rPr lang="fr-CH" dirty="0"/>
-              <a:t>Création de la banque à questions</a:t>
-            </a:r>
-          </a:p>
-        </p:txBody>
-      </p:sp>
-    </p:spTree>
-    <p:extLst>
-      <p:ext uri="{BB962C8B-B14F-4D97-AF65-F5344CB8AC3E}">
-        <p14:creationId xmlns:p14="http://schemas.microsoft.com/office/powerpoint/2010/main" val="1734631288"/>
-      </p:ext>
-    </p:extLst>
-  </p:cSld>
-  <p:clrMapOvr>
-    <a:masterClrMapping/>
-  </p:clrMapOvr>
-</p:sld>
-</file>
-
-<file path=ppt/slides/slide5.xml><?xml version="1.0" encoding="utf-8"?>
-<p:sld xmlns:a="http://schemas.openxmlformats.org/drawingml/2006/main" xmlns:r="http://schemas.openxmlformats.org/officeDocument/2006/relationships" xmlns:p="http://schemas.openxmlformats.org/presentationml/2006/main">
-  <p:cSld>
-    <p:spTree>
-      <p:nvGrpSpPr>
-        <p:cNvPr id="1" name=""/>
-        <p:cNvGrpSpPr/>
-        <p:nvPr/>
-      </p:nvGrpSpPr>
-      <p:grpSpPr>
-        <a:xfrm>
-          <a:off x="0" y="0"/>
-          <a:ext cx="0" cy="0"/>
-          <a:chOff x="0" y="0"/>
-          <a:chExt cx="0" cy="0"/>
-        </a:xfrm>
-      </p:grpSpPr>
-      <p:sp>
-        <p:nvSpPr>
-          <p:cNvPr id="2" name="Titre 1">
-            <a:extLst>
-              <a:ext uri="{FF2B5EF4-FFF2-40B4-BE49-F238E27FC236}">
-                <a16:creationId xmlns:a16="http://schemas.microsoft.com/office/drawing/2014/main" id="{4751B5CA-B9A9-A6CE-2C2A-398EB24CEB60}"/>
-              </a:ext>
-            </a:extLst>
-          </p:cNvPr>
-          <p:cNvSpPr>
-            <a:spLocks noGrp="1"/>
-          </p:cNvSpPr>
-          <p:nvPr>
-            <p:ph type="title"/>
-          </p:nvPr>
-        </p:nvSpPr>
-        <p:spPr/>
-        <p:txBody>
-          <a:bodyPr/>
-          <a:lstStyle/>
-          <a:p>
-            <a:r>
-              <a:rPr lang="fr-CH" dirty="0"/>
-              <a:t>Annexes</a:t>
-            </a:r>
-          </a:p>
-        </p:txBody>
-      </p:sp>
-      <p:sp>
-        <p:nvSpPr>
-          <p:cNvPr id="3" name="Espace réservé du contenu 2">
-            <a:extLst>
-              <a:ext uri="{FF2B5EF4-FFF2-40B4-BE49-F238E27FC236}">
-                <a16:creationId xmlns:a16="http://schemas.microsoft.com/office/drawing/2014/main" id="{81B232AB-9118-A383-95D2-48DDE10CC526}"/>
-              </a:ext>
-            </a:extLst>
-          </p:cNvPr>
-          <p:cNvSpPr>
-            <a:spLocks noGrp="1"/>
-          </p:cNvSpPr>
-          <p:nvPr>
-            <p:ph idx="1"/>
-          </p:nvPr>
-        </p:nvSpPr>
-        <p:spPr/>
-        <p:txBody>
-          <a:bodyPr/>
-          <a:lstStyle/>
-          <a:p>
-            <a:r>
-              <a:rPr lang="fr-CH" dirty="0"/>
-              <a:t>Création du fichier pour le matériels nécessaires </a:t>
-            </a:r>
-          </a:p>
-          <a:p>
-            <a:r>
-              <a:rPr lang="fr-CH" dirty="0"/>
-              <a:t>Création du fichier avec le retour de M. Sahli</a:t>
-            </a:r>
-          </a:p>
-        </p:txBody>
-      </p:sp>
-    </p:spTree>
-    <p:extLst>
-      <p:ext uri="{BB962C8B-B14F-4D97-AF65-F5344CB8AC3E}">
-        <p14:creationId xmlns:p14="http://schemas.microsoft.com/office/powerpoint/2010/main" val="78487149"/>
-      </p:ext>
-    </p:extLst>
-  </p:cSld>
-  <p:clrMapOvr>
-    <a:masterClrMapping/>
-  </p:clrMapOvr>
-</p:sld>
-</file>
-
-<file path=ppt/slides/slide6.xml><?xml version="1.0" encoding="utf-8"?>
+<file path=ppt/slides/slide10.xml><?xml version="1.0" encoding="utf-8"?>
 <p:sld xmlns:a="http://schemas.openxmlformats.org/drawingml/2006/main" xmlns:r="http://schemas.openxmlformats.org/officeDocument/2006/relationships" xmlns:p="http://schemas.openxmlformats.org/presentationml/2006/main">
   <p:cSld>
     <p:bg>
@@ -4578,7 +4206,7 @@
       </p:grpSpPr>
       <p:sp>
         <p:nvSpPr>
-          <p:cNvPr id="20" name="Freeform: Shape 9">
+          <p:cNvPr id="9" name="Freeform: Shape 8">
             <a:extLst>
               <a:ext uri="{FF2B5EF4-FFF2-40B4-BE49-F238E27FC236}">
                 <a16:creationId xmlns:a16="http://schemas.microsoft.com/office/drawing/2014/main" id="{774A975B-A886-5202-0489-6965514A0D14}"/>
@@ -4686,7 +4314,7 @@
       </p:sp>
       <p:sp>
         <p:nvSpPr>
-          <p:cNvPr id="21" name="Freeform: Shape 11">
+          <p:cNvPr id="11" name="Freeform: Shape 10">
             <a:extLst>
               <a:ext uri="{FF2B5EF4-FFF2-40B4-BE49-F238E27FC236}">
                 <a16:creationId xmlns:a16="http://schemas.microsoft.com/office/drawing/2014/main" id="{EA67E988-5919-57BB-C7DE-D3EAD38A3045}"/>
@@ -4782,12 +4410,12 @@
           </a:p>
         </p:txBody>
       </p:sp>
-      <p:sp>
-        <p:nvSpPr>
-          <p:cNvPr id="22" name="Rectangle 21">
-            <a:extLst>
-              <a:ext uri="{FF2B5EF4-FFF2-40B4-BE49-F238E27FC236}">
-                <a16:creationId xmlns:a16="http://schemas.microsoft.com/office/drawing/2014/main" id="{0EECA69B-4C2A-7F31-8019-E90DB3BD49CB}"/>
+      <p:sp useBgFill="1">
+        <p:nvSpPr>
+          <p:cNvPr id="13" name="Rectangle 12">
+            <a:extLst>
+              <a:ext uri="{FF2B5EF4-FFF2-40B4-BE49-F238E27FC236}">
+                <a16:creationId xmlns:a16="http://schemas.microsoft.com/office/drawing/2014/main" id="{E20BB609-EF92-42DB-836C-0699A590B5CF}"/>
               </a:ext>
               <a:ext uri="{C183D7F6-B498-43B3-948B-1728B52AA6E4}">
                 <adec:decorative xmlns:adec="http://schemas.microsoft.com/office/drawing/2017/decorative" val="1"/>
@@ -4808,38 +4436,19 @@
         <p:spPr>
           <a:xfrm>
             <a:off x="0" y="0"/>
-            <a:ext cx="12192000" cy="6858000"/>
+            <a:ext cx="12192000" cy="6858001"/>
           </a:xfrm>
           <a:prstGeom prst="rect">
             <a:avLst/>
           </a:prstGeom>
-          <a:solidFill>
-            <a:schemeClr val="bg1"/>
-          </a:solidFill>
-          <a:ln w="12700" cap="flat" cmpd="sng" algn="ctr">
+          <a:ln>
             <a:noFill/>
-            <a:prstDash val="solid"/>
-            <a:miter lim="800000"/>
           </a:ln>
-          <a:effectLst/>
-          <a:extLst>
-            <a:ext uri="{91240B29-F687-4F45-9708-019B960494DF}">
-              <a14:hiddenLine xmlns:a14="http://schemas.microsoft.com/office/drawing/2010/main" w="12700" cap="flat" cmpd="sng" algn="ctr">
-                <a:solidFill>
-                  <a:schemeClr val="accent1">
-                    <a:shade val="15000"/>
-                  </a:schemeClr>
-                </a:solidFill>
-                <a:prstDash val="solid"/>
-                <a:miter lim="800000"/>
-              </a14:hiddenLine>
-            </a:ext>
-          </a:extLst>
         </p:spPr>
         <p:style>
           <a:lnRef idx="2">
             <a:schemeClr val="accent1">
-              <a:shade val="15000"/>
+              <a:shade val="50000"/>
             </a:schemeClr>
           </a:lnRef>
           <a:fillRef idx="1">
@@ -4856,65 +4465,28 @@
           <a:bodyPr rtlCol="0" anchor="ctr"/>
           <a:lstStyle/>
           <a:p>
-            <a:pPr marL="0" marR="0" lvl="0" indent="0" algn="ctr" defTabSz="914400" rtl="0" eaLnBrk="1" fontAlgn="auto" latinLnBrk="0" hangingPunct="1">
-              <a:lnSpc>
-                <a:spcPct val="100000"/>
-              </a:lnSpc>
-              <a:spcBef>
-                <a:spcPts val="0"/>
-              </a:spcBef>
-              <a:spcAft>
-                <a:spcPts val="0"/>
-              </a:spcAft>
-              <a:buClrTx/>
-              <a:buSzTx/>
-              <a:buFontTx/>
-              <a:buNone/>
-              <a:tabLst/>
-              <a:defRPr/>
-            </a:pPr>
-            <a:endParaRPr kumimoji="0" lang="en-US" sz="1800" b="0" i="0" u="none" strike="noStrike" kern="1200" cap="none" spc="0" normalizeH="0" baseline="0" noProof="0">
-              <a:ln>
-                <a:noFill/>
-              </a:ln>
-              <a:solidFill>
-                <a:prstClr val="white"/>
-              </a:solidFill>
-              <a:effectLst/>
-              <a:uLnTx/>
-              <a:uFillTx/>
-              <a:latin typeface="Bierstadt"/>
-              <a:ea typeface="+mn-ea"/>
-              <a:cs typeface="+mn-cs"/>
-            </a:endParaRPr>
+            <a:pPr algn="ctr"/>
+            <a:endParaRPr lang="en-US" dirty="0"/>
           </a:p>
         </p:txBody>
       </p:sp>
       <p:pic>
         <p:nvPicPr>
-          <p:cNvPr id="5" name="Espace réservé du contenu 4">
-            <a:extLst>
-              <a:ext uri="{FF2B5EF4-FFF2-40B4-BE49-F238E27FC236}">
-                <a16:creationId xmlns:a16="http://schemas.microsoft.com/office/drawing/2014/main" id="{97DEAC92-ADF9-6A1D-98C0-0E77062EEC45}"/>
+          <p:cNvPr id="5" name="Picture 4">
+            <a:extLst>
+              <a:ext uri="{FF2B5EF4-FFF2-40B4-BE49-F238E27FC236}">
+                <a16:creationId xmlns:a16="http://schemas.microsoft.com/office/drawing/2014/main" id="{827C1362-236A-6BAD-A329-94810AF9A7F0}"/>
               </a:ext>
             </a:extLst>
           </p:cNvPr>
           <p:cNvPicPr>
-            <a:picLocks noGrp="1" noChangeAspect="1"/>
+            <a:picLocks noChangeAspect="1"/>
           </p:cNvPicPr>
-          <p:nvPr>
-            <p:ph idx="1"/>
-          </p:nvPr>
+          <p:nvPr/>
         </p:nvPicPr>
         <p:blipFill>
-          <a:blip r:embed="rId2">
-            <a:extLst>
-              <a:ext uri="{28A0092B-C50C-407E-A947-70E740481C1C}">
-                <a14:useLocalDpi xmlns:a14="http://schemas.microsoft.com/office/drawing/2010/main" val="0"/>
-              </a:ext>
-            </a:extLst>
-          </a:blip>
-          <a:srcRect l="4484" t="1615" b="18194"/>
+          <a:blip r:embed="rId2"/>
+          <a:srcRect l="25"/>
           <a:stretch>
             <a:fillRect/>
           </a:stretch>
@@ -4922,7 +4494,7 @@
         <p:spPr>
           <a:xfrm>
             <a:off x="20" y="10"/>
-            <a:ext cx="12191980" cy="6857990"/>
+            <a:ext cx="12188932" cy="6857990"/>
           </a:xfrm>
           <a:prstGeom prst="rect">
             <a:avLst/>
@@ -4931,10 +4503,10 @@
       </p:pic>
       <p:sp>
         <p:nvSpPr>
-          <p:cNvPr id="23" name="Rectangle 22">
-            <a:extLst>
-              <a:ext uri="{FF2B5EF4-FFF2-40B4-BE49-F238E27FC236}">
-                <a16:creationId xmlns:a16="http://schemas.microsoft.com/office/drawing/2014/main" id="{857DEAC1-B3AA-6569-0A44-A191DF2F3C67}"/>
+          <p:cNvPr id="15" name="Rectangle 14">
+            <a:extLst>
+              <a:ext uri="{FF2B5EF4-FFF2-40B4-BE49-F238E27FC236}">
+                <a16:creationId xmlns:a16="http://schemas.microsoft.com/office/drawing/2014/main" id="{637992A9-1E8C-4E57-B4F4-EE2D38E504A2}"/>
               </a:ext>
               <a:ext uri="{C183D7F6-B498-43B3-948B-1728B52AA6E4}">
                 <adec:decorative xmlns:adec="http://schemas.microsoft.com/office/drawing/2017/decorative" val="1"/>
@@ -4953,17 +4525,177 @@
           </p:nvPr>
         </p:nvSpPr>
         <p:spPr>
+          <a:xfrm rot="16200000">
+            <a:off x="389239" y="-389238"/>
+            <a:ext cx="6858000" cy="7636476"/>
+          </a:xfrm>
+          <a:prstGeom prst="rect">
+            <a:avLst/>
+          </a:prstGeom>
+          <a:gradFill>
+            <a:gsLst>
+              <a:gs pos="100000">
+                <a:srgbClr val="000000">
+                  <a:alpha val="0"/>
+                </a:srgbClr>
+              </a:gs>
+              <a:gs pos="0">
+                <a:schemeClr val="tx1"/>
+              </a:gs>
+              <a:gs pos="0">
+                <a:srgbClr val="000000">
+                  <a:alpha val="70000"/>
+                </a:srgbClr>
+              </a:gs>
+            </a:gsLst>
+            <a:lin ang="5400000" scaled="1"/>
+          </a:gradFill>
+          <a:ln>
+            <a:noFill/>
+          </a:ln>
+        </p:spPr>
+        <p:style>
+          <a:lnRef idx="2">
+            <a:schemeClr val="accent1">
+              <a:shade val="50000"/>
+            </a:schemeClr>
+          </a:lnRef>
+          <a:fillRef idx="1">
+            <a:schemeClr val="accent1"/>
+          </a:fillRef>
+          <a:effectRef idx="0">
+            <a:schemeClr val="accent1"/>
+          </a:effectRef>
+          <a:fontRef idx="minor">
+            <a:schemeClr val="lt1"/>
+          </a:fontRef>
+        </p:style>
+        <p:txBody>
+          <a:bodyPr rtlCol="0" anchor="ctr"/>
+          <a:lstStyle/>
+          <a:p>
+            <a:pPr algn="ctr"/>
+            <a:endParaRPr lang="en-US"/>
+          </a:p>
+        </p:txBody>
+      </p:sp>
+      <p:sp>
+        <p:nvSpPr>
+          <p:cNvPr id="2" name="Titre 1">
+            <a:extLst>
+              <a:ext uri="{FF2B5EF4-FFF2-40B4-BE49-F238E27FC236}">
+                <a16:creationId xmlns:a16="http://schemas.microsoft.com/office/drawing/2014/main" id="{E34E0744-9D9A-00B0-9E8E-D0320984E3F4}"/>
+              </a:ext>
+            </a:extLst>
+          </p:cNvPr>
+          <p:cNvSpPr>
+            <a:spLocks noGrp="1"/>
+          </p:cNvSpPr>
+          <p:nvPr>
+            <p:ph type="title"/>
+          </p:nvPr>
+        </p:nvSpPr>
+        <p:spPr>
           <a:xfrm>
-            <a:off x="0" y="5577840"/>
-            <a:ext cx="12191999" cy="1280160"/>
+            <a:off x="517870" y="978407"/>
+            <a:ext cx="5021182" cy="3309511"/>
+          </a:xfrm>
+        </p:spPr>
+        <p:txBody>
+          <a:bodyPr vert="horz" lIns="91440" tIns="45720" rIns="91440" bIns="45720" rtlCol="0" anchor="t">
+            <a:normAutofit/>
+          </a:bodyPr>
+          <a:lstStyle/>
+          <a:p>
+            <a:r>
+              <a:rPr lang="en-US" sz="6000">
+                <a:solidFill>
+                  <a:srgbClr val="FFFFFF"/>
+                </a:solidFill>
+              </a:rPr>
+              <a:t>AstroLab</a:t>
+            </a:r>
+          </a:p>
+        </p:txBody>
+      </p:sp>
+      <p:sp>
+        <p:nvSpPr>
+          <p:cNvPr id="3" name="Espace réservé du contenu 2">
+            <a:extLst>
+              <a:ext uri="{FF2B5EF4-FFF2-40B4-BE49-F238E27FC236}">
+                <a16:creationId xmlns:a16="http://schemas.microsoft.com/office/drawing/2014/main" id="{0C44115A-CC4B-00F3-04DA-D24F28C4E5EA}"/>
+              </a:ext>
+            </a:extLst>
+          </p:cNvPr>
+          <p:cNvSpPr>
+            <a:spLocks noGrp="1"/>
+          </p:cNvSpPr>
+          <p:nvPr>
+            <p:ph idx="1"/>
+          </p:nvPr>
+        </p:nvSpPr>
+        <p:spPr>
+          <a:xfrm>
+            <a:off x="517870" y="4482450"/>
+            <a:ext cx="5040785" cy="1724029"/>
+          </a:xfrm>
+        </p:spPr>
+        <p:txBody>
+          <a:bodyPr vert="horz" lIns="91440" tIns="45720" rIns="91440" bIns="45720" rtlCol="0" anchor="t">
+            <a:normAutofit/>
+          </a:bodyPr>
+          <a:lstStyle/>
+          <a:p>
+            <a:pPr marL="0" indent="0">
+              <a:buNone/>
+            </a:pPr>
+            <a:r>
+              <a:rPr lang="en-US" sz="2200" i="1" kern="1200">
+                <a:solidFill>
+                  <a:srgbClr val="FFFFFF"/>
+                </a:solidFill>
+                <a:latin typeface="+mn-lt"/>
+                <a:ea typeface="+mn-ea"/>
+                <a:cs typeface="+mn-cs"/>
+              </a:rPr>
+              <a:t>Projet en python</a:t>
+            </a:r>
+          </a:p>
+        </p:txBody>
+      </p:sp>
+      <p:sp>
+        <p:nvSpPr>
+          <p:cNvPr id="17" name="Rectangle 16">
+            <a:extLst>
+              <a:ext uri="{FF2B5EF4-FFF2-40B4-BE49-F238E27FC236}">
+                <a16:creationId xmlns:a16="http://schemas.microsoft.com/office/drawing/2014/main" id="{B2C335F7-F61C-4EB4-80F2-4B1438FE66BB}"/>
+              </a:ext>
+              <a:ext uri="{C183D7F6-B498-43B3-948B-1728B52AA6E4}">
+                <adec:decorative xmlns:adec="http://schemas.microsoft.com/office/drawing/2017/decorative" val="1"/>
+              </a:ext>
+            </a:extLst>
+          </p:cNvPr>
+          <p:cNvSpPr>
+            <a:spLocks noGrp="1" noRot="1" noChangeAspect="1" noMove="1" noResize="1" noEditPoints="1" noAdjustHandles="1" noChangeArrowheads="1" noChangeShapeType="1" noTextEdit="1"/>
+          </p:cNvSpPr>
+          <p:nvPr>
+            <p:extLst>
+              <p:ext uri="{386F3935-93C4-4BCD-93E2-E3B085C9AB24}">
+                <p16:designElem xmlns:p16="http://schemas.microsoft.com/office/powerpoint/2015/main" val="1"/>
+              </p:ext>
+            </p:extLst>
+          </p:nvPr>
+        </p:nvSpPr>
+        <p:spPr>
+          <a:xfrm>
+            <a:off x="517870" y="508090"/>
+            <a:ext cx="5021183" cy="149279"/>
           </a:xfrm>
           <a:prstGeom prst="rect">
             <a:avLst/>
           </a:prstGeom>
           <a:solidFill>
-            <a:schemeClr val="bg1">
-              <a:alpha val="28000"/>
-            </a:schemeClr>
+            <a:srgbClr val="FFFFFF"/>
           </a:solidFill>
           <a:ln>
             <a:noFill/>
@@ -4989,82 +4721,15 @@
           <a:bodyPr rtlCol="0" anchor="ctr"/>
           <a:lstStyle/>
           <a:p>
-            <a:pPr marL="0" marR="0" lvl="0" indent="0" algn="ctr" defTabSz="914400" rtl="0" eaLnBrk="1" fontAlgn="auto" latinLnBrk="0" hangingPunct="1">
-              <a:lnSpc>
-                <a:spcPct val="100000"/>
-              </a:lnSpc>
-              <a:spcBef>
-                <a:spcPts val="0"/>
-              </a:spcBef>
-              <a:spcAft>
-                <a:spcPts val="0"/>
-              </a:spcAft>
-              <a:buClrTx/>
-              <a:buSzTx/>
-              <a:buFontTx/>
-              <a:buNone/>
-              <a:tabLst/>
-              <a:defRPr/>
-            </a:pPr>
-            <a:endParaRPr kumimoji="0" lang="en-US" sz="1800" b="0" i="0" u="none" strike="noStrike" kern="1200" cap="none" spc="0" normalizeH="0" baseline="0" noProof="0">
-              <a:ln>
-                <a:noFill/>
-              </a:ln>
-              <a:solidFill>
-                <a:prstClr val="white"/>
-              </a:solidFill>
-              <a:effectLst/>
-              <a:uLnTx/>
-              <a:uFillTx/>
-              <a:latin typeface="Bierstadt"/>
-              <a:ea typeface="+mn-ea"/>
-              <a:cs typeface="+mn-cs"/>
-            </a:endParaRPr>
-          </a:p>
-        </p:txBody>
-      </p:sp>
-      <p:sp>
-        <p:nvSpPr>
-          <p:cNvPr id="2" name="Titre 1">
-            <a:extLst>
-              <a:ext uri="{FF2B5EF4-FFF2-40B4-BE49-F238E27FC236}">
-                <a16:creationId xmlns:a16="http://schemas.microsoft.com/office/drawing/2014/main" id="{5533CF7B-BA68-278B-A783-54828C4176F2}"/>
-              </a:ext>
-            </a:extLst>
-          </p:cNvPr>
-          <p:cNvSpPr>
-            <a:spLocks noGrp="1"/>
-          </p:cNvSpPr>
-          <p:nvPr>
-            <p:ph type="title"/>
-          </p:nvPr>
-        </p:nvSpPr>
-        <p:spPr>
-          <a:xfrm>
-            <a:off x="320039" y="5731580"/>
-            <a:ext cx="11686033" cy="980116"/>
-          </a:xfrm>
-          <a:ln>
-            <a:noFill/>
-          </a:ln>
-        </p:spPr>
-        <p:txBody>
-          <a:bodyPr vert="horz" lIns="91440" tIns="45720" rIns="91440" bIns="45720" rtlCol="0" anchor="ctr">
-            <a:normAutofit/>
-          </a:bodyPr>
-          <a:lstStyle/>
-          <a:p>
-            <a:r>
-              <a:rPr lang="fr-CH" dirty="0"/>
-              <a:t>Projet DemoMot 2025-2026</a:t>
-            </a:r>
+            <a:pPr algn="ctr"/>
+            <a:endParaRPr lang="en-US"/>
           </a:p>
         </p:txBody>
       </p:sp>
     </p:spTree>
     <p:extLst>
       <p:ext uri="{BB962C8B-B14F-4D97-AF65-F5344CB8AC3E}">
-        <p14:creationId xmlns:p14="http://schemas.microsoft.com/office/powerpoint/2010/main" val="1444886072"/>
+        <p14:creationId xmlns:p14="http://schemas.microsoft.com/office/powerpoint/2010/main" val="832870440"/>
       </p:ext>
     </p:extLst>
   </p:cSld>
@@ -5074,7 +4739,7 @@
 </p:sld>
 </file>
 
-<file path=ppt/slides/slide7.xml><?xml version="1.0" encoding="utf-8"?>
+<file path=ppt/slides/slide11.xml><?xml version="1.0" encoding="utf-8"?>
 <p:sld xmlns:a="http://schemas.openxmlformats.org/drawingml/2006/main" xmlns:r="http://schemas.openxmlformats.org/officeDocument/2006/relationships" xmlns:p="http://schemas.openxmlformats.org/presentationml/2006/main">
   <p:cSld>
     <p:spTree>
@@ -5096,7 +4761,7 @@
           <p:cNvPr id="2" name="Titre 1">
             <a:extLst>
               <a:ext uri="{FF2B5EF4-FFF2-40B4-BE49-F238E27FC236}">
-                <a16:creationId xmlns:a16="http://schemas.microsoft.com/office/drawing/2014/main" id="{523419E0-15C6-46E7-70B2-34653D777685}"/>
+                <a16:creationId xmlns:a16="http://schemas.microsoft.com/office/drawing/2014/main" id="{0CD193FF-2B7B-BC23-F6D7-D46536517DE1}"/>
               </a:ext>
             </a:extLst>
           </p:cNvPr>
@@ -5124,7 +4789,7 @@
           <p:cNvPr id="3" name="Espace réservé du contenu 2">
             <a:extLst>
               <a:ext uri="{FF2B5EF4-FFF2-40B4-BE49-F238E27FC236}">
-                <a16:creationId xmlns:a16="http://schemas.microsoft.com/office/drawing/2014/main" id="{14088F4B-426E-9596-B618-28846F9E3873}"/>
+                <a16:creationId xmlns:a16="http://schemas.microsoft.com/office/drawing/2014/main" id="{E1121C98-EC16-3C52-8342-E449BCD3F200}"/>
               </a:ext>
             </a:extLst>
           </p:cNvPr>
@@ -5141,70 +4806,18 @@
           <a:lstStyle/>
           <a:p>
             <a:r>
-              <a:rPr lang="fr-CH" b="1" dirty="0"/>
-              <a:t>Éduquer par l'Espace</a:t>
-            </a:r>
-          </a:p>
-          <a:p>
-            <a:pPr lvl="1"/>
-            <a:r>
               <a:rPr lang="fr-CH" dirty="0"/>
-              <a:t>AgaMoon est un site web éducatif dédié à la Lune. </a:t>
-            </a:r>
-          </a:p>
-          <a:p>
-            <a:pPr lvl="1"/>
+              <a:t>Apprendre un nouveau langage : Python</a:t>
+            </a:r>
+          </a:p>
+          <a:p>
             <a:r>
               <a:rPr lang="fr-CH" dirty="0"/>
-              <a:t>Le projet explore quatre piliers : les données physiques, les phases lunaires, l'histoire de l'exploration et une galerie de photos authentiques.</a:t>
-            </a:r>
-          </a:p>
-          <a:p>
-            <a:r>
-              <a:rPr lang="fr-CH" b="1" dirty="0"/>
-              <a:t>Langages &amp; Standards</a:t>
-            </a:r>
-          </a:p>
-          <a:p>
-            <a:r>
-              <a:rPr lang="fr-CH" dirty="0"/>
-              <a:t>Développement pur en </a:t>
-            </a:r>
-            <a:r>
-              <a:rPr lang="fr-CH" b="1" dirty="0"/>
-              <a:t>HTML5</a:t>
-            </a:r>
-            <a:r>
-              <a:rPr lang="fr-CH" dirty="0"/>
-              <a:t> et </a:t>
-            </a:r>
-            <a:r>
-              <a:rPr lang="fr-CH" b="1" dirty="0"/>
-              <a:t>CSS3</a:t>
-            </a:r>
-            <a:r>
-              <a:rPr lang="fr-CH" dirty="0"/>
-              <a:t> pour garantir une structure sémantique et un design moderne et responsive.</a:t>
-            </a:r>
-          </a:p>
-          <a:p>
-            <a:r>
-              <a:rPr lang="fr-CH" b="1" dirty="0"/>
-              <a:t>Environnement</a:t>
-            </a:r>
-          </a:p>
-          <a:p>
-            <a:r>
-              <a:rPr lang="fr-CH" dirty="0"/>
-              <a:t>Utilisation de </a:t>
-            </a:r>
-            <a:r>
-              <a:rPr lang="fr-CH" b="1" dirty="0"/>
-              <a:t>Visual Studio Code</a:t>
-            </a:r>
-            <a:r>
-              <a:rPr lang="fr-CH" dirty="0"/>
-              <a:t> comme IDE principal, optimisé pour un workflow fluide entre le code et le rendu navigateur.</a:t>
+              <a:t>Faire un projet avec </a:t>
+            </a:r>
+            <a:r>
+              <a:rPr lang="fr-CH"/>
+              <a:t>des calculs</a:t>
             </a:r>
           </a:p>
         </p:txBody>
@@ -5212,7 +4825,7 @@
     </p:spTree>
     <p:extLst>
       <p:ext uri="{BB962C8B-B14F-4D97-AF65-F5344CB8AC3E}">
-        <p14:creationId xmlns:p14="http://schemas.microsoft.com/office/powerpoint/2010/main" val="3353841106"/>
+        <p14:creationId xmlns:p14="http://schemas.microsoft.com/office/powerpoint/2010/main" val="3658721233"/>
       </p:ext>
     </p:extLst>
   </p:cSld>
@@ -5222,7 +4835,7 @@
 </p:sld>
 </file>
 
-<file path=ppt/slides/slide8.xml><?xml version="1.0" encoding="utf-8"?>
+<file path=ppt/slides/slide2.xml><?xml version="1.0" encoding="utf-8"?>
 <p:sld xmlns:a="http://schemas.openxmlformats.org/drawingml/2006/main" xmlns:r="http://schemas.openxmlformats.org/officeDocument/2006/relationships" xmlns:p="http://schemas.openxmlformats.org/presentationml/2006/main">
   <p:cSld>
     <p:spTree>
@@ -5244,7 +4857,7 @@
           <p:cNvPr id="2" name="Titre 1">
             <a:extLst>
               <a:ext uri="{FF2B5EF4-FFF2-40B4-BE49-F238E27FC236}">
-                <a16:creationId xmlns:a16="http://schemas.microsoft.com/office/drawing/2014/main" id="{39CDB58D-7818-6269-97FE-DB12D816E353}"/>
+                <a16:creationId xmlns:a16="http://schemas.microsoft.com/office/drawing/2014/main" id="{BD894843-3D1F-45BD-DF89-B0EE380FC91E}"/>
               </a:ext>
             </a:extLst>
           </p:cNvPr>
@@ -5262,7 +4875,7 @@
           <a:p>
             <a:r>
               <a:rPr lang="fr-CH" dirty="0"/>
-              <a:t>Cahier des charges</a:t>
+              <a:t>Buzzer</a:t>
             </a:r>
           </a:p>
         </p:txBody>
@@ -5272,7 +4885,7 @@
           <p:cNvPr id="3" name="Espace réservé du contenu 2">
             <a:extLst>
               <a:ext uri="{FF2B5EF4-FFF2-40B4-BE49-F238E27FC236}">
-                <a16:creationId xmlns:a16="http://schemas.microsoft.com/office/drawing/2014/main" id="{1173D744-E38A-8D6D-6C85-1B94E33E8328}"/>
+                <a16:creationId xmlns:a16="http://schemas.microsoft.com/office/drawing/2014/main" id="{02FC0054-0C20-4F7D-DF95-8DDE257CBAFB}"/>
               </a:ext>
             </a:extLst>
           </p:cNvPr>
@@ -5289,63 +4902,34 @@
           <a:lstStyle/>
           <a:p>
             <a:r>
-              <a:rPr lang="fr-CH" b="1" dirty="0"/>
-              <a:t>Données Scientifiques :</a:t>
-            </a:r>
-            <a:r>
               <a:rPr lang="fr-CH" dirty="0"/>
-              <a:t> Affichage d'informations générales précises sur la Lune.</a:t>
-            </a:r>
-          </a:p>
-          <a:p>
-            <a:r>
-              <a:rPr lang="fr-CH" b="1" dirty="0"/>
-              <a:t>Cycle Lunaire :</a:t>
+              <a:t>Aider à la création du </a:t>
+            </a:r>
+            <a:r>
+              <a:rPr lang="fr-CH" dirty="0" err="1"/>
+              <a:t>Kahoot</a:t>
             </a:r>
             <a:r>
               <a:rPr lang="fr-CH" dirty="0"/>
-              <a:t> Présentation des huit phases avec illustrations dédiées.</a:t>
-            </a:r>
-          </a:p>
-          <a:p>
-            <a:r>
-              <a:rPr lang="fr-CH" b="1" dirty="0"/>
-              <a:t>Galerie Visuelle :</a:t>
-            </a:r>
-            <a:r>
-              <a:rPr lang="fr-CH" dirty="0"/>
-              <a:t> Mise à disposition d'une banque d'images astronomiques.</a:t>
-            </a:r>
-          </a:p>
-          <a:p>
-            <a:r>
-              <a:rPr lang="fr-CH" b="1" dirty="0"/>
-              <a:t>UX Intuitive :</a:t>
-            </a:r>
-            <a:r>
-              <a:rPr lang="fr-CH" dirty="0"/>
-              <a:t> Navigation simple et fluide sur une seule page (Single Page).</a:t>
-            </a:r>
-          </a:p>
-          <a:p>
-            <a:r>
-              <a:rPr lang="fr-CH" b="1"/>
-              <a:t>Adaptabilité :</a:t>
-            </a:r>
-            <a:r>
-              <a:rPr lang="fr-CH"/>
-              <a:t> Design 100% responsive pour tous types d'écrans.</a:t>
-            </a:r>
-          </a:p>
-          <a:p>
-            <a:endParaRPr lang="fr-CH"/>
+              <a:t> avec Liam Bauchard : </a:t>
+            </a:r>
+            <a:r>
+              <a:rPr lang="fr-CH" dirty="0">
+                <a:hlinkClick r:id="rId2"/>
+              </a:rPr>
+              <a:t>https://create.kahoot.it/share/x-portesouvertes-bauchard-buzzer-quiz/13bce810-5c9e-422c-8d9d-d6591684c67d</a:t>
+            </a:r>
+            <a:endParaRPr lang="fr-CH" dirty="0"/>
+          </a:p>
+          <a:p>
+            <a:endParaRPr lang="fr-CH" dirty="0"/>
           </a:p>
         </p:txBody>
       </p:sp>
     </p:spTree>
     <p:extLst>
       <p:ext uri="{BB962C8B-B14F-4D97-AF65-F5344CB8AC3E}">
-        <p14:creationId xmlns:p14="http://schemas.microsoft.com/office/powerpoint/2010/main" val="102074461"/>
+        <p14:creationId xmlns:p14="http://schemas.microsoft.com/office/powerpoint/2010/main" val="317335013"/>
       </p:ext>
     </p:extLst>
   </p:cSld>
@@ -5355,7 +4939,277 @@
 </p:sld>
 </file>
 
-<file path=ppt/slides/slide9.xml><?xml version="1.0" encoding="utf-8"?>
+<file path=ppt/slides/slide3.xml><?xml version="1.0" encoding="utf-8"?>
+<p:sld xmlns:a="http://schemas.openxmlformats.org/drawingml/2006/main" xmlns:r="http://schemas.openxmlformats.org/officeDocument/2006/relationships" xmlns:p="http://schemas.openxmlformats.org/presentationml/2006/main">
+  <p:cSld>
+    <p:spTree>
+      <p:nvGrpSpPr>
+        <p:cNvPr id="1" name=""/>
+        <p:cNvGrpSpPr/>
+        <p:nvPr/>
+      </p:nvGrpSpPr>
+      <p:grpSpPr>
+        <a:xfrm>
+          <a:off x="0" y="0"/>
+          <a:ext cx="0" cy="0"/>
+          <a:chOff x="0" y="0"/>
+          <a:chExt cx="0" cy="0"/>
+        </a:xfrm>
+      </p:grpSpPr>
+      <p:sp>
+        <p:nvSpPr>
+          <p:cNvPr id="2" name="Titre 1">
+            <a:extLst>
+              <a:ext uri="{FF2B5EF4-FFF2-40B4-BE49-F238E27FC236}">
+                <a16:creationId xmlns:a16="http://schemas.microsoft.com/office/drawing/2014/main" id="{F6DAD9EE-4B23-643B-4DC1-F77898C6BF8C}"/>
+              </a:ext>
+            </a:extLst>
+          </p:cNvPr>
+          <p:cNvSpPr>
+            <a:spLocks noGrp="1"/>
+          </p:cNvSpPr>
+          <p:nvPr>
+            <p:ph type="title"/>
+          </p:nvPr>
+        </p:nvSpPr>
+        <p:spPr/>
+        <p:txBody>
+          <a:bodyPr/>
+          <a:lstStyle/>
+          <a:p>
+            <a:r>
+              <a:rPr lang="fr-CH" dirty="0"/>
+              <a:t>Cadavre Exquis</a:t>
+            </a:r>
+          </a:p>
+        </p:txBody>
+      </p:sp>
+      <p:sp>
+        <p:nvSpPr>
+          <p:cNvPr id="3" name="Espace réservé du contenu 2">
+            <a:extLst>
+              <a:ext uri="{FF2B5EF4-FFF2-40B4-BE49-F238E27FC236}">
+                <a16:creationId xmlns:a16="http://schemas.microsoft.com/office/drawing/2014/main" id="{B85C1AD1-F3F2-AE6A-95A3-A307D8511D15}"/>
+              </a:ext>
+            </a:extLst>
+          </p:cNvPr>
+          <p:cNvSpPr>
+            <a:spLocks noGrp="1"/>
+          </p:cNvSpPr>
+          <p:nvPr>
+            <p:ph idx="1"/>
+          </p:nvPr>
+        </p:nvSpPr>
+        <p:spPr/>
+        <p:txBody>
+          <a:bodyPr/>
+          <a:lstStyle/>
+          <a:p>
+            <a:r>
+              <a:rPr lang="fr-CH" dirty="0"/>
+              <a:t>Aider à la création du fichier Word d’aide au code avec Noah</a:t>
+            </a:r>
+          </a:p>
+        </p:txBody>
+      </p:sp>
+    </p:spTree>
+    <p:extLst>
+      <p:ext uri="{BB962C8B-B14F-4D97-AF65-F5344CB8AC3E}">
+        <p14:creationId xmlns:p14="http://schemas.microsoft.com/office/powerpoint/2010/main" val="261395948"/>
+      </p:ext>
+    </p:extLst>
+  </p:cSld>
+  <p:clrMapOvr>
+    <a:masterClrMapping/>
+  </p:clrMapOvr>
+</p:sld>
+</file>
+
+<file path=ppt/slides/slide4.xml><?xml version="1.0" encoding="utf-8"?>
+<p:sld xmlns:a="http://schemas.openxmlformats.org/drawingml/2006/main" xmlns:r="http://schemas.openxmlformats.org/officeDocument/2006/relationships" xmlns:p="http://schemas.openxmlformats.org/presentationml/2006/main">
+  <p:cSld>
+    <p:spTree>
+      <p:nvGrpSpPr>
+        <p:cNvPr id="1" name=""/>
+        <p:cNvGrpSpPr/>
+        <p:nvPr/>
+      </p:nvGrpSpPr>
+      <p:grpSpPr>
+        <a:xfrm>
+          <a:off x="0" y="0"/>
+          <a:ext cx="0" cy="0"/>
+          <a:chOff x="0" y="0"/>
+          <a:chExt cx="0" cy="0"/>
+        </a:xfrm>
+      </p:grpSpPr>
+      <p:sp>
+        <p:nvSpPr>
+          <p:cNvPr id="2" name="Titre 1">
+            <a:extLst>
+              <a:ext uri="{FF2B5EF4-FFF2-40B4-BE49-F238E27FC236}">
+                <a16:creationId xmlns:a16="http://schemas.microsoft.com/office/drawing/2014/main" id="{969C35A0-150C-6CDA-942E-F691CBDACD33}"/>
+              </a:ext>
+            </a:extLst>
+          </p:cNvPr>
+          <p:cNvSpPr>
+            <a:spLocks noGrp="1"/>
+          </p:cNvSpPr>
+          <p:nvPr>
+            <p:ph type="title"/>
+          </p:nvPr>
+        </p:nvSpPr>
+        <p:spPr/>
+        <p:txBody>
+          <a:bodyPr/>
+          <a:lstStyle/>
+          <a:p>
+            <a:r>
+              <a:rPr lang="fr-CH" dirty="0"/>
+              <a:t>Imposteur</a:t>
+            </a:r>
+          </a:p>
+        </p:txBody>
+      </p:sp>
+      <p:sp>
+        <p:nvSpPr>
+          <p:cNvPr id="3" name="Espace réservé du contenu 2">
+            <a:extLst>
+              <a:ext uri="{FF2B5EF4-FFF2-40B4-BE49-F238E27FC236}">
+                <a16:creationId xmlns:a16="http://schemas.microsoft.com/office/drawing/2014/main" id="{2FA53BE3-7655-4799-6A30-70C3111FC1E1}"/>
+              </a:ext>
+            </a:extLst>
+          </p:cNvPr>
+          <p:cNvSpPr>
+            <a:spLocks noGrp="1"/>
+          </p:cNvSpPr>
+          <p:nvPr>
+            <p:ph idx="1"/>
+          </p:nvPr>
+        </p:nvSpPr>
+        <p:spPr/>
+        <p:txBody>
+          <a:bodyPr/>
+          <a:lstStyle/>
+          <a:p>
+            <a:r>
+              <a:rPr lang="fr-CH" dirty="0"/>
+              <a:t>Création du CdC </a:t>
+            </a:r>
+          </a:p>
+          <a:p>
+            <a:r>
+              <a:rPr lang="fr-CH" dirty="0"/>
+              <a:t>Création de la banque à questions</a:t>
+            </a:r>
+          </a:p>
+        </p:txBody>
+      </p:sp>
+    </p:spTree>
+    <p:extLst>
+      <p:ext uri="{BB962C8B-B14F-4D97-AF65-F5344CB8AC3E}">
+        <p14:creationId xmlns:p14="http://schemas.microsoft.com/office/powerpoint/2010/main" val="1734631288"/>
+      </p:ext>
+    </p:extLst>
+  </p:cSld>
+  <p:clrMapOvr>
+    <a:masterClrMapping/>
+  </p:clrMapOvr>
+</p:sld>
+</file>
+
+<file path=ppt/slides/slide5.xml><?xml version="1.0" encoding="utf-8"?>
+<p:sld xmlns:a="http://schemas.openxmlformats.org/drawingml/2006/main" xmlns:r="http://schemas.openxmlformats.org/officeDocument/2006/relationships" xmlns:p="http://schemas.openxmlformats.org/presentationml/2006/main">
+  <p:cSld>
+    <p:spTree>
+      <p:nvGrpSpPr>
+        <p:cNvPr id="1" name=""/>
+        <p:cNvGrpSpPr/>
+        <p:nvPr/>
+      </p:nvGrpSpPr>
+      <p:grpSpPr>
+        <a:xfrm>
+          <a:off x="0" y="0"/>
+          <a:ext cx="0" cy="0"/>
+          <a:chOff x="0" y="0"/>
+          <a:chExt cx="0" cy="0"/>
+        </a:xfrm>
+      </p:grpSpPr>
+      <p:sp>
+        <p:nvSpPr>
+          <p:cNvPr id="2" name="Titre 1">
+            <a:extLst>
+              <a:ext uri="{FF2B5EF4-FFF2-40B4-BE49-F238E27FC236}">
+                <a16:creationId xmlns:a16="http://schemas.microsoft.com/office/drawing/2014/main" id="{4751B5CA-B9A9-A6CE-2C2A-398EB24CEB60}"/>
+              </a:ext>
+            </a:extLst>
+          </p:cNvPr>
+          <p:cNvSpPr>
+            <a:spLocks noGrp="1"/>
+          </p:cNvSpPr>
+          <p:nvPr>
+            <p:ph type="title"/>
+          </p:nvPr>
+        </p:nvSpPr>
+        <p:spPr/>
+        <p:txBody>
+          <a:bodyPr/>
+          <a:lstStyle/>
+          <a:p>
+            <a:r>
+              <a:rPr lang="fr-CH" dirty="0"/>
+              <a:t>Annexes</a:t>
+            </a:r>
+          </a:p>
+        </p:txBody>
+      </p:sp>
+      <p:sp>
+        <p:nvSpPr>
+          <p:cNvPr id="3" name="Espace réservé du contenu 2">
+            <a:extLst>
+              <a:ext uri="{FF2B5EF4-FFF2-40B4-BE49-F238E27FC236}">
+                <a16:creationId xmlns:a16="http://schemas.microsoft.com/office/drawing/2014/main" id="{81B232AB-9118-A383-95D2-48DDE10CC526}"/>
+              </a:ext>
+            </a:extLst>
+          </p:cNvPr>
+          <p:cNvSpPr>
+            <a:spLocks noGrp="1"/>
+          </p:cNvSpPr>
+          <p:nvPr>
+            <p:ph idx="1"/>
+          </p:nvPr>
+        </p:nvSpPr>
+        <p:spPr/>
+        <p:txBody>
+          <a:bodyPr/>
+          <a:lstStyle/>
+          <a:p>
+            <a:r>
+              <a:rPr lang="fr-CH" dirty="0"/>
+              <a:t>Création du fichier pour le matériels nécessaires </a:t>
+            </a:r>
+          </a:p>
+          <a:p>
+            <a:r>
+              <a:rPr lang="fr-CH" dirty="0"/>
+              <a:t>Création du fichier avec le retour de M. Sahli</a:t>
+            </a:r>
+          </a:p>
+        </p:txBody>
+      </p:sp>
+    </p:spTree>
+    <p:extLst>
+      <p:ext uri="{BB962C8B-B14F-4D97-AF65-F5344CB8AC3E}">
+        <p14:creationId xmlns:p14="http://schemas.microsoft.com/office/powerpoint/2010/main" val="78487149"/>
+      </p:ext>
+    </p:extLst>
+  </p:cSld>
+  <p:clrMapOvr>
+    <a:masterClrMapping/>
+  </p:clrMapOvr>
+</p:sld>
+</file>
+
+<file path=ppt/slides/slide6.xml><?xml version="1.0" encoding="utf-8"?>
 <p:sld xmlns:a="http://schemas.openxmlformats.org/drawingml/2006/main" xmlns:r="http://schemas.openxmlformats.org/officeDocument/2006/relationships" xmlns:p="http://schemas.openxmlformats.org/presentationml/2006/main">
   <p:cSld>
     <p:bg>
@@ -5382,7 +5236,7 @@
       </p:grpSpPr>
       <p:sp>
         <p:nvSpPr>
-          <p:cNvPr id="9" name="Freeform: Shape 8">
+          <p:cNvPr id="20" name="Freeform: Shape 9">
             <a:extLst>
               <a:ext uri="{FF2B5EF4-FFF2-40B4-BE49-F238E27FC236}">
                 <a16:creationId xmlns:a16="http://schemas.microsoft.com/office/drawing/2014/main" id="{774A975B-A886-5202-0489-6965514A0D14}"/>
@@ -5490,7 +5344,7 @@
       </p:sp>
       <p:sp>
         <p:nvSpPr>
-          <p:cNvPr id="11" name="Freeform: Shape 10">
+          <p:cNvPr id="21" name="Freeform: Shape 11">
             <a:extLst>
               <a:ext uri="{FF2B5EF4-FFF2-40B4-BE49-F238E27FC236}">
                 <a16:creationId xmlns:a16="http://schemas.microsoft.com/office/drawing/2014/main" id="{EA67E988-5919-57BB-C7DE-D3EAD38A3045}"/>
@@ -5586,12 +5440,12 @@
           </a:p>
         </p:txBody>
       </p:sp>
-      <p:sp useBgFill="1">
-        <p:nvSpPr>
-          <p:cNvPr id="13" name="Rectangle 12">
-            <a:extLst>
-              <a:ext uri="{FF2B5EF4-FFF2-40B4-BE49-F238E27FC236}">
-                <a16:creationId xmlns:a16="http://schemas.microsoft.com/office/drawing/2014/main" id="{E20BB609-EF92-42DB-836C-0699A590B5CF}"/>
+      <p:sp>
+        <p:nvSpPr>
+          <p:cNvPr id="22" name="Rectangle 21">
+            <a:extLst>
+              <a:ext uri="{FF2B5EF4-FFF2-40B4-BE49-F238E27FC236}">
+                <a16:creationId xmlns:a16="http://schemas.microsoft.com/office/drawing/2014/main" id="{0EECA69B-4C2A-7F31-8019-E90DB3BD49CB}"/>
               </a:ext>
               <a:ext uri="{C183D7F6-B498-43B3-948B-1728B52AA6E4}">
                 <adec:decorative xmlns:adec="http://schemas.microsoft.com/office/drawing/2017/decorative" val="1"/>
@@ -5612,19 +5466,38 @@
         <p:spPr>
           <a:xfrm>
             <a:off x="0" y="0"/>
-            <a:ext cx="12192000" cy="6858001"/>
+            <a:ext cx="12192000" cy="6858000"/>
           </a:xfrm>
           <a:prstGeom prst="rect">
             <a:avLst/>
           </a:prstGeom>
-          <a:ln>
+          <a:solidFill>
+            <a:schemeClr val="bg1"/>
+          </a:solidFill>
+          <a:ln w="12700" cap="flat" cmpd="sng" algn="ctr">
             <a:noFill/>
+            <a:prstDash val="solid"/>
+            <a:miter lim="800000"/>
           </a:ln>
+          <a:effectLst/>
+          <a:extLst>
+            <a:ext uri="{91240B29-F687-4F45-9708-019B960494DF}">
+              <a14:hiddenLine xmlns:a14="http://schemas.microsoft.com/office/drawing/2010/main" w="12700" cap="flat" cmpd="sng" algn="ctr">
+                <a:solidFill>
+                  <a:schemeClr val="accent1">
+                    <a:shade val="15000"/>
+                  </a:schemeClr>
+                </a:solidFill>
+                <a:prstDash val="solid"/>
+                <a:miter lim="800000"/>
+              </a14:hiddenLine>
+            </a:ext>
+          </a:extLst>
         </p:spPr>
         <p:style>
           <a:lnRef idx="2">
             <a:schemeClr val="accent1">
-              <a:shade val="50000"/>
+              <a:shade val="15000"/>
             </a:schemeClr>
           </a:lnRef>
           <a:fillRef idx="1">
@@ -5641,28 +5514,65 @@
           <a:bodyPr rtlCol="0" anchor="ctr"/>
           <a:lstStyle/>
           <a:p>
-            <a:pPr algn="ctr"/>
-            <a:endParaRPr lang="en-US" dirty="0"/>
+            <a:pPr marL="0" marR="0" lvl="0" indent="0" algn="ctr" defTabSz="914400" rtl="0" eaLnBrk="1" fontAlgn="auto" latinLnBrk="0" hangingPunct="1">
+              <a:lnSpc>
+                <a:spcPct val="100000"/>
+              </a:lnSpc>
+              <a:spcBef>
+                <a:spcPts val="0"/>
+              </a:spcBef>
+              <a:spcAft>
+                <a:spcPts val="0"/>
+              </a:spcAft>
+              <a:buClrTx/>
+              <a:buSzTx/>
+              <a:buFontTx/>
+              <a:buNone/>
+              <a:tabLst/>
+              <a:defRPr/>
+            </a:pPr>
+            <a:endParaRPr kumimoji="0" lang="en-US" sz="1800" b="0" i="0" u="none" strike="noStrike" kern="1200" cap="none" spc="0" normalizeH="0" baseline="0" noProof="0">
+              <a:ln>
+                <a:noFill/>
+              </a:ln>
+              <a:solidFill>
+                <a:prstClr val="white"/>
+              </a:solidFill>
+              <a:effectLst/>
+              <a:uLnTx/>
+              <a:uFillTx/>
+              <a:latin typeface="Bierstadt"/>
+              <a:ea typeface="+mn-ea"/>
+              <a:cs typeface="+mn-cs"/>
+            </a:endParaRPr>
           </a:p>
         </p:txBody>
       </p:sp>
       <p:pic>
         <p:nvPicPr>
-          <p:cNvPr id="5" name="Picture 4">
-            <a:extLst>
-              <a:ext uri="{FF2B5EF4-FFF2-40B4-BE49-F238E27FC236}">
-                <a16:creationId xmlns:a16="http://schemas.microsoft.com/office/drawing/2014/main" id="{827C1362-236A-6BAD-A329-94810AF9A7F0}"/>
+          <p:cNvPr id="5" name="Espace réservé du contenu 4">
+            <a:extLst>
+              <a:ext uri="{FF2B5EF4-FFF2-40B4-BE49-F238E27FC236}">
+                <a16:creationId xmlns:a16="http://schemas.microsoft.com/office/drawing/2014/main" id="{97DEAC92-ADF9-6A1D-98C0-0E77062EEC45}"/>
               </a:ext>
             </a:extLst>
           </p:cNvPr>
           <p:cNvPicPr>
-            <a:picLocks noChangeAspect="1"/>
+            <a:picLocks noGrp="1" noChangeAspect="1"/>
           </p:cNvPicPr>
-          <p:nvPr/>
+          <p:nvPr>
+            <p:ph idx="1"/>
+          </p:nvPr>
         </p:nvPicPr>
         <p:blipFill>
-          <a:blip r:embed="rId2"/>
-          <a:srcRect l="25"/>
+          <a:blip r:embed="rId2">
+            <a:extLst>
+              <a:ext uri="{28A0092B-C50C-407E-A947-70E740481C1C}">
+                <a14:useLocalDpi xmlns:a14="http://schemas.microsoft.com/office/drawing/2010/main" val="0"/>
+              </a:ext>
+            </a:extLst>
+          </a:blip>
+          <a:srcRect l="4484" t="1615" b="18194"/>
           <a:stretch>
             <a:fillRect/>
           </a:stretch>
@@ -5670,7 +5580,7 @@
         <p:spPr>
           <a:xfrm>
             <a:off x="20" y="10"/>
-            <a:ext cx="12188932" cy="6857990"/>
+            <a:ext cx="12191980" cy="6857990"/>
           </a:xfrm>
           <a:prstGeom prst="rect">
             <a:avLst/>
@@ -5679,10 +5589,10 @@
       </p:pic>
       <p:sp>
         <p:nvSpPr>
-          <p:cNvPr id="15" name="Rectangle 14">
-            <a:extLst>
-              <a:ext uri="{FF2B5EF4-FFF2-40B4-BE49-F238E27FC236}">
-                <a16:creationId xmlns:a16="http://schemas.microsoft.com/office/drawing/2014/main" id="{637992A9-1E8C-4E57-B4F4-EE2D38E504A2}"/>
+          <p:cNvPr id="23" name="Rectangle 22">
+            <a:extLst>
+              <a:ext uri="{FF2B5EF4-FFF2-40B4-BE49-F238E27FC236}">
+                <a16:creationId xmlns:a16="http://schemas.microsoft.com/office/drawing/2014/main" id="{857DEAC1-B3AA-6569-0A44-A191DF2F3C67}"/>
               </a:ext>
               <a:ext uri="{C183D7F6-B498-43B3-948B-1728B52AA6E4}">
                 <adec:decorative xmlns:adec="http://schemas.microsoft.com/office/drawing/2017/decorative" val="1"/>
@@ -5701,177 +5611,17 @@
           </p:nvPr>
         </p:nvSpPr>
         <p:spPr>
-          <a:xfrm rot="16200000">
-            <a:off x="389239" y="-389238"/>
-            <a:ext cx="6858000" cy="7636476"/>
-          </a:xfrm>
-          <a:prstGeom prst="rect">
-            <a:avLst/>
-          </a:prstGeom>
-          <a:gradFill>
-            <a:gsLst>
-              <a:gs pos="100000">
-                <a:srgbClr val="000000">
-                  <a:alpha val="0"/>
-                </a:srgbClr>
-              </a:gs>
-              <a:gs pos="0">
-                <a:schemeClr val="tx1"/>
-              </a:gs>
-              <a:gs pos="0">
-                <a:srgbClr val="000000">
-                  <a:alpha val="70000"/>
-                </a:srgbClr>
-              </a:gs>
-            </a:gsLst>
-            <a:lin ang="5400000" scaled="1"/>
-          </a:gradFill>
-          <a:ln>
-            <a:noFill/>
-          </a:ln>
-        </p:spPr>
-        <p:style>
-          <a:lnRef idx="2">
-            <a:schemeClr val="accent1">
-              <a:shade val="50000"/>
-            </a:schemeClr>
-          </a:lnRef>
-          <a:fillRef idx="1">
-            <a:schemeClr val="accent1"/>
-          </a:fillRef>
-          <a:effectRef idx="0">
-            <a:schemeClr val="accent1"/>
-          </a:effectRef>
-          <a:fontRef idx="minor">
-            <a:schemeClr val="lt1"/>
-          </a:fontRef>
-        </p:style>
-        <p:txBody>
-          <a:bodyPr rtlCol="0" anchor="ctr"/>
-          <a:lstStyle/>
-          <a:p>
-            <a:pPr algn="ctr"/>
-            <a:endParaRPr lang="en-US"/>
-          </a:p>
-        </p:txBody>
-      </p:sp>
-      <p:sp>
-        <p:nvSpPr>
-          <p:cNvPr id="2" name="Titre 1">
-            <a:extLst>
-              <a:ext uri="{FF2B5EF4-FFF2-40B4-BE49-F238E27FC236}">
-                <a16:creationId xmlns:a16="http://schemas.microsoft.com/office/drawing/2014/main" id="{E34E0744-9D9A-00B0-9E8E-D0320984E3F4}"/>
-              </a:ext>
-            </a:extLst>
-          </p:cNvPr>
-          <p:cNvSpPr>
-            <a:spLocks noGrp="1"/>
-          </p:cNvSpPr>
-          <p:nvPr>
-            <p:ph type="title"/>
-          </p:nvPr>
-        </p:nvSpPr>
-        <p:spPr>
           <a:xfrm>
-            <a:off x="517870" y="978407"/>
-            <a:ext cx="5021182" cy="3309511"/>
-          </a:xfrm>
-        </p:spPr>
-        <p:txBody>
-          <a:bodyPr vert="horz" lIns="91440" tIns="45720" rIns="91440" bIns="45720" rtlCol="0" anchor="t">
-            <a:normAutofit/>
-          </a:bodyPr>
-          <a:lstStyle/>
-          <a:p>
-            <a:r>
-              <a:rPr lang="en-US" sz="6000">
-                <a:solidFill>
-                  <a:srgbClr val="FFFFFF"/>
-                </a:solidFill>
-              </a:rPr>
-              <a:t>AstroLab</a:t>
-            </a:r>
-          </a:p>
-        </p:txBody>
-      </p:sp>
-      <p:sp>
-        <p:nvSpPr>
-          <p:cNvPr id="3" name="Espace réservé du contenu 2">
-            <a:extLst>
-              <a:ext uri="{FF2B5EF4-FFF2-40B4-BE49-F238E27FC236}">
-                <a16:creationId xmlns:a16="http://schemas.microsoft.com/office/drawing/2014/main" id="{0C44115A-CC4B-00F3-04DA-D24F28C4E5EA}"/>
-              </a:ext>
-            </a:extLst>
-          </p:cNvPr>
-          <p:cNvSpPr>
-            <a:spLocks noGrp="1"/>
-          </p:cNvSpPr>
-          <p:nvPr>
-            <p:ph idx="1"/>
-          </p:nvPr>
-        </p:nvSpPr>
-        <p:spPr>
-          <a:xfrm>
-            <a:off x="517870" y="4482450"/>
-            <a:ext cx="5040785" cy="1724029"/>
-          </a:xfrm>
-        </p:spPr>
-        <p:txBody>
-          <a:bodyPr vert="horz" lIns="91440" tIns="45720" rIns="91440" bIns="45720" rtlCol="0" anchor="t">
-            <a:normAutofit/>
-          </a:bodyPr>
-          <a:lstStyle/>
-          <a:p>
-            <a:pPr marL="0" indent="0">
-              <a:buNone/>
-            </a:pPr>
-            <a:r>
-              <a:rPr lang="en-US" sz="2200" i="1" kern="1200">
-                <a:solidFill>
-                  <a:srgbClr val="FFFFFF"/>
-                </a:solidFill>
-                <a:latin typeface="+mn-lt"/>
-                <a:ea typeface="+mn-ea"/>
-                <a:cs typeface="+mn-cs"/>
-              </a:rPr>
-              <a:t>Projet en python</a:t>
-            </a:r>
-          </a:p>
-        </p:txBody>
-      </p:sp>
-      <p:sp>
-        <p:nvSpPr>
-          <p:cNvPr id="17" name="Rectangle 16">
-            <a:extLst>
-              <a:ext uri="{FF2B5EF4-FFF2-40B4-BE49-F238E27FC236}">
-                <a16:creationId xmlns:a16="http://schemas.microsoft.com/office/drawing/2014/main" id="{B2C335F7-F61C-4EB4-80F2-4B1438FE66BB}"/>
-              </a:ext>
-              <a:ext uri="{C183D7F6-B498-43B3-948B-1728B52AA6E4}">
-                <adec:decorative xmlns:adec="http://schemas.microsoft.com/office/drawing/2017/decorative" val="1"/>
-              </a:ext>
-            </a:extLst>
-          </p:cNvPr>
-          <p:cNvSpPr>
-            <a:spLocks noGrp="1" noRot="1" noChangeAspect="1" noMove="1" noResize="1" noEditPoints="1" noAdjustHandles="1" noChangeArrowheads="1" noChangeShapeType="1" noTextEdit="1"/>
-          </p:cNvSpPr>
-          <p:nvPr>
-            <p:extLst>
-              <p:ext uri="{386F3935-93C4-4BCD-93E2-E3B085C9AB24}">
-                <p16:designElem xmlns:p16="http://schemas.microsoft.com/office/powerpoint/2015/main" val="1"/>
-              </p:ext>
-            </p:extLst>
-          </p:nvPr>
-        </p:nvSpPr>
-        <p:spPr>
-          <a:xfrm>
-            <a:off x="517870" y="508090"/>
-            <a:ext cx="5021183" cy="149279"/>
+            <a:off x="0" y="5577840"/>
+            <a:ext cx="12191999" cy="1280160"/>
           </a:xfrm>
           <a:prstGeom prst="rect">
             <a:avLst/>
           </a:prstGeom>
           <a:solidFill>
-            <a:srgbClr val="FFFFFF"/>
+            <a:schemeClr val="bg1">
+              <a:alpha val="28000"/>
+            </a:schemeClr>
           </a:solidFill>
           <a:ln>
             <a:noFill/>
@@ -5897,20 +5647,435 @@
           <a:bodyPr rtlCol="0" anchor="ctr"/>
           <a:lstStyle/>
           <a:p>
-            <a:pPr algn="ctr"/>
-            <a:endParaRPr lang="en-US"/>
+            <a:pPr marL="0" marR="0" lvl="0" indent="0" algn="ctr" defTabSz="914400" rtl="0" eaLnBrk="1" fontAlgn="auto" latinLnBrk="0" hangingPunct="1">
+              <a:lnSpc>
+                <a:spcPct val="100000"/>
+              </a:lnSpc>
+              <a:spcBef>
+                <a:spcPts val="0"/>
+              </a:spcBef>
+              <a:spcAft>
+                <a:spcPts val="0"/>
+              </a:spcAft>
+              <a:buClrTx/>
+              <a:buSzTx/>
+              <a:buFontTx/>
+              <a:buNone/>
+              <a:tabLst/>
+              <a:defRPr/>
+            </a:pPr>
+            <a:endParaRPr kumimoji="0" lang="en-US" sz="1800" b="0" i="0" u="none" strike="noStrike" kern="1200" cap="none" spc="0" normalizeH="0" baseline="0" noProof="0">
+              <a:ln>
+                <a:noFill/>
+              </a:ln>
+              <a:solidFill>
+                <a:prstClr val="white"/>
+              </a:solidFill>
+              <a:effectLst/>
+              <a:uLnTx/>
+              <a:uFillTx/>
+              <a:latin typeface="Bierstadt"/>
+              <a:ea typeface="+mn-ea"/>
+              <a:cs typeface="+mn-cs"/>
+            </a:endParaRPr>
+          </a:p>
+        </p:txBody>
+      </p:sp>
+      <p:sp>
+        <p:nvSpPr>
+          <p:cNvPr id="2" name="Titre 1">
+            <a:extLst>
+              <a:ext uri="{FF2B5EF4-FFF2-40B4-BE49-F238E27FC236}">
+                <a16:creationId xmlns:a16="http://schemas.microsoft.com/office/drawing/2014/main" id="{5533CF7B-BA68-278B-A783-54828C4176F2}"/>
+              </a:ext>
+            </a:extLst>
+          </p:cNvPr>
+          <p:cNvSpPr>
+            <a:spLocks noGrp="1"/>
+          </p:cNvSpPr>
+          <p:nvPr>
+            <p:ph type="title"/>
+          </p:nvPr>
+        </p:nvSpPr>
+        <p:spPr>
+          <a:xfrm>
+            <a:off x="320039" y="5731580"/>
+            <a:ext cx="11686033" cy="980116"/>
+          </a:xfrm>
+          <a:ln>
+            <a:noFill/>
+          </a:ln>
+        </p:spPr>
+        <p:txBody>
+          <a:bodyPr vert="horz" lIns="91440" tIns="45720" rIns="91440" bIns="45720" rtlCol="0" anchor="ctr">
+            <a:normAutofit/>
+          </a:bodyPr>
+          <a:lstStyle/>
+          <a:p>
+            <a:r>
+              <a:rPr lang="fr-CH" dirty="0"/>
+              <a:t>Projet DemoMot 2025-2026</a:t>
+            </a:r>
           </a:p>
         </p:txBody>
       </p:sp>
     </p:spTree>
     <p:extLst>
       <p:ext uri="{BB962C8B-B14F-4D97-AF65-F5344CB8AC3E}">
-        <p14:creationId xmlns:p14="http://schemas.microsoft.com/office/powerpoint/2010/main" val="832870440"/>
+        <p14:creationId xmlns:p14="http://schemas.microsoft.com/office/powerpoint/2010/main" val="1444886072"/>
       </p:ext>
     </p:extLst>
   </p:cSld>
   <p:clrMapOvr>
     <a:overrideClrMapping bg1="dk1" tx1="lt1" bg2="dk2" tx2="lt2" accent1="accent1" accent2="accent2" accent3="accent3" accent4="accent4" accent5="accent5" accent6="accent6" hlink="hlink" folHlink="folHlink"/>
+  </p:clrMapOvr>
+</p:sld>
+</file>
+
+<file path=ppt/slides/slide7.xml><?xml version="1.0" encoding="utf-8"?>
+<p:sld xmlns:a="http://schemas.openxmlformats.org/drawingml/2006/main" xmlns:r="http://schemas.openxmlformats.org/officeDocument/2006/relationships" xmlns:p="http://schemas.openxmlformats.org/presentationml/2006/main">
+  <p:cSld>
+    <p:spTree>
+      <p:nvGrpSpPr>
+        <p:cNvPr id="1" name=""/>
+        <p:cNvGrpSpPr/>
+        <p:nvPr/>
+      </p:nvGrpSpPr>
+      <p:grpSpPr>
+        <a:xfrm>
+          <a:off x="0" y="0"/>
+          <a:ext cx="0" cy="0"/>
+          <a:chOff x="0" y="0"/>
+          <a:chExt cx="0" cy="0"/>
+        </a:xfrm>
+      </p:grpSpPr>
+      <p:sp>
+        <p:nvSpPr>
+          <p:cNvPr id="2" name="Titre 1">
+            <a:extLst>
+              <a:ext uri="{FF2B5EF4-FFF2-40B4-BE49-F238E27FC236}">
+                <a16:creationId xmlns:a16="http://schemas.microsoft.com/office/drawing/2014/main" id="{523419E0-15C6-46E7-70B2-34653D777685}"/>
+              </a:ext>
+            </a:extLst>
+          </p:cNvPr>
+          <p:cNvSpPr>
+            <a:spLocks noGrp="1"/>
+          </p:cNvSpPr>
+          <p:nvPr>
+            <p:ph type="title"/>
+          </p:nvPr>
+        </p:nvSpPr>
+        <p:spPr/>
+        <p:txBody>
+          <a:bodyPr/>
+          <a:lstStyle/>
+          <a:p>
+            <a:r>
+              <a:rPr lang="fr-CH" dirty="0"/>
+              <a:t>Pourquoi ce projet ?</a:t>
+            </a:r>
+          </a:p>
+        </p:txBody>
+      </p:sp>
+      <p:sp>
+        <p:nvSpPr>
+          <p:cNvPr id="3" name="Espace réservé du contenu 2">
+            <a:extLst>
+              <a:ext uri="{FF2B5EF4-FFF2-40B4-BE49-F238E27FC236}">
+                <a16:creationId xmlns:a16="http://schemas.microsoft.com/office/drawing/2014/main" id="{14088F4B-426E-9596-B618-28846F9E3873}"/>
+              </a:ext>
+            </a:extLst>
+          </p:cNvPr>
+          <p:cNvSpPr>
+            <a:spLocks noGrp="1"/>
+          </p:cNvSpPr>
+          <p:nvPr>
+            <p:ph idx="1"/>
+          </p:nvPr>
+        </p:nvSpPr>
+        <p:spPr/>
+        <p:txBody>
+          <a:bodyPr/>
+          <a:lstStyle/>
+          <a:p>
+            <a:r>
+              <a:rPr lang="fr-CH" b="1" dirty="0"/>
+              <a:t>Éduquer par l'Espace</a:t>
+            </a:r>
+          </a:p>
+          <a:p>
+            <a:pPr lvl="1"/>
+            <a:r>
+              <a:rPr lang="fr-CH" dirty="0"/>
+              <a:t>AgaMoon est un site web éducatif dédié à la Lune. </a:t>
+            </a:r>
+          </a:p>
+          <a:p>
+            <a:pPr lvl="1"/>
+            <a:r>
+              <a:rPr lang="fr-CH" dirty="0"/>
+              <a:t>Le projet explore quatre piliers : les données physiques, les phases lunaires, l'histoire de l'exploration et une galerie de photos authentiques.</a:t>
+            </a:r>
+          </a:p>
+          <a:p>
+            <a:r>
+              <a:rPr lang="fr-CH" b="1" dirty="0"/>
+              <a:t>Langages &amp; Standards</a:t>
+            </a:r>
+          </a:p>
+          <a:p>
+            <a:r>
+              <a:rPr lang="fr-CH" dirty="0"/>
+              <a:t>Développement pur en </a:t>
+            </a:r>
+            <a:r>
+              <a:rPr lang="fr-CH" b="1" dirty="0"/>
+              <a:t>HTML5</a:t>
+            </a:r>
+            <a:r>
+              <a:rPr lang="fr-CH" dirty="0"/>
+              <a:t> et </a:t>
+            </a:r>
+            <a:r>
+              <a:rPr lang="fr-CH" b="1" dirty="0"/>
+              <a:t>CSS3</a:t>
+            </a:r>
+            <a:r>
+              <a:rPr lang="fr-CH" dirty="0"/>
+              <a:t> pour garantir une structure sémantique et un design moderne et responsive.</a:t>
+            </a:r>
+          </a:p>
+          <a:p>
+            <a:r>
+              <a:rPr lang="fr-CH" b="1" dirty="0"/>
+              <a:t>Environnement</a:t>
+            </a:r>
+          </a:p>
+          <a:p>
+            <a:r>
+              <a:rPr lang="fr-CH" dirty="0"/>
+              <a:t>Utilisation de </a:t>
+            </a:r>
+            <a:r>
+              <a:rPr lang="fr-CH" b="1" dirty="0"/>
+              <a:t>Visual Studio Code</a:t>
+            </a:r>
+            <a:r>
+              <a:rPr lang="fr-CH" dirty="0"/>
+              <a:t> comme IDE principal, optimisé pour un workflow fluide entre le code et le rendu navigateur.</a:t>
+            </a:r>
+          </a:p>
+        </p:txBody>
+      </p:sp>
+    </p:spTree>
+    <p:extLst>
+      <p:ext uri="{BB962C8B-B14F-4D97-AF65-F5344CB8AC3E}">
+        <p14:creationId xmlns:p14="http://schemas.microsoft.com/office/powerpoint/2010/main" val="3353841106"/>
+      </p:ext>
+    </p:extLst>
+  </p:cSld>
+  <p:clrMapOvr>
+    <a:masterClrMapping/>
+  </p:clrMapOvr>
+</p:sld>
+</file>
+
+<file path=ppt/slides/slide8.xml><?xml version="1.0" encoding="utf-8"?>
+<p:sld xmlns:a="http://schemas.openxmlformats.org/drawingml/2006/main" xmlns:r="http://schemas.openxmlformats.org/officeDocument/2006/relationships" xmlns:p="http://schemas.openxmlformats.org/presentationml/2006/main">
+  <p:cSld>
+    <p:spTree>
+      <p:nvGrpSpPr>
+        <p:cNvPr id="1" name=""/>
+        <p:cNvGrpSpPr/>
+        <p:nvPr/>
+      </p:nvGrpSpPr>
+      <p:grpSpPr>
+        <a:xfrm>
+          <a:off x="0" y="0"/>
+          <a:ext cx="0" cy="0"/>
+          <a:chOff x="0" y="0"/>
+          <a:chExt cx="0" cy="0"/>
+        </a:xfrm>
+      </p:grpSpPr>
+      <p:sp>
+        <p:nvSpPr>
+          <p:cNvPr id="2" name="Titre 1">
+            <a:extLst>
+              <a:ext uri="{FF2B5EF4-FFF2-40B4-BE49-F238E27FC236}">
+                <a16:creationId xmlns:a16="http://schemas.microsoft.com/office/drawing/2014/main" id="{39CDB58D-7818-6269-97FE-DB12D816E353}"/>
+              </a:ext>
+            </a:extLst>
+          </p:cNvPr>
+          <p:cNvSpPr>
+            <a:spLocks noGrp="1"/>
+          </p:cNvSpPr>
+          <p:nvPr>
+            <p:ph type="title"/>
+          </p:nvPr>
+        </p:nvSpPr>
+        <p:spPr/>
+        <p:txBody>
+          <a:bodyPr/>
+          <a:lstStyle/>
+          <a:p>
+            <a:r>
+              <a:rPr lang="fr-CH" dirty="0"/>
+              <a:t>Cahier des charges</a:t>
+            </a:r>
+          </a:p>
+        </p:txBody>
+      </p:sp>
+      <p:sp>
+        <p:nvSpPr>
+          <p:cNvPr id="3" name="Espace réservé du contenu 2">
+            <a:extLst>
+              <a:ext uri="{FF2B5EF4-FFF2-40B4-BE49-F238E27FC236}">
+                <a16:creationId xmlns:a16="http://schemas.microsoft.com/office/drawing/2014/main" id="{1173D744-E38A-8D6D-6C85-1B94E33E8328}"/>
+              </a:ext>
+            </a:extLst>
+          </p:cNvPr>
+          <p:cNvSpPr>
+            <a:spLocks noGrp="1"/>
+          </p:cNvSpPr>
+          <p:nvPr>
+            <p:ph idx="1"/>
+          </p:nvPr>
+        </p:nvSpPr>
+        <p:spPr/>
+        <p:txBody>
+          <a:bodyPr/>
+          <a:lstStyle/>
+          <a:p>
+            <a:r>
+              <a:rPr lang="fr-CH" b="1" dirty="0"/>
+              <a:t>Données Scientifiques :</a:t>
+            </a:r>
+            <a:r>
+              <a:rPr lang="fr-CH" dirty="0"/>
+              <a:t> Affichage d'informations générales précises sur la Lune.</a:t>
+            </a:r>
+          </a:p>
+          <a:p>
+            <a:r>
+              <a:rPr lang="fr-CH" b="1" dirty="0"/>
+              <a:t>Cycle Lunaire :</a:t>
+            </a:r>
+            <a:r>
+              <a:rPr lang="fr-CH" dirty="0"/>
+              <a:t> Présentation des huit phases avec illustrations dédiées.</a:t>
+            </a:r>
+          </a:p>
+          <a:p>
+            <a:r>
+              <a:rPr lang="fr-CH" b="1" dirty="0"/>
+              <a:t>Galerie Visuelle :</a:t>
+            </a:r>
+            <a:r>
+              <a:rPr lang="fr-CH" dirty="0"/>
+              <a:t> Mise à disposition d'une banque d'images astronomiques.</a:t>
+            </a:r>
+          </a:p>
+          <a:p>
+            <a:r>
+              <a:rPr lang="fr-CH" b="1" dirty="0"/>
+              <a:t>UX Intuitive :</a:t>
+            </a:r>
+            <a:r>
+              <a:rPr lang="fr-CH" dirty="0"/>
+              <a:t> Navigation simple et fluide sur une seule page (Single Page).</a:t>
+            </a:r>
+          </a:p>
+          <a:p>
+            <a:r>
+              <a:rPr lang="fr-CH" b="1" dirty="0"/>
+              <a:t>Adaptabilité :</a:t>
+            </a:r>
+            <a:r>
+              <a:rPr lang="fr-CH" dirty="0"/>
+              <a:t> Design 100% responsive pour tous types d'écrans.</a:t>
+            </a:r>
+          </a:p>
+          <a:p>
+            <a:endParaRPr lang="fr-CH" dirty="0"/>
+          </a:p>
+        </p:txBody>
+      </p:sp>
+    </p:spTree>
+    <p:extLst>
+      <p:ext uri="{BB962C8B-B14F-4D97-AF65-F5344CB8AC3E}">
+        <p14:creationId xmlns:p14="http://schemas.microsoft.com/office/powerpoint/2010/main" val="102074461"/>
+      </p:ext>
+    </p:extLst>
+  </p:cSld>
+  <p:clrMapOvr>
+    <a:masterClrMapping/>
+  </p:clrMapOvr>
+</p:sld>
+</file>
+
+<file path=ppt/slides/slide9.xml><?xml version="1.0" encoding="utf-8"?>
+<p:sld xmlns:a="http://schemas.openxmlformats.org/drawingml/2006/main" xmlns:r="http://schemas.openxmlformats.org/officeDocument/2006/relationships" xmlns:p="http://schemas.openxmlformats.org/presentationml/2006/main">
+  <p:cSld>
+    <p:spTree>
+      <p:nvGrpSpPr>
+        <p:cNvPr id="1" name=""/>
+        <p:cNvGrpSpPr/>
+        <p:nvPr/>
+      </p:nvGrpSpPr>
+      <p:grpSpPr>
+        <a:xfrm>
+          <a:off x="0" y="0"/>
+          <a:ext cx="0" cy="0"/>
+          <a:chOff x="0" y="0"/>
+          <a:chExt cx="0" cy="0"/>
+        </a:xfrm>
+      </p:grpSpPr>
+      <p:sp>
+        <p:nvSpPr>
+          <p:cNvPr id="2" name="Titre 1">
+            <a:extLst>
+              <a:ext uri="{FF2B5EF4-FFF2-40B4-BE49-F238E27FC236}">
+                <a16:creationId xmlns:a16="http://schemas.microsoft.com/office/drawing/2014/main" id="{D0AE247B-784E-CA2F-2D02-4273E444927D}"/>
+              </a:ext>
+            </a:extLst>
+          </p:cNvPr>
+          <p:cNvSpPr>
+            <a:spLocks noGrp="1"/>
+          </p:cNvSpPr>
+          <p:nvPr>
+            <p:ph type="title"/>
+          </p:nvPr>
+        </p:nvSpPr>
+        <p:spPr/>
+        <p:txBody>
+          <a:bodyPr>
+            <a:normAutofit fontScale="90000"/>
+          </a:bodyPr>
+          <a:lstStyle/>
+          <a:p>
+            <a:r>
+              <a:rPr lang="fr-CH" b="0" dirty="0"/>
+              <a:t>Extrait du Journal de Travail</a:t>
+            </a:r>
+            <a:br>
+              <a:rPr lang="fr-CH" b="0" dirty="0"/>
+            </a:br>
+            <a:br>
+              <a:rPr lang="fr-CH" dirty="0"/>
+            </a:br>
+            <a:endParaRPr lang="fr-CH" dirty="0"/>
+          </a:p>
+        </p:txBody>
+      </p:sp>
+    </p:spTree>
+    <p:extLst>
+      <p:ext uri="{BB962C8B-B14F-4D97-AF65-F5344CB8AC3E}">
+        <p14:creationId xmlns:p14="http://schemas.microsoft.com/office/powerpoint/2010/main" val="684144989"/>
+      </p:ext>
+    </p:extLst>
+  </p:cSld>
+  <p:clrMapOvr>
+    <a:masterClrMapping/>
   </p:clrMapOvr>
 </p:sld>
 </file>

</xml_diff>

<commit_message>
update : changer structure .json
</commit_message>
<xml_diff>
--- a/annexe/Presentation.pptx
+++ b/annexe/Presentation.pptx
@@ -4813,11 +4813,7 @@
           <a:p>
             <a:r>
               <a:rPr lang="fr-CH" dirty="0"/>
-              <a:t>Faire un projet avec </a:t>
-            </a:r>
-            <a:r>
-              <a:rPr lang="fr-CH"/>
-              <a:t>des calculs</a:t>
+              <a:t>Faire un projet avec des calculs</a:t>
             </a:r>
           </a:p>
         </p:txBody>

</xml_diff>

<commit_message>
update : ameliorer pptx
</commit_message>
<xml_diff>
--- a/annexe/Presentation.pptx
+++ b/annexe/Presentation.pptx
@@ -122,6 +122,2431 @@
 </p:presentation>
 </file>
 
+<file path=ppt/diagrams/colors1.xml><?xml version="1.0" encoding="utf-8"?>
+<dgm:colorsDef xmlns:dgm="http://schemas.openxmlformats.org/drawingml/2006/diagram" xmlns:a="http://schemas.openxmlformats.org/drawingml/2006/main" uniqueId="urn:microsoft.com/office/officeart/2018/5/colors/Iconchunking_neutralbg_accent1_2">
+  <dgm:title val=""/>
+  <dgm:desc val=""/>
+  <dgm:catLst>
+    <dgm:cat type="accent1" pri="11200"/>
+  </dgm:catLst>
+  <dgm:styleLbl name="node0">
+    <dgm:fillClrLst meth="repeat">
+      <a:schemeClr val="accent1"/>
+    </dgm:fillClrLst>
+    <dgm:linClrLst meth="repeat">
+      <a:schemeClr val="lt1"/>
+    </dgm:linClrLst>
+    <dgm:effectClrLst/>
+    <dgm:txLinClrLst/>
+    <dgm:txFillClrLst/>
+    <dgm:txEffectClrLst/>
+  </dgm:styleLbl>
+  <dgm:styleLbl name="alignNode1">
+    <dgm:fillClrLst meth="repeat">
+      <a:schemeClr val="accent1"/>
+    </dgm:fillClrLst>
+    <dgm:linClrLst meth="repeat">
+      <a:schemeClr val="accent1"/>
+    </dgm:linClrLst>
+    <dgm:effectClrLst/>
+    <dgm:txLinClrLst/>
+    <dgm:txFillClrLst/>
+    <dgm:txEffectClrLst/>
+  </dgm:styleLbl>
+  <dgm:styleLbl name="node1">
+    <dgm:fillClrLst meth="repeat">
+      <a:schemeClr val="accent1"/>
+    </dgm:fillClrLst>
+    <dgm:linClrLst meth="repeat">
+      <a:schemeClr val="lt1">
+        <a:alpha val="0"/>
+      </a:schemeClr>
+    </dgm:linClrLst>
+    <dgm:effectClrLst/>
+    <dgm:txLinClrLst/>
+    <dgm:txFillClrLst/>
+    <dgm:txEffectClrLst/>
+  </dgm:styleLbl>
+  <dgm:styleLbl name="lnNode1">
+    <dgm:fillClrLst meth="repeat">
+      <a:schemeClr val="accent1"/>
+    </dgm:fillClrLst>
+    <dgm:linClrLst meth="repeat">
+      <a:schemeClr val="lt1"/>
+    </dgm:linClrLst>
+    <dgm:effectClrLst/>
+    <dgm:txLinClrLst/>
+    <dgm:txFillClrLst/>
+    <dgm:txEffectClrLst/>
+  </dgm:styleLbl>
+  <dgm:styleLbl name="vennNode1">
+    <dgm:fillClrLst meth="repeat">
+      <a:schemeClr val="accent1">
+        <a:alpha val="50000"/>
+      </a:schemeClr>
+    </dgm:fillClrLst>
+    <dgm:linClrLst meth="repeat">
+      <a:schemeClr val="lt1"/>
+    </dgm:linClrLst>
+    <dgm:effectClrLst/>
+    <dgm:txLinClrLst/>
+    <dgm:txFillClrLst/>
+    <dgm:txEffectClrLst/>
+  </dgm:styleLbl>
+  <dgm:styleLbl name="node2">
+    <dgm:fillClrLst meth="repeat">
+      <a:schemeClr val="accent1"/>
+    </dgm:fillClrLst>
+    <dgm:linClrLst meth="repeat">
+      <a:schemeClr val="lt1"/>
+    </dgm:linClrLst>
+    <dgm:effectClrLst/>
+    <dgm:txLinClrLst/>
+    <dgm:txFillClrLst/>
+    <dgm:txEffectClrLst/>
+  </dgm:styleLbl>
+  <dgm:styleLbl name="node3">
+    <dgm:fillClrLst meth="repeat">
+      <a:schemeClr val="accent1"/>
+    </dgm:fillClrLst>
+    <dgm:linClrLst meth="repeat">
+      <a:schemeClr val="lt1"/>
+    </dgm:linClrLst>
+    <dgm:effectClrLst/>
+    <dgm:txLinClrLst/>
+    <dgm:txFillClrLst/>
+    <dgm:txEffectClrLst/>
+  </dgm:styleLbl>
+  <dgm:styleLbl name="node4">
+    <dgm:fillClrLst meth="repeat">
+      <a:schemeClr val="accent1"/>
+    </dgm:fillClrLst>
+    <dgm:linClrLst meth="repeat">
+      <a:schemeClr val="lt1"/>
+    </dgm:linClrLst>
+    <dgm:effectClrLst/>
+    <dgm:txLinClrLst/>
+    <dgm:txFillClrLst/>
+    <dgm:txEffectClrLst/>
+  </dgm:styleLbl>
+  <dgm:styleLbl name="fgImgPlace1">
+    <dgm:fillClrLst meth="repeat">
+      <a:schemeClr val="accent1">
+        <a:tint val="50000"/>
+      </a:schemeClr>
+    </dgm:fillClrLst>
+    <dgm:linClrLst meth="repeat">
+      <a:schemeClr val="lt1"/>
+    </dgm:linClrLst>
+    <dgm:effectClrLst/>
+    <dgm:txLinClrLst/>
+    <dgm:txFillClrLst meth="repeat">
+      <a:schemeClr val="lt1"/>
+    </dgm:txFillClrLst>
+    <dgm:txEffectClrLst/>
+  </dgm:styleLbl>
+  <dgm:styleLbl name="alignImgPlace1">
+    <dgm:fillClrLst meth="repeat">
+      <a:schemeClr val="accent1">
+        <a:tint val="50000"/>
+      </a:schemeClr>
+    </dgm:fillClrLst>
+    <dgm:linClrLst meth="repeat">
+      <a:schemeClr val="lt1"/>
+    </dgm:linClrLst>
+    <dgm:effectClrLst/>
+    <dgm:txLinClrLst/>
+    <dgm:txFillClrLst meth="repeat">
+      <a:schemeClr val="lt1"/>
+    </dgm:txFillClrLst>
+    <dgm:txEffectClrLst/>
+  </dgm:styleLbl>
+  <dgm:styleLbl name="bgImgPlace1">
+    <dgm:fillClrLst meth="repeat">
+      <a:schemeClr val="accent1">
+        <a:tint val="50000"/>
+      </a:schemeClr>
+    </dgm:fillClrLst>
+    <dgm:linClrLst meth="repeat">
+      <a:schemeClr val="lt1"/>
+    </dgm:linClrLst>
+    <dgm:effectClrLst/>
+    <dgm:txLinClrLst/>
+    <dgm:txFillClrLst meth="repeat">
+      <a:schemeClr val="lt1"/>
+    </dgm:txFillClrLst>
+    <dgm:txEffectClrLst/>
+  </dgm:styleLbl>
+  <dgm:styleLbl name="sibTrans2D1">
+    <dgm:fillClrLst meth="repeat">
+      <a:schemeClr val="accent1">
+        <a:tint val="60000"/>
+      </a:schemeClr>
+    </dgm:fillClrLst>
+    <dgm:linClrLst meth="repeat">
+      <a:schemeClr val="accent1">
+        <a:tint val="60000"/>
+      </a:schemeClr>
+    </dgm:linClrLst>
+    <dgm:effectClrLst/>
+    <dgm:txLinClrLst/>
+    <dgm:txFillClrLst/>
+    <dgm:txEffectClrLst/>
+  </dgm:styleLbl>
+  <dgm:styleLbl name="fgSibTrans2D1">
+    <dgm:fillClrLst meth="repeat">
+      <a:schemeClr val="accent1">
+        <a:tint val="60000"/>
+      </a:schemeClr>
+    </dgm:fillClrLst>
+    <dgm:linClrLst meth="repeat">
+      <a:schemeClr val="accent1">
+        <a:tint val="60000"/>
+      </a:schemeClr>
+    </dgm:linClrLst>
+    <dgm:effectClrLst/>
+    <dgm:txLinClrLst/>
+    <dgm:txFillClrLst/>
+    <dgm:txEffectClrLst/>
+  </dgm:styleLbl>
+  <dgm:styleLbl name="bgSibTrans2D1">
+    <dgm:fillClrLst meth="repeat">
+      <a:schemeClr val="accent1">
+        <a:tint val="60000"/>
+      </a:schemeClr>
+    </dgm:fillClrLst>
+    <dgm:linClrLst meth="repeat">
+      <a:schemeClr val="accent1">
+        <a:tint val="60000"/>
+      </a:schemeClr>
+    </dgm:linClrLst>
+    <dgm:effectClrLst/>
+    <dgm:txLinClrLst/>
+    <dgm:txFillClrLst/>
+    <dgm:txEffectClrLst/>
+  </dgm:styleLbl>
+  <dgm:styleLbl name="sibTrans1D1">
+    <dgm:fillClrLst meth="repeat">
+      <a:schemeClr val="accent1"/>
+    </dgm:fillClrLst>
+    <dgm:linClrLst meth="repeat">
+      <a:schemeClr val="accent1"/>
+    </dgm:linClrLst>
+    <dgm:effectClrLst/>
+    <dgm:txLinClrLst/>
+    <dgm:txFillClrLst meth="repeat">
+      <a:schemeClr val="tx1"/>
+    </dgm:txFillClrLst>
+    <dgm:txEffectClrLst/>
+  </dgm:styleLbl>
+  <dgm:styleLbl name="callout">
+    <dgm:fillClrLst meth="repeat">
+      <a:schemeClr val="accent1"/>
+    </dgm:fillClrLst>
+    <dgm:linClrLst meth="repeat">
+      <a:schemeClr val="accent1">
+        <a:tint val="50000"/>
+      </a:schemeClr>
+    </dgm:linClrLst>
+    <dgm:effectClrLst/>
+    <dgm:txLinClrLst/>
+    <dgm:txFillClrLst meth="repeat">
+      <a:schemeClr val="tx1"/>
+    </dgm:txFillClrLst>
+    <dgm:txEffectClrLst/>
+  </dgm:styleLbl>
+  <dgm:styleLbl name="asst0">
+    <dgm:fillClrLst meth="repeat">
+      <a:schemeClr val="accent1"/>
+    </dgm:fillClrLst>
+    <dgm:linClrLst meth="repeat">
+      <a:schemeClr val="lt1"/>
+    </dgm:linClrLst>
+    <dgm:effectClrLst/>
+    <dgm:txLinClrLst/>
+    <dgm:txFillClrLst/>
+    <dgm:txEffectClrLst/>
+  </dgm:styleLbl>
+  <dgm:styleLbl name="asst1">
+    <dgm:fillClrLst meth="repeat">
+      <a:schemeClr val="accent1"/>
+    </dgm:fillClrLst>
+    <dgm:linClrLst meth="repeat">
+      <a:schemeClr val="lt1"/>
+    </dgm:linClrLst>
+    <dgm:effectClrLst/>
+    <dgm:txLinClrLst/>
+    <dgm:txFillClrLst/>
+    <dgm:txEffectClrLst/>
+  </dgm:styleLbl>
+  <dgm:styleLbl name="asst2">
+    <dgm:fillClrLst meth="repeat">
+      <a:schemeClr val="accent1"/>
+    </dgm:fillClrLst>
+    <dgm:linClrLst meth="repeat">
+      <a:schemeClr val="lt1"/>
+    </dgm:linClrLst>
+    <dgm:effectClrLst/>
+    <dgm:txLinClrLst/>
+    <dgm:txFillClrLst/>
+    <dgm:txEffectClrLst/>
+  </dgm:styleLbl>
+  <dgm:styleLbl name="asst3">
+    <dgm:fillClrLst meth="repeat">
+      <a:schemeClr val="accent1"/>
+    </dgm:fillClrLst>
+    <dgm:linClrLst meth="repeat">
+      <a:schemeClr val="lt1"/>
+    </dgm:linClrLst>
+    <dgm:effectClrLst/>
+    <dgm:txLinClrLst/>
+    <dgm:txFillClrLst/>
+    <dgm:txEffectClrLst/>
+  </dgm:styleLbl>
+  <dgm:styleLbl name="asst4">
+    <dgm:fillClrLst meth="repeat">
+      <a:schemeClr val="accent1"/>
+    </dgm:fillClrLst>
+    <dgm:linClrLst meth="repeat">
+      <a:schemeClr val="lt1"/>
+    </dgm:linClrLst>
+    <dgm:effectClrLst/>
+    <dgm:txLinClrLst/>
+    <dgm:txFillClrLst/>
+    <dgm:txEffectClrLst/>
+  </dgm:styleLbl>
+  <dgm:styleLbl name="parChTrans2D1">
+    <dgm:fillClrLst meth="repeat">
+      <a:schemeClr val="accent1">
+        <a:tint val="60000"/>
+      </a:schemeClr>
+    </dgm:fillClrLst>
+    <dgm:linClrLst meth="repeat">
+      <a:schemeClr val="accent1">
+        <a:tint val="60000"/>
+      </a:schemeClr>
+    </dgm:linClrLst>
+    <dgm:effectClrLst/>
+    <dgm:txLinClrLst/>
+    <dgm:txFillClrLst meth="repeat">
+      <a:schemeClr val="lt1"/>
+    </dgm:txFillClrLst>
+    <dgm:txEffectClrLst/>
+  </dgm:styleLbl>
+  <dgm:styleLbl name="parChTrans2D2">
+    <dgm:fillClrLst meth="repeat">
+      <a:schemeClr val="accent1"/>
+    </dgm:fillClrLst>
+    <dgm:linClrLst meth="repeat">
+      <a:schemeClr val="accent1"/>
+    </dgm:linClrLst>
+    <dgm:effectClrLst/>
+    <dgm:txLinClrLst/>
+    <dgm:txFillClrLst meth="repeat">
+      <a:schemeClr val="lt1"/>
+    </dgm:txFillClrLst>
+    <dgm:txEffectClrLst/>
+  </dgm:styleLbl>
+  <dgm:styleLbl name="parChTrans2D3">
+    <dgm:fillClrLst meth="repeat">
+      <a:schemeClr val="accent1"/>
+    </dgm:fillClrLst>
+    <dgm:linClrLst meth="repeat">
+      <a:schemeClr val="accent1"/>
+    </dgm:linClrLst>
+    <dgm:effectClrLst/>
+    <dgm:txLinClrLst/>
+    <dgm:txFillClrLst meth="repeat">
+      <a:schemeClr val="lt1"/>
+    </dgm:txFillClrLst>
+    <dgm:txEffectClrLst/>
+  </dgm:styleLbl>
+  <dgm:styleLbl name="parChTrans2D4">
+    <dgm:fillClrLst meth="repeat">
+      <a:schemeClr val="accent1"/>
+    </dgm:fillClrLst>
+    <dgm:linClrLst meth="repeat">
+      <a:schemeClr val="accent1"/>
+    </dgm:linClrLst>
+    <dgm:effectClrLst/>
+    <dgm:txLinClrLst/>
+    <dgm:txFillClrLst meth="repeat">
+      <a:schemeClr val="lt1"/>
+    </dgm:txFillClrLst>
+    <dgm:txEffectClrLst/>
+  </dgm:styleLbl>
+  <dgm:styleLbl name="parChTrans1D1">
+    <dgm:fillClrLst meth="repeat">
+      <a:schemeClr val="accent1"/>
+    </dgm:fillClrLst>
+    <dgm:linClrLst meth="repeat">
+      <a:schemeClr val="accent1">
+        <a:shade val="60000"/>
+      </a:schemeClr>
+    </dgm:linClrLst>
+    <dgm:effectClrLst/>
+    <dgm:txLinClrLst/>
+    <dgm:txFillClrLst meth="repeat">
+      <a:schemeClr val="tx1"/>
+    </dgm:txFillClrLst>
+    <dgm:txEffectClrLst/>
+  </dgm:styleLbl>
+  <dgm:styleLbl name="parChTrans1D2">
+    <dgm:fillClrLst meth="repeat">
+      <a:schemeClr val="accent1"/>
+    </dgm:fillClrLst>
+    <dgm:linClrLst meth="repeat">
+      <a:schemeClr val="accent1">
+        <a:shade val="60000"/>
+      </a:schemeClr>
+    </dgm:linClrLst>
+    <dgm:effectClrLst/>
+    <dgm:txLinClrLst/>
+    <dgm:txFillClrLst meth="repeat">
+      <a:schemeClr val="tx1"/>
+    </dgm:txFillClrLst>
+    <dgm:txEffectClrLst/>
+  </dgm:styleLbl>
+  <dgm:styleLbl name="parChTrans1D3">
+    <dgm:fillClrLst meth="repeat">
+      <a:schemeClr val="accent1"/>
+    </dgm:fillClrLst>
+    <dgm:linClrLst meth="repeat">
+      <a:schemeClr val="accent1">
+        <a:shade val="80000"/>
+      </a:schemeClr>
+    </dgm:linClrLst>
+    <dgm:effectClrLst/>
+    <dgm:txLinClrLst/>
+    <dgm:txFillClrLst meth="repeat">
+      <a:schemeClr val="tx1"/>
+    </dgm:txFillClrLst>
+    <dgm:txEffectClrLst/>
+  </dgm:styleLbl>
+  <dgm:styleLbl name="parChTrans1D4">
+    <dgm:fillClrLst meth="repeat">
+      <a:schemeClr val="accent1"/>
+    </dgm:fillClrLst>
+    <dgm:linClrLst meth="repeat">
+      <a:schemeClr val="accent1">
+        <a:shade val="80000"/>
+      </a:schemeClr>
+    </dgm:linClrLst>
+    <dgm:effectClrLst/>
+    <dgm:txLinClrLst/>
+    <dgm:txFillClrLst meth="repeat">
+      <a:schemeClr val="tx1"/>
+    </dgm:txFillClrLst>
+    <dgm:txEffectClrLst/>
+  </dgm:styleLbl>
+  <dgm:styleLbl name="fgAcc1">
+    <dgm:fillClrLst meth="repeat">
+      <a:schemeClr val="lt1">
+        <a:alpha val="90000"/>
+      </a:schemeClr>
+    </dgm:fillClrLst>
+    <dgm:linClrLst meth="repeat">
+      <a:schemeClr val="accent1"/>
+    </dgm:linClrLst>
+    <dgm:effectClrLst/>
+    <dgm:txLinClrLst/>
+    <dgm:txFillClrLst meth="repeat">
+      <a:schemeClr val="dk1"/>
+    </dgm:txFillClrLst>
+    <dgm:txEffectClrLst/>
+  </dgm:styleLbl>
+  <dgm:styleLbl name="conFgAcc1">
+    <dgm:fillClrLst meth="repeat">
+      <a:schemeClr val="lt1">
+        <a:alpha val="90000"/>
+      </a:schemeClr>
+    </dgm:fillClrLst>
+    <dgm:linClrLst meth="repeat">
+      <a:schemeClr val="accent1"/>
+    </dgm:linClrLst>
+    <dgm:effectClrLst/>
+    <dgm:txLinClrLst/>
+    <dgm:txFillClrLst meth="repeat">
+      <a:schemeClr val="dk1"/>
+    </dgm:txFillClrLst>
+    <dgm:txEffectClrLst/>
+  </dgm:styleLbl>
+  <dgm:styleLbl name="alignAcc1">
+    <dgm:fillClrLst meth="repeat">
+      <a:schemeClr val="lt1">
+        <a:alpha val="90000"/>
+      </a:schemeClr>
+    </dgm:fillClrLst>
+    <dgm:linClrLst meth="repeat">
+      <a:schemeClr val="accent1"/>
+    </dgm:linClrLst>
+    <dgm:effectClrLst/>
+    <dgm:txLinClrLst/>
+    <dgm:txFillClrLst meth="repeat">
+      <a:schemeClr val="dk1"/>
+    </dgm:txFillClrLst>
+    <dgm:txEffectClrLst/>
+  </dgm:styleLbl>
+  <dgm:styleLbl name="trAlignAcc1">
+    <dgm:fillClrLst meth="repeat">
+      <a:schemeClr val="lt1">
+        <a:alpha val="40000"/>
+      </a:schemeClr>
+    </dgm:fillClrLst>
+    <dgm:linClrLst meth="repeat">
+      <a:schemeClr val="accent1"/>
+    </dgm:linClrLst>
+    <dgm:effectClrLst/>
+    <dgm:txLinClrLst/>
+    <dgm:txFillClrLst meth="repeat">
+      <a:schemeClr val="dk1"/>
+    </dgm:txFillClrLst>
+    <dgm:txEffectClrLst/>
+  </dgm:styleLbl>
+  <dgm:styleLbl name="bgAcc1">
+    <dgm:fillClrLst meth="repeat">
+      <a:schemeClr val="lt1">
+        <a:alpha val="90000"/>
+      </a:schemeClr>
+    </dgm:fillClrLst>
+    <dgm:linClrLst meth="repeat">
+      <a:schemeClr val="accent1"/>
+    </dgm:linClrLst>
+    <dgm:effectClrLst/>
+    <dgm:txLinClrLst/>
+    <dgm:txFillClrLst meth="repeat">
+      <a:schemeClr val="dk1"/>
+    </dgm:txFillClrLst>
+    <dgm:txEffectClrLst/>
+  </dgm:styleLbl>
+  <dgm:styleLbl name="solidFgAcc1">
+    <dgm:fillClrLst meth="repeat">
+      <a:schemeClr val="lt1"/>
+    </dgm:fillClrLst>
+    <dgm:linClrLst meth="repeat">
+      <a:schemeClr val="accent1"/>
+    </dgm:linClrLst>
+    <dgm:effectClrLst/>
+    <dgm:txLinClrLst/>
+    <dgm:txFillClrLst meth="repeat">
+      <a:schemeClr val="dk1"/>
+    </dgm:txFillClrLst>
+    <dgm:txEffectClrLst/>
+  </dgm:styleLbl>
+  <dgm:styleLbl name="solidAlignAcc1">
+    <dgm:fillClrLst meth="repeat">
+      <a:schemeClr val="lt1"/>
+    </dgm:fillClrLst>
+    <dgm:linClrLst meth="repeat">
+      <a:schemeClr val="accent1"/>
+    </dgm:linClrLst>
+    <dgm:effectClrLst/>
+    <dgm:txLinClrLst/>
+    <dgm:txFillClrLst meth="repeat">
+      <a:schemeClr val="dk1"/>
+    </dgm:txFillClrLst>
+    <dgm:txEffectClrLst/>
+  </dgm:styleLbl>
+  <dgm:styleLbl name="solidBgAcc1">
+    <dgm:fillClrLst meth="repeat">
+      <a:schemeClr val="lt1"/>
+    </dgm:fillClrLst>
+    <dgm:linClrLst meth="repeat">
+      <a:schemeClr val="accent1"/>
+    </dgm:linClrLst>
+    <dgm:effectClrLst/>
+    <dgm:txLinClrLst/>
+    <dgm:txFillClrLst meth="repeat">
+      <a:schemeClr val="dk1"/>
+    </dgm:txFillClrLst>
+    <dgm:txEffectClrLst/>
+  </dgm:styleLbl>
+  <dgm:styleLbl name="fgAccFollowNode1">
+    <dgm:fillClrLst meth="repeat">
+      <a:schemeClr val="accent1">
+        <a:alpha val="90000"/>
+        <a:tint val="40000"/>
+      </a:schemeClr>
+    </dgm:fillClrLst>
+    <dgm:linClrLst meth="repeat">
+      <a:schemeClr val="accent1">
+        <a:alpha val="90000"/>
+        <a:tint val="40000"/>
+      </a:schemeClr>
+    </dgm:linClrLst>
+    <dgm:effectClrLst/>
+    <dgm:txLinClrLst/>
+    <dgm:txFillClrLst meth="repeat">
+      <a:schemeClr val="dk1"/>
+    </dgm:txFillClrLst>
+    <dgm:txEffectClrLst/>
+  </dgm:styleLbl>
+  <dgm:styleLbl name="alignAccFollowNode1">
+    <dgm:fillClrLst meth="repeat">
+      <a:schemeClr val="accent1">
+        <a:alpha val="90000"/>
+        <a:tint val="40000"/>
+      </a:schemeClr>
+    </dgm:fillClrLst>
+    <dgm:linClrLst meth="repeat">
+      <a:schemeClr val="accent1">
+        <a:alpha val="90000"/>
+        <a:tint val="40000"/>
+      </a:schemeClr>
+    </dgm:linClrLst>
+    <dgm:effectClrLst/>
+    <dgm:txLinClrLst/>
+    <dgm:txFillClrLst meth="repeat">
+      <a:schemeClr val="dk1"/>
+    </dgm:txFillClrLst>
+    <dgm:txEffectClrLst/>
+  </dgm:styleLbl>
+  <dgm:styleLbl name="bgAccFollowNode1">
+    <dgm:fillClrLst meth="repeat">
+      <a:schemeClr val="accent1">
+        <a:alpha val="90000"/>
+        <a:tint val="40000"/>
+      </a:schemeClr>
+    </dgm:fillClrLst>
+    <dgm:linClrLst meth="repeat">
+      <a:schemeClr val="accent1">
+        <a:alpha val="90000"/>
+        <a:tint val="40000"/>
+      </a:schemeClr>
+    </dgm:linClrLst>
+    <dgm:effectClrLst/>
+    <dgm:txLinClrLst/>
+    <dgm:txFillClrLst meth="repeat">
+      <a:schemeClr val="dk1"/>
+    </dgm:txFillClrLst>
+    <dgm:txEffectClrLst/>
+  </dgm:styleLbl>
+  <dgm:styleLbl name="fgAcc0">
+    <dgm:fillClrLst meth="repeat">
+      <a:schemeClr val="lt1">
+        <a:alpha val="90000"/>
+      </a:schemeClr>
+    </dgm:fillClrLst>
+    <dgm:linClrLst meth="repeat">
+      <a:schemeClr val="accent1"/>
+    </dgm:linClrLst>
+    <dgm:effectClrLst/>
+    <dgm:txLinClrLst/>
+    <dgm:txFillClrLst meth="repeat">
+      <a:schemeClr val="dk1"/>
+    </dgm:txFillClrLst>
+    <dgm:txEffectClrLst/>
+  </dgm:styleLbl>
+  <dgm:styleLbl name="fgAcc2">
+    <dgm:fillClrLst meth="repeat">
+      <a:schemeClr val="lt1">
+        <a:alpha val="90000"/>
+      </a:schemeClr>
+    </dgm:fillClrLst>
+    <dgm:linClrLst meth="repeat">
+      <a:schemeClr val="accent1"/>
+    </dgm:linClrLst>
+    <dgm:effectClrLst/>
+    <dgm:txLinClrLst/>
+    <dgm:txFillClrLst meth="repeat">
+      <a:schemeClr val="dk1"/>
+    </dgm:txFillClrLst>
+    <dgm:txEffectClrLst/>
+  </dgm:styleLbl>
+  <dgm:styleLbl name="fgAcc3">
+    <dgm:fillClrLst meth="repeat">
+      <a:schemeClr val="lt1">
+        <a:alpha val="90000"/>
+      </a:schemeClr>
+    </dgm:fillClrLst>
+    <dgm:linClrLst meth="repeat">
+      <a:schemeClr val="accent1"/>
+    </dgm:linClrLst>
+    <dgm:effectClrLst/>
+    <dgm:txLinClrLst/>
+    <dgm:txFillClrLst meth="repeat">
+      <a:schemeClr val="dk1"/>
+    </dgm:txFillClrLst>
+    <dgm:txEffectClrLst/>
+  </dgm:styleLbl>
+  <dgm:styleLbl name="fgAcc4">
+    <dgm:fillClrLst meth="repeat">
+      <a:schemeClr val="lt1">
+        <a:alpha val="90000"/>
+      </a:schemeClr>
+    </dgm:fillClrLst>
+    <dgm:linClrLst meth="repeat">
+      <a:schemeClr val="accent1"/>
+    </dgm:linClrLst>
+    <dgm:effectClrLst/>
+    <dgm:txLinClrLst/>
+    <dgm:txFillClrLst meth="repeat">
+      <a:schemeClr val="dk1"/>
+    </dgm:txFillClrLst>
+    <dgm:txEffectClrLst/>
+  </dgm:styleLbl>
+  <dgm:styleLbl name="bgShp">
+    <dgm:fillClrLst meth="repeat">
+      <a:schemeClr val="bg1">
+        <a:lumMod val="95000"/>
+      </a:schemeClr>
+    </dgm:fillClrLst>
+    <dgm:linClrLst meth="repeat">
+      <a:schemeClr val="accent1"/>
+    </dgm:linClrLst>
+    <dgm:effectClrLst/>
+    <dgm:txLinClrLst/>
+    <dgm:txFillClrLst meth="repeat">
+      <a:schemeClr val="dk1"/>
+    </dgm:txFillClrLst>
+    <dgm:txEffectClrLst/>
+  </dgm:styleLbl>
+  <dgm:styleLbl name="dkBgShp">
+    <dgm:fillClrLst meth="repeat">
+      <a:schemeClr val="accent1">
+        <a:shade val="80000"/>
+      </a:schemeClr>
+    </dgm:fillClrLst>
+    <dgm:linClrLst meth="repeat">
+      <a:schemeClr val="accent1"/>
+    </dgm:linClrLst>
+    <dgm:effectClrLst/>
+    <dgm:txLinClrLst/>
+    <dgm:txFillClrLst meth="repeat">
+      <a:schemeClr val="lt1"/>
+    </dgm:txFillClrLst>
+    <dgm:txEffectClrLst/>
+  </dgm:styleLbl>
+  <dgm:styleLbl name="trBgShp">
+    <dgm:fillClrLst meth="repeat">
+      <a:schemeClr val="accent1">
+        <a:tint val="50000"/>
+        <a:alpha val="40000"/>
+      </a:schemeClr>
+    </dgm:fillClrLst>
+    <dgm:linClrLst meth="repeat">
+      <a:schemeClr val="accent1"/>
+    </dgm:linClrLst>
+    <dgm:effectClrLst/>
+    <dgm:txLinClrLst/>
+    <dgm:txFillClrLst meth="repeat">
+      <a:schemeClr val="lt1"/>
+    </dgm:txFillClrLst>
+    <dgm:txEffectClrLst/>
+  </dgm:styleLbl>
+  <dgm:styleLbl name="fgShp">
+    <dgm:fillClrLst meth="repeat">
+      <a:schemeClr val="accent1">
+        <a:tint val="60000"/>
+      </a:schemeClr>
+    </dgm:fillClrLst>
+    <dgm:linClrLst meth="repeat">
+      <a:schemeClr val="lt1"/>
+    </dgm:linClrLst>
+    <dgm:effectClrLst/>
+    <dgm:txLinClrLst/>
+    <dgm:txFillClrLst meth="repeat">
+      <a:schemeClr val="dk1"/>
+    </dgm:txFillClrLst>
+    <dgm:txEffectClrLst/>
+  </dgm:styleLbl>
+  <dgm:styleLbl name="revTx">
+    <dgm:fillClrLst meth="repeat">
+      <a:schemeClr val="lt1">
+        <a:alpha val="0"/>
+      </a:schemeClr>
+    </dgm:fillClrLst>
+    <dgm:linClrLst meth="repeat">
+      <a:schemeClr val="dk1">
+        <a:alpha val="0"/>
+      </a:schemeClr>
+    </dgm:linClrLst>
+    <dgm:effectClrLst/>
+    <dgm:txLinClrLst/>
+    <dgm:txFillClrLst meth="repeat">
+      <a:schemeClr val="tx1"/>
+    </dgm:txFillClrLst>
+    <dgm:txEffectClrLst/>
+  </dgm:styleLbl>
+</dgm:colorsDef>
+</file>
+
+<file path=ppt/diagrams/data1.xml><?xml version="1.0" encoding="utf-8"?>
+<dgm:dataModel xmlns:dgm="http://schemas.openxmlformats.org/drawingml/2006/diagram" xmlns:a="http://schemas.openxmlformats.org/drawingml/2006/main">
+  <dgm:ptLst>
+    <dgm:pt modelId="{CEFE2C82-2EF5-4777-BFE7-0DA03B660312}" type="doc">
+      <dgm:prSet loTypeId="urn:microsoft.com/office/officeart/2018/2/layout/IconLabelList" loCatId="icon" qsTypeId="urn:microsoft.com/office/officeart/2005/8/quickstyle/simple1" qsCatId="simple" csTypeId="urn:microsoft.com/office/officeart/2018/5/colors/Iconchunking_neutralbg_accent1_2" csCatId="accent1" phldr="1"/>
+      <dgm:spPr/>
+      <dgm:t>
+        <a:bodyPr/>
+        <a:lstStyle/>
+        <a:p>
+          <a:endParaRPr lang="en-US"/>
+        </a:p>
+      </dgm:t>
+    </dgm:pt>
+    <dgm:pt modelId="{7B4EB37C-65E1-4320-A1C8-6A01837487C0}">
+      <dgm:prSet/>
+      <dgm:spPr/>
+      <dgm:t>
+        <a:bodyPr/>
+        <a:lstStyle/>
+        <a:p>
+          <a:r>
+            <a:rPr lang="fr-CH"/>
+            <a:t>Création du fichier pour le matériels nécessaires </a:t>
+          </a:r>
+          <a:endParaRPr lang="en-US"/>
+        </a:p>
+      </dgm:t>
+    </dgm:pt>
+    <dgm:pt modelId="{9BE07BCD-4549-4F8C-AF28-63EE5C9C4E01}" type="parTrans" cxnId="{F60DAC35-B5F4-4D45-8776-DFD4BBF18DD6}">
+      <dgm:prSet/>
+      <dgm:spPr/>
+      <dgm:t>
+        <a:bodyPr/>
+        <a:lstStyle/>
+        <a:p>
+          <a:endParaRPr lang="en-US"/>
+        </a:p>
+      </dgm:t>
+    </dgm:pt>
+    <dgm:pt modelId="{2878D96C-055C-4654-A12B-EEA45CF78BEB}" type="sibTrans" cxnId="{F60DAC35-B5F4-4D45-8776-DFD4BBF18DD6}">
+      <dgm:prSet/>
+      <dgm:spPr/>
+      <dgm:t>
+        <a:bodyPr/>
+        <a:lstStyle/>
+        <a:p>
+          <a:endParaRPr lang="en-US"/>
+        </a:p>
+      </dgm:t>
+    </dgm:pt>
+    <dgm:pt modelId="{B1743F7D-99B5-4190-BA02-2DE7073F6B59}">
+      <dgm:prSet/>
+      <dgm:spPr/>
+      <dgm:t>
+        <a:bodyPr/>
+        <a:lstStyle/>
+        <a:p>
+          <a:r>
+            <a:rPr lang="fr-CH"/>
+            <a:t>Création du fichier avec le retour de M. Sahli</a:t>
+          </a:r>
+          <a:endParaRPr lang="en-US"/>
+        </a:p>
+      </dgm:t>
+    </dgm:pt>
+    <dgm:pt modelId="{88A11634-6DAA-47B0-BCB7-935FA0C593AC}" type="parTrans" cxnId="{A3F5E842-2F80-45F4-9299-6DB77CFEC81D}">
+      <dgm:prSet/>
+      <dgm:spPr/>
+      <dgm:t>
+        <a:bodyPr/>
+        <a:lstStyle/>
+        <a:p>
+          <a:endParaRPr lang="en-US"/>
+        </a:p>
+      </dgm:t>
+    </dgm:pt>
+    <dgm:pt modelId="{D0440B15-D985-4006-9BEE-DF79E11AAFD7}" type="sibTrans" cxnId="{A3F5E842-2F80-45F4-9299-6DB77CFEC81D}">
+      <dgm:prSet/>
+      <dgm:spPr/>
+      <dgm:t>
+        <a:bodyPr/>
+        <a:lstStyle/>
+        <a:p>
+          <a:endParaRPr lang="en-US"/>
+        </a:p>
+      </dgm:t>
+    </dgm:pt>
+    <dgm:pt modelId="{DE564F7C-45E9-46C7-901E-E3EB90DB5F0C}" type="pres">
+      <dgm:prSet presAssocID="{CEFE2C82-2EF5-4777-BFE7-0DA03B660312}" presName="root" presStyleCnt="0">
+        <dgm:presLayoutVars>
+          <dgm:dir/>
+          <dgm:resizeHandles val="exact"/>
+        </dgm:presLayoutVars>
+      </dgm:prSet>
+      <dgm:spPr/>
+    </dgm:pt>
+    <dgm:pt modelId="{6A42CE9E-23B5-4FD0-BB55-804F57B4272A}" type="pres">
+      <dgm:prSet presAssocID="{7B4EB37C-65E1-4320-A1C8-6A01837487C0}" presName="compNode" presStyleCnt="0"/>
+      <dgm:spPr/>
+    </dgm:pt>
+    <dgm:pt modelId="{279B3533-5314-450C-A22D-72FAE911C470}" type="pres">
+      <dgm:prSet presAssocID="{7B4EB37C-65E1-4320-A1C8-6A01837487C0}" presName="iconRect" presStyleLbl="node1" presStyleIdx="0" presStyleCnt="2"/>
+      <dgm:spPr>
+        <a:blipFill>
+          <a:blip xmlns:r="http://schemas.openxmlformats.org/officeDocument/2006/relationships">
+            <a:extLst>
+              <a:ext uri="{28A0092B-C50C-407E-A947-70E740481C1C}">
+                <a14:useLocalDpi xmlns:a14="http://schemas.microsoft.com/office/drawing/2010/main" val="0"/>
+              </a:ext>
+              <a:ext uri="{96DAC541-7B7A-43D3-8B79-37D633B846F1}">
+                <asvg:svgBlip xmlns:asvg="http://schemas.microsoft.com/office/drawing/2016/SVG/main" r:embed="rId1"/>
+              </a:ext>
+            </a:extLst>
+          </a:blip>
+          <a:stretch>
+            <a:fillRect/>
+          </a:stretch>
+        </a:blipFill>
+        <a:ln>
+          <a:noFill/>
+        </a:ln>
+      </dgm:spPr>
+      <dgm:extLst>
+        <a:ext uri="{E40237B7-FDA0-4F09-8148-C483321AD2D9}">
+          <dgm14:cNvPr xmlns:dgm14="http://schemas.microsoft.com/office/drawing/2010/diagram" id="0" name="" descr="Document"/>
+        </a:ext>
+      </dgm:extLst>
+    </dgm:pt>
+    <dgm:pt modelId="{1B85644A-60A1-43A7-9C06-F988AFB9A402}" type="pres">
+      <dgm:prSet presAssocID="{7B4EB37C-65E1-4320-A1C8-6A01837487C0}" presName="spaceRect" presStyleCnt="0"/>
+      <dgm:spPr/>
+    </dgm:pt>
+    <dgm:pt modelId="{16685366-0A94-42C3-A8CB-193F2F5363F7}" type="pres">
+      <dgm:prSet presAssocID="{7B4EB37C-65E1-4320-A1C8-6A01837487C0}" presName="textRect" presStyleLbl="revTx" presStyleIdx="0" presStyleCnt="2">
+        <dgm:presLayoutVars>
+          <dgm:chMax val="1"/>
+          <dgm:chPref val="1"/>
+        </dgm:presLayoutVars>
+      </dgm:prSet>
+      <dgm:spPr/>
+    </dgm:pt>
+    <dgm:pt modelId="{F499BA24-3DEC-4A05-BF9C-AA48C49F6CD9}" type="pres">
+      <dgm:prSet presAssocID="{2878D96C-055C-4654-A12B-EEA45CF78BEB}" presName="sibTrans" presStyleCnt="0"/>
+      <dgm:spPr/>
+    </dgm:pt>
+    <dgm:pt modelId="{19808E52-4748-4BB3-AF06-17E3A78D4C5A}" type="pres">
+      <dgm:prSet presAssocID="{B1743F7D-99B5-4190-BA02-2DE7073F6B59}" presName="compNode" presStyleCnt="0"/>
+      <dgm:spPr/>
+    </dgm:pt>
+    <dgm:pt modelId="{A6DE06F4-093C-43DD-98EE-E2813756FCB4}" type="pres">
+      <dgm:prSet presAssocID="{B1743F7D-99B5-4190-BA02-2DE7073F6B59}" presName="iconRect" presStyleLbl="node1" presStyleIdx="1" presStyleCnt="2"/>
+      <dgm:spPr>
+        <a:blipFill>
+          <a:blip xmlns:r="http://schemas.openxmlformats.org/officeDocument/2006/relationships">
+            <a:extLst>
+              <a:ext uri="{28A0092B-C50C-407E-A947-70E740481C1C}">
+                <a14:useLocalDpi xmlns:a14="http://schemas.microsoft.com/office/drawing/2010/main" val="0"/>
+              </a:ext>
+              <a:ext uri="{96DAC541-7B7A-43D3-8B79-37D633B846F1}">
+                <asvg:svgBlip xmlns:asvg="http://schemas.microsoft.com/office/drawing/2016/SVG/main" r:embed="rId2"/>
+              </a:ext>
+            </a:extLst>
+          </a:blip>
+          <a:stretch>
+            <a:fillRect/>
+          </a:stretch>
+        </a:blipFill>
+        <a:ln>
+          <a:noFill/>
+        </a:ln>
+      </dgm:spPr>
+      <dgm:extLst>
+        <a:ext uri="{E40237B7-FDA0-4F09-8148-C483321AD2D9}">
+          <dgm14:cNvPr xmlns:dgm14="http://schemas.microsoft.com/office/drawing/2010/diagram" id="0" name="" descr="Jouer"/>
+        </a:ext>
+      </dgm:extLst>
+    </dgm:pt>
+    <dgm:pt modelId="{AD5C9213-8655-48FE-BB06-2349664ABCCC}" type="pres">
+      <dgm:prSet presAssocID="{B1743F7D-99B5-4190-BA02-2DE7073F6B59}" presName="spaceRect" presStyleCnt="0"/>
+      <dgm:spPr/>
+    </dgm:pt>
+    <dgm:pt modelId="{D0ACE368-23CF-4CBE-847E-EE16D07F7549}" type="pres">
+      <dgm:prSet presAssocID="{B1743F7D-99B5-4190-BA02-2DE7073F6B59}" presName="textRect" presStyleLbl="revTx" presStyleIdx="1" presStyleCnt="2">
+        <dgm:presLayoutVars>
+          <dgm:chMax val="1"/>
+          <dgm:chPref val="1"/>
+        </dgm:presLayoutVars>
+      </dgm:prSet>
+      <dgm:spPr/>
+    </dgm:pt>
+  </dgm:ptLst>
+  <dgm:cxnLst>
+    <dgm:cxn modelId="{F60DAC35-B5F4-4D45-8776-DFD4BBF18DD6}" srcId="{CEFE2C82-2EF5-4777-BFE7-0DA03B660312}" destId="{7B4EB37C-65E1-4320-A1C8-6A01837487C0}" srcOrd="0" destOrd="0" parTransId="{9BE07BCD-4549-4F8C-AF28-63EE5C9C4E01}" sibTransId="{2878D96C-055C-4654-A12B-EEA45CF78BEB}"/>
+    <dgm:cxn modelId="{A3F5E842-2F80-45F4-9299-6DB77CFEC81D}" srcId="{CEFE2C82-2EF5-4777-BFE7-0DA03B660312}" destId="{B1743F7D-99B5-4190-BA02-2DE7073F6B59}" srcOrd="1" destOrd="0" parTransId="{88A11634-6DAA-47B0-BCB7-935FA0C593AC}" sibTransId="{D0440B15-D985-4006-9BEE-DF79E11AAFD7}"/>
+    <dgm:cxn modelId="{CA2BFC42-7C9B-44C8-9E4B-0E7B57A51C34}" type="presOf" srcId="{CEFE2C82-2EF5-4777-BFE7-0DA03B660312}" destId="{DE564F7C-45E9-46C7-901E-E3EB90DB5F0C}" srcOrd="0" destOrd="0" presId="urn:microsoft.com/office/officeart/2018/2/layout/IconLabelList"/>
+    <dgm:cxn modelId="{0C5983B8-8CFA-40AB-B7F8-14B3D80ABFD1}" type="presOf" srcId="{B1743F7D-99B5-4190-BA02-2DE7073F6B59}" destId="{D0ACE368-23CF-4CBE-847E-EE16D07F7549}" srcOrd="0" destOrd="0" presId="urn:microsoft.com/office/officeart/2018/2/layout/IconLabelList"/>
+    <dgm:cxn modelId="{12F80CBD-6A7F-4AF3-83A0-F70929F529EE}" type="presOf" srcId="{7B4EB37C-65E1-4320-A1C8-6A01837487C0}" destId="{16685366-0A94-42C3-A8CB-193F2F5363F7}" srcOrd="0" destOrd="0" presId="urn:microsoft.com/office/officeart/2018/2/layout/IconLabelList"/>
+    <dgm:cxn modelId="{519AAF2E-1F25-4B74-A0DC-73E854D23896}" type="presParOf" srcId="{DE564F7C-45E9-46C7-901E-E3EB90DB5F0C}" destId="{6A42CE9E-23B5-4FD0-BB55-804F57B4272A}" srcOrd="0" destOrd="0" presId="urn:microsoft.com/office/officeart/2018/2/layout/IconLabelList"/>
+    <dgm:cxn modelId="{53ABF2F3-6E33-4FC4-978C-F5641DA39145}" type="presParOf" srcId="{6A42CE9E-23B5-4FD0-BB55-804F57B4272A}" destId="{279B3533-5314-450C-A22D-72FAE911C470}" srcOrd="0" destOrd="0" presId="urn:microsoft.com/office/officeart/2018/2/layout/IconLabelList"/>
+    <dgm:cxn modelId="{786736A8-2F1C-4149-9561-0D96F420CA03}" type="presParOf" srcId="{6A42CE9E-23B5-4FD0-BB55-804F57B4272A}" destId="{1B85644A-60A1-43A7-9C06-F988AFB9A402}" srcOrd="1" destOrd="0" presId="urn:microsoft.com/office/officeart/2018/2/layout/IconLabelList"/>
+    <dgm:cxn modelId="{04253BBB-80AF-4972-84BB-C18D3678D9FD}" type="presParOf" srcId="{6A42CE9E-23B5-4FD0-BB55-804F57B4272A}" destId="{16685366-0A94-42C3-A8CB-193F2F5363F7}" srcOrd="2" destOrd="0" presId="urn:microsoft.com/office/officeart/2018/2/layout/IconLabelList"/>
+    <dgm:cxn modelId="{DF585AE8-B493-4CC9-BD9B-ACE70AF97D10}" type="presParOf" srcId="{DE564F7C-45E9-46C7-901E-E3EB90DB5F0C}" destId="{F499BA24-3DEC-4A05-BF9C-AA48C49F6CD9}" srcOrd="1" destOrd="0" presId="urn:microsoft.com/office/officeart/2018/2/layout/IconLabelList"/>
+    <dgm:cxn modelId="{D4FA4EC5-0136-4C10-B1DB-5CE92DB62713}" type="presParOf" srcId="{DE564F7C-45E9-46C7-901E-E3EB90DB5F0C}" destId="{19808E52-4748-4BB3-AF06-17E3A78D4C5A}" srcOrd="2" destOrd="0" presId="urn:microsoft.com/office/officeart/2018/2/layout/IconLabelList"/>
+    <dgm:cxn modelId="{38705AAF-B537-4FFF-A1C1-487B83B4BE91}" type="presParOf" srcId="{19808E52-4748-4BB3-AF06-17E3A78D4C5A}" destId="{A6DE06F4-093C-43DD-98EE-E2813756FCB4}" srcOrd="0" destOrd="0" presId="urn:microsoft.com/office/officeart/2018/2/layout/IconLabelList"/>
+    <dgm:cxn modelId="{CAC0B1FE-56C2-45A3-9EBE-AD3EB93959C4}" type="presParOf" srcId="{19808E52-4748-4BB3-AF06-17E3A78D4C5A}" destId="{AD5C9213-8655-48FE-BB06-2349664ABCCC}" srcOrd="1" destOrd="0" presId="urn:microsoft.com/office/officeart/2018/2/layout/IconLabelList"/>
+    <dgm:cxn modelId="{E55F9AEF-7DCD-4E06-84A9-F7063DCBF755}" type="presParOf" srcId="{19808E52-4748-4BB3-AF06-17E3A78D4C5A}" destId="{D0ACE368-23CF-4CBE-847E-EE16D07F7549}" srcOrd="2" destOrd="0" presId="urn:microsoft.com/office/officeart/2018/2/layout/IconLabelList"/>
+  </dgm:cxnLst>
+  <dgm:bg/>
+  <dgm:whole/>
+  <dgm:extLst>
+    <a:ext uri="http://schemas.microsoft.com/office/drawing/2008/diagram">
+      <dsp:dataModelExt xmlns:dsp="http://schemas.microsoft.com/office/drawing/2008/diagram" relId="rId6" minVer="http://schemas.openxmlformats.org/drawingml/2006/diagram"/>
+    </a:ext>
+  </dgm:extLst>
+</dgm:dataModel>
+</file>
+
+<file path=ppt/diagrams/drawing1.xml><?xml version="1.0" encoding="utf-8"?>
+<dsp:drawing xmlns:dgm="http://schemas.openxmlformats.org/drawingml/2006/diagram" xmlns:dsp="http://schemas.microsoft.com/office/drawing/2008/diagram" xmlns:a="http://schemas.openxmlformats.org/drawingml/2006/main">
+  <dsp:spTree>
+    <dsp:nvGrpSpPr>
+      <dsp:cNvPr id="0" name=""/>
+      <dsp:cNvGrpSpPr/>
+    </dsp:nvGrpSpPr>
+    <dsp:grpSpPr/>
+    <dsp:sp modelId="{279B3533-5314-450C-A22D-72FAE911C470}">
+      <dsp:nvSpPr>
+        <dsp:cNvPr id="0" name=""/>
+        <dsp:cNvSpPr/>
+      </dsp:nvSpPr>
+      <dsp:spPr>
+        <a:xfrm>
+          <a:off x="2068474" y="316490"/>
+          <a:ext cx="1944000" cy="1944000"/>
+        </a:xfrm>
+        <a:prstGeom prst="rect">
+          <a:avLst/>
+        </a:prstGeom>
+        <a:blipFill>
+          <a:blip xmlns:r="http://schemas.openxmlformats.org/officeDocument/2006/relationships">
+            <a:extLst>
+              <a:ext uri="{28A0092B-C50C-407E-A947-70E740481C1C}">
+                <a14:useLocalDpi xmlns:a14="http://schemas.microsoft.com/office/drawing/2010/main" val="0"/>
+              </a:ext>
+              <a:ext uri="{96DAC541-7B7A-43D3-8B79-37D633B846F1}">
+                <asvg:svgBlip xmlns:asvg="http://schemas.microsoft.com/office/drawing/2016/SVG/main" r:embed="rId1"/>
+              </a:ext>
+            </a:extLst>
+          </a:blip>
+          <a:stretch>
+            <a:fillRect/>
+          </a:stretch>
+        </a:blipFill>
+        <a:ln w="19050" cap="flat" cmpd="sng" algn="ctr">
+          <a:noFill/>
+          <a:prstDash val="solid"/>
+          <a:miter lim="800000"/>
+        </a:ln>
+        <a:effectLst/>
+      </dsp:spPr>
+      <dsp:style>
+        <a:lnRef idx="2">
+          <a:scrgbClr r="0" g="0" b="0"/>
+        </a:lnRef>
+        <a:fillRef idx="1">
+          <a:scrgbClr r="0" g="0" b="0"/>
+        </a:fillRef>
+        <a:effectRef idx="0">
+          <a:scrgbClr r="0" g="0" b="0"/>
+        </a:effectRef>
+        <a:fontRef idx="minor">
+          <a:schemeClr val="lt1"/>
+        </a:fontRef>
+      </dsp:style>
+    </dsp:sp>
+    <dsp:sp modelId="{16685366-0A94-42C3-A8CB-193F2F5363F7}">
+      <dsp:nvSpPr>
+        <dsp:cNvPr id="0" name=""/>
+        <dsp:cNvSpPr/>
+      </dsp:nvSpPr>
+      <dsp:spPr>
+        <a:xfrm>
+          <a:off x="880474" y="2730647"/>
+          <a:ext cx="4320000" cy="720000"/>
+        </a:xfrm>
+        <a:prstGeom prst="rect">
+          <a:avLst/>
+        </a:prstGeom>
+        <a:noFill/>
+        <a:ln>
+          <a:noFill/>
+        </a:ln>
+        <a:effectLst/>
+      </dsp:spPr>
+      <dsp:style>
+        <a:lnRef idx="0">
+          <a:scrgbClr r="0" g="0" b="0"/>
+        </a:lnRef>
+        <a:fillRef idx="0">
+          <a:scrgbClr r="0" g="0" b="0"/>
+        </a:fillRef>
+        <a:effectRef idx="0">
+          <a:scrgbClr r="0" g="0" b="0"/>
+        </a:effectRef>
+        <a:fontRef idx="minor"/>
+      </dsp:style>
+      <dsp:txBody>
+        <a:bodyPr spcFirstLastPara="0" vert="horz" wrap="square" lIns="0" tIns="0" rIns="0" bIns="0" numCol="1" spcCol="1270" anchor="t" anchorCtr="0">
+          <a:noAutofit/>
+        </a:bodyPr>
+        <a:lstStyle/>
+        <a:p>
+          <a:pPr marL="0" lvl="0" indent="0" algn="ctr" defTabSz="1155700">
+            <a:lnSpc>
+              <a:spcPct val="90000"/>
+            </a:lnSpc>
+            <a:spcBef>
+              <a:spcPct val="0"/>
+            </a:spcBef>
+            <a:spcAft>
+              <a:spcPct val="35000"/>
+            </a:spcAft>
+            <a:buNone/>
+          </a:pPr>
+          <a:r>
+            <a:rPr lang="fr-CH" sz="2600" kern="1200"/>
+            <a:t>Création du fichier pour le matériels nécessaires </a:t>
+          </a:r>
+          <a:endParaRPr lang="en-US" sz="2600" kern="1200"/>
+        </a:p>
+      </dsp:txBody>
+      <dsp:txXfrm>
+        <a:off x="880474" y="2730647"/>
+        <a:ext cx="4320000" cy="720000"/>
+      </dsp:txXfrm>
+    </dsp:sp>
+    <dsp:sp modelId="{A6DE06F4-093C-43DD-98EE-E2813756FCB4}">
+      <dsp:nvSpPr>
+        <dsp:cNvPr id="0" name=""/>
+        <dsp:cNvSpPr/>
+      </dsp:nvSpPr>
+      <dsp:spPr>
+        <a:xfrm>
+          <a:off x="7144475" y="316490"/>
+          <a:ext cx="1944000" cy="1944000"/>
+        </a:xfrm>
+        <a:prstGeom prst="rect">
+          <a:avLst/>
+        </a:prstGeom>
+        <a:blipFill>
+          <a:blip xmlns:r="http://schemas.openxmlformats.org/officeDocument/2006/relationships">
+            <a:extLst>
+              <a:ext uri="{28A0092B-C50C-407E-A947-70E740481C1C}">
+                <a14:useLocalDpi xmlns:a14="http://schemas.microsoft.com/office/drawing/2010/main" val="0"/>
+              </a:ext>
+              <a:ext uri="{96DAC541-7B7A-43D3-8B79-37D633B846F1}">
+                <asvg:svgBlip xmlns:asvg="http://schemas.microsoft.com/office/drawing/2016/SVG/main" r:embed="rId2"/>
+              </a:ext>
+            </a:extLst>
+          </a:blip>
+          <a:stretch>
+            <a:fillRect/>
+          </a:stretch>
+        </a:blipFill>
+        <a:ln w="19050" cap="flat" cmpd="sng" algn="ctr">
+          <a:noFill/>
+          <a:prstDash val="solid"/>
+          <a:miter lim="800000"/>
+        </a:ln>
+        <a:effectLst/>
+      </dsp:spPr>
+      <dsp:style>
+        <a:lnRef idx="2">
+          <a:scrgbClr r="0" g="0" b="0"/>
+        </a:lnRef>
+        <a:fillRef idx="1">
+          <a:scrgbClr r="0" g="0" b="0"/>
+        </a:fillRef>
+        <a:effectRef idx="0">
+          <a:scrgbClr r="0" g="0" b="0"/>
+        </a:effectRef>
+        <a:fontRef idx="minor">
+          <a:schemeClr val="lt1"/>
+        </a:fontRef>
+      </dsp:style>
+    </dsp:sp>
+    <dsp:sp modelId="{D0ACE368-23CF-4CBE-847E-EE16D07F7549}">
+      <dsp:nvSpPr>
+        <dsp:cNvPr id="0" name=""/>
+        <dsp:cNvSpPr/>
+      </dsp:nvSpPr>
+      <dsp:spPr>
+        <a:xfrm>
+          <a:off x="5956475" y="2730647"/>
+          <a:ext cx="4320000" cy="720000"/>
+        </a:xfrm>
+        <a:prstGeom prst="rect">
+          <a:avLst/>
+        </a:prstGeom>
+        <a:noFill/>
+        <a:ln>
+          <a:noFill/>
+        </a:ln>
+        <a:effectLst/>
+      </dsp:spPr>
+      <dsp:style>
+        <a:lnRef idx="0">
+          <a:scrgbClr r="0" g="0" b="0"/>
+        </a:lnRef>
+        <a:fillRef idx="0">
+          <a:scrgbClr r="0" g="0" b="0"/>
+        </a:fillRef>
+        <a:effectRef idx="0">
+          <a:scrgbClr r="0" g="0" b="0"/>
+        </a:effectRef>
+        <a:fontRef idx="minor"/>
+      </dsp:style>
+      <dsp:txBody>
+        <a:bodyPr spcFirstLastPara="0" vert="horz" wrap="square" lIns="0" tIns="0" rIns="0" bIns="0" numCol="1" spcCol="1270" anchor="t" anchorCtr="0">
+          <a:noAutofit/>
+        </a:bodyPr>
+        <a:lstStyle/>
+        <a:p>
+          <a:pPr marL="0" lvl="0" indent="0" algn="ctr" defTabSz="1155700">
+            <a:lnSpc>
+              <a:spcPct val="90000"/>
+            </a:lnSpc>
+            <a:spcBef>
+              <a:spcPct val="0"/>
+            </a:spcBef>
+            <a:spcAft>
+              <a:spcPct val="35000"/>
+            </a:spcAft>
+            <a:buNone/>
+          </a:pPr>
+          <a:r>
+            <a:rPr lang="fr-CH" sz="2600" kern="1200"/>
+            <a:t>Création du fichier avec le retour de M. Sahli</a:t>
+          </a:r>
+          <a:endParaRPr lang="en-US" sz="2600" kern="1200"/>
+        </a:p>
+      </dsp:txBody>
+      <dsp:txXfrm>
+        <a:off x="5956475" y="2730647"/>
+        <a:ext cx="4320000" cy="720000"/>
+      </dsp:txXfrm>
+    </dsp:sp>
+  </dsp:spTree>
+</dsp:drawing>
+</file>
+
+<file path=ppt/diagrams/layout1.xml><?xml version="1.0" encoding="utf-8"?>
+<dgm:layoutDef xmlns:dgm="http://schemas.openxmlformats.org/drawingml/2006/diagram" xmlns:a="http://schemas.openxmlformats.org/drawingml/2006/main" uniqueId="urn:microsoft.com/office/officeart/2018/2/layout/IconLabelList">
+  <dgm:title val="Icon Label List"/>
+  <dgm:desc val="Use to show non-sequential or grouped chunks of information accompanied by a related visuals. Works best with icons or small pictures with short text captions."/>
+  <dgm:catLst>
+    <dgm:cat type="icon" pri="500"/>
+  </dgm:catLst>
+  <dgm:sampData useDef="1">
+    <dgm:dataModel>
+      <dgm:ptLst/>
+      <dgm:bg/>
+      <dgm:whole/>
+    </dgm:dataModel>
+  </dgm:sampData>
+  <dgm:styleData useDef="1">
+    <dgm:dataModel>
+      <dgm:ptLst/>
+      <dgm:bg/>
+      <dgm:whole/>
+    </dgm:dataModel>
+  </dgm:styleData>
+  <dgm:clrData useDef="1">
+    <dgm:dataModel>
+      <dgm:ptLst/>
+      <dgm:bg/>
+      <dgm:whole/>
+    </dgm:dataModel>
+  </dgm:clrData>
+  <dgm:layoutNode name="root">
+    <dgm:varLst>
+      <dgm:dir/>
+      <dgm:resizeHandles val="exact"/>
+    </dgm:varLst>
+    <dgm:choose name="Name0">
+      <dgm:if name="Name1" axis="self" func="var" arg="dir" op="equ" val="norm">
+        <dgm:alg type="snake">
+          <dgm:param type="grDir" val="tL"/>
+          <dgm:param type="flowDir" val="row"/>
+          <dgm:param type="contDir" val="sameDir"/>
+          <dgm:param type="off" val="ctr"/>
+          <dgm:param type="vertAlign" val="mid"/>
+          <dgm:param type="horzAlign" val="ctr"/>
+        </dgm:alg>
+      </dgm:if>
+      <dgm:else name="Name2">
+        <dgm:alg type="snake">
+          <dgm:param type="grDir" val="tR"/>
+          <dgm:param type="flowDir" val="row"/>
+          <dgm:param type="contDir" val="sameDir"/>
+          <dgm:param type="off" val="ctr"/>
+          <dgm:param type="vertAlign" val="mid"/>
+          <dgm:param type="horzAlign" val="ctr"/>
+        </dgm:alg>
+      </dgm:else>
+    </dgm:choose>
+    <dgm:shape xmlns:r="http://schemas.openxmlformats.org/officeDocument/2006/relationships" r:blip="">
+      <dgm:adjLst/>
+    </dgm:shape>
+    <dgm:presOf/>
+    <dgm:choose name="Name3">
+      <dgm:if name="Name4" axis="ch" ptType="node" func="cnt" op="lte" val="2">
+        <dgm:constrLst>
+          <dgm:constr type="h" for="ch" forName="compNode" refType="h" fact="0.4"/>
+          <dgm:constr type="w" for="ch" forName="compNode" val="120"/>
+          <dgm:constr type="w" for="ch" forName="sibTrans" refType="w" refFor="ch" refForName="compNode" fact="0.175"/>
+          <dgm:constr type="sp" refType="w" refFor="ch" refForName="compNode" op="equ" fact="0.25"/>
+          <dgm:constr type="primFontSz" for="des" ptType="node" op="equ" val="50"/>
+          <dgm:constr type="h" for="des" forName="compNode" op="equ"/>
+          <dgm:constr type="h" for="des" forName="textRect" op="equ"/>
+        </dgm:constrLst>
+      </dgm:if>
+      <dgm:if name="Name5" axis="ch" ptType="node" func="cnt" op="lte" val="4">
+        <dgm:constrLst>
+          <dgm:constr type="h" for="ch" forName="compNode" refType="h" fact="0.4"/>
+          <dgm:constr type="w" for="ch" forName="compNode" refType="w"/>
+          <dgm:constr type="w" for="ch" forName="sibTrans" refType="w" refFor="ch" refForName="compNode" fact="0.175"/>
+          <dgm:constr type="sp" refType="w" refFor="ch" refForName="compNode" op="equ" fact="0.25"/>
+          <dgm:constr type="primFontSz" for="des" ptType="node" op="equ" val="36"/>
+          <dgm:constr type="h" for="des" forName="compNode" op="equ"/>
+          <dgm:constr type="h" for="des" forName="textRect" op="equ"/>
+        </dgm:constrLst>
+      </dgm:if>
+      <dgm:else name="Name6">
+        <dgm:constrLst>
+          <dgm:constr type="h" for="ch" forName="compNode" refType="h" fact="0.4"/>
+          <dgm:constr type="w" for="ch" forName="compNode" refType="w"/>
+          <dgm:constr type="w" for="ch" forName="sibTrans" refType="w" refFor="ch" refForName="compNode" fact="0.175"/>
+          <dgm:constr type="sp" refType="w" refFor="ch" refForName="compNode" op="equ" fact="0.25"/>
+          <dgm:constr type="primFontSz" for="des" ptType="node" op="equ" val="24"/>
+          <dgm:constr type="h" for="des" forName="compNode" op="equ"/>
+          <dgm:constr type="h" for="des" forName="textRect" op="equ"/>
+        </dgm:constrLst>
+      </dgm:else>
+    </dgm:choose>
+    <dgm:ruleLst>
+      <dgm:rule type="w" for="ch" forName="compNode" val="50" fact="NaN" max="NaN"/>
+    </dgm:ruleLst>
+    <dgm:forEach name="Name7" axis="ch" ptType="node">
+      <dgm:layoutNode name="compNode">
+        <dgm:alg type="composite"/>
+        <dgm:shape xmlns:r="http://schemas.openxmlformats.org/officeDocument/2006/relationships" r:blip="">
+          <dgm:adjLst/>
+        </dgm:shape>
+        <dgm:presOf axis="self"/>
+        <dgm:constrLst>
+          <dgm:constr type="w" for="ch" forName="iconRect" refType="w" fact="0.45"/>
+          <dgm:constr type="h" for="ch" forName="iconRect" refType="w" refFor="ch" refForName="iconRect"/>
+          <dgm:constr type="ctrX" for="ch" forName="iconRect" refType="w" fact="0.5"/>
+          <dgm:constr type="t" for="ch" forName="iconRect"/>
+          <dgm:constr type="h" for="ch" forName="spaceRect" refType="h" fact="0.15"/>
+          <dgm:constr type="w" for="ch" forName="spaceRect" refType="w"/>
+          <dgm:constr type="l" for="ch" forName="spaceRect"/>
+          <dgm:constr type="t" for="ch" forName="spaceRect" refType="b" refFor="ch" refForName="iconRect"/>
+          <dgm:constr type="h" for="ch" forName="textRect" val="20"/>
+          <dgm:constr type="w" for="ch" forName="textRect" refType="w"/>
+          <dgm:constr type="l" for="ch" forName="textRect"/>
+          <dgm:constr type="t" for="ch" forName="textRect" refType="b" refFor="ch" refForName="spaceRect"/>
+        </dgm:constrLst>
+        <dgm:ruleLst>
+          <dgm:rule type="h" val="INF" fact="NaN" max="NaN"/>
+        </dgm:ruleLst>
+        <dgm:layoutNode name="iconRect" styleLbl="node1">
+          <dgm:alg type="sp"/>
+          <dgm:shape xmlns:r="http://schemas.openxmlformats.org/officeDocument/2006/relationships" type="rect" r:blip="" blipPhldr="1">
+            <dgm:adjLst/>
+          </dgm:shape>
+          <dgm:presOf/>
+          <dgm:constrLst/>
+          <dgm:ruleLst/>
+        </dgm:layoutNode>
+        <dgm:layoutNode name="spaceRect">
+          <dgm:alg type="sp"/>
+          <dgm:shape xmlns:r="http://schemas.openxmlformats.org/officeDocument/2006/relationships" r:blip="">
+            <dgm:adjLst/>
+          </dgm:shape>
+          <dgm:presOf/>
+          <dgm:constrLst/>
+          <dgm:ruleLst/>
+        </dgm:layoutNode>
+        <dgm:layoutNode name="textRect" styleLbl="revTx">
+          <dgm:varLst>
+            <dgm:chMax val="1"/>
+            <dgm:chPref val="1"/>
+          </dgm:varLst>
+          <dgm:alg type="tx">
+            <dgm:param type="txAnchorVert" val="t"/>
+          </dgm:alg>
+          <dgm:shape xmlns:r="http://schemas.openxmlformats.org/officeDocument/2006/relationships" type="rect" r:blip="">
+            <dgm:adjLst/>
+          </dgm:shape>
+          <dgm:presOf axis="self" ptType="node"/>
+          <dgm:constrLst>
+            <dgm:constr type="lMarg"/>
+            <dgm:constr type="rMarg"/>
+            <dgm:constr type="tMarg"/>
+            <dgm:constr type="bMarg"/>
+          </dgm:constrLst>
+          <dgm:ruleLst>
+            <dgm:rule type="primFontSz" val="11" fact="NaN" max="NaN"/>
+            <dgm:rule type="h" val="INF" fact="NaN" max="NaN"/>
+          </dgm:ruleLst>
+        </dgm:layoutNode>
+      </dgm:layoutNode>
+      <dgm:forEach name="Name8" axis="followSib" ptType="sibTrans" cnt="1">
+        <dgm:layoutNode name="sibTrans">
+          <dgm:alg type="sp"/>
+          <dgm:shape xmlns:r="http://schemas.openxmlformats.org/officeDocument/2006/relationships" r:blip="">
+            <dgm:adjLst/>
+          </dgm:shape>
+          <dgm:presOf axis="self"/>
+          <dgm:constrLst/>
+          <dgm:ruleLst/>
+        </dgm:layoutNode>
+      </dgm:forEach>
+    </dgm:forEach>
+  </dgm:layoutNode>
+  <dgm:extLst>
+    <a:ext uri="{68A01E43-0DF5-4B5B-8FA6-DAF915123BFB}">
+      <dgm1612:lstStyle xmlns:dgm1612="http://schemas.microsoft.com/office/drawing/2016/12/diagram">
+        <a:lvl1pPr>
+          <a:lnSpc>
+            <a:spcPct val="100000"/>
+          </a:lnSpc>
+        </a:lvl1pPr>
+      </dgm1612:lstStyle>
+    </a:ext>
+  </dgm:extLst>
+</dgm:layoutDef>
+</file>
+
+<file path=ppt/diagrams/quickStyle1.xml><?xml version="1.0" encoding="utf-8"?>
+<dgm:styleDef xmlns:dgm="http://schemas.openxmlformats.org/drawingml/2006/diagram" xmlns:a="http://schemas.openxmlformats.org/drawingml/2006/main" uniqueId="urn:microsoft.com/office/officeart/2005/8/quickstyle/simple1">
+  <dgm:title val=""/>
+  <dgm:desc val=""/>
+  <dgm:catLst>
+    <dgm:cat type="simple" pri="10100"/>
+  </dgm:catLst>
+  <dgm:scene3d>
+    <a:camera prst="orthographicFront"/>
+    <a:lightRig rig="threePt" dir="t"/>
+  </dgm:scene3d>
+  <dgm:styleLbl name="node0">
+    <dgm:scene3d>
+      <a:camera prst="orthographicFront"/>
+      <a:lightRig rig="threePt" dir="t"/>
+    </dgm:scene3d>
+    <dgm:sp3d/>
+    <dgm:txPr/>
+    <dgm:style>
+      <a:lnRef idx="2">
+        <a:scrgbClr r="0" g="0" b="0"/>
+      </a:lnRef>
+      <a:fillRef idx="1">
+        <a:scrgbClr r="0" g="0" b="0"/>
+      </a:fillRef>
+      <a:effectRef idx="0">
+        <a:scrgbClr r="0" g="0" b="0"/>
+      </a:effectRef>
+      <a:fontRef idx="minor">
+        <a:schemeClr val="lt1"/>
+      </a:fontRef>
+    </dgm:style>
+  </dgm:styleLbl>
+  <dgm:styleLbl name="lnNode1">
+    <dgm:scene3d>
+      <a:camera prst="orthographicFront"/>
+      <a:lightRig rig="threePt" dir="t"/>
+    </dgm:scene3d>
+    <dgm:sp3d/>
+    <dgm:txPr/>
+    <dgm:style>
+      <a:lnRef idx="2">
+        <a:scrgbClr r="0" g="0" b="0"/>
+      </a:lnRef>
+      <a:fillRef idx="1">
+        <a:scrgbClr r="0" g="0" b="0"/>
+      </a:fillRef>
+      <a:effectRef idx="0">
+        <a:scrgbClr r="0" g="0" b="0"/>
+      </a:effectRef>
+      <a:fontRef idx="minor">
+        <a:schemeClr val="lt1"/>
+      </a:fontRef>
+    </dgm:style>
+  </dgm:styleLbl>
+  <dgm:styleLbl name="vennNode1">
+    <dgm:scene3d>
+      <a:camera prst="orthographicFront"/>
+      <a:lightRig rig="threePt" dir="t"/>
+    </dgm:scene3d>
+    <dgm:sp3d/>
+    <dgm:txPr/>
+    <dgm:style>
+      <a:lnRef idx="2">
+        <a:scrgbClr r="0" g="0" b="0"/>
+      </a:lnRef>
+      <a:fillRef idx="1">
+        <a:scrgbClr r="0" g="0" b="0"/>
+      </a:fillRef>
+      <a:effectRef idx="0">
+        <a:scrgbClr r="0" g="0" b="0"/>
+      </a:effectRef>
+      <a:fontRef idx="minor">
+        <a:schemeClr val="tx1"/>
+      </a:fontRef>
+    </dgm:style>
+  </dgm:styleLbl>
+  <dgm:styleLbl name="alignNode1">
+    <dgm:scene3d>
+      <a:camera prst="orthographicFront"/>
+      <a:lightRig rig="threePt" dir="t"/>
+    </dgm:scene3d>
+    <dgm:sp3d/>
+    <dgm:txPr/>
+    <dgm:style>
+      <a:lnRef idx="2">
+        <a:scrgbClr r="0" g="0" b="0"/>
+      </a:lnRef>
+      <a:fillRef idx="1">
+        <a:scrgbClr r="0" g="0" b="0"/>
+      </a:fillRef>
+      <a:effectRef idx="0">
+        <a:scrgbClr r="0" g="0" b="0"/>
+      </a:effectRef>
+      <a:fontRef idx="minor">
+        <a:schemeClr val="lt1"/>
+      </a:fontRef>
+    </dgm:style>
+  </dgm:styleLbl>
+  <dgm:styleLbl name="node1">
+    <dgm:scene3d>
+      <a:camera prst="orthographicFront"/>
+      <a:lightRig rig="threePt" dir="t"/>
+    </dgm:scene3d>
+    <dgm:sp3d/>
+    <dgm:txPr/>
+    <dgm:style>
+      <a:lnRef idx="2">
+        <a:scrgbClr r="0" g="0" b="0"/>
+      </a:lnRef>
+      <a:fillRef idx="1">
+        <a:scrgbClr r="0" g="0" b="0"/>
+      </a:fillRef>
+      <a:effectRef idx="0">
+        <a:scrgbClr r="0" g="0" b="0"/>
+      </a:effectRef>
+      <a:fontRef idx="minor">
+        <a:schemeClr val="lt1"/>
+      </a:fontRef>
+    </dgm:style>
+  </dgm:styleLbl>
+  <dgm:styleLbl name="node2">
+    <dgm:scene3d>
+      <a:camera prst="orthographicFront"/>
+      <a:lightRig rig="threePt" dir="t"/>
+    </dgm:scene3d>
+    <dgm:sp3d/>
+    <dgm:txPr/>
+    <dgm:style>
+      <a:lnRef idx="2">
+        <a:scrgbClr r="0" g="0" b="0"/>
+      </a:lnRef>
+      <a:fillRef idx="1">
+        <a:scrgbClr r="0" g="0" b="0"/>
+      </a:fillRef>
+      <a:effectRef idx="0">
+        <a:scrgbClr r="0" g="0" b="0"/>
+      </a:effectRef>
+      <a:fontRef idx="minor">
+        <a:schemeClr val="lt1"/>
+      </a:fontRef>
+    </dgm:style>
+  </dgm:styleLbl>
+  <dgm:styleLbl name="node3">
+    <dgm:scene3d>
+      <a:camera prst="orthographicFront"/>
+      <a:lightRig rig="threePt" dir="t"/>
+    </dgm:scene3d>
+    <dgm:sp3d/>
+    <dgm:txPr/>
+    <dgm:style>
+      <a:lnRef idx="2">
+        <a:scrgbClr r="0" g="0" b="0"/>
+      </a:lnRef>
+      <a:fillRef idx="1">
+        <a:scrgbClr r="0" g="0" b="0"/>
+      </a:fillRef>
+      <a:effectRef idx="0">
+        <a:scrgbClr r="0" g="0" b="0"/>
+      </a:effectRef>
+      <a:fontRef idx="minor">
+        <a:schemeClr val="lt1"/>
+      </a:fontRef>
+    </dgm:style>
+  </dgm:styleLbl>
+  <dgm:styleLbl name="node4">
+    <dgm:scene3d>
+      <a:camera prst="orthographicFront"/>
+      <a:lightRig rig="threePt" dir="t"/>
+    </dgm:scene3d>
+    <dgm:sp3d/>
+    <dgm:txPr/>
+    <dgm:style>
+      <a:lnRef idx="2">
+        <a:scrgbClr r="0" g="0" b="0"/>
+      </a:lnRef>
+      <a:fillRef idx="1">
+        <a:scrgbClr r="0" g="0" b="0"/>
+      </a:fillRef>
+      <a:effectRef idx="0">
+        <a:scrgbClr r="0" g="0" b="0"/>
+      </a:effectRef>
+      <a:fontRef idx="minor">
+        <a:schemeClr val="lt1"/>
+      </a:fontRef>
+    </dgm:style>
+  </dgm:styleLbl>
+  <dgm:styleLbl name="fgImgPlace1">
+    <dgm:scene3d>
+      <a:camera prst="orthographicFront"/>
+      <a:lightRig rig="threePt" dir="t"/>
+    </dgm:scene3d>
+    <dgm:sp3d/>
+    <dgm:txPr/>
+    <dgm:style>
+      <a:lnRef idx="2">
+        <a:scrgbClr r="0" g="0" b="0"/>
+      </a:lnRef>
+      <a:fillRef idx="1">
+        <a:scrgbClr r="0" g="0" b="0"/>
+      </a:fillRef>
+      <a:effectRef idx="0">
+        <a:scrgbClr r="0" g="0" b="0"/>
+      </a:effectRef>
+      <a:fontRef idx="minor"/>
+    </dgm:style>
+  </dgm:styleLbl>
+  <dgm:styleLbl name="alignImgPlace1">
+    <dgm:scene3d>
+      <a:camera prst="orthographicFront"/>
+      <a:lightRig rig="threePt" dir="t"/>
+    </dgm:scene3d>
+    <dgm:sp3d/>
+    <dgm:txPr/>
+    <dgm:style>
+      <a:lnRef idx="2">
+        <a:scrgbClr r="0" g="0" b="0"/>
+      </a:lnRef>
+      <a:fillRef idx="1">
+        <a:scrgbClr r="0" g="0" b="0"/>
+      </a:fillRef>
+      <a:effectRef idx="0">
+        <a:scrgbClr r="0" g="0" b="0"/>
+      </a:effectRef>
+      <a:fontRef idx="minor"/>
+    </dgm:style>
+  </dgm:styleLbl>
+  <dgm:styleLbl name="bgImgPlace1">
+    <dgm:scene3d>
+      <a:camera prst="orthographicFront"/>
+      <a:lightRig rig="threePt" dir="t"/>
+    </dgm:scene3d>
+    <dgm:sp3d/>
+    <dgm:txPr/>
+    <dgm:style>
+      <a:lnRef idx="2">
+        <a:scrgbClr r="0" g="0" b="0"/>
+      </a:lnRef>
+      <a:fillRef idx="1">
+        <a:scrgbClr r="0" g="0" b="0"/>
+      </a:fillRef>
+      <a:effectRef idx="0">
+        <a:scrgbClr r="0" g="0" b="0"/>
+      </a:effectRef>
+      <a:fontRef idx="minor"/>
+    </dgm:style>
+  </dgm:styleLbl>
+  <dgm:styleLbl name="sibTrans2D1">
+    <dgm:scene3d>
+      <a:camera prst="orthographicFront"/>
+      <a:lightRig rig="threePt" dir="t"/>
+    </dgm:scene3d>
+    <dgm:sp3d/>
+    <dgm:txPr/>
+    <dgm:style>
+      <a:lnRef idx="0">
+        <a:scrgbClr r="0" g="0" b="0"/>
+      </a:lnRef>
+      <a:fillRef idx="1">
+        <a:scrgbClr r="0" g="0" b="0"/>
+      </a:fillRef>
+      <a:effectRef idx="0">
+        <a:scrgbClr r="0" g="0" b="0"/>
+      </a:effectRef>
+      <a:fontRef idx="minor">
+        <a:schemeClr val="lt1"/>
+      </a:fontRef>
+    </dgm:style>
+  </dgm:styleLbl>
+  <dgm:styleLbl name="fgSibTrans2D1">
+    <dgm:scene3d>
+      <a:camera prst="orthographicFront"/>
+      <a:lightRig rig="threePt" dir="t"/>
+    </dgm:scene3d>
+    <dgm:sp3d/>
+    <dgm:txPr/>
+    <dgm:style>
+      <a:lnRef idx="0">
+        <a:scrgbClr r="0" g="0" b="0"/>
+      </a:lnRef>
+      <a:fillRef idx="1">
+        <a:scrgbClr r="0" g="0" b="0"/>
+      </a:fillRef>
+      <a:effectRef idx="0">
+        <a:scrgbClr r="0" g="0" b="0"/>
+      </a:effectRef>
+      <a:fontRef idx="minor">
+        <a:schemeClr val="lt1"/>
+      </a:fontRef>
+    </dgm:style>
+  </dgm:styleLbl>
+  <dgm:styleLbl name="bgSibTrans2D1">
+    <dgm:scene3d>
+      <a:camera prst="orthographicFront"/>
+      <a:lightRig rig="threePt" dir="t"/>
+    </dgm:scene3d>
+    <dgm:sp3d/>
+    <dgm:txPr/>
+    <dgm:style>
+      <a:lnRef idx="0">
+        <a:scrgbClr r="0" g="0" b="0"/>
+      </a:lnRef>
+      <a:fillRef idx="1">
+        <a:scrgbClr r="0" g="0" b="0"/>
+      </a:fillRef>
+      <a:effectRef idx="0">
+        <a:scrgbClr r="0" g="0" b="0"/>
+      </a:effectRef>
+      <a:fontRef idx="minor">
+        <a:schemeClr val="lt1"/>
+      </a:fontRef>
+    </dgm:style>
+  </dgm:styleLbl>
+  <dgm:styleLbl name="sibTrans1D1">
+    <dgm:scene3d>
+      <a:camera prst="orthographicFront"/>
+      <a:lightRig rig="threePt" dir="t"/>
+    </dgm:scene3d>
+    <dgm:sp3d/>
+    <dgm:txPr/>
+    <dgm:style>
+      <a:lnRef idx="1">
+        <a:scrgbClr r="0" g="0" b="0"/>
+      </a:lnRef>
+      <a:fillRef idx="0">
+        <a:scrgbClr r="0" g="0" b="0"/>
+      </a:fillRef>
+      <a:effectRef idx="0">
+        <a:scrgbClr r="0" g="0" b="0"/>
+      </a:effectRef>
+      <a:fontRef idx="minor"/>
+    </dgm:style>
+  </dgm:styleLbl>
+  <dgm:styleLbl name="callout">
+    <dgm:scene3d>
+      <a:camera prst="orthographicFront"/>
+      <a:lightRig rig="threePt" dir="t"/>
+    </dgm:scene3d>
+    <dgm:sp3d/>
+    <dgm:txPr/>
+    <dgm:style>
+      <a:lnRef idx="2">
+        <a:scrgbClr r="0" g="0" b="0"/>
+      </a:lnRef>
+      <a:fillRef idx="1">
+        <a:scrgbClr r="0" g="0" b="0"/>
+      </a:fillRef>
+      <a:effectRef idx="0">
+        <a:scrgbClr r="0" g="0" b="0"/>
+      </a:effectRef>
+      <a:fontRef idx="minor"/>
+    </dgm:style>
+  </dgm:styleLbl>
+  <dgm:styleLbl name="asst0">
+    <dgm:scene3d>
+      <a:camera prst="orthographicFront"/>
+      <a:lightRig rig="threePt" dir="t"/>
+    </dgm:scene3d>
+    <dgm:sp3d/>
+    <dgm:txPr/>
+    <dgm:style>
+      <a:lnRef idx="2">
+        <a:scrgbClr r="0" g="0" b="0"/>
+      </a:lnRef>
+      <a:fillRef idx="1">
+        <a:scrgbClr r="0" g="0" b="0"/>
+      </a:fillRef>
+      <a:effectRef idx="0">
+        <a:scrgbClr r="0" g="0" b="0"/>
+      </a:effectRef>
+      <a:fontRef idx="minor">
+        <a:schemeClr val="lt1"/>
+      </a:fontRef>
+    </dgm:style>
+  </dgm:styleLbl>
+  <dgm:styleLbl name="asst1">
+    <dgm:scene3d>
+      <a:camera prst="orthographicFront"/>
+      <a:lightRig rig="threePt" dir="t"/>
+    </dgm:scene3d>
+    <dgm:sp3d/>
+    <dgm:txPr/>
+    <dgm:style>
+      <a:lnRef idx="2">
+        <a:scrgbClr r="0" g="0" b="0"/>
+      </a:lnRef>
+      <a:fillRef idx="1">
+        <a:scrgbClr r="0" g="0" b="0"/>
+      </a:fillRef>
+      <a:effectRef idx="0">
+        <a:scrgbClr r="0" g="0" b="0"/>
+      </a:effectRef>
+      <a:fontRef idx="minor">
+        <a:schemeClr val="lt1"/>
+      </a:fontRef>
+    </dgm:style>
+  </dgm:styleLbl>
+  <dgm:styleLbl name="asst2">
+    <dgm:scene3d>
+      <a:camera prst="orthographicFront"/>
+      <a:lightRig rig="threePt" dir="t"/>
+    </dgm:scene3d>
+    <dgm:sp3d/>
+    <dgm:txPr/>
+    <dgm:style>
+      <a:lnRef idx="2">
+        <a:scrgbClr r="0" g="0" b="0"/>
+      </a:lnRef>
+      <a:fillRef idx="1">
+        <a:scrgbClr r="0" g="0" b="0"/>
+      </a:fillRef>
+      <a:effectRef idx="0">
+        <a:scrgbClr r="0" g="0" b="0"/>
+      </a:effectRef>
+      <a:fontRef idx="minor">
+        <a:schemeClr val="lt1"/>
+      </a:fontRef>
+    </dgm:style>
+  </dgm:styleLbl>
+  <dgm:styleLbl name="asst3">
+    <dgm:scene3d>
+      <a:camera prst="orthographicFront"/>
+      <a:lightRig rig="threePt" dir="t"/>
+    </dgm:scene3d>
+    <dgm:sp3d/>
+    <dgm:txPr/>
+    <dgm:style>
+      <a:lnRef idx="2">
+        <a:scrgbClr r="0" g="0" b="0"/>
+      </a:lnRef>
+      <a:fillRef idx="1">
+        <a:scrgbClr r="0" g="0" b="0"/>
+      </a:fillRef>
+      <a:effectRef idx="0">
+        <a:scrgbClr r="0" g="0" b="0"/>
+      </a:effectRef>
+      <a:fontRef idx="minor">
+        <a:schemeClr val="lt1"/>
+      </a:fontRef>
+    </dgm:style>
+  </dgm:styleLbl>
+  <dgm:styleLbl name="asst4">
+    <dgm:scene3d>
+      <a:camera prst="orthographicFront"/>
+      <a:lightRig rig="threePt" dir="t"/>
+    </dgm:scene3d>
+    <dgm:sp3d/>
+    <dgm:txPr/>
+    <dgm:style>
+      <a:lnRef idx="2">
+        <a:scrgbClr r="0" g="0" b="0"/>
+      </a:lnRef>
+      <a:fillRef idx="1">
+        <a:scrgbClr r="0" g="0" b="0"/>
+      </a:fillRef>
+      <a:effectRef idx="0">
+        <a:scrgbClr r="0" g="0" b="0"/>
+      </a:effectRef>
+      <a:fontRef idx="minor">
+        <a:schemeClr val="lt1"/>
+      </a:fontRef>
+    </dgm:style>
+  </dgm:styleLbl>
+  <dgm:styleLbl name="parChTrans2D1">
+    <dgm:scene3d>
+      <a:camera prst="orthographicFront"/>
+      <a:lightRig rig="threePt" dir="t"/>
+    </dgm:scene3d>
+    <dgm:sp3d/>
+    <dgm:txPr/>
+    <dgm:style>
+      <a:lnRef idx="2">
+        <a:scrgbClr r="0" g="0" b="0"/>
+      </a:lnRef>
+      <a:fillRef idx="1">
+        <a:scrgbClr r="0" g="0" b="0"/>
+      </a:fillRef>
+      <a:effectRef idx="0">
+        <a:scrgbClr r="0" g="0" b="0"/>
+      </a:effectRef>
+      <a:fontRef idx="minor">
+        <a:schemeClr val="lt1"/>
+      </a:fontRef>
+    </dgm:style>
+  </dgm:styleLbl>
+  <dgm:styleLbl name="parChTrans2D2">
+    <dgm:scene3d>
+      <a:camera prst="orthographicFront"/>
+      <a:lightRig rig="threePt" dir="t"/>
+    </dgm:scene3d>
+    <dgm:sp3d/>
+    <dgm:txPr/>
+    <dgm:style>
+      <a:lnRef idx="2">
+        <a:scrgbClr r="0" g="0" b="0"/>
+      </a:lnRef>
+      <a:fillRef idx="1">
+        <a:scrgbClr r="0" g="0" b="0"/>
+      </a:fillRef>
+      <a:effectRef idx="0">
+        <a:scrgbClr r="0" g="0" b="0"/>
+      </a:effectRef>
+      <a:fontRef idx="minor">
+        <a:schemeClr val="lt1"/>
+      </a:fontRef>
+    </dgm:style>
+  </dgm:styleLbl>
+  <dgm:styleLbl name="parChTrans2D3">
+    <dgm:scene3d>
+      <a:camera prst="orthographicFront"/>
+      <a:lightRig rig="threePt" dir="t"/>
+    </dgm:scene3d>
+    <dgm:sp3d/>
+    <dgm:txPr/>
+    <dgm:style>
+      <a:lnRef idx="2">
+        <a:scrgbClr r="0" g="0" b="0"/>
+      </a:lnRef>
+      <a:fillRef idx="1">
+        <a:scrgbClr r="0" g="0" b="0"/>
+      </a:fillRef>
+      <a:effectRef idx="0">
+        <a:scrgbClr r="0" g="0" b="0"/>
+      </a:effectRef>
+      <a:fontRef idx="minor">
+        <a:schemeClr val="lt1"/>
+      </a:fontRef>
+    </dgm:style>
+  </dgm:styleLbl>
+  <dgm:styleLbl name="parChTrans2D4">
+    <dgm:scene3d>
+      <a:camera prst="orthographicFront"/>
+      <a:lightRig rig="threePt" dir="t"/>
+    </dgm:scene3d>
+    <dgm:sp3d/>
+    <dgm:txPr/>
+    <dgm:style>
+      <a:lnRef idx="2">
+        <a:scrgbClr r="0" g="0" b="0"/>
+      </a:lnRef>
+      <a:fillRef idx="1">
+        <a:scrgbClr r="0" g="0" b="0"/>
+      </a:fillRef>
+      <a:effectRef idx="0">
+        <a:scrgbClr r="0" g="0" b="0"/>
+      </a:effectRef>
+      <a:fontRef idx="minor">
+        <a:schemeClr val="lt1"/>
+      </a:fontRef>
+    </dgm:style>
+  </dgm:styleLbl>
+  <dgm:styleLbl name="parChTrans1D1">
+    <dgm:scene3d>
+      <a:camera prst="orthographicFront"/>
+      <a:lightRig rig="threePt" dir="t"/>
+    </dgm:scene3d>
+    <dgm:sp3d/>
+    <dgm:txPr/>
+    <dgm:style>
+      <a:lnRef idx="2">
+        <a:scrgbClr r="0" g="0" b="0"/>
+      </a:lnRef>
+      <a:fillRef idx="0">
+        <a:scrgbClr r="0" g="0" b="0"/>
+      </a:fillRef>
+      <a:effectRef idx="0">
+        <a:scrgbClr r="0" g="0" b="0"/>
+      </a:effectRef>
+      <a:fontRef idx="minor"/>
+    </dgm:style>
+  </dgm:styleLbl>
+  <dgm:styleLbl name="parChTrans1D2">
+    <dgm:scene3d>
+      <a:camera prst="orthographicFront"/>
+      <a:lightRig rig="threePt" dir="t"/>
+    </dgm:scene3d>
+    <dgm:sp3d/>
+    <dgm:txPr/>
+    <dgm:style>
+      <a:lnRef idx="2">
+        <a:scrgbClr r="0" g="0" b="0"/>
+      </a:lnRef>
+      <a:fillRef idx="0">
+        <a:scrgbClr r="0" g="0" b="0"/>
+      </a:fillRef>
+      <a:effectRef idx="0">
+        <a:scrgbClr r="0" g="0" b="0"/>
+      </a:effectRef>
+      <a:fontRef idx="minor"/>
+    </dgm:style>
+  </dgm:styleLbl>
+  <dgm:styleLbl name="parChTrans1D3">
+    <dgm:scene3d>
+      <a:camera prst="orthographicFront"/>
+      <a:lightRig rig="threePt" dir="t"/>
+    </dgm:scene3d>
+    <dgm:sp3d/>
+    <dgm:txPr/>
+    <dgm:style>
+      <a:lnRef idx="2">
+        <a:scrgbClr r="0" g="0" b="0"/>
+      </a:lnRef>
+      <a:fillRef idx="0">
+        <a:scrgbClr r="0" g="0" b="0"/>
+      </a:fillRef>
+      <a:effectRef idx="0">
+        <a:scrgbClr r="0" g="0" b="0"/>
+      </a:effectRef>
+      <a:fontRef idx="minor"/>
+    </dgm:style>
+  </dgm:styleLbl>
+  <dgm:styleLbl name="parChTrans1D4">
+    <dgm:scene3d>
+      <a:camera prst="orthographicFront"/>
+      <a:lightRig rig="threePt" dir="t"/>
+    </dgm:scene3d>
+    <dgm:sp3d/>
+    <dgm:txPr/>
+    <dgm:style>
+      <a:lnRef idx="2">
+        <a:scrgbClr r="0" g="0" b="0"/>
+      </a:lnRef>
+      <a:fillRef idx="0">
+        <a:scrgbClr r="0" g="0" b="0"/>
+      </a:fillRef>
+      <a:effectRef idx="0">
+        <a:scrgbClr r="0" g="0" b="0"/>
+      </a:effectRef>
+      <a:fontRef idx="minor"/>
+    </dgm:style>
+  </dgm:styleLbl>
+  <dgm:styleLbl name="fgAcc1">
+    <dgm:scene3d>
+      <a:camera prst="orthographicFront"/>
+      <a:lightRig rig="threePt" dir="t"/>
+    </dgm:scene3d>
+    <dgm:sp3d/>
+    <dgm:txPr/>
+    <dgm:style>
+      <a:lnRef idx="2">
+        <a:scrgbClr r="0" g="0" b="0"/>
+      </a:lnRef>
+      <a:fillRef idx="1">
+        <a:scrgbClr r="0" g="0" b="0"/>
+      </a:fillRef>
+      <a:effectRef idx="0">
+        <a:scrgbClr r="0" g="0" b="0"/>
+      </a:effectRef>
+      <a:fontRef idx="minor"/>
+    </dgm:style>
+  </dgm:styleLbl>
+  <dgm:styleLbl name="conFgAcc1">
+    <dgm:scene3d>
+      <a:camera prst="orthographicFront"/>
+      <a:lightRig rig="threePt" dir="t"/>
+    </dgm:scene3d>
+    <dgm:sp3d/>
+    <dgm:txPr/>
+    <dgm:style>
+      <a:lnRef idx="2">
+        <a:scrgbClr r="0" g="0" b="0"/>
+      </a:lnRef>
+      <a:fillRef idx="1">
+        <a:scrgbClr r="0" g="0" b="0"/>
+      </a:fillRef>
+      <a:effectRef idx="0">
+        <a:scrgbClr r="0" g="0" b="0"/>
+      </a:effectRef>
+      <a:fontRef idx="minor"/>
+    </dgm:style>
+  </dgm:styleLbl>
+  <dgm:styleLbl name="alignAcc1">
+    <dgm:scene3d>
+      <a:camera prst="orthographicFront"/>
+      <a:lightRig rig="threePt" dir="t"/>
+    </dgm:scene3d>
+    <dgm:sp3d/>
+    <dgm:txPr/>
+    <dgm:style>
+      <a:lnRef idx="2">
+        <a:scrgbClr r="0" g="0" b="0"/>
+      </a:lnRef>
+      <a:fillRef idx="1">
+        <a:scrgbClr r="0" g="0" b="0"/>
+      </a:fillRef>
+      <a:effectRef idx="0">
+        <a:scrgbClr r="0" g="0" b="0"/>
+      </a:effectRef>
+      <a:fontRef idx="minor"/>
+    </dgm:style>
+  </dgm:styleLbl>
+  <dgm:styleLbl name="trAlignAcc1">
+    <dgm:scene3d>
+      <a:camera prst="orthographicFront"/>
+      <a:lightRig rig="threePt" dir="t"/>
+    </dgm:scene3d>
+    <dgm:sp3d/>
+    <dgm:txPr/>
+    <dgm:style>
+      <a:lnRef idx="1">
+        <a:scrgbClr r="0" g="0" b="0"/>
+      </a:lnRef>
+      <a:fillRef idx="1">
+        <a:scrgbClr r="0" g="0" b="0"/>
+      </a:fillRef>
+      <a:effectRef idx="0">
+        <a:scrgbClr r="0" g="0" b="0"/>
+      </a:effectRef>
+      <a:fontRef idx="minor"/>
+    </dgm:style>
+  </dgm:styleLbl>
+  <dgm:styleLbl name="bgAcc1">
+    <dgm:scene3d>
+      <a:camera prst="orthographicFront"/>
+      <a:lightRig rig="threePt" dir="t"/>
+    </dgm:scene3d>
+    <dgm:sp3d/>
+    <dgm:txPr/>
+    <dgm:style>
+      <a:lnRef idx="2">
+        <a:scrgbClr r="0" g="0" b="0"/>
+      </a:lnRef>
+      <a:fillRef idx="1">
+        <a:scrgbClr r="0" g="0" b="0"/>
+      </a:fillRef>
+      <a:effectRef idx="0">
+        <a:scrgbClr r="0" g="0" b="0"/>
+      </a:effectRef>
+      <a:fontRef idx="minor"/>
+    </dgm:style>
+  </dgm:styleLbl>
+  <dgm:styleLbl name="solidFgAcc1">
+    <dgm:scene3d>
+      <a:camera prst="orthographicFront"/>
+      <a:lightRig rig="threePt" dir="t"/>
+    </dgm:scene3d>
+    <dgm:sp3d/>
+    <dgm:txPr/>
+    <dgm:style>
+      <a:lnRef idx="2">
+        <a:scrgbClr r="0" g="0" b="0"/>
+      </a:lnRef>
+      <a:fillRef idx="1">
+        <a:scrgbClr r="0" g="0" b="0"/>
+      </a:fillRef>
+      <a:effectRef idx="0">
+        <a:scrgbClr r="0" g="0" b="0"/>
+      </a:effectRef>
+      <a:fontRef idx="minor"/>
+    </dgm:style>
+  </dgm:styleLbl>
+  <dgm:styleLbl name="solidAlignAcc1">
+    <dgm:scene3d>
+      <a:camera prst="orthographicFront"/>
+      <a:lightRig rig="threePt" dir="t"/>
+    </dgm:scene3d>
+    <dgm:sp3d/>
+    <dgm:txPr/>
+    <dgm:style>
+      <a:lnRef idx="2">
+        <a:scrgbClr r="0" g="0" b="0"/>
+      </a:lnRef>
+      <a:fillRef idx="1">
+        <a:scrgbClr r="0" g="0" b="0"/>
+      </a:fillRef>
+      <a:effectRef idx="0">
+        <a:scrgbClr r="0" g="0" b="0"/>
+      </a:effectRef>
+      <a:fontRef idx="minor"/>
+    </dgm:style>
+  </dgm:styleLbl>
+  <dgm:styleLbl name="solidBgAcc1">
+    <dgm:scene3d>
+      <a:camera prst="orthographicFront"/>
+      <a:lightRig rig="threePt" dir="t"/>
+    </dgm:scene3d>
+    <dgm:sp3d/>
+    <dgm:txPr/>
+    <dgm:style>
+      <a:lnRef idx="2">
+        <a:scrgbClr r="0" g="0" b="0"/>
+      </a:lnRef>
+      <a:fillRef idx="1">
+        <a:scrgbClr r="0" g="0" b="0"/>
+      </a:fillRef>
+      <a:effectRef idx="0">
+        <a:scrgbClr r="0" g="0" b="0"/>
+      </a:effectRef>
+      <a:fontRef idx="minor"/>
+    </dgm:style>
+  </dgm:styleLbl>
+  <dgm:styleLbl name="fgAccFollowNode1">
+    <dgm:scene3d>
+      <a:camera prst="orthographicFront"/>
+      <a:lightRig rig="threePt" dir="t"/>
+    </dgm:scene3d>
+    <dgm:sp3d/>
+    <dgm:txPr/>
+    <dgm:style>
+      <a:lnRef idx="2">
+        <a:scrgbClr r="0" g="0" b="0"/>
+      </a:lnRef>
+      <a:fillRef idx="1">
+        <a:scrgbClr r="0" g="0" b="0"/>
+      </a:fillRef>
+      <a:effectRef idx="0">
+        <a:scrgbClr r="0" g="0" b="0"/>
+      </a:effectRef>
+      <a:fontRef idx="minor"/>
+    </dgm:style>
+  </dgm:styleLbl>
+  <dgm:styleLbl name="alignAccFollowNode1">
+    <dgm:scene3d>
+      <a:camera prst="orthographicFront"/>
+      <a:lightRig rig="threePt" dir="t"/>
+    </dgm:scene3d>
+    <dgm:sp3d/>
+    <dgm:txPr/>
+    <dgm:style>
+      <a:lnRef idx="2">
+        <a:scrgbClr r="0" g="0" b="0"/>
+      </a:lnRef>
+      <a:fillRef idx="1">
+        <a:scrgbClr r="0" g="0" b="0"/>
+      </a:fillRef>
+      <a:effectRef idx="0">
+        <a:scrgbClr r="0" g="0" b="0"/>
+      </a:effectRef>
+      <a:fontRef idx="minor"/>
+    </dgm:style>
+  </dgm:styleLbl>
+  <dgm:styleLbl name="bgAccFollowNode1">
+    <dgm:scene3d>
+      <a:camera prst="orthographicFront"/>
+      <a:lightRig rig="threePt" dir="t"/>
+    </dgm:scene3d>
+    <dgm:sp3d/>
+    <dgm:txPr/>
+    <dgm:style>
+      <a:lnRef idx="2">
+        <a:scrgbClr r="0" g="0" b="0"/>
+      </a:lnRef>
+      <a:fillRef idx="1">
+        <a:scrgbClr r="0" g="0" b="0"/>
+      </a:fillRef>
+      <a:effectRef idx="0">
+        <a:scrgbClr r="0" g="0" b="0"/>
+      </a:effectRef>
+      <a:fontRef idx="minor"/>
+    </dgm:style>
+  </dgm:styleLbl>
+  <dgm:styleLbl name="fgAcc0">
+    <dgm:scene3d>
+      <a:camera prst="orthographicFront"/>
+      <a:lightRig rig="threePt" dir="t"/>
+    </dgm:scene3d>
+    <dgm:sp3d/>
+    <dgm:txPr/>
+    <dgm:style>
+      <a:lnRef idx="2">
+        <a:scrgbClr r="0" g="0" b="0"/>
+      </a:lnRef>
+      <a:fillRef idx="1">
+        <a:scrgbClr r="0" g="0" b="0"/>
+      </a:fillRef>
+      <a:effectRef idx="0">
+        <a:scrgbClr r="0" g="0" b="0"/>
+      </a:effectRef>
+      <a:fontRef idx="minor"/>
+    </dgm:style>
+  </dgm:styleLbl>
+  <dgm:styleLbl name="fgAcc2">
+    <dgm:scene3d>
+      <a:camera prst="orthographicFront"/>
+      <a:lightRig rig="threePt" dir="t"/>
+    </dgm:scene3d>
+    <dgm:sp3d/>
+    <dgm:txPr/>
+    <dgm:style>
+      <a:lnRef idx="2">
+        <a:scrgbClr r="0" g="0" b="0"/>
+      </a:lnRef>
+      <a:fillRef idx="1">
+        <a:scrgbClr r="0" g="0" b="0"/>
+      </a:fillRef>
+      <a:effectRef idx="0">
+        <a:scrgbClr r="0" g="0" b="0"/>
+      </a:effectRef>
+      <a:fontRef idx="minor"/>
+    </dgm:style>
+  </dgm:styleLbl>
+  <dgm:styleLbl name="fgAcc3">
+    <dgm:scene3d>
+      <a:camera prst="orthographicFront"/>
+      <a:lightRig rig="threePt" dir="t"/>
+    </dgm:scene3d>
+    <dgm:sp3d/>
+    <dgm:txPr/>
+    <dgm:style>
+      <a:lnRef idx="2">
+        <a:scrgbClr r="0" g="0" b="0"/>
+      </a:lnRef>
+      <a:fillRef idx="1">
+        <a:scrgbClr r="0" g="0" b="0"/>
+      </a:fillRef>
+      <a:effectRef idx="0">
+        <a:scrgbClr r="0" g="0" b="0"/>
+      </a:effectRef>
+      <a:fontRef idx="minor"/>
+    </dgm:style>
+  </dgm:styleLbl>
+  <dgm:styleLbl name="fgAcc4">
+    <dgm:scene3d>
+      <a:camera prst="orthographicFront"/>
+      <a:lightRig rig="threePt" dir="t"/>
+    </dgm:scene3d>
+    <dgm:sp3d/>
+    <dgm:txPr/>
+    <dgm:style>
+      <a:lnRef idx="2">
+        <a:scrgbClr r="0" g="0" b="0"/>
+      </a:lnRef>
+      <a:fillRef idx="1">
+        <a:scrgbClr r="0" g="0" b="0"/>
+      </a:fillRef>
+      <a:effectRef idx="0">
+        <a:scrgbClr r="0" g="0" b="0"/>
+      </a:effectRef>
+      <a:fontRef idx="minor"/>
+    </dgm:style>
+  </dgm:styleLbl>
+  <dgm:styleLbl name="bgShp">
+    <dgm:scene3d>
+      <a:camera prst="orthographicFront"/>
+      <a:lightRig rig="threePt" dir="t"/>
+    </dgm:scene3d>
+    <dgm:sp3d/>
+    <dgm:txPr/>
+    <dgm:style>
+      <a:lnRef idx="0">
+        <a:scrgbClr r="0" g="0" b="0"/>
+      </a:lnRef>
+      <a:fillRef idx="1">
+        <a:scrgbClr r="0" g="0" b="0"/>
+      </a:fillRef>
+      <a:effectRef idx="0">
+        <a:scrgbClr r="0" g="0" b="0"/>
+      </a:effectRef>
+      <a:fontRef idx="minor"/>
+    </dgm:style>
+  </dgm:styleLbl>
+  <dgm:styleLbl name="dkBgShp">
+    <dgm:scene3d>
+      <a:camera prst="orthographicFront"/>
+      <a:lightRig rig="threePt" dir="t"/>
+    </dgm:scene3d>
+    <dgm:sp3d/>
+    <dgm:txPr/>
+    <dgm:style>
+      <a:lnRef idx="0">
+        <a:scrgbClr r="0" g="0" b="0"/>
+      </a:lnRef>
+      <a:fillRef idx="1">
+        <a:scrgbClr r="0" g="0" b="0"/>
+      </a:fillRef>
+      <a:effectRef idx="0">
+        <a:scrgbClr r="0" g="0" b="0"/>
+      </a:effectRef>
+      <a:fontRef idx="minor"/>
+    </dgm:style>
+  </dgm:styleLbl>
+  <dgm:styleLbl name="trBgShp">
+    <dgm:scene3d>
+      <a:camera prst="orthographicFront"/>
+      <a:lightRig rig="threePt" dir="t"/>
+    </dgm:scene3d>
+    <dgm:sp3d/>
+    <dgm:txPr/>
+    <dgm:style>
+      <a:lnRef idx="0">
+        <a:scrgbClr r="0" g="0" b="0"/>
+      </a:lnRef>
+      <a:fillRef idx="1">
+        <a:scrgbClr r="0" g="0" b="0"/>
+      </a:fillRef>
+      <a:effectRef idx="0">
+        <a:scrgbClr r="0" g="0" b="0"/>
+      </a:effectRef>
+      <a:fontRef idx="minor"/>
+    </dgm:style>
+  </dgm:styleLbl>
+  <dgm:styleLbl name="fgShp">
+    <dgm:scene3d>
+      <a:camera prst="orthographicFront"/>
+      <a:lightRig rig="threePt" dir="t"/>
+    </dgm:scene3d>
+    <dgm:sp3d/>
+    <dgm:txPr/>
+    <dgm:style>
+      <a:lnRef idx="2">
+        <a:scrgbClr r="0" g="0" b="0"/>
+      </a:lnRef>
+      <a:fillRef idx="1">
+        <a:scrgbClr r="0" g="0" b="0"/>
+      </a:fillRef>
+      <a:effectRef idx="0">
+        <a:scrgbClr r="0" g="0" b="0"/>
+      </a:effectRef>
+      <a:fontRef idx="minor"/>
+    </dgm:style>
+  </dgm:styleLbl>
+  <dgm:styleLbl name="revTx">
+    <dgm:scene3d>
+      <a:camera prst="orthographicFront"/>
+      <a:lightRig rig="threePt" dir="t"/>
+    </dgm:scene3d>
+    <dgm:sp3d/>
+    <dgm:txPr/>
+    <dgm:style>
+      <a:lnRef idx="0">
+        <a:scrgbClr r="0" g="0" b="0"/>
+      </a:lnRef>
+      <a:fillRef idx="0">
+        <a:scrgbClr r="0" g="0" b="0"/>
+      </a:fillRef>
+      <a:effectRef idx="0">
+        <a:scrgbClr r="0" g="0" b="0"/>
+      </a:effectRef>
+      <a:fontRef idx="minor"/>
+    </dgm:style>
+  </dgm:styleLbl>
+</dgm:styleDef>
+</file>
+
 <file path=ppt/slideLayouts/slideLayout1.xml><?xml version="1.0" encoding="utf-8"?>
 <p:sldLayout xmlns:a="http://schemas.openxmlformats.org/drawingml/2006/main" xmlns:r="http://schemas.openxmlformats.org/officeDocument/2006/relationships" xmlns:p="http://schemas.openxmlformats.org/presentationml/2006/main" type="title" preserve="1">
   <p:cSld name="Title Slide">
@@ -405,7 +2830,7 @@
           <a:p>
             <a:fld id="{E80C50CD-E178-4744-9B35-B2F624D6C5E9}" type="datetimeFigureOut">
               <a:rPr lang="en-US" smtClean="0"/>
-              <a:t>6/18/2026</a:t>
+              <a:t>6/19/2026</a:t>
             </a:fld>
             <a:endParaRPr lang="en-US"/>
           </a:p>
@@ -603,7 +3028,7 @@
           <a:p>
             <a:fld id="{E80C50CD-E178-4744-9B35-B2F624D6C5E9}" type="datetimeFigureOut">
               <a:rPr lang="en-US" smtClean="0"/>
-              <a:t>6/18/2026</a:t>
+              <a:t>6/19/2026</a:t>
             </a:fld>
             <a:endParaRPr lang="en-US"/>
           </a:p>
@@ -811,7 +3236,7 @@
           <a:p>
             <a:fld id="{E80C50CD-E178-4744-9B35-B2F624D6C5E9}" type="datetimeFigureOut">
               <a:rPr lang="en-US" smtClean="0"/>
-              <a:t>6/18/2026</a:t>
+              <a:t>6/19/2026</a:t>
             </a:fld>
             <a:endParaRPr lang="en-US"/>
           </a:p>
@@ -1061,7 +3486,7 @@
           <a:p>
             <a:fld id="{E80C50CD-E178-4744-9B35-B2F624D6C5E9}" type="datetimeFigureOut">
               <a:rPr lang="en-US" smtClean="0"/>
-              <a:t>6/18/2026</a:t>
+              <a:t>6/19/2026</a:t>
             </a:fld>
             <a:endParaRPr lang="en-US"/>
           </a:p>
@@ -1340,7 +3765,7 @@
           <a:p>
             <a:fld id="{E80C50CD-E178-4744-9B35-B2F624D6C5E9}" type="datetimeFigureOut">
               <a:rPr lang="en-US" smtClean="0"/>
-              <a:t>6/18/2026</a:t>
+              <a:t>6/19/2026</a:t>
             </a:fld>
             <a:endParaRPr lang="en-US"/>
           </a:p>
@@ -1657,7 +4082,7 @@
           <a:p>
             <a:fld id="{E80C50CD-E178-4744-9B35-B2F624D6C5E9}" type="datetimeFigureOut">
               <a:rPr lang="en-US" smtClean="0"/>
-              <a:t>6/18/2026</a:t>
+              <a:t>6/19/2026</a:t>
             </a:fld>
             <a:endParaRPr lang="en-US"/>
           </a:p>
@@ -2073,7 +4498,7 @@
           <a:p>
             <a:fld id="{E80C50CD-E178-4744-9B35-B2F624D6C5E9}" type="datetimeFigureOut">
               <a:rPr lang="en-US" smtClean="0"/>
-              <a:t>6/18/2026</a:t>
+              <a:t>6/19/2026</a:t>
             </a:fld>
             <a:endParaRPr lang="en-US"/>
           </a:p>
@@ -2214,7 +4639,7 @@
           <a:p>
             <a:fld id="{E80C50CD-E178-4744-9B35-B2F624D6C5E9}" type="datetimeFigureOut">
               <a:rPr lang="en-US" smtClean="0"/>
-              <a:t>6/18/2026</a:t>
+              <a:t>6/19/2026</a:t>
             </a:fld>
             <a:endParaRPr lang="en-US"/>
           </a:p>
@@ -2327,7 +4752,7 @@
           <a:p>
             <a:fld id="{E80C50CD-E178-4744-9B35-B2F624D6C5E9}" type="datetimeFigureOut">
               <a:rPr lang="en-US" smtClean="0"/>
-              <a:t>6/18/2026</a:t>
+              <a:t>6/19/2026</a:t>
             </a:fld>
             <a:endParaRPr lang="en-US"/>
           </a:p>
@@ -2644,7 +5069,7 @@
           <a:p>
             <a:fld id="{E80C50CD-E178-4744-9B35-B2F624D6C5E9}" type="datetimeFigureOut">
               <a:rPr lang="en-US" smtClean="0"/>
-              <a:t>6/18/2026</a:t>
+              <a:t>6/19/2026</a:t>
             </a:fld>
             <a:endParaRPr lang="en-US"/>
           </a:p>
@@ -2936,7 +5361,7 @@
           <a:p>
             <a:fld id="{E80C50CD-E178-4744-9B35-B2F624D6C5E9}" type="datetimeFigureOut">
               <a:rPr lang="en-US" smtClean="0"/>
-              <a:t>6/18/2026</a:t>
+              <a:t>6/19/2026</a:t>
             </a:fld>
             <a:endParaRPr lang="en-US"/>
           </a:p>
@@ -3176,7 +5601,7 @@
             <a:fld id="{E80C50CD-E178-4744-9B35-B2F624D6C5E9}" type="datetimeFigureOut">
               <a:rPr lang="en-US" smtClean="0"/>
               <a:pPr/>
-              <a:t>6/18/2026</a:t>
+              <a:t>6/19/2026</a:t>
             </a:fld>
             <a:endParaRPr lang="en-US"/>
           </a:p>
@@ -4834,6 +7259,14 @@
 <file path=ppt/slides/slide2.xml><?xml version="1.0" encoding="utf-8"?>
 <p:sld xmlns:a="http://schemas.openxmlformats.org/drawingml/2006/main" xmlns:r="http://schemas.openxmlformats.org/officeDocument/2006/relationships" xmlns:p="http://schemas.openxmlformats.org/presentationml/2006/main">
   <p:cSld>
+    <p:bg>
+      <p:bgPr>
+        <a:solidFill>
+          <a:schemeClr val="bg1"/>
+        </a:solidFill>
+        <a:effectLst/>
+      </p:bgPr>
+    </p:bg>
     <p:spTree>
       <p:nvGrpSpPr>
         <p:cNvPr id="1" name=""/>
@@ -4848,6 +7281,95 @@
           <a:chExt cx="0" cy="0"/>
         </a:xfrm>
       </p:grpSpPr>
+      <p:sp useBgFill="1">
+        <p:nvSpPr>
+          <p:cNvPr id="13" name="Rectangle 12">
+            <a:extLst>
+              <a:ext uri="{FF2B5EF4-FFF2-40B4-BE49-F238E27FC236}">
+                <a16:creationId xmlns:a16="http://schemas.microsoft.com/office/drawing/2014/main" id="{34C0330F-1D4F-4552-B799-615DD237B6DE}"/>
+              </a:ext>
+              <a:ext uri="{C183D7F6-B498-43B3-948B-1728B52AA6E4}">
+                <adec:decorative xmlns:adec="http://schemas.microsoft.com/office/drawing/2017/decorative" val="1"/>
+              </a:ext>
+            </a:extLst>
+          </p:cNvPr>
+          <p:cNvSpPr>
+            <a:spLocks noGrp="1" noRot="1" noChangeAspect="1" noMove="1" noResize="1" noEditPoints="1" noAdjustHandles="1" noChangeArrowheads="1" noChangeShapeType="1" noTextEdit="1"/>
+          </p:cNvSpPr>
+          <p:nvPr>
+            <p:extLst>
+              <p:ext uri="{386F3935-93C4-4BCD-93E2-E3B085C9AB24}">
+                <p16:designElem xmlns:p16="http://schemas.microsoft.com/office/powerpoint/2015/main" val="1"/>
+              </p:ext>
+            </p:extLst>
+          </p:nvPr>
+        </p:nvSpPr>
+        <p:spPr>
+          <a:xfrm>
+            <a:off x="0" y="0"/>
+            <a:ext cx="12188952" cy="6857995"/>
+          </a:xfrm>
+          <a:prstGeom prst="rect">
+            <a:avLst/>
+          </a:prstGeom>
+          <a:ln>
+            <a:noFill/>
+          </a:ln>
+        </p:spPr>
+        <p:style>
+          <a:lnRef idx="2">
+            <a:schemeClr val="accent1">
+              <a:shade val="50000"/>
+            </a:schemeClr>
+          </a:lnRef>
+          <a:fillRef idx="1">
+            <a:schemeClr val="accent1"/>
+          </a:fillRef>
+          <a:effectRef idx="0">
+            <a:schemeClr val="accent1"/>
+          </a:effectRef>
+          <a:fontRef idx="minor">
+            <a:schemeClr val="lt1"/>
+          </a:fontRef>
+        </p:style>
+        <p:txBody>
+          <a:bodyPr rtlCol="0" anchor="ctr"/>
+          <a:lstStyle/>
+          <a:p>
+            <a:pPr marL="0" marR="0" lvl="0" indent="0" algn="ctr" defTabSz="914400" rtl="0" eaLnBrk="1" fontAlgn="auto" latinLnBrk="0" hangingPunct="1">
+              <a:lnSpc>
+                <a:spcPct val="100000"/>
+              </a:lnSpc>
+              <a:spcBef>
+                <a:spcPts val="0"/>
+              </a:spcBef>
+              <a:spcAft>
+                <a:spcPts val="0"/>
+              </a:spcAft>
+              <a:buClrTx/>
+              <a:buSzTx/>
+              <a:buFontTx/>
+              <a:buNone/>
+              <a:tabLst/>
+              <a:defRPr/>
+            </a:pPr>
+            <a:endParaRPr kumimoji="0" lang="en-US" sz="1800" b="0" i="0" u="none" strike="noStrike" kern="1200" cap="none" spc="0" normalizeH="0" baseline="0" noProof="0" dirty="0">
+              <a:ln>
+                <a:noFill/>
+              </a:ln>
+              <a:solidFill>
+                <a:prstClr val="white"/>
+              </a:solidFill>
+              <a:effectLst/>
+              <a:uLnTx/>
+              <a:uFillTx/>
+              <a:latin typeface="Bierstadt"/>
+              <a:ea typeface="+mn-ea"/>
+              <a:cs typeface="+mn-cs"/>
+            </a:endParaRPr>
+          </a:p>
+        </p:txBody>
+      </p:sp>
       <p:sp>
         <p:nvSpPr>
           <p:cNvPr id="2" name="Titre 1">
@@ -4864,15 +7386,115 @@
             <p:ph type="title"/>
           </p:nvPr>
         </p:nvSpPr>
-        <p:spPr/>
-        <p:txBody>
-          <a:bodyPr/>
+        <p:spPr>
+          <a:xfrm>
+            <a:off x="521208" y="978408"/>
+            <a:ext cx="4754880" cy="1463040"/>
+          </a:xfrm>
+        </p:spPr>
+        <p:txBody>
+          <a:bodyPr>
+            <a:normAutofit/>
+          </a:bodyPr>
           <a:lstStyle/>
           <a:p>
             <a:r>
-              <a:rPr lang="fr-CH" dirty="0"/>
+              <a:rPr lang="fr-CH"/>
               <a:t>Buzzer</a:t>
             </a:r>
+            <a:endParaRPr lang="fr-CH" dirty="0"/>
+          </a:p>
+        </p:txBody>
+      </p:sp>
+      <p:sp>
+        <p:nvSpPr>
+          <p:cNvPr id="14" name="Rectangle 13">
+            <a:extLst>
+              <a:ext uri="{FF2B5EF4-FFF2-40B4-BE49-F238E27FC236}">
+                <a16:creationId xmlns:a16="http://schemas.microsoft.com/office/drawing/2014/main" id="{92BE0106-0C20-465B-A1BE-0BAC2737B1AD}"/>
+              </a:ext>
+              <a:ext uri="{C183D7F6-B498-43B3-948B-1728B52AA6E4}">
+                <adec:decorative xmlns:adec="http://schemas.microsoft.com/office/drawing/2017/decorative" val="1"/>
+              </a:ext>
+            </a:extLst>
+          </p:cNvPr>
+          <p:cNvSpPr>
+            <a:spLocks noGrp="1" noRot="1" noChangeAspect="1" noMove="1" noResize="1" noEditPoints="1" noAdjustHandles="1" noChangeArrowheads="1" noChangeShapeType="1" noTextEdit="1"/>
+          </p:cNvSpPr>
+          <p:nvPr>
+            <p:extLst>
+              <p:ext uri="{386F3935-93C4-4BCD-93E2-E3B085C9AB24}">
+                <p16:designElem xmlns:p16="http://schemas.microsoft.com/office/powerpoint/2015/main" val="1"/>
+              </p:ext>
+            </p:extLst>
+          </p:nvPr>
+        </p:nvSpPr>
+        <p:spPr>
+          <a:xfrm>
+            <a:off x="517871" y="508090"/>
+            <a:ext cx="4672966" cy="149279"/>
+          </a:xfrm>
+          <a:prstGeom prst="rect">
+            <a:avLst/>
+          </a:prstGeom>
+          <a:solidFill>
+            <a:schemeClr val="tx1"/>
+          </a:solidFill>
+          <a:ln>
+            <a:noFill/>
+          </a:ln>
+        </p:spPr>
+        <p:style>
+          <a:lnRef idx="2">
+            <a:schemeClr val="accent1">
+              <a:shade val="50000"/>
+            </a:schemeClr>
+          </a:lnRef>
+          <a:fillRef idx="1">
+            <a:schemeClr val="accent1"/>
+          </a:fillRef>
+          <a:effectRef idx="0">
+            <a:schemeClr val="accent1"/>
+          </a:effectRef>
+          <a:fontRef idx="minor">
+            <a:schemeClr val="lt1"/>
+          </a:fontRef>
+        </p:style>
+        <p:txBody>
+          <a:bodyPr rtlCol="0" anchor="ctr"/>
+          <a:lstStyle/>
+          <a:p>
+            <a:pPr marL="0" marR="0" lvl="0" indent="0" algn="ctr" defTabSz="914400" rtl="0" eaLnBrk="1" fontAlgn="auto" latinLnBrk="0" hangingPunct="1">
+              <a:lnSpc>
+                <a:spcPct val="100000"/>
+              </a:lnSpc>
+              <a:spcBef>
+                <a:spcPts val="0"/>
+              </a:spcBef>
+              <a:spcAft>
+                <a:spcPts val="0"/>
+              </a:spcAft>
+              <a:buClrTx/>
+              <a:buSzTx/>
+              <a:buFontTx/>
+              <a:buNone/>
+              <a:tabLst/>
+              <a:defRPr/>
+            </a:pPr>
+            <a:endParaRPr kumimoji="0" lang="en-US" sz="1800" b="0" i="0" u="none" strike="noStrike" kern="1200" cap="none" spc="0" normalizeH="0" baseline="0" noProof="0">
+              <a:ln>
+                <a:noFill/>
+              </a:ln>
+              <a:solidFill>
+                <a:prstClr val="white"/>
+              </a:solidFill>
+              <a:effectLst/>
+              <a:uLnTx/>
+              <a:uFillTx/>
+              <a:latin typeface="Bierstadt"/>
+              <a:ea typeface="+mn-ea"/>
+              <a:cs typeface="+mn-cs"/>
+            </a:endParaRPr>
           </a:p>
         </p:txBody>
       </p:sp>
@@ -4892,9 +7514,16 @@
             <p:ph idx="1"/>
           </p:nvPr>
         </p:nvSpPr>
-        <p:spPr/>
-        <p:txBody>
-          <a:bodyPr/>
+        <p:spPr>
+          <a:xfrm>
+            <a:off x="521208" y="2578608"/>
+            <a:ext cx="4672584" cy="3767328"/>
+          </a:xfrm>
+        </p:spPr>
+        <p:txBody>
+          <a:bodyPr>
+            <a:normAutofit/>
+          </a:bodyPr>
           <a:lstStyle/>
           <a:p>
             <a:r>
@@ -4922,6 +7551,37 @@
           </a:p>
         </p:txBody>
       </p:sp>
+      <p:pic>
+        <p:nvPicPr>
+          <p:cNvPr id="4" name="Image 3" descr="Kahoot Logo, symbol, meaning, history, PNG, brand">
+            <a:extLst>
+              <a:ext uri="{FF2B5EF4-FFF2-40B4-BE49-F238E27FC236}">
+                <a16:creationId xmlns:a16="http://schemas.microsoft.com/office/drawing/2014/main" id="{9B336863-7BFD-C7BD-DAE2-2A2FBE9205CE}"/>
+              </a:ext>
+            </a:extLst>
+          </p:cNvPr>
+          <p:cNvPicPr>
+            <a:picLocks noChangeAspect="1"/>
+          </p:cNvPicPr>
+          <p:nvPr/>
+        </p:nvPicPr>
+        <p:blipFill>
+          <a:blip r:embed="rId3"/>
+          <a:srcRect l="22029" r="23043" b="2"/>
+          <a:stretch>
+            <a:fillRect/>
+          </a:stretch>
+        </p:blipFill>
+        <p:spPr>
+          <a:xfrm>
+            <a:off x="5958018" y="508090"/>
+            <a:ext cx="5709726" cy="5846989"/>
+          </a:xfrm>
+          <a:prstGeom prst="rect">
+            <a:avLst/>
+          </a:prstGeom>
+        </p:spPr>
+      </p:pic>
     </p:spTree>
     <p:extLst>
       <p:ext uri="{BB962C8B-B14F-4D97-AF65-F5344CB8AC3E}">
@@ -4938,6 +7598,14 @@
 <file path=ppt/slides/slide3.xml><?xml version="1.0" encoding="utf-8"?>
 <p:sld xmlns:a="http://schemas.openxmlformats.org/drawingml/2006/main" xmlns:r="http://schemas.openxmlformats.org/officeDocument/2006/relationships" xmlns:p="http://schemas.openxmlformats.org/presentationml/2006/main">
   <p:cSld>
+    <p:bg>
+      <p:bgPr>
+        <a:solidFill>
+          <a:schemeClr val="bg1"/>
+        </a:solidFill>
+        <a:effectLst/>
+      </p:bgPr>
+    </p:bg>
     <p:spTree>
       <p:nvGrpSpPr>
         <p:cNvPr id="1" name=""/>
@@ -4952,6 +7620,95 @@
           <a:chExt cx="0" cy="0"/>
         </a:xfrm>
       </p:grpSpPr>
+      <p:sp useBgFill="1">
+        <p:nvSpPr>
+          <p:cNvPr id="9" name="Rectangle 8">
+            <a:extLst>
+              <a:ext uri="{FF2B5EF4-FFF2-40B4-BE49-F238E27FC236}">
+                <a16:creationId xmlns:a16="http://schemas.microsoft.com/office/drawing/2014/main" id="{34C0330F-1D4F-4552-B799-615DD237B6DE}"/>
+              </a:ext>
+              <a:ext uri="{C183D7F6-B498-43B3-948B-1728B52AA6E4}">
+                <adec:decorative xmlns:adec="http://schemas.microsoft.com/office/drawing/2017/decorative" val="1"/>
+              </a:ext>
+            </a:extLst>
+          </p:cNvPr>
+          <p:cNvSpPr>
+            <a:spLocks noGrp="1" noRot="1" noChangeAspect="1" noMove="1" noResize="1" noEditPoints="1" noAdjustHandles="1" noChangeArrowheads="1" noChangeShapeType="1" noTextEdit="1"/>
+          </p:cNvSpPr>
+          <p:nvPr>
+            <p:extLst>
+              <p:ext uri="{386F3935-93C4-4BCD-93E2-E3B085C9AB24}">
+                <p16:designElem xmlns:p16="http://schemas.microsoft.com/office/powerpoint/2015/main" val="1"/>
+              </p:ext>
+            </p:extLst>
+          </p:nvPr>
+        </p:nvSpPr>
+        <p:spPr>
+          <a:xfrm>
+            <a:off x="0" y="0"/>
+            <a:ext cx="12188952" cy="6857995"/>
+          </a:xfrm>
+          <a:prstGeom prst="rect">
+            <a:avLst/>
+          </a:prstGeom>
+          <a:ln>
+            <a:noFill/>
+          </a:ln>
+        </p:spPr>
+        <p:style>
+          <a:lnRef idx="2">
+            <a:schemeClr val="accent1">
+              <a:shade val="50000"/>
+            </a:schemeClr>
+          </a:lnRef>
+          <a:fillRef idx="1">
+            <a:schemeClr val="accent1"/>
+          </a:fillRef>
+          <a:effectRef idx="0">
+            <a:schemeClr val="accent1"/>
+          </a:effectRef>
+          <a:fontRef idx="minor">
+            <a:schemeClr val="lt1"/>
+          </a:fontRef>
+        </p:style>
+        <p:txBody>
+          <a:bodyPr rtlCol="0" anchor="ctr"/>
+          <a:lstStyle/>
+          <a:p>
+            <a:pPr marL="0" marR="0" lvl="0" indent="0" algn="ctr" defTabSz="914400" rtl="0" eaLnBrk="1" fontAlgn="auto" latinLnBrk="0" hangingPunct="1">
+              <a:lnSpc>
+                <a:spcPct val="100000"/>
+              </a:lnSpc>
+              <a:spcBef>
+                <a:spcPts val="0"/>
+              </a:spcBef>
+              <a:spcAft>
+                <a:spcPts val="0"/>
+              </a:spcAft>
+              <a:buClrTx/>
+              <a:buSzTx/>
+              <a:buFontTx/>
+              <a:buNone/>
+              <a:tabLst/>
+              <a:defRPr/>
+            </a:pPr>
+            <a:endParaRPr kumimoji="0" lang="en-US" sz="1800" b="0" i="0" u="none" strike="noStrike" kern="1200" cap="none" spc="0" normalizeH="0" baseline="0" noProof="0" dirty="0">
+              <a:ln>
+                <a:noFill/>
+              </a:ln>
+              <a:solidFill>
+                <a:prstClr val="white"/>
+              </a:solidFill>
+              <a:effectLst/>
+              <a:uLnTx/>
+              <a:uFillTx/>
+              <a:latin typeface="Bierstadt"/>
+              <a:ea typeface="+mn-ea"/>
+              <a:cs typeface="+mn-cs"/>
+            </a:endParaRPr>
+          </a:p>
+        </p:txBody>
+      </p:sp>
       <p:sp>
         <p:nvSpPr>
           <p:cNvPr id="2" name="Titre 1">
@@ -4968,9 +7725,16 @@
             <p:ph type="title"/>
           </p:nvPr>
         </p:nvSpPr>
-        <p:spPr/>
-        <p:txBody>
-          <a:bodyPr/>
+        <p:spPr>
+          <a:xfrm>
+            <a:off x="521208" y="978408"/>
+            <a:ext cx="4754880" cy="1463040"/>
+          </a:xfrm>
+        </p:spPr>
+        <p:txBody>
+          <a:bodyPr>
+            <a:normAutofit/>
+          </a:bodyPr>
           <a:lstStyle/>
           <a:p>
             <a:r>
@@ -4982,6 +7746,98 @@
       </p:sp>
       <p:sp>
         <p:nvSpPr>
+          <p:cNvPr id="11" name="Rectangle 10">
+            <a:extLst>
+              <a:ext uri="{FF2B5EF4-FFF2-40B4-BE49-F238E27FC236}">
+                <a16:creationId xmlns:a16="http://schemas.microsoft.com/office/drawing/2014/main" id="{92BE0106-0C20-465B-A1BE-0BAC2737B1AD}"/>
+              </a:ext>
+              <a:ext uri="{C183D7F6-B498-43B3-948B-1728B52AA6E4}">
+                <adec:decorative xmlns:adec="http://schemas.microsoft.com/office/drawing/2017/decorative" val="1"/>
+              </a:ext>
+            </a:extLst>
+          </p:cNvPr>
+          <p:cNvSpPr>
+            <a:spLocks noGrp="1" noRot="1" noChangeAspect="1" noMove="1" noResize="1" noEditPoints="1" noAdjustHandles="1" noChangeArrowheads="1" noChangeShapeType="1" noTextEdit="1"/>
+          </p:cNvSpPr>
+          <p:nvPr>
+            <p:extLst>
+              <p:ext uri="{386F3935-93C4-4BCD-93E2-E3B085C9AB24}">
+                <p16:designElem xmlns:p16="http://schemas.microsoft.com/office/powerpoint/2015/main" val="1"/>
+              </p:ext>
+            </p:extLst>
+          </p:nvPr>
+        </p:nvSpPr>
+        <p:spPr>
+          <a:xfrm>
+            <a:off x="517871" y="508090"/>
+            <a:ext cx="4672966" cy="149279"/>
+          </a:xfrm>
+          <a:prstGeom prst="rect">
+            <a:avLst/>
+          </a:prstGeom>
+          <a:solidFill>
+            <a:schemeClr val="tx1"/>
+          </a:solidFill>
+          <a:ln>
+            <a:noFill/>
+          </a:ln>
+        </p:spPr>
+        <p:style>
+          <a:lnRef idx="2">
+            <a:schemeClr val="accent1">
+              <a:shade val="50000"/>
+            </a:schemeClr>
+          </a:lnRef>
+          <a:fillRef idx="1">
+            <a:schemeClr val="accent1"/>
+          </a:fillRef>
+          <a:effectRef idx="0">
+            <a:schemeClr val="accent1"/>
+          </a:effectRef>
+          <a:fontRef idx="minor">
+            <a:schemeClr val="lt1"/>
+          </a:fontRef>
+        </p:style>
+        <p:txBody>
+          <a:bodyPr rtlCol="0" anchor="ctr"/>
+          <a:lstStyle/>
+          <a:p>
+            <a:pPr marL="0" marR="0" lvl="0" indent="0" algn="ctr" defTabSz="914400" rtl="0" eaLnBrk="1" fontAlgn="auto" latinLnBrk="0" hangingPunct="1">
+              <a:lnSpc>
+                <a:spcPct val="100000"/>
+              </a:lnSpc>
+              <a:spcBef>
+                <a:spcPts val="0"/>
+              </a:spcBef>
+              <a:spcAft>
+                <a:spcPts val="0"/>
+              </a:spcAft>
+              <a:buClrTx/>
+              <a:buSzTx/>
+              <a:buFontTx/>
+              <a:buNone/>
+              <a:tabLst/>
+              <a:defRPr/>
+            </a:pPr>
+            <a:endParaRPr kumimoji="0" lang="en-US" sz="1800" b="0" i="0" u="none" strike="noStrike" kern="1200" cap="none" spc="0" normalizeH="0" baseline="0" noProof="0">
+              <a:ln>
+                <a:noFill/>
+              </a:ln>
+              <a:solidFill>
+                <a:prstClr val="white"/>
+              </a:solidFill>
+              <a:effectLst/>
+              <a:uLnTx/>
+              <a:uFillTx/>
+              <a:latin typeface="Bierstadt"/>
+              <a:ea typeface="+mn-ea"/>
+              <a:cs typeface="+mn-cs"/>
+            </a:endParaRPr>
+          </a:p>
+        </p:txBody>
+      </p:sp>
+      <p:sp>
+        <p:nvSpPr>
           <p:cNvPr id="3" name="Espace réservé du contenu 2">
             <a:extLst>
               <a:ext uri="{FF2B5EF4-FFF2-40B4-BE49-F238E27FC236}">
@@ -4996,9 +7852,16 @@
             <p:ph idx="1"/>
           </p:nvPr>
         </p:nvSpPr>
-        <p:spPr/>
-        <p:txBody>
-          <a:bodyPr/>
+        <p:spPr>
+          <a:xfrm>
+            <a:off x="521208" y="2578608"/>
+            <a:ext cx="4672584" cy="3767328"/>
+          </a:xfrm>
+        </p:spPr>
+        <p:txBody>
+          <a:bodyPr>
+            <a:normAutofit/>
+          </a:bodyPr>
           <a:lstStyle/>
           <a:p>
             <a:r>
@@ -5008,6 +7871,37 @@
           </a:p>
         </p:txBody>
       </p:sp>
+      <p:pic>
+        <p:nvPicPr>
+          <p:cNvPr id="4" name="Image 3" descr="Images sur Logo internet : Téléchargement gratuit sur ...">
+            <a:extLst>
+              <a:ext uri="{FF2B5EF4-FFF2-40B4-BE49-F238E27FC236}">
+                <a16:creationId xmlns:a16="http://schemas.microsoft.com/office/drawing/2014/main" id="{2F941A74-9099-850C-004F-AD72CCC97012}"/>
+              </a:ext>
+            </a:extLst>
+          </p:cNvPr>
+          <p:cNvPicPr>
+            <a:picLocks noChangeAspect="1"/>
+          </p:cNvPicPr>
+          <p:nvPr/>
+        </p:nvPicPr>
+        <p:blipFill>
+          <a:blip r:embed="rId2"/>
+          <a:srcRect l="1159" r="1186" b="-3"/>
+          <a:stretch>
+            <a:fillRect/>
+          </a:stretch>
+        </p:blipFill>
+        <p:spPr>
+          <a:xfrm>
+            <a:off x="5958018" y="508090"/>
+            <a:ext cx="5709726" cy="5846989"/>
+          </a:xfrm>
+          <a:prstGeom prst="rect">
+            <a:avLst/>
+          </a:prstGeom>
+        </p:spPr>
+      </p:pic>
     </p:spTree>
     <p:extLst>
       <p:ext uri="{BB962C8B-B14F-4D97-AF65-F5344CB8AC3E}">
@@ -5018,12 +7912,112 @@
   <p:clrMapOvr>
     <a:masterClrMapping/>
   </p:clrMapOvr>
+  <p:timing>
+    <p:tnLst>
+      <p:par>
+        <p:cTn id="1" dur="indefinite" restart="never" nodeType="tmRoot">
+          <p:childTnLst>
+            <p:seq concurrent="1" nextAc="seek">
+              <p:cTn id="2" dur="indefinite" nodeType="mainSeq">
+                <p:childTnLst>
+                  <p:par>
+                    <p:cTn id="3" fill="hold">
+                      <p:stCondLst>
+                        <p:cond delay="indefinite"/>
+                        <p:cond evt="onBegin" delay="0">
+                          <p:tn val="2"/>
+                        </p:cond>
+                      </p:stCondLst>
+                      <p:childTnLst>
+                        <p:par>
+                          <p:cTn id="4" fill="hold">
+                            <p:stCondLst>
+                              <p:cond delay="0"/>
+                            </p:stCondLst>
+                            <p:childTnLst>
+                              <p:par>
+                                <p:cTn id="5" presetID="10" presetClass="entr" presetSubtype="0" fill="hold" grpId="0" nodeType="withEffect">
+                                  <p:stCondLst>
+                                    <p:cond delay="1000"/>
+                                  </p:stCondLst>
+                                  <p:iterate type="lt">
+                                    <p:tmPct val="10000"/>
+                                  </p:iterate>
+                                  <p:childTnLst>
+                                    <p:set>
+                                      <p:cBhvr>
+                                        <p:cTn id="6" dur="1" fill="hold">
+                                          <p:stCondLst>
+                                            <p:cond delay="0"/>
+                                          </p:stCondLst>
+                                        </p:cTn>
+                                        <p:tgtEl>
+                                          <p:spTgt spid="2"/>
+                                        </p:tgtEl>
+                                        <p:attrNameLst>
+                                          <p:attrName>style.visibility</p:attrName>
+                                        </p:attrNameLst>
+                                      </p:cBhvr>
+                                      <p:to>
+                                        <p:strVal val="visible"/>
+                                      </p:to>
+                                    </p:set>
+                                    <p:animEffect transition="in" filter="fade">
+                                      <p:cBhvr>
+                                        <p:cTn id="7" dur="400"/>
+                                        <p:tgtEl>
+                                          <p:spTgt spid="2"/>
+                                        </p:tgtEl>
+                                      </p:cBhvr>
+                                    </p:animEffect>
+                                  </p:childTnLst>
+                                </p:cTn>
+                              </p:par>
+                            </p:childTnLst>
+                          </p:cTn>
+                        </p:par>
+                      </p:childTnLst>
+                    </p:cTn>
+                  </p:par>
+                </p:childTnLst>
+              </p:cTn>
+              <p:prevCondLst>
+                <p:cond evt="onPrev" delay="0">
+                  <p:tgtEl>
+                    <p:sldTgt/>
+                  </p:tgtEl>
+                </p:cond>
+              </p:prevCondLst>
+              <p:nextCondLst>
+                <p:cond evt="onNext" delay="0">
+                  <p:tgtEl>
+                    <p:sldTgt/>
+                  </p:tgtEl>
+                </p:cond>
+              </p:nextCondLst>
+            </p:seq>
+          </p:childTnLst>
+        </p:cTn>
+      </p:par>
+    </p:tnLst>
+    <p:bldLst>
+      <p:bldP spid="2" grpId="0"/>
+    </p:bldLst>
+  </p:timing>
 </p:sld>
 </file>
 
 <file path=ppt/slides/slide4.xml><?xml version="1.0" encoding="utf-8"?>
 <p:sld xmlns:a="http://schemas.openxmlformats.org/drawingml/2006/main" xmlns:r="http://schemas.openxmlformats.org/officeDocument/2006/relationships" xmlns:p="http://schemas.openxmlformats.org/presentationml/2006/main">
   <p:cSld>
+    <p:bg>
+      <p:bgPr>
+        <a:solidFill>
+          <a:schemeClr val="bg1"/>
+        </a:solidFill>
+        <a:effectLst/>
+      </p:bgPr>
+    </p:bg>
     <p:spTree>
       <p:nvGrpSpPr>
         <p:cNvPr id="1" name=""/>
@@ -5038,6 +8032,66 @@
           <a:chExt cx="0" cy="0"/>
         </a:xfrm>
       </p:grpSpPr>
+      <p:sp useBgFill="1">
+        <p:nvSpPr>
+          <p:cNvPr id="9" name="Rectangle 8">
+            <a:extLst>
+              <a:ext uri="{FF2B5EF4-FFF2-40B4-BE49-F238E27FC236}">
+                <a16:creationId xmlns:a16="http://schemas.microsoft.com/office/drawing/2014/main" id="{AD1BDCCC-E676-2A7E-BE11-2B8C23DB287F}"/>
+              </a:ext>
+              <a:ext uri="{C183D7F6-B498-43B3-948B-1728B52AA6E4}">
+                <adec:decorative xmlns:adec="http://schemas.microsoft.com/office/drawing/2017/decorative" val="1"/>
+              </a:ext>
+            </a:extLst>
+          </p:cNvPr>
+          <p:cNvSpPr>
+            <a:spLocks noGrp="1" noRot="1" noChangeAspect="1" noMove="1" noResize="1" noEditPoints="1" noAdjustHandles="1" noChangeArrowheads="1" noChangeShapeType="1" noTextEdit="1"/>
+          </p:cNvSpPr>
+          <p:nvPr>
+            <p:extLst>
+              <p:ext uri="{386F3935-93C4-4BCD-93E2-E3B085C9AB24}">
+                <p16:designElem xmlns:p16="http://schemas.microsoft.com/office/powerpoint/2015/main" val="1"/>
+              </p:ext>
+            </p:extLst>
+          </p:nvPr>
+        </p:nvSpPr>
+        <p:spPr>
+          <a:xfrm>
+            <a:off x="0" y="0"/>
+            <a:ext cx="12188952" cy="6857995"/>
+          </a:xfrm>
+          <a:prstGeom prst="rect">
+            <a:avLst/>
+          </a:prstGeom>
+          <a:ln>
+            <a:noFill/>
+          </a:ln>
+        </p:spPr>
+        <p:style>
+          <a:lnRef idx="2">
+            <a:schemeClr val="accent1">
+              <a:shade val="50000"/>
+            </a:schemeClr>
+          </a:lnRef>
+          <a:fillRef idx="1">
+            <a:schemeClr val="accent1"/>
+          </a:fillRef>
+          <a:effectRef idx="0">
+            <a:schemeClr val="accent1"/>
+          </a:effectRef>
+          <a:fontRef idx="minor">
+            <a:schemeClr val="lt1"/>
+          </a:fontRef>
+        </p:style>
+        <p:txBody>
+          <a:bodyPr rtlCol="0" anchor="ctr"/>
+          <a:lstStyle/>
+          <a:p>
+            <a:pPr algn="ctr"/>
+            <a:endParaRPr lang="en-US" dirty="0"/>
+          </a:p>
+        </p:txBody>
+      </p:sp>
       <p:sp>
         <p:nvSpPr>
           <p:cNvPr id="2" name="Titre 1">
@@ -5054,18 +8108,164 @@
             <p:ph type="title"/>
           </p:nvPr>
         </p:nvSpPr>
-        <p:spPr/>
-        <p:txBody>
-          <a:bodyPr/>
+        <p:spPr>
+          <a:xfrm>
+            <a:off x="521208" y="978408"/>
+            <a:ext cx="11155680" cy="1115568"/>
+          </a:xfrm>
+        </p:spPr>
+        <p:txBody>
+          <a:bodyPr>
+            <a:normAutofit/>
+          </a:bodyPr>
           <a:lstStyle/>
           <a:p>
             <a:r>
-              <a:rPr lang="fr-CH" dirty="0"/>
+              <a:rPr lang="fr-CH"/>
               <a:t>Imposteur</a:t>
             </a:r>
-          </a:p>
-        </p:txBody>
-      </p:sp>
+            <a:endParaRPr lang="fr-CH" dirty="0"/>
+          </a:p>
+        </p:txBody>
+      </p:sp>
+      <p:sp>
+        <p:nvSpPr>
+          <p:cNvPr id="11" name="Freeform: Shape 10">
+            <a:extLst>
+              <a:ext uri="{FF2B5EF4-FFF2-40B4-BE49-F238E27FC236}">
+                <a16:creationId xmlns:a16="http://schemas.microsoft.com/office/drawing/2014/main" id="{781C97B1-8A09-6383-8C65-A3B73577816A}"/>
+              </a:ext>
+              <a:ext uri="{C183D7F6-B498-43B3-948B-1728B52AA6E4}">
+                <adec:decorative xmlns:adec="http://schemas.microsoft.com/office/drawing/2017/decorative" val="1"/>
+              </a:ext>
+            </a:extLst>
+          </p:cNvPr>
+          <p:cNvSpPr>
+            <a:spLocks noGrp="1" noRot="1" noChangeAspect="1" noMove="1" noResize="1" noEditPoints="1" noAdjustHandles="1" noChangeArrowheads="1" noChangeShapeType="1" noTextEdit="1"/>
+          </p:cNvSpPr>
+          <p:nvPr>
+            <p:extLst>
+              <p:ext uri="{386F3935-93C4-4BCD-93E2-E3B085C9AB24}">
+                <p16:designElem xmlns:p16="http://schemas.microsoft.com/office/powerpoint/2015/main" val="1"/>
+              </p:ext>
+            </p:extLst>
+          </p:nvPr>
+        </p:nvSpPr>
+        <p:spPr>
+          <a:xfrm>
+            <a:off x="517869" y="508090"/>
+            <a:ext cx="11153214" cy="149279"/>
+          </a:xfrm>
+          <a:custGeom>
+            <a:avLst/>
+            <a:gdLst>
+              <a:gd name="connsiteX0" fmla="*/ 0 w 8085002"/>
+              <a:gd name="connsiteY0" fmla="*/ 0 h 149279"/>
+              <a:gd name="connsiteX1" fmla="*/ 8085002 w 8085002"/>
+              <a:gd name="connsiteY1" fmla="*/ 0 h 149279"/>
+              <a:gd name="connsiteX2" fmla="*/ 8085002 w 8085002"/>
+              <a:gd name="connsiteY2" fmla="*/ 149279 h 149279"/>
+              <a:gd name="connsiteX3" fmla="*/ 0 w 8085002"/>
+              <a:gd name="connsiteY3" fmla="*/ 149279 h 149279"/>
+            </a:gdLst>
+            <a:ahLst/>
+            <a:cxnLst>
+              <a:cxn ang="0">
+                <a:pos x="connsiteX0" y="connsiteY0"/>
+              </a:cxn>
+              <a:cxn ang="0">
+                <a:pos x="connsiteX1" y="connsiteY1"/>
+              </a:cxn>
+              <a:cxn ang="0">
+                <a:pos x="connsiteX2" y="connsiteY2"/>
+              </a:cxn>
+              <a:cxn ang="0">
+                <a:pos x="connsiteX3" y="connsiteY3"/>
+              </a:cxn>
+            </a:cxnLst>
+            <a:rect l="l" t="t" r="r" b="b"/>
+            <a:pathLst>
+              <a:path w="8085002" h="149279">
+                <a:moveTo>
+                  <a:pt x="0" y="0"/>
+                </a:moveTo>
+                <a:lnTo>
+                  <a:pt x="8085002" y="0"/>
+                </a:lnTo>
+                <a:lnTo>
+                  <a:pt x="8085002" y="149279"/>
+                </a:lnTo>
+                <a:lnTo>
+                  <a:pt x="0" y="149279"/>
+                </a:lnTo>
+                <a:close/>
+              </a:path>
+            </a:pathLst>
+          </a:custGeom>
+          <a:solidFill>
+            <a:schemeClr val="tx1"/>
+          </a:solidFill>
+          <a:ln>
+            <a:noFill/>
+          </a:ln>
+        </p:spPr>
+        <p:style>
+          <a:lnRef idx="2">
+            <a:schemeClr val="accent1">
+              <a:shade val="50000"/>
+            </a:schemeClr>
+          </a:lnRef>
+          <a:fillRef idx="1">
+            <a:schemeClr val="accent1"/>
+          </a:fillRef>
+          <a:effectRef idx="0">
+            <a:schemeClr val="accent1"/>
+          </a:effectRef>
+          <a:fontRef idx="minor">
+            <a:schemeClr val="lt1"/>
+          </a:fontRef>
+        </p:style>
+        <p:txBody>
+          <a:bodyPr wrap="square" rtlCol="0" anchor="ctr">
+            <a:noAutofit/>
+          </a:bodyPr>
+          <a:lstStyle/>
+          <a:p>
+            <a:pPr algn="ctr"/>
+            <a:endParaRPr lang="en-US"/>
+          </a:p>
+        </p:txBody>
+      </p:sp>
+      <p:pic>
+        <p:nvPicPr>
+          <p:cNvPr id="4" name="Image 3">
+            <a:extLst>
+              <a:ext uri="{FF2B5EF4-FFF2-40B4-BE49-F238E27FC236}">
+                <a16:creationId xmlns:a16="http://schemas.microsoft.com/office/drawing/2014/main" id="{5790571E-7720-0DCF-754F-2C36BA04717A}"/>
+              </a:ext>
+            </a:extLst>
+          </p:cNvPr>
+          <p:cNvPicPr>
+            <a:picLocks noChangeAspect="1"/>
+          </p:cNvPicPr>
+          <p:nvPr/>
+        </p:nvPicPr>
+        <p:blipFill>
+          <a:blip r:embed="rId2"/>
+          <a:stretch>
+            <a:fillRect/>
+          </a:stretch>
+        </p:blipFill>
+        <p:spPr>
+          <a:xfrm>
+            <a:off x="517868" y="2749818"/>
+            <a:ext cx="5639091" cy="3171988"/>
+          </a:xfrm>
+          <a:prstGeom prst="rect">
+            <a:avLst/>
+          </a:prstGeom>
+        </p:spPr>
+      </p:pic>
       <p:sp>
         <p:nvSpPr>
           <p:cNvPr id="3" name="Espace réservé du contenu 2">
@@ -5082,9 +8282,16 @@
             <p:ph idx="1"/>
           </p:nvPr>
         </p:nvSpPr>
-        <p:spPr/>
-        <p:txBody>
-          <a:bodyPr/>
+        <p:spPr>
+          <a:xfrm>
+            <a:off x="6547104" y="2304288"/>
+            <a:ext cx="5129784" cy="4050792"/>
+          </a:xfrm>
+        </p:spPr>
+        <p:txBody>
+          <a:bodyPr>
+            <a:normAutofit/>
+          </a:bodyPr>
           <a:lstStyle/>
           <a:p>
             <a:r>
@@ -5116,6 +8323,14 @@
 <file path=ppt/slides/slide5.xml><?xml version="1.0" encoding="utf-8"?>
 <p:sld xmlns:a="http://schemas.openxmlformats.org/drawingml/2006/main" xmlns:r="http://schemas.openxmlformats.org/officeDocument/2006/relationships" xmlns:p="http://schemas.openxmlformats.org/presentationml/2006/main">
   <p:cSld>
+    <p:bg>
+      <p:bgPr>
+        <a:solidFill>
+          <a:schemeClr val="bg1"/>
+        </a:solidFill>
+        <a:effectLst/>
+      </p:bgPr>
+    </p:bg>
     <p:spTree>
       <p:nvGrpSpPr>
         <p:cNvPr id="1" name=""/>
@@ -5130,6 +8345,66 @@
           <a:chExt cx="0" cy="0"/>
         </a:xfrm>
       </p:grpSpPr>
+      <p:sp useBgFill="1">
+        <p:nvSpPr>
+          <p:cNvPr id="9" name="Rectangle 8">
+            <a:extLst>
+              <a:ext uri="{FF2B5EF4-FFF2-40B4-BE49-F238E27FC236}">
+                <a16:creationId xmlns:a16="http://schemas.microsoft.com/office/drawing/2014/main" id="{04213918-F1EB-4BCE-BE23-F5E9851EE05C}"/>
+              </a:ext>
+              <a:ext uri="{C183D7F6-B498-43B3-948B-1728B52AA6E4}">
+                <adec:decorative xmlns:adec="http://schemas.microsoft.com/office/drawing/2017/decorative" val="1"/>
+              </a:ext>
+            </a:extLst>
+          </p:cNvPr>
+          <p:cNvSpPr>
+            <a:spLocks noGrp="1" noRot="1" noChangeAspect="1" noMove="1" noResize="1" noEditPoints="1" noAdjustHandles="1" noChangeArrowheads="1" noChangeShapeType="1" noTextEdit="1"/>
+          </p:cNvSpPr>
+          <p:nvPr>
+            <p:extLst>
+              <p:ext uri="{386F3935-93C4-4BCD-93E2-E3B085C9AB24}">
+                <p16:designElem xmlns:p16="http://schemas.microsoft.com/office/powerpoint/2015/main" val="1"/>
+              </p:ext>
+            </p:extLst>
+          </p:nvPr>
+        </p:nvSpPr>
+        <p:spPr>
+          <a:xfrm>
+            <a:off x="0" y="0"/>
+            <a:ext cx="12188952" cy="6857995"/>
+          </a:xfrm>
+          <a:prstGeom prst="rect">
+            <a:avLst/>
+          </a:prstGeom>
+          <a:ln>
+            <a:noFill/>
+          </a:ln>
+        </p:spPr>
+        <p:style>
+          <a:lnRef idx="2">
+            <a:schemeClr val="accent1">
+              <a:shade val="50000"/>
+            </a:schemeClr>
+          </a:lnRef>
+          <a:fillRef idx="1">
+            <a:schemeClr val="accent1"/>
+          </a:fillRef>
+          <a:effectRef idx="0">
+            <a:schemeClr val="accent1"/>
+          </a:effectRef>
+          <a:fontRef idx="minor">
+            <a:schemeClr val="lt1"/>
+          </a:fontRef>
+        </p:style>
+        <p:txBody>
+          <a:bodyPr rtlCol="0" anchor="ctr"/>
+          <a:lstStyle/>
+          <a:p>
+            <a:pPr algn="ctr"/>
+            <a:endParaRPr lang="en-US" dirty="0"/>
+          </a:p>
+        </p:txBody>
+      </p:sp>
       <p:sp>
         <p:nvSpPr>
           <p:cNvPr id="2" name="Titre 1">
@@ -5146,9 +8421,16 @@
             <p:ph type="title"/>
           </p:nvPr>
         </p:nvSpPr>
-        <p:spPr/>
-        <p:txBody>
-          <a:bodyPr/>
+        <p:spPr>
+          <a:xfrm>
+            <a:off x="521208" y="978408"/>
+            <a:ext cx="11155680" cy="1463040"/>
+          </a:xfrm>
+        </p:spPr>
+        <p:txBody>
+          <a:bodyPr>
+            <a:normAutofit/>
+          </a:bodyPr>
           <a:lstStyle/>
           <a:p>
             <a:r>
@@ -5160,38 +8442,98 @@
       </p:sp>
       <p:sp>
         <p:nvSpPr>
-          <p:cNvPr id="3" name="Espace réservé du contenu 2">
-            <a:extLst>
-              <a:ext uri="{FF2B5EF4-FFF2-40B4-BE49-F238E27FC236}">
-                <a16:creationId xmlns:a16="http://schemas.microsoft.com/office/drawing/2014/main" id="{81B232AB-9118-A383-95D2-48DDE10CC526}"/>
-              </a:ext>
-            </a:extLst>
-          </p:cNvPr>
-          <p:cNvSpPr>
-            <a:spLocks noGrp="1"/>
-          </p:cNvSpPr>
+          <p:cNvPr id="11" name="Rectangle 10">
+            <a:extLst>
+              <a:ext uri="{FF2B5EF4-FFF2-40B4-BE49-F238E27FC236}">
+                <a16:creationId xmlns:a16="http://schemas.microsoft.com/office/drawing/2014/main" id="{2062E862-C7F7-4CA1-B929-D0B75F5E9FB9}"/>
+              </a:ext>
+              <a:ext uri="{C183D7F6-B498-43B3-948B-1728B52AA6E4}">
+                <adec:decorative xmlns:adec="http://schemas.microsoft.com/office/drawing/2017/decorative" val="1"/>
+              </a:ext>
+            </a:extLst>
+          </p:cNvPr>
+          <p:cNvSpPr>
+            <a:spLocks noGrp="1" noRot="1" noChangeAspect="1" noMove="1" noResize="1" noEditPoints="1" noAdjustHandles="1" noChangeArrowheads="1" noChangeShapeType="1" noTextEdit="1"/>
+          </p:cNvSpPr>
+          <p:nvPr>
+            <p:extLst>
+              <p:ext uri="{386F3935-93C4-4BCD-93E2-E3B085C9AB24}">
+                <p16:designElem xmlns:p16="http://schemas.microsoft.com/office/powerpoint/2015/main" val="1"/>
+              </p:ext>
+            </p:extLst>
+          </p:nvPr>
+        </p:nvSpPr>
+        <p:spPr>
+          <a:xfrm>
+            <a:off x="517869" y="508090"/>
+            <a:ext cx="11155680" cy="149279"/>
+          </a:xfrm>
+          <a:prstGeom prst="rect">
+            <a:avLst/>
+          </a:prstGeom>
+          <a:solidFill>
+            <a:schemeClr val="tx1"/>
+          </a:solidFill>
+          <a:ln>
+            <a:noFill/>
+          </a:ln>
+        </p:spPr>
+        <p:style>
+          <a:lnRef idx="2">
+            <a:schemeClr val="accent1">
+              <a:shade val="50000"/>
+            </a:schemeClr>
+          </a:lnRef>
+          <a:fillRef idx="1">
+            <a:schemeClr val="accent1"/>
+          </a:fillRef>
+          <a:effectRef idx="0">
+            <a:schemeClr val="accent1"/>
+          </a:effectRef>
+          <a:fontRef idx="minor">
+            <a:schemeClr val="lt1"/>
+          </a:fontRef>
+        </p:style>
+        <p:txBody>
+          <a:bodyPr rtlCol="0" anchor="ctr"/>
+          <a:lstStyle/>
+          <a:p>
+            <a:pPr algn="ctr"/>
+            <a:endParaRPr lang="en-US"/>
+          </a:p>
+        </p:txBody>
+      </p:sp>
+      <p:graphicFrame>
+        <p:nvGraphicFramePr>
+          <p:cNvPr id="5" name="Espace réservé du contenu 2">
+            <a:extLst>
+              <a:ext uri="{FF2B5EF4-FFF2-40B4-BE49-F238E27FC236}">
+                <a16:creationId xmlns:a16="http://schemas.microsoft.com/office/drawing/2014/main" id="{86C2D27C-7317-AC61-36A9-D627CE3EA97A}"/>
+              </a:ext>
+            </a:extLst>
+          </p:cNvPr>
+          <p:cNvGraphicFramePr>
+            <a:graphicFrameLocks noGrp="1"/>
+          </p:cNvGraphicFramePr>
           <p:nvPr>
             <p:ph idx="1"/>
-          </p:nvPr>
-        </p:nvSpPr>
-        <p:spPr/>
-        <p:txBody>
-          <a:bodyPr/>
-          <a:lstStyle/>
-          <a:p>
-            <a:r>
-              <a:rPr lang="fr-CH" dirty="0"/>
-              <a:t>Création du fichier pour le matériels nécessaires </a:t>
-            </a:r>
-          </a:p>
-          <a:p>
-            <a:r>
-              <a:rPr lang="fr-CH" dirty="0"/>
-              <a:t>Création du fichier avec le retour de M. Sahli</a:t>
-            </a:r>
-          </a:p>
-        </p:txBody>
-      </p:sp>
+            <p:extLst>
+              <p:ext uri="{D42A27DB-BD31-4B8C-83A1-F6EECF244321}">
+                <p14:modId xmlns:p14="http://schemas.microsoft.com/office/powerpoint/2010/main" val="1826076837"/>
+              </p:ext>
+            </p:extLst>
+          </p:nvPr>
+        </p:nvGraphicFramePr>
+        <p:xfrm>
+          <a:off x="520700" y="2578100"/>
+          <a:ext cx="11156950" cy="3767138"/>
+        </p:xfrm>
+        <a:graphic>
+          <a:graphicData uri="http://schemas.openxmlformats.org/drawingml/2006/diagram">
+            <dgm:relIds xmlns:dgm="http://schemas.openxmlformats.org/drawingml/2006/diagram" xmlns:r="http://schemas.openxmlformats.org/officeDocument/2006/relationships" r:dm="rId2" r:lo="rId3" r:qs="rId4" r:cs="rId5"/>
+          </a:graphicData>
+        </a:graphic>
+      </p:graphicFrame>
     </p:spTree>
     <p:extLst>
       <p:ext uri="{BB962C8B-B14F-4D97-AF65-F5344CB8AC3E}">

</xml_diff>

<commit_message>
update : mettre à jour pptx
</commit_message>
<xml_diff>
--- a/annexe/Presentation.pptx
+++ b/annexe/Presentation.pptx
@@ -12,10 +12,9 @@
     <p:sldId id="262" r:id="rId6"/>
     <p:sldId id="257" r:id="rId7"/>
     <p:sldId id="263" r:id="rId8"/>
-    <p:sldId id="264" r:id="rId9"/>
-    <p:sldId id="265" r:id="rId10"/>
-    <p:sldId id="258" r:id="rId11"/>
-    <p:sldId id="266" r:id="rId12"/>
+    <p:sldId id="258" r:id="rId9"/>
+    <p:sldId id="266" r:id="rId10"/>
+    <p:sldId id="267" r:id="rId11"/>
   </p:sldIdLst>
   <p:sldSz cx="12192000" cy="6858000"/>
   <p:notesSz cx="6858000" cy="9144000"/>
@@ -875,7 +874,7 @@
 <dgm:dataModel xmlns:dgm="http://schemas.openxmlformats.org/drawingml/2006/diagram" xmlns:a="http://schemas.openxmlformats.org/drawingml/2006/main">
   <dgm:ptLst>
     <dgm:pt modelId="{CEFE2C82-2EF5-4777-BFE7-0DA03B660312}" type="doc">
-      <dgm:prSet loTypeId="urn:microsoft.com/office/officeart/2018/2/layout/IconLabelList" loCatId="icon" qsTypeId="urn:microsoft.com/office/officeart/2005/8/quickstyle/simple1" qsCatId="simple" csTypeId="urn:microsoft.com/office/officeart/2018/5/colors/Iconchunking_neutralbg_accent1_2" csCatId="accent1" phldr="1"/>
+      <dgm:prSet loTypeId="urn:microsoft.com/office/officeart/2008/layout/LinedList" loCatId="list" qsTypeId="urn:microsoft.com/office/officeart/2005/8/quickstyle/simple1" qsCatId="simple" csTypeId="urn:microsoft.com/office/officeart/2018/5/colors/Iconchunking_neutralbg_accent1_2" csCatId="accent1" phldr="1"/>
       <dgm:spPr/>
       <dgm:t>
         <a:bodyPr/>
@@ -893,10 +892,10 @@
         <a:lstStyle/>
         <a:p>
           <a:r>
-            <a:rPr lang="fr-CH"/>
+            <a:rPr lang="fr-CH" dirty="0"/>
             <a:t>Création du fichier pour le matériels nécessaires </a:t>
           </a:r>
-          <a:endParaRPr lang="en-US"/>
+          <a:endParaRPr lang="en-US" dirty="0"/>
         </a:p>
       </dgm:t>
     </dgm:pt>
@@ -930,10 +929,10 @@
         <a:lstStyle/>
         <a:p>
           <a:r>
-            <a:rPr lang="fr-CH"/>
+            <a:rPr lang="fr-CH" dirty="0"/>
             <a:t>Création du fichier avec le retour de M. Sahli</a:t>
           </a:r>
-          <a:endParaRPr lang="en-US"/>
+          <a:endParaRPr lang="en-US" dirty="0"/>
         </a:p>
       </dgm:t>
     </dgm:pt>
@@ -959,125 +958,63 @@
         </a:p>
       </dgm:t>
     </dgm:pt>
-    <dgm:pt modelId="{DE564F7C-45E9-46C7-901E-E3EB90DB5F0C}" type="pres">
-      <dgm:prSet presAssocID="{CEFE2C82-2EF5-4777-BFE7-0DA03B660312}" presName="root" presStyleCnt="0">
+    <dgm:pt modelId="{EA2DC5E0-B912-4B82-92B0-B5A07E303795}" type="pres">
+      <dgm:prSet presAssocID="{CEFE2C82-2EF5-4777-BFE7-0DA03B660312}" presName="vert0" presStyleCnt="0">
         <dgm:presLayoutVars>
           <dgm:dir/>
-          <dgm:resizeHandles val="exact"/>
+          <dgm:animOne val="branch"/>
+          <dgm:animLvl val="lvl"/>
         </dgm:presLayoutVars>
       </dgm:prSet>
       <dgm:spPr/>
     </dgm:pt>
-    <dgm:pt modelId="{6A42CE9E-23B5-4FD0-BB55-804F57B4272A}" type="pres">
-      <dgm:prSet presAssocID="{7B4EB37C-65E1-4320-A1C8-6A01837487C0}" presName="compNode" presStyleCnt="0"/>
+    <dgm:pt modelId="{EAC43F18-9025-4AA1-B14A-44E3002A361A}" type="pres">
+      <dgm:prSet presAssocID="{7B4EB37C-65E1-4320-A1C8-6A01837487C0}" presName="thickLine" presStyleLbl="alignNode1" presStyleIdx="0" presStyleCnt="2"/>
       <dgm:spPr/>
     </dgm:pt>
-    <dgm:pt modelId="{279B3533-5314-450C-A22D-72FAE911C470}" type="pres">
-      <dgm:prSet presAssocID="{7B4EB37C-65E1-4320-A1C8-6A01837487C0}" presName="iconRect" presStyleLbl="node1" presStyleIdx="0" presStyleCnt="2"/>
-      <dgm:spPr>
-        <a:blipFill>
-          <a:blip xmlns:r="http://schemas.openxmlformats.org/officeDocument/2006/relationships">
-            <a:extLst>
-              <a:ext uri="{28A0092B-C50C-407E-A947-70E740481C1C}">
-                <a14:useLocalDpi xmlns:a14="http://schemas.microsoft.com/office/drawing/2010/main" val="0"/>
-              </a:ext>
-              <a:ext uri="{96DAC541-7B7A-43D3-8B79-37D633B846F1}">
-                <asvg:svgBlip xmlns:asvg="http://schemas.microsoft.com/office/drawing/2016/SVG/main" r:embed="rId1"/>
-              </a:ext>
-            </a:extLst>
-          </a:blip>
-          <a:stretch>
-            <a:fillRect/>
-          </a:stretch>
-        </a:blipFill>
-        <a:ln>
-          <a:noFill/>
-        </a:ln>
-      </dgm:spPr>
-      <dgm:extLst>
-        <a:ext uri="{E40237B7-FDA0-4F09-8148-C483321AD2D9}">
-          <dgm14:cNvPr xmlns:dgm14="http://schemas.microsoft.com/office/drawing/2010/diagram" id="0" name="" descr="Document"/>
-        </a:ext>
-      </dgm:extLst>
-    </dgm:pt>
-    <dgm:pt modelId="{1B85644A-60A1-43A7-9C06-F988AFB9A402}" type="pres">
-      <dgm:prSet presAssocID="{7B4EB37C-65E1-4320-A1C8-6A01837487C0}" presName="spaceRect" presStyleCnt="0"/>
+    <dgm:pt modelId="{708E7981-87DE-4811-9E17-B63C5920DFB5}" type="pres">
+      <dgm:prSet presAssocID="{7B4EB37C-65E1-4320-A1C8-6A01837487C0}" presName="horz1" presStyleCnt="0"/>
       <dgm:spPr/>
     </dgm:pt>
-    <dgm:pt modelId="{16685366-0A94-42C3-A8CB-193F2F5363F7}" type="pres">
-      <dgm:prSet presAssocID="{7B4EB37C-65E1-4320-A1C8-6A01837487C0}" presName="textRect" presStyleLbl="revTx" presStyleIdx="0" presStyleCnt="2">
-        <dgm:presLayoutVars>
-          <dgm:chMax val="1"/>
-          <dgm:chPref val="1"/>
-        </dgm:presLayoutVars>
-      </dgm:prSet>
+    <dgm:pt modelId="{2E8A60AF-1707-43CE-870A-BAF4DB4CCB16}" type="pres">
+      <dgm:prSet presAssocID="{7B4EB37C-65E1-4320-A1C8-6A01837487C0}" presName="tx1" presStyleLbl="revTx" presStyleIdx="0" presStyleCnt="2"/>
       <dgm:spPr/>
     </dgm:pt>
-    <dgm:pt modelId="{F499BA24-3DEC-4A05-BF9C-AA48C49F6CD9}" type="pres">
-      <dgm:prSet presAssocID="{2878D96C-055C-4654-A12B-EEA45CF78BEB}" presName="sibTrans" presStyleCnt="0"/>
+    <dgm:pt modelId="{CB9FCD34-D67C-4631-B82B-8809FF96AC82}" type="pres">
+      <dgm:prSet presAssocID="{7B4EB37C-65E1-4320-A1C8-6A01837487C0}" presName="vert1" presStyleCnt="0"/>
       <dgm:spPr/>
     </dgm:pt>
-    <dgm:pt modelId="{19808E52-4748-4BB3-AF06-17E3A78D4C5A}" type="pres">
-      <dgm:prSet presAssocID="{B1743F7D-99B5-4190-BA02-2DE7073F6B59}" presName="compNode" presStyleCnt="0"/>
+    <dgm:pt modelId="{6A85BD19-7F4D-4D2D-AC21-C20A3A4E6E43}" type="pres">
+      <dgm:prSet presAssocID="{B1743F7D-99B5-4190-BA02-2DE7073F6B59}" presName="thickLine" presStyleLbl="alignNode1" presStyleIdx="1" presStyleCnt="2"/>
       <dgm:spPr/>
     </dgm:pt>
-    <dgm:pt modelId="{A6DE06F4-093C-43DD-98EE-E2813756FCB4}" type="pres">
-      <dgm:prSet presAssocID="{B1743F7D-99B5-4190-BA02-2DE7073F6B59}" presName="iconRect" presStyleLbl="node1" presStyleIdx="1" presStyleCnt="2"/>
-      <dgm:spPr>
-        <a:blipFill>
-          <a:blip xmlns:r="http://schemas.openxmlformats.org/officeDocument/2006/relationships">
-            <a:extLst>
-              <a:ext uri="{28A0092B-C50C-407E-A947-70E740481C1C}">
-                <a14:useLocalDpi xmlns:a14="http://schemas.microsoft.com/office/drawing/2010/main" val="0"/>
-              </a:ext>
-              <a:ext uri="{96DAC541-7B7A-43D3-8B79-37D633B846F1}">
-                <asvg:svgBlip xmlns:asvg="http://schemas.microsoft.com/office/drawing/2016/SVG/main" r:embed="rId2"/>
-              </a:ext>
-            </a:extLst>
-          </a:blip>
-          <a:stretch>
-            <a:fillRect/>
-          </a:stretch>
-        </a:blipFill>
-        <a:ln>
-          <a:noFill/>
-        </a:ln>
-      </dgm:spPr>
-      <dgm:extLst>
-        <a:ext uri="{E40237B7-FDA0-4F09-8148-C483321AD2D9}">
-          <dgm14:cNvPr xmlns:dgm14="http://schemas.microsoft.com/office/drawing/2010/diagram" id="0" name="" descr="Jouer"/>
-        </a:ext>
-      </dgm:extLst>
-    </dgm:pt>
-    <dgm:pt modelId="{AD5C9213-8655-48FE-BB06-2349664ABCCC}" type="pres">
-      <dgm:prSet presAssocID="{B1743F7D-99B5-4190-BA02-2DE7073F6B59}" presName="spaceRect" presStyleCnt="0"/>
+    <dgm:pt modelId="{90D3898D-86DB-4DE9-9A49-23DB2EBAD30D}" type="pres">
+      <dgm:prSet presAssocID="{B1743F7D-99B5-4190-BA02-2DE7073F6B59}" presName="horz1" presStyleCnt="0"/>
       <dgm:spPr/>
     </dgm:pt>
-    <dgm:pt modelId="{D0ACE368-23CF-4CBE-847E-EE16D07F7549}" type="pres">
-      <dgm:prSet presAssocID="{B1743F7D-99B5-4190-BA02-2DE7073F6B59}" presName="textRect" presStyleLbl="revTx" presStyleIdx="1" presStyleCnt="2">
-        <dgm:presLayoutVars>
-          <dgm:chMax val="1"/>
-          <dgm:chPref val="1"/>
-        </dgm:presLayoutVars>
-      </dgm:prSet>
+    <dgm:pt modelId="{CA0381D3-4C7F-41B8-B6B0-F32D10F42831}" type="pres">
+      <dgm:prSet presAssocID="{B1743F7D-99B5-4190-BA02-2DE7073F6B59}" presName="tx1" presStyleLbl="revTx" presStyleIdx="1" presStyleCnt="2"/>
+      <dgm:spPr/>
+    </dgm:pt>
+    <dgm:pt modelId="{B2944739-840B-490C-90AC-473B938723E8}" type="pres">
+      <dgm:prSet presAssocID="{B1743F7D-99B5-4190-BA02-2DE7073F6B59}" presName="vert1" presStyleCnt="0"/>
       <dgm:spPr/>
     </dgm:pt>
   </dgm:ptLst>
   <dgm:cxnLst>
     <dgm:cxn modelId="{F60DAC35-B5F4-4D45-8776-DFD4BBF18DD6}" srcId="{CEFE2C82-2EF5-4777-BFE7-0DA03B660312}" destId="{7B4EB37C-65E1-4320-A1C8-6A01837487C0}" srcOrd="0" destOrd="0" parTransId="{9BE07BCD-4549-4F8C-AF28-63EE5C9C4E01}" sibTransId="{2878D96C-055C-4654-A12B-EEA45CF78BEB}"/>
     <dgm:cxn modelId="{A3F5E842-2F80-45F4-9299-6DB77CFEC81D}" srcId="{CEFE2C82-2EF5-4777-BFE7-0DA03B660312}" destId="{B1743F7D-99B5-4190-BA02-2DE7073F6B59}" srcOrd="1" destOrd="0" parTransId="{88A11634-6DAA-47B0-BCB7-935FA0C593AC}" sibTransId="{D0440B15-D985-4006-9BEE-DF79E11AAFD7}"/>
-    <dgm:cxn modelId="{CA2BFC42-7C9B-44C8-9E4B-0E7B57A51C34}" type="presOf" srcId="{CEFE2C82-2EF5-4777-BFE7-0DA03B660312}" destId="{DE564F7C-45E9-46C7-901E-E3EB90DB5F0C}" srcOrd="0" destOrd="0" presId="urn:microsoft.com/office/officeart/2018/2/layout/IconLabelList"/>
-    <dgm:cxn modelId="{0C5983B8-8CFA-40AB-B7F8-14B3D80ABFD1}" type="presOf" srcId="{B1743F7D-99B5-4190-BA02-2DE7073F6B59}" destId="{D0ACE368-23CF-4CBE-847E-EE16D07F7549}" srcOrd="0" destOrd="0" presId="urn:microsoft.com/office/officeart/2018/2/layout/IconLabelList"/>
-    <dgm:cxn modelId="{12F80CBD-6A7F-4AF3-83A0-F70929F529EE}" type="presOf" srcId="{7B4EB37C-65E1-4320-A1C8-6A01837487C0}" destId="{16685366-0A94-42C3-A8CB-193F2F5363F7}" srcOrd="0" destOrd="0" presId="urn:microsoft.com/office/officeart/2018/2/layout/IconLabelList"/>
-    <dgm:cxn modelId="{519AAF2E-1F25-4B74-A0DC-73E854D23896}" type="presParOf" srcId="{DE564F7C-45E9-46C7-901E-E3EB90DB5F0C}" destId="{6A42CE9E-23B5-4FD0-BB55-804F57B4272A}" srcOrd="0" destOrd="0" presId="urn:microsoft.com/office/officeart/2018/2/layout/IconLabelList"/>
-    <dgm:cxn modelId="{53ABF2F3-6E33-4FC4-978C-F5641DA39145}" type="presParOf" srcId="{6A42CE9E-23B5-4FD0-BB55-804F57B4272A}" destId="{279B3533-5314-450C-A22D-72FAE911C470}" srcOrd="0" destOrd="0" presId="urn:microsoft.com/office/officeart/2018/2/layout/IconLabelList"/>
-    <dgm:cxn modelId="{786736A8-2F1C-4149-9561-0D96F420CA03}" type="presParOf" srcId="{6A42CE9E-23B5-4FD0-BB55-804F57B4272A}" destId="{1B85644A-60A1-43A7-9C06-F988AFB9A402}" srcOrd="1" destOrd="0" presId="urn:microsoft.com/office/officeart/2018/2/layout/IconLabelList"/>
-    <dgm:cxn modelId="{04253BBB-80AF-4972-84BB-C18D3678D9FD}" type="presParOf" srcId="{6A42CE9E-23B5-4FD0-BB55-804F57B4272A}" destId="{16685366-0A94-42C3-A8CB-193F2F5363F7}" srcOrd="2" destOrd="0" presId="urn:microsoft.com/office/officeart/2018/2/layout/IconLabelList"/>
-    <dgm:cxn modelId="{DF585AE8-B493-4CC9-BD9B-ACE70AF97D10}" type="presParOf" srcId="{DE564F7C-45E9-46C7-901E-E3EB90DB5F0C}" destId="{F499BA24-3DEC-4A05-BF9C-AA48C49F6CD9}" srcOrd="1" destOrd="0" presId="urn:microsoft.com/office/officeart/2018/2/layout/IconLabelList"/>
-    <dgm:cxn modelId="{D4FA4EC5-0136-4C10-B1DB-5CE92DB62713}" type="presParOf" srcId="{DE564F7C-45E9-46C7-901E-E3EB90DB5F0C}" destId="{19808E52-4748-4BB3-AF06-17E3A78D4C5A}" srcOrd="2" destOrd="0" presId="urn:microsoft.com/office/officeart/2018/2/layout/IconLabelList"/>
-    <dgm:cxn modelId="{38705AAF-B537-4FFF-A1C1-487B83B4BE91}" type="presParOf" srcId="{19808E52-4748-4BB3-AF06-17E3A78D4C5A}" destId="{A6DE06F4-093C-43DD-98EE-E2813756FCB4}" srcOrd="0" destOrd="0" presId="urn:microsoft.com/office/officeart/2018/2/layout/IconLabelList"/>
-    <dgm:cxn modelId="{CAC0B1FE-56C2-45A3-9EBE-AD3EB93959C4}" type="presParOf" srcId="{19808E52-4748-4BB3-AF06-17E3A78D4C5A}" destId="{AD5C9213-8655-48FE-BB06-2349664ABCCC}" srcOrd="1" destOrd="0" presId="urn:microsoft.com/office/officeart/2018/2/layout/IconLabelList"/>
-    <dgm:cxn modelId="{E55F9AEF-7DCD-4E06-84A9-F7063DCBF755}" type="presParOf" srcId="{19808E52-4748-4BB3-AF06-17E3A78D4C5A}" destId="{D0ACE368-23CF-4CBE-847E-EE16D07F7549}" srcOrd="2" destOrd="0" presId="urn:microsoft.com/office/officeart/2018/2/layout/IconLabelList"/>
+    <dgm:cxn modelId="{4614284B-D4F6-4156-97F8-19694BA5E932}" type="presOf" srcId="{7B4EB37C-65E1-4320-A1C8-6A01837487C0}" destId="{2E8A60AF-1707-43CE-870A-BAF4DB4CCB16}" srcOrd="0" destOrd="0" presId="urn:microsoft.com/office/officeart/2008/layout/LinedList"/>
+    <dgm:cxn modelId="{05B0416E-5BC9-4DD8-82F1-711B63B920CD}" type="presOf" srcId="{CEFE2C82-2EF5-4777-BFE7-0DA03B660312}" destId="{EA2DC5E0-B912-4B82-92B0-B5A07E303795}" srcOrd="0" destOrd="0" presId="urn:microsoft.com/office/officeart/2008/layout/LinedList"/>
+    <dgm:cxn modelId="{7FED44A4-D546-448E-A4FE-BA42015235A6}" type="presOf" srcId="{B1743F7D-99B5-4190-BA02-2DE7073F6B59}" destId="{CA0381D3-4C7F-41B8-B6B0-F32D10F42831}" srcOrd="0" destOrd="0" presId="urn:microsoft.com/office/officeart/2008/layout/LinedList"/>
+    <dgm:cxn modelId="{BCD189DB-4A26-4BE1-A66C-E4294BB27527}" type="presParOf" srcId="{EA2DC5E0-B912-4B82-92B0-B5A07E303795}" destId="{EAC43F18-9025-4AA1-B14A-44E3002A361A}" srcOrd="0" destOrd="0" presId="urn:microsoft.com/office/officeart/2008/layout/LinedList"/>
+    <dgm:cxn modelId="{E6CFEE0A-A673-4344-9ECD-F868F5C1CFC9}" type="presParOf" srcId="{EA2DC5E0-B912-4B82-92B0-B5A07E303795}" destId="{708E7981-87DE-4811-9E17-B63C5920DFB5}" srcOrd="1" destOrd="0" presId="urn:microsoft.com/office/officeart/2008/layout/LinedList"/>
+    <dgm:cxn modelId="{469EDF3A-51F8-4A34-8771-3E9D0E523FCB}" type="presParOf" srcId="{708E7981-87DE-4811-9E17-B63C5920DFB5}" destId="{2E8A60AF-1707-43CE-870A-BAF4DB4CCB16}" srcOrd="0" destOrd="0" presId="urn:microsoft.com/office/officeart/2008/layout/LinedList"/>
+    <dgm:cxn modelId="{5FF66977-D5D3-4565-AE85-9E522BE16E61}" type="presParOf" srcId="{708E7981-87DE-4811-9E17-B63C5920DFB5}" destId="{CB9FCD34-D67C-4631-B82B-8809FF96AC82}" srcOrd="1" destOrd="0" presId="urn:microsoft.com/office/officeart/2008/layout/LinedList"/>
+    <dgm:cxn modelId="{A5E18CFA-8304-46B9-8A32-CA94F488A954}" type="presParOf" srcId="{EA2DC5E0-B912-4B82-92B0-B5A07E303795}" destId="{6A85BD19-7F4D-4D2D-AC21-C20A3A4E6E43}" srcOrd="2" destOrd="0" presId="urn:microsoft.com/office/officeart/2008/layout/LinedList"/>
+    <dgm:cxn modelId="{61885C7F-5A3D-48B7-8A6C-2141A3A2B4B6}" type="presParOf" srcId="{EA2DC5E0-B912-4B82-92B0-B5A07E303795}" destId="{90D3898D-86DB-4DE9-9A49-23DB2EBAD30D}" srcOrd="3" destOrd="0" presId="urn:microsoft.com/office/officeart/2008/layout/LinedList"/>
+    <dgm:cxn modelId="{A204AF67-DA74-48F4-9485-A6295801AA09}" type="presParOf" srcId="{90D3898D-86DB-4DE9-9A49-23DB2EBAD30D}" destId="{CA0381D3-4C7F-41B8-B6B0-F32D10F42831}" srcOrd="0" destOrd="0" presId="urn:microsoft.com/office/officeart/2008/layout/LinedList"/>
+    <dgm:cxn modelId="{5B4A8725-D11C-4E5D-9926-80C20F8B70C3}" type="presParOf" srcId="{90D3898D-86DB-4DE9-9A49-23DB2EBAD30D}" destId="{B2944739-840B-490C-90AC-473B938723E8}" srcOrd="1" destOrd="0" presId="urn:microsoft.com/office/officeart/2008/layout/LinedList"/>
   </dgm:cxnLst>
   <dgm:bg/>
   <dgm:whole/>
@@ -1097,36 +1034,36 @@
       <dsp:cNvGrpSpPr/>
     </dsp:nvGrpSpPr>
     <dsp:grpSpPr/>
-    <dsp:sp modelId="{279B3533-5314-450C-A22D-72FAE911C470}">
+    <dsp:sp modelId="{EAC43F18-9025-4AA1-B14A-44E3002A361A}">
       <dsp:nvSpPr>
         <dsp:cNvPr id="0" name=""/>
         <dsp:cNvSpPr/>
       </dsp:nvSpPr>
       <dsp:spPr>
         <a:xfrm>
-          <a:off x="2068474" y="316490"/>
-          <a:ext cx="1944000" cy="1944000"/>
+          <a:off x="0" y="0"/>
+          <a:ext cx="11156950" cy="0"/>
         </a:xfrm>
-        <a:prstGeom prst="rect">
+        <a:prstGeom prst="line">
           <a:avLst/>
         </a:prstGeom>
-        <a:blipFill>
-          <a:blip xmlns:r="http://schemas.openxmlformats.org/officeDocument/2006/relationships">
-            <a:extLst>
-              <a:ext uri="{28A0092B-C50C-407E-A947-70E740481C1C}">
-                <a14:useLocalDpi xmlns:a14="http://schemas.microsoft.com/office/drawing/2010/main" val="0"/>
-              </a:ext>
-              <a:ext uri="{96DAC541-7B7A-43D3-8B79-37D633B846F1}">
-                <asvg:svgBlip xmlns:asvg="http://schemas.microsoft.com/office/drawing/2016/SVG/main" r:embed="rId1"/>
-              </a:ext>
-            </a:extLst>
-          </a:blip>
-          <a:stretch>
-            <a:fillRect/>
-          </a:stretch>
-        </a:blipFill>
+        <a:solidFill>
+          <a:schemeClr val="accent1">
+            <a:hueOff val="0"/>
+            <a:satOff val="0"/>
+            <a:lumOff val="0"/>
+            <a:alphaOff val="0"/>
+          </a:schemeClr>
+        </a:solidFill>
         <a:ln w="19050" cap="flat" cmpd="sng" algn="ctr">
-          <a:noFill/>
+          <a:solidFill>
+            <a:schemeClr val="accent1">
+              <a:hueOff val="0"/>
+              <a:satOff val="0"/>
+              <a:lumOff val="0"/>
+              <a:alphaOff val="0"/>
+            </a:schemeClr>
+          </a:solidFill>
           <a:prstDash val="solid"/>
           <a:miter lim="800000"/>
         </a:ln>
@@ -1147,15 +1084,15 @@
         </a:fontRef>
       </dsp:style>
     </dsp:sp>
-    <dsp:sp modelId="{16685366-0A94-42C3-A8CB-193F2F5363F7}">
+    <dsp:sp modelId="{2E8A60AF-1707-43CE-870A-BAF4DB4CCB16}">
       <dsp:nvSpPr>
         <dsp:cNvPr id="0" name=""/>
         <dsp:cNvSpPr/>
       </dsp:nvSpPr>
       <dsp:spPr>
         <a:xfrm>
-          <a:off x="880474" y="2730647"/>
-          <a:ext cx="4320000" cy="720000"/>
+          <a:off x="0" y="0"/>
+          <a:ext cx="11156950" cy="1883568"/>
         </a:xfrm>
         <a:prstGeom prst="rect">
           <a:avLst/>
@@ -1179,12 +1116,12 @@
         <a:fontRef idx="minor"/>
       </dsp:style>
       <dsp:txBody>
-        <a:bodyPr spcFirstLastPara="0" vert="horz" wrap="square" lIns="0" tIns="0" rIns="0" bIns="0" numCol="1" spcCol="1270" anchor="t" anchorCtr="0">
+        <a:bodyPr spcFirstLastPara="0" vert="horz" wrap="square" lIns="201930" tIns="201930" rIns="201930" bIns="201930" numCol="1" spcCol="1270" anchor="t" anchorCtr="0">
           <a:noAutofit/>
         </a:bodyPr>
         <a:lstStyle/>
         <a:p>
-          <a:pPr marL="0" lvl="0" indent="0" algn="ctr" defTabSz="1155700">
+          <a:pPr marL="0" lvl="0" indent="0" algn="l" defTabSz="2355850">
             <a:lnSpc>
               <a:spcPct val="90000"/>
             </a:lnSpc>
@@ -1197,47 +1134,47 @@
             <a:buNone/>
           </a:pPr>
           <a:r>
-            <a:rPr lang="fr-CH" sz="2600" kern="1200"/>
+            <a:rPr lang="fr-CH" sz="5300" kern="1200" dirty="0"/>
             <a:t>Création du fichier pour le matériels nécessaires </a:t>
           </a:r>
-          <a:endParaRPr lang="en-US" sz="2600" kern="1200"/>
+          <a:endParaRPr lang="en-US" sz="5300" kern="1200" dirty="0"/>
         </a:p>
       </dsp:txBody>
       <dsp:txXfrm>
-        <a:off x="880474" y="2730647"/>
-        <a:ext cx="4320000" cy="720000"/>
+        <a:off x="0" y="0"/>
+        <a:ext cx="11156950" cy="1883568"/>
       </dsp:txXfrm>
     </dsp:sp>
-    <dsp:sp modelId="{A6DE06F4-093C-43DD-98EE-E2813756FCB4}">
+    <dsp:sp modelId="{6A85BD19-7F4D-4D2D-AC21-C20A3A4E6E43}">
       <dsp:nvSpPr>
         <dsp:cNvPr id="0" name=""/>
         <dsp:cNvSpPr/>
       </dsp:nvSpPr>
       <dsp:spPr>
         <a:xfrm>
-          <a:off x="7144475" y="316490"/>
-          <a:ext cx="1944000" cy="1944000"/>
+          <a:off x="0" y="1883568"/>
+          <a:ext cx="11156950" cy="0"/>
         </a:xfrm>
-        <a:prstGeom prst="rect">
+        <a:prstGeom prst="line">
           <a:avLst/>
         </a:prstGeom>
-        <a:blipFill>
-          <a:blip xmlns:r="http://schemas.openxmlformats.org/officeDocument/2006/relationships">
-            <a:extLst>
-              <a:ext uri="{28A0092B-C50C-407E-A947-70E740481C1C}">
-                <a14:useLocalDpi xmlns:a14="http://schemas.microsoft.com/office/drawing/2010/main" val="0"/>
-              </a:ext>
-              <a:ext uri="{96DAC541-7B7A-43D3-8B79-37D633B846F1}">
-                <asvg:svgBlip xmlns:asvg="http://schemas.microsoft.com/office/drawing/2016/SVG/main" r:embed="rId2"/>
-              </a:ext>
-            </a:extLst>
-          </a:blip>
-          <a:stretch>
-            <a:fillRect/>
-          </a:stretch>
-        </a:blipFill>
+        <a:solidFill>
+          <a:schemeClr val="accent1">
+            <a:hueOff val="0"/>
+            <a:satOff val="0"/>
+            <a:lumOff val="0"/>
+            <a:alphaOff val="0"/>
+          </a:schemeClr>
+        </a:solidFill>
         <a:ln w="19050" cap="flat" cmpd="sng" algn="ctr">
-          <a:noFill/>
+          <a:solidFill>
+            <a:schemeClr val="accent1">
+              <a:hueOff val="0"/>
+              <a:satOff val="0"/>
+              <a:lumOff val="0"/>
+              <a:alphaOff val="0"/>
+            </a:schemeClr>
+          </a:solidFill>
           <a:prstDash val="solid"/>
           <a:miter lim="800000"/>
         </a:ln>
@@ -1258,15 +1195,15 @@
         </a:fontRef>
       </dsp:style>
     </dsp:sp>
-    <dsp:sp modelId="{D0ACE368-23CF-4CBE-847E-EE16D07F7549}">
+    <dsp:sp modelId="{CA0381D3-4C7F-41B8-B6B0-F32D10F42831}">
       <dsp:nvSpPr>
         <dsp:cNvPr id="0" name=""/>
         <dsp:cNvSpPr/>
       </dsp:nvSpPr>
       <dsp:spPr>
         <a:xfrm>
-          <a:off x="5956475" y="2730647"/>
-          <a:ext cx="4320000" cy="720000"/>
+          <a:off x="0" y="1883568"/>
+          <a:ext cx="11156950" cy="1883568"/>
         </a:xfrm>
         <a:prstGeom prst="rect">
           <a:avLst/>
@@ -1290,12 +1227,12 @@
         <a:fontRef idx="minor"/>
       </dsp:style>
       <dsp:txBody>
-        <a:bodyPr spcFirstLastPara="0" vert="horz" wrap="square" lIns="0" tIns="0" rIns="0" bIns="0" numCol="1" spcCol="1270" anchor="t" anchorCtr="0">
+        <a:bodyPr spcFirstLastPara="0" vert="horz" wrap="square" lIns="201930" tIns="201930" rIns="201930" bIns="201930" numCol="1" spcCol="1270" anchor="t" anchorCtr="0">
           <a:noAutofit/>
         </a:bodyPr>
         <a:lstStyle/>
         <a:p>
-          <a:pPr marL="0" lvl="0" indent="0" algn="ctr" defTabSz="1155700">
+          <a:pPr marL="0" lvl="0" indent="0" algn="l" defTabSz="2355850">
             <a:lnSpc>
               <a:spcPct val="90000"/>
             </a:lnSpc>
@@ -1308,15 +1245,15 @@
             <a:buNone/>
           </a:pPr>
           <a:r>
-            <a:rPr lang="fr-CH" sz="2600" kern="1200"/>
+            <a:rPr lang="fr-CH" sz="5300" kern="1200" dirty="0"/>
             <a:t>Création du fichier avec le retour de M. Sahli</a:t>
           </a:r>
-          <a:endParaRPr lang="en-US" sz="2600" kern="1200"/>
+          <a:endParaRPr lang="en-US" sz="5300" kern="1200" dirty="0"/>
         </a:p>
       </dsp:txBody>
       <dsp:txXfrm>
-        <a:off x="5956475" y="2730647"/>
-        <a:ext cx="4320000" cy="720000"/>
+        <a:off x="0" y="1883568"/>
+        <a:ext cx="11156950" cy="1883568"/>
       </dsp:txXfrm>
     </dsp:sp>
   </dsp:spTree>
@@ -1324,57 +1261,103 @@
 </file>
 
 <file path=ppt/diagrams/layout1.xml><?xml version="1.0" encoding="utf-8"?>
-<dgm:layoutDef xmlns:dgm="http://schemas.openxmlformats.org/drawingml/2006/diagram" xmlns:a="http://schemas.openxmlformats.org/drawingml/2006/main" uniqueId="urn:microsoft.com/office/officeart/2018/2/layout/IconLabelList">
-  <dgm:title val="Icon Label List"/>
-  <dgm:desc val="Use to show non-sequential or grouped chunks of information accompanied by a related visuals. Works best with icons or small pictures with short text captions."/>
+<dgm:layoutDef xmlns:dgm="http://schemas.openxmlformats.org/drawingml/2006/diagram" xmlns:a="http://schemas.openxmlformats.org/drawingml/2006/main" uniqueId="urn:microsoft.com/office/officeart/2008/layout/LinedList">
+  <dgm:title val=""/>
+  <dgm:desc val=""/>
   <dgm:catLst>
-    <dgm:cat type="icon" pri="500"/>
+    <dgm:cat type="hierarchy" pri="8000"/>
+    <dgm:cat type="list" pri="2500"/>
   </dgm:catLst>
-  <dgm:sampData useDef="1">
+  <dgm:sampData>
     <dgm:dataModel>
-      <dgm:ptLst/>
+      <dgm:ptLst>
+        <dgm:pt modelId="0" type="doc"/>
+        <dgm:pt modelId="1">
+          <dgm:prSet phldr="1"/>
+        </dgm:pt>
+        <dgm:pt modelId="11">
+          <dgm:prSet phldr="1"/>
+        </dgm:pt>
+        <dgm:pt modelId="12">
+          <dgm:prSet phldr="1"/>
+        </dgm:pt>
+        <dgm:pt modelId="13">
+          <dgm:prSet phldr="1"/>
+        </dgm:pt>
+      </dgm:ptLst>
+      <dgm:cxnLst>
+        <dgm:cxn modelId="2" srcId="0" destId="1" srcOrd="0" destOrd="0"/>
+        <dgm:cxn modelId="3" srcId="1" destId="11" srcOrd="0" destOrd="0"/>
+        <dgm:cxn modelId="4" srcId="1" destId="12" srcOrd="1" destOrd="0"/>
+        <dgm:cxn modelId="5" srcId="1" destId="13" srcOrd="2" destOrd="0"/>
+      </dgm:cxnLst>
       <dgm:bg/>
       <dgm:whole/>
     </dgm:dataModel>
   </dgm:sampData>
-  <dgm:styleData useDef="1">
+  <dgm:styleData>
     <dgm:dataModel>
-      <dgm:ptLst/>
+      <dgm:ptLst>
+        <dgm:pt modelId="0" type="doc"/>
+        <dgm:pt modelId="1">
+          <dgm:prSet phldr="1"/>
+        </dgm:pt>
+        <dgm:pt modelId="11">
+          <dgm:prSet phldr="1"/>
+        </dgm:pt>
+        <dgm:pt modelId="12">
+          <dgm:prSet phldr="1"/>
+        </dgm:pt>
+      </dgm:ptLst>
+      <dgm:cxnLst>
+        <dgm:cxn modelId="2" srcId="0" destId="1" srcOrd="0" destOrd="0"/>
+        <dgm:cxn modelId="3" srcId="1" destId="11" srcOrd="0" destOrd="0"/>
+        <dgm:cxn modelId="4" srcId="1" destId="12" srcOrd="1" destOrd="0"/>
+      </dgm:cxnLst>
       <dgm:bg/>
       <dgm:whole/>
     </dgm:dataModel>
   </dgm:styleData>
-  <dgm:clrData useDef="1">
+  <dgm:clrData>
     <dgm:dataModel>
-      <dgm:ptLst/>
+      <dgm:ptLst>
+        <dgm:pt modelId="0" type="doc"/>
+        <dgm:pt modelId="1">
+          <dgm:prSet phldr="1"/>
+        </dgm:pt>
+        <dgm:pt modelId="11">
+          <dgm:prSet phldr="1"/>
+        </dgm:pt>
+        <dgm:pt modelId="12">
+          <dgm:prSet phldr="1"/>
+        </dgm:pt>
+      </dgm:ptLst>
+      <dgm:cxnLst>
+        <dgm:cxn modelId="2" srcId="0" destId="1" srcOrd="0" destOrd="0"/>
+        <dgm:cxn modelId="3" srcId="1" destId="11" srcOrd="0" destOrd="0"/>
+        <dgm:cxn modelId="4" srcId="1" destId="12" srcOrd="1" destOrd="0"/>
+      </dgm:cxnLst>
       <dgm:bg/>
       <dgm:whole/>
     </dgm:dataModel>
   </dgm:clrData>
-  <dgm:layoutNode name="root">
+  <dgm:layoutNode name="vert0">
     <dgm:varLst>
       <dgm:dir/>
-      <dgm:resizeHandles val="exact"/>
+      <dgm:animOne val="branch"/>
+      <dgm:animLvl val="lvl"/>
     </dgm:varLst>
     <dgm:choose name="Name0">
-      <dgm:if name="Name1" axis="self" func="var" arg="dir" op="equ" val="norm">
-        <dgm:alg type="snake">
-          <dgm:param type="grDir" val="tL"/>
-          <dgm:param type="flowDir" val="row"/>
-          <dgm:param type="contDir" val="sameDir"/>
-          <dgm:param type="off" val="ctr"/>
-          <dgm:param type="vertAlign" val="mid"/>
-          <dgm:param type="horzAlign" val="ctr"/>
+      <dgm:if name="Name1" func="var" arg="dir" op="equ" val="norm">
+        <dgm:alg type="lin">
+          <dgm:param type="linDir" val="fromT"/>
+          <dgm:param type="nodeHorzAlign" val="l"/>
         </dgm:alg>
       </dgm:if>
       <dgm:else name="Name2">
-        <dgm:alg type="snake">
-          <dgm:param type="grDir" val="tR"/>
-          <dgm:param type="flowDir" val="row"/>
-          <dgm:param type="contDir" val="sameDir"/>
-          <dgm:param type="off" val="ctr"/>
-          <dgm:param type="vertAlign" val="mid"/>
-          <dgm:param type="horzAlign" val="ctr"/>
+        <dgm:alg type="lin">
+          <dgm:param type="linDir" val="fromT"/>
+          <dgm:param type="nodeHorzAlign" val="r"/>
         </dgm:alg>
       </dgm:else>
     </dgm:choose>
@@ -1382,134 +1365,364 @@
       <dgm:adjLst/>
     </dgm:shape>
     <dgm:presOf/>
-    <dgm:choose name="Name3">
-      <dgm:if name="Name4" axis="ch" ptType="node" func="cnt" op="lte" val="2">
-        <dgm:constrLst>
-          <dgm:constr type="h" for="ch" forName="compNode" refType="h" fact="0.4"/>
-          <dgm:constr type="w" for="ch" forName="compNode" val="120"/>
-          <dgm:constr type="w" for="ch" forName="sibTrans" refType="w" refFor="ch" refForName="compNode" fact="0.175"/>
-          <dgm:constr type="sp" refType="w" refFor="ch" refForName="compNode" op="equ" fact="0.25"/>
-          <dgm:constr type="primFontSz" for="des" ptType="node" op="equ" val="50"/>
-          <dgm:constr type="h" for="des" forName="compNode" op="equ"/>
-          <dgm:constr type="h" for="des" forName="textRect" op="equ"/>
-        </dgm:constrLst>
-      </dgm:if>
-      <dgm:if name="Name5" axis="ch" ptType="node" func="cnt" op="lte" val="4">
-        <dgm:constrLst>
-          <dgm:constr type="h" for="ch" forName="compNode" refType="h" fact="0.4"/>
-          <dgm:constr type="w" for="ch" forName="compNode" refType="w"/>
-          <dgm:constr type="w" for="ch" forName="sibTrans" refType="w" refFor="ch" refForName="compNode" fact="0.175"/>
-          <dgm:constr type="sp" refType="w" refFor="ch" refForName="compNode" op="equ" fact="0.25"/>
-          <dgm:constr type="primFontSz" for="des" ptType="node" op="equ" val="36"/>
-          <dgm:constr type="h" for="des" forName="compNode" op="equ"/>
-          <dgm:constr type="h" for="des" forName="textRect" op="equ"/>
-        </dgm:constrLst>
-      </dgm:if>
-      <dgm:else name="Name6">
-        <dgm:constrLst>
-          <dgm:constr type="h" for="ch" forName="compNode" refType="h" fact="0.4"/>
-          <dgm:constr type="w" for="ch" forName="compNode" refType="w"/>
-          <dgm:constr type="w" for="ch" forName="sibTrans" refType="w" refFor="ch" refForName="compNode" fact="0.175"/>
-          <dgm:constr type="sp" refType="w" refFor="ch" refForName="compNode" op="equ" fact="0.25"/>
-          <dgm:constr type="primFontSz" for="des" ptType="node" op="equ" val="24"/>
-          <dgm:constr type="h" for="des" forName="compNode" op="equ"/>
-          <dgm:constr type="h" for="des" forName="textRect" op="equ"/>
-        </dgm:constrLst>
-      </dgm:else>
-    </dgm:choose>
-    <dgm:ruleLst>
-      <dgm:rule type="w" for="ch" forName="compNode" val="50" fact="NaN" max="NaN"/>
-    </dgm:ruleLst>
-    <dgm:forEach name="Name7" axis="ch" ptType="node">
-      <dgm:layoutNode name="compNode">
-        <dgm:alg type="composite"/>
+    <dgm:constrLst>
+      <dgm:constr type="w" for="ch" forName="horz1" refType="w"/>
+      <dgm:constr type="h" for="ch" forName="horz1" refType="h"/>
+      <dgm:constr type="h" for="des" forName="vert1" refType="h"/>
+      <dgm:constr type="h" for="des" forName="tx1" refType="h"/>
+      <dgm:constr type="h" for="des" forName="horz2" refType="h"/>
+      <dgm:constr type="h" for="des" forName="vert2" refType="h"/>
+      <dgm:constr type="h" for="des" forName="horz3" refType="h"/>
+      <dgm:constr type="h" for="des" forName="vert3" refType="h"/>
+      <dgm:constr type="h" for="des" forName="horz4" refType="h"/>
+      <dgm:constr type="h" for="des" ptType="node" refType="h"/>
+      <dgm:constr type="primFontSz" for="des" forName="tx1" op="equ" val="65"/>
+      <dgm:constr type="primFontSz" for="des" forName="tx2" op="equ" val="65"/>
+      <dgm:constr type="primFontSz" for="des" forName="tx3" op="equ" val="65"/>
+      <dgm:constr type="primFontSz" for="des" forName="tx4" op="equ" val="65"/>
+      <dgm:constr type="w" for="des" forName="thickLine" refType="w"/>
+      <dgm:constr type="h" for="des" forName="thickLine"/>
+      <dgm:constr type="h" for="des" forName="thinLine1"/>
+      <dgm:constr type="h" for="des" forName="thinLine2b"/>
+      <dgm:constr type="h" for="des" forName="thinLine3"/>
+      <dgm:constr type="h" for="des" forName="vertSpace2a" refType="h" fact="0.05"/>
+      <dgm:constr type="h" for="des" forName="vertSpace2b" refType="h" refFor="des" refForName="vertSpace2a"/>
+    </dgm:constrLst>
+    <dgm:forEach name="Name3" axis="ch" ptType="node">
+      <dgm:layoutNode name="thickLine" styleLbl="alignNode1">
+        <dgm:alg type="sp"/>
+        <dgm:shape xmlns:r="http://schemas.openxmlformats.org/officeDocument/2006/relationships" type="line" r:blip="">
+          <dgm:adjLst/>
+        </dgm:shape>
+        <dgm:presOf/>
+      </dgm:layoutNode>
+      <dgm:layoutNode name="horz1">
+        <dgm:choose name="Name4">
+          <dgm:if name="Name5" func="var" arg="dir" op="equ" val="norm">
+            <dgm:alg type="lin">
+              <dgm:param type="linDir" val="fromL"/>
+              <dgm:param type="nodeVertAlign" val="t"/>
+            </dgm:alg>
+          </dgm:if>
+          <dgm:else name="Name6">
+            <dgm:alg type="lin">
+              <dgm:param type="linDir" val="fromR"/>
+              <dgm:param type="nodeVertAlign" val="t"/>
+            </dgm:alg>
+          </dgm:else>
+        </dgm:choose>
         <dgm:shape xmlns:r="http://schemas.openxmlformats.org/officeDocument/2006/relationships" r:blip="">
           <dgm:adjLst/>
         </dgm:shape>
-        <dgm:presOf axis="self"/>
-        <dgm:constrLst>
-          <dgm:constr type="w" for="ch" forName="iconRect" refType="w" fact="0.45"/>
-          <dgm:constr type="h" for="ch" forName="iconRect" refType="w" refFor="ch" refForName="iconRect"/>
-          <dgm:constr type="ctrX" for="ch" forName="iconRect" refType="w" fact="0.5"/>
-          <dgm:constr type="t" for="ch" forName="iconRect"/>
-          <dgm:constr type="h" for="ch" forName="spaceRect" refType="h" fact="0.15"/>
-          <dgm:constr type="w" for="ch" forName="spaceRect" refType="w"/>
-          <dgm:constr type="l" for="ch" forName="spaceRect"/>
-          <dgm:constr type="t" for="ch" forName="spaceRect" refType="b" refFor="ch" refForName="iconRect"/>
-          <dgm:constr type="h" for="ch" forName="textRect" val="20"/>
-          <dgm:constr type="w" for="ch" forName="textRect" refType="w"/>
-          <dgm:constr type="l" for="ch" forName="textRect"/>
-          <dgm:constr type="t" for="ch" forName="textRect" refType="b" refFor="ch" refForName="spaceRect"/>
-        </dgm:constrLst>
-        <dgm:ruleLst>
-          <dgm:rule type="h" val="INF" fact="NaN" max="NaN"/>
-        </dgm:ruleLst>
-        <dgm:layoutNode name="iconRect" styleLbl="node1">
-          <dgm:alg type="sp"/>
-          <dgm:shape xmlns:r="http://schemas.openxmlformats.org/officeDocument/2006/relationships" type="rect" r:blip="" blipPhldr="1">
-            <dgm:adjLst/>
-          </dgm:shape>
-          <dgm:presOf/>
-          <dgm:constrLst/>
-          <dgm:ruleLst/>
-        </dgm:layoutNode>
-        <dgm:layoutNode name="spaceRect">
-          <dgm:alg type="sp"/>
-          <dgm:shape xmlns:r="http://schemas.openxmlformats.org/officeDocument/2006/relationships" r:blip="">
-            <dgm:adjLst/>
-          </dgm:shape>
-          <dgm:presOf/>
-          <dgm:constrLst/>
-          <dgm:ruleLst/>
-        </dgm:layoutNode>
-        <dgm:layoutNode name="textRect" styleLbl="revTx">
-          <dgm:varLst>
-            <dgm:chMax val="1"/>
-            <dgm:chPref val="1"/>
-          </dgm:varLst>
+        <dgm:presOf/>
+        <dgm:choose name="Name7">
+          <dgm:if name="Name8" axis="root des" func="maxDepth" op="equ" val="1">
+            <dgm:constrLst>
+              <dgm:constr type="w" for="ch" forName="tx1" refType="w"/>
+            </dgm:constrLst>
+          </dgm:if>
+          <dgm:if name="Name9" axis="root des" func="maxDepth" op="equ" val="2">
+            <dgm:constrLst>
+              <dgm:constr type="w" for="ch" forName="tx1" refType="w" fact="0.2"/>
+              <dgm:constr type="w" for="des" forName="tx2" refType="w" fact="0.785"/>
+              <dgm:constr type="w" for="des" forName="horzSpace2" refType="w" fact="0.015"/>
+              <dgm:constr type="w" for="des" forName="thinLine2b" refType="w" fact="0.8"/>
+            </dgm:constrLst>
+          </dgm:if>
+          <dgm:if name="Name10" axis="root des" func="maxDepth" op="equ" val="3">
+            <dgm:constrLst>
+              <dgm:constr type="w" for="ch" forName="tx1" refType="w" fact="0.2"/>
+              <dgm:constr type="w" for="des" forName="tx2" refType="w" fact="0.385"/>
+              <dgm:constr type="w" for="des" forName="tx3" refType="w" fact="0.385"/>
+              <dgm:constr type="w" for="des" forName="horzSpace2" refType="w" fact="0.015"/>
+              <dgm:constr type="w" for="des" forName="horzSpace3" refType="w" fact="0.015"/>
+              <dgm:constr type="w" for="des" forName="thinLine2b" refType="w" fact="0.8"/>
+              <dgm:constr type="w" for="des" forName="thinLine3" refType="w" fact="0.385"/>
+            </dgm:constrLst>
+          </dgm:if>
+          <dgm:if name="Name11" axis="root des" func="maxDepth" op="gte" val="4">
+            <dgm:constrLst>
+              <dgm:constr type="w" for="ch" forName="tx1" refType="w" fact="0.2"/>
+              <dgm:constr type="w" for="des" forName="tx2" refType="w" fact="0.2516"/>
+              <dgm:constr type="w" for="des" forName="tx3" refType="w" fact="0.2516"/>
+              <dgm:constr type="w" for="des" forName="tx4" refType="w" fact="0.2516"/>
+              <dgm:constr type="w" for="des" forName="horzSpace2" refType="w" fact="0.015"/>
+              <dgm:constr type="w" for="des" forName="horzSpace3" refType="w" fact="0.015"/>
+              <dgm:constr type="w" for="des" forName="horzSpace4" refType="w" fact="0.015"/>
+              <dgm:constr type="w" for="des" forName="thinLine2b" refType="w" fact="0.8"/>
+              <dgm:constr type="w" for="des" forName="thinLine3" refType="w" fact="0.5332"/>
+            </dgm:constrLst>
+          </dgm:if>
+          <dgm:else name="Name12"/>
+        </dgm:choose>
+        <dgm:layoutNode name="tx1" styleLbl="revTx">
           <dgm:alg type="tx">
+            <dgm:param type="parTxLTRAlign" val="l"/>
+            <dgm:param type="parTxRTLAlign" val="r"/>
             <dgm:param type="txAnchorVert" val="t"/>
           </dgm:alg>
           <dgm:shape xmlns:r="http://schemas.openxmlformats.org/officeDocument/2006/relationships" type="rect" r:blip="">
             <dgm:adjLst/>
           </dgm:shape>
-          <dgm:presOf axis="self" ptType="node"/>
+          <dgm:presOf axis="self"/>
           <dgm:constrLst>
-            <dgm:constr type="lMarg"/>
-            <dgm:constr type="rMarg"/>
-            <dgm:constr type="tMarg"/>
-            <dgm:constr type="bMarg"/>
+            <dgm:constr type="tMarg" refType="primFontSz" fact="0.3"/>
+            <dgm:constr type="bMarg" refType="primFontSz" fact="0.3"/>
+            <dgm:constr type="lMarg" refType="primFontSz" fact="0.3"/>
+            <dgm:constr type="rMarg" refType="primFontSz" fact="0.3"/>
           </dgm:constrLst>
           <dgm:ruleLst>
-            <dgm:rule type="primFontSz" val="11" fact="NaN" max="NaN"/>
-            <dgm:rule type="h" val="INF" fact="NaN" max="NaN"/>
+            <dgm:rule type="primFontSz" val="5" fact="NaN" max="NaN"/>
           </dgm:ruleLst>
         </dgm:layoutNode>
-      </dgm:layoutNode>
-      <dgm:forEach name="Name8" axis="followSib" ptType="sibTrans" cnt="1">
-        <dgm:layoutNode name="sibTrans">
-          <dgm:alg type="sp"/>
+        <dgm:layoutNode name="vert1">
+          <dgm:choose name="Name13">
+            <dgm:if name="Name14" func="var" arg="dir" op="equ" val="norm">
+              <dgm:alg type="lin">
+                <dgm:param type="linDir" val="fromT"/>
+                <dgm:param type="nodeHorzAlign" val="l"/>
+              </dgm:alg>
+            </dgm:if>
+            <dgm:else name="Name15">
+              <dgm:alg type="lin">
+                <dgm:param type="linDir" val="fromT"/>
+                <dgm:param type="nodeHorzAlign" val="r"/>
+              </dgm:alg>
+            </dgm:else>
+          </dgm:choose>
           <dgm:shape xmlns:r="http://schemas.openxmlformats.org/officeDocument/2006/relationships" r:blip="">
             <dgm:adjLst/>
           </dgm:shape>
-          <dgm:presOf axis="self"/>
-          <dgm:constrLst/>
-          <dgm:ruleLst/>
+          <dgm:presOf/>
+          <dgm:forEach name="Name16" axis="ch" ptType="node">
+            <dgm:choose name="Name17">
+              <dgm:if name="Name18" axis="self" ptType="node" func="pos" op="equ" val="1">
+                <dgm:layoutNode name="vertSpace2a">
+                  <dgm:alg type="sp"/>
+                  <dgm:shape xmlns:r="http://schemas.openxmlformats.org/officeDocument/2006/relationships" r:blip="">
+                    <dgm:adjLst/>
+                  </dgm:shape>
+                  <dgm:presOf/>
+                </dgm:layoutNode>
+              </dgm:if>
+              <dgm:else name="Name19"/>
+            </dgm:choose>
+            <dgm:layoutNode name="horz2">
+              <dgm:choose name="Name20">
+                <dgm:if name="Name21" func="var" arg="dir" op="equ" val="norm">
+                  <dgm:alg type="lin">
+                    <dgm:param type="linDir" val="fromL"/>
+                    <dgm:param type="nodeVertAlign" val="t"/>
+                  </dgm:alg>
+                </dgm:if>
+                <dgm:else name="Name22">
+                  <dgm:alg type="lin">
+                    <dgm:param type="linDir" val="fromR"/>
+                    <dgm:param type="nodeVertAlign" val="t"/>
+                  </dgm:alg>
+                </dgm:else>
+              </dgm:choose>
+              <dgm:shape xmlns:r="http://schemas.openxmlformats.org/officeDocument/2006/relationships" r:blip="">
+                <dgm:adjLst/>
+              </dgm:shape>
+              <dgm:presOf/>
+              <dgm:layoutNode name="horzSpace2">
+                <dgm:alg type="sp"/>
+                <dgm:shape xmlns:r="http://schemas.openxmlformats.org/officeDocument/2006/relationships" r:blip="">
+                  <dgm:adjLst/>
+                </dgm:shape>
+                <dgm:presOf/>
+              </dgm:layoutNode>
+              <dgm:layoutNode name="tx2" styleLbl="revTx">
+                <dgm:alg type="tx">
+                  <dgm:param type="parTxLTRAlign" val="l"/>
+                  <dgm:param type="parTxRTLAlign" val="r"/>
+                  <dgm:param type="txAnchorVert" val="t"/>
+                </dgm:alg>
+                <dgm:shape xmlns:r="http://schemas.openxmlformats.org/officeDocument/2006/relationships" type="rect" r:blip="">
+                  <dgm:adjLst/>
+                </dgm:shape>
+                <dgm:presOf axis="self"/>
+                <dgm:constrLst>
+                  <dgm:constr type="tMarg" refType="primFontSz" fact="0.3"/>
+                  <dgm:constr type="bMarg" refType="primFontSz" fact="0.3"/>
+                  <dgm:constr type="lMarg" refType="primFontSz" fact="0.3"/>
+                  <dgm:constr type="rMarg" refType="primFontSz" fact="0.3"/>
+                </dgm:constrLst>
+                <dgm:ruleLst>
+                  <dgm:rule type="primFontSz" val="5" fact="NaN" max="NaN"/>
+                </dgm:ruleLst>
+              </dgm:layoutNode>
+              <dgm:layoutNode name="vert2">
+                <dgm:choose name="Name23">
+                  <dgm:if name="Name24" func="var" arg="dir" op="equ" val="norm">
+                    <dgm:alg type="lin">
+                      <dgm:param type="linDir" val="fromT"/>
+                      <dgm:param type="nodeHorzAlign" val="l"/>
+                    </dgm:alg>
+                  </dgm:if>
+                  <dgm:else name="Name25">
+                    <dgm:alg type="lin">
+                      <dgm:param type="linDir" val="fromT"/>
+                      <dgm:param type="nodeHorzAlign" val="r"/>
+                    </dgm:alg>
+                  </dgm:else>
+                </dgm:choose>
+                <dgm:shape xmlns:r="http://schemas.openxmlformats.org/officeDocument/2006/relationships" r:blip="">
+                  <dgm:adjLst/>
+                </dgm:shape>
+                <dgm:presOf/>
+                <dgm:forEach name="Name26" axis="ch" ptType="node">
+                  <dgm:layoutNode name="horz3">
+                    <dgm:choose name="Name27">
+                      <dgm:if name="Name28" func="var" arg="dir" op="equ" val="norm">
+                        <dgm:alg type="lin">
+                          <dgm:param type="linDir" val="fromL"/>
+                          <dgm:param type="nodeVertAlign" val="t"/>
+                        </dgm:alg>
+                      </dgm:if>
+                      <dgm:else name="Name29">
+                        <dgm:alg type="lin">
+                          <dgm:param type="linDir" val="fromR"/>
+                          <dgm:param type="nodeVertAlign" val="t"/>
+                        </dgm:alg>
+                      </dgm:else>
+                    </dgm:choose>
+                    <dgm:shape xmlns:r="http://schemas.openxmlformats.org/officeDocument/2006/relationships" r:blip="">
+                      <dgm:adjLst/>
+                    </dgm:shape>
+                    <dgm:presOf/>
+                    <dgm:layoutNode name="horzSpace3">
+                      <dgm:alg type="sp"/>
+                      <dgm:shape xmlns:r="http://schemas.openxmlformats.org/officeDocument/2006/relationships" r:blip="">
+                        <dgm:adjLst/>
+                      </dgm:shape>
+                      <dgm:presOf/>
+                    </dgm:layoutNode>
+                    <dgm:layoutNode name="tx3" styleLbl="revTx">
+                      <dgm:alg type="tx">
+                        <dgm:param type="parTxLTRAlign" val="l"/>
+                        <dgm:param type="parTxRTLAlign" val="r"/>
+                        <dgm:param type="txAnchorVert" val="t"/>
+                      </dgm:alg>
+                      <dgm:shape xmlns:r="http://schemas.openxmlformats.org/officeDocument/2006/relationships" type="rect" r:blip="">
+                        <dgm:adjLst/>
+                      </dgm:shape>
+                      <dgm:presOf axis="self"/>
+                      <dgm:constrLst>
+                        <dgm:constr type="tMarg" refType="primFontSz" fact="0.3"/>
+                        <dgm:constr type="bMarg" refType="primFontSz" fact="0.3"/>
+                        <dgm:constr type="lMarg" refType="primFontSz" fact="0.3"/>
+                        <dgm:constr type="rMarg" refType="primFontSz" fact="0.3"/>
+                      </dgm:constrLst>
+                      <dgm:ruleLst>
+                        <dgm:rule type="primFontSz" val="5" fact="NaN" max="NaN"/>
+                      </dgm:ruleLst>
+                    </dgm:layoutNode>
+                    <dgm:layoutNode name="vert3">
+                      <dgm:choose name="Name30">
+                        <dgm:if name="Name31" func="var" arg="dir" op="equ" val="norm">
+                          <dgm:alg type="lin">
+                            <dgm:param type="linDir" val="fromT"/>
+                            <dgm:param type="nodeHorzAlign" val="l"/>
+                          </dgm:alg>
+                        </dgm:if>
+                        <dgm:else name="Name32">
+                          <dgm:alg type="lin">
+                            <dgm:param type="linDir" val="fromT"/>
+                            <dgm:param type="nodeHorzAlign" val="r"/>
+                          </dgm:alg>
+                        </dgm:else>
+                      </dgm:choose>
+                      <dgm:shape xmlns:r="http://schemas.openxmlformats.org/officeDocument/2006/relationships" r:blip="">
+                        <dgm:adjLst/>
+                      </dgm:shape>
+                      <dgm:presOf/>
+                      <dgm:forEach name="Name33" axis="ch" ptType="node">
+                        <dgm:layoutNode name="horz4">
+                          <dgm:choose name="Name34">
+                            <dgm:if name="Name35" func="var" arg="dir" op="equ" val="norm">
+                              <dgm:alg type="lin">
+                                <dgm:param type="linDir" val="fromL"/>
+                                <dgm:param type="nodeVertAlign" val="t"/>
+                              </dgm:alg>
+                            </dgm:if>
+                            <dgm:else name="Name36">
+                              <dgm:alg type="lin">
+                                <dgm:param type="linDir" val="fromR"/>
+                                <dgm:param type="nodeVertAlign" val="t"/>
+                              </dgm:alg>
+                            </dgm:else>
+                          </dgm:choose>
+                          <dgm:shape xmlns:r="http://schemas.openxmlformats.org/officeDocument/2006/relationships" r:blip="">
+                            <dgm:adjLst/>
+                          </dgm:shape>
+                          <dgm:presOf/>
+                          <dgm:layoutNode name="horzSpace4">
+                            <dgm:alg type="sp"/>
+                            <dgm:shape xmlns:r="http://schemas.openxmlformats.org/officeDocument/2006/relationships" r:blip="">
+                              <dgm:adjLst/>
+                            </dgm:shape>
+                            <dgm:presOf/>
+                          </dgm:layoutNode>
+                          <dgm:layoutNode name="tx4" styleLbl="revTx">
+                            <dgm:varLst>
+                              <dgm:bulletEnabled val="1"/>
+                            </dgm:varLst>
+                            <dgm:alg type="tx">
+                              <dgm:param type="parTxLTRAlign" val="l"/>
+                              <dgm:param type="parTxRTLAlign" val="r"/>
+                              <dgm:param type="txAnchorVert" val="t"/>
+                            </dgm:alg>
+                            <dgm:shape xmlns:r="http://schemas.openxmlformats.org/officeDocument/2006/relationships" type="rect" r:blip="">
+                              <dgm:adjLst/>
+                            </dgm:shape>
+                            <dgm:presOf axis="desOrSelf" ptType="node"/>
+                            <dgm:constrLst>
+                              <dgm:constr type="tMarg" refType="primFontSz" fact="0.3"/>
+                              <dgm:constr type="bMarg" refType="primFontSz" fact="0.3"/>
+                              <dgm:constr type="lMarg" refType="primFontSz" fact="0.3"/>
+                              <dgm:constr type="rMarg" refType="primFontSz" fact="0.3"/>
+                            </dgm:constrLst>
+                            <dgm:ruleLst>
+                              <dgm:rule type="primFontSz" val="5" fact="NaN" max="NaN"/>
+                            </dgm:ruleLst>
+                          </dgm:layoutNode>
+                        </dgm:layoutNode>
+                      </dgm:forEach>
+                    </dgm:layoutNode>
+                  </dgm:layoutNode>
+                  <dgm:forEach name="Name37" axis="followSib" ptType="sibTrans" cnt="1">
+                    <dgm:layoutNode name="thinLine3" styleLbl="callout">
+                      <dgm:alg type="sp"/>
+                      <dgm:shape xmlns:r="http://schemas.openxmlformats.org/officeDocument/2006/relationships" type="line" r:blip="">
+                        <dgm:adjLst/>
+                      </dgm:shape>
+                      <dgm:presOf/>
+                    </dgm:layoutNode>
+                  </dgm:forEach>
+                </dgm:forEach>
+              </dgm:layoutNode>
+            </dgm:layoutNode>
+            <dgm:layoutNode name="thinLine2b" styleLbl="callout">
+              <dgm:alg type="sp"/>
+              <dgm:shape xmlns:r="http://schemas.openxmlformats.org/officeDocument/2006/relationships" type="line" r:blip="">
+                <dgm:adjLst/>
+              </dgm:shape>
+              <dgm:presOf/>
+            </dgm:layoutNode>
+            <dgm:layoutNode name="vertSpace2b">
+              <dgm:alg type="sp"/>
+              <dgm:shape xmlns:r="http://schemas.openxmlformats.org/officeDocument/2006/relationships" r:blip="">
+                <dgm:adjLst/>
+              </dgm:shape>
+              <dgm:presOf/>
+            </dgm:layoutNode>
+          </dgm:forEach>
         </dgm:layoutNode>
-      </dgm:forEach>
+      </dgm:layoutNode>
     </dgm:forEach>
   </dgm:layoutNode>
-  <dgm:extLst>
-    <a:ext uri="{68A01E43-0DF5-4B5B-8FA6-DAF915123BFB}">
-      <dgm1612:lstStyle xmlns:dgm1612="http://schemas.microsoft.com/office/drawing/2016/12/diagram">
-        <a:lvl1pPr>
-          <a:lnSpc>
-            <a:spcPct val="100000"/>
-          </a:lnSpc>
-        </a:lvl1pPr>
-      </dgm1612:lstStyle>
-    </a:ext>
-  </dgm:extLst>
 </dgm:layoutDef>
 </file>
 
@@ -2830,7 +3043,7 @@
           <a:p>
             <a:fld id="{E80C50CD-E178-4744-9B35-B2F624D6C5E9}" type="datetimeFigureOut">
               <a:rPr lang="en-US" smtClean="0"/>
-              <a:t>6/19/2026</a:t>
+              <a:t>6/22/2026</a:t>
             </a:fld>
             <a:endParaRPr lang="en-US"/>
           </a:p>
@@ -3028,7 +3241,7 @@
           <a:p>
             <a:fld id="{E80C50CD-E178-4744-9B35-B2F624D6C5E9}" type="datetimeFigureOut">
               <a:rPr lang="en-US" smtClean="0"/>
-              <a:t>6/19/2026</a:t>
+              <a:t>6/22/2026</a:t>
             </a:fld>
             <a:endParaRPr lang="en-US"/>
           </a:p>
@@ -3236,7 +3449,7 @@
           <a:p>
             <a:fld id="{E80C50CD-E178-4744-9B35-B2F624D6C5E9}" type="datetimeFigureOut">
               <a:rPr lang="en-US" smtClean="0"/>
-              <a:t>6/19/2026</a:t>
+              <a:t>6/22/2026</a:t>
             </a:fld>
             <a:endParaRPr lang="en-US"/>
           </a:p>
@@ -3486,7 +3699,7 @@
           <a:p>
             <a:fld id="{E80C50CD-E178-4744-9B35-B2F624D6C5E9}" type="datetimeFigureOut">
               <a:rPr lang="en-US" smtClean="0"/>
-              <a:t>6/19/2026</a:t>
+              <a:t>6/22/2026</a:t>
             </a:fld>
             <a:endParaRPr lang="en-US"/>
           </a:p>
@@ -3765,7 +3978,7 @@
           <a:p>
             <a:fld id="{E80C50CD-E178-4744-9B35-B2F624D6C5E9}" type="datetimeFigureOut">
               <a:rPr lang="en-US" smtClean="0"/>
-              <a:t>6/19/2026</a:t>
+              <a:t>6/22/2026</a:t>
             </a:fld>
             <a:endParaRPr lang="en-US"/>
           </a:p>
@@ -4082,7 +4295,7 @@
           <a:p>
             <a:fld id="{E80C50CD-E178-4744-9B35-B2F624D6C5E9}" type="datetimeFigureOut">
               <a:rPr lang="en-US" smtClean="0"/>
-              <a:t>6/19/2026</a:t>
+              <a:t>6/22/2026</a:t>
             </a:fld>
             <a:endParaRPr lang="en-US"/>
           </a:p>
@@ -4498,7 +4711,7 @@
           <a:p>
             <a:fld id="{E80C50CD-E178-4744-9B35-B2F624D6C5E9}" type="datetimeFigureOut">
               <a:rPr lang="en-US" smtClean="0"/>
-              <a:t>6/19/2026</a:t>
+              <a:t>6/22/2026</a:t>
             </a:fld>
             <a:endParaRPr lang="en-US"/>
           </a:p>
@@ -4639,7 +4852,7 @@
           <a:p>
             <a:fld id="{E80C50CD-E178-4744-9B35-B2F624D6C5E9}" type="datetimeFigureOut">
               <a:rPr lang="en-US" smtClean="0"/>
-              <a:t>6/19/2026</a:t>
+              <a:t>6/22/2026</a:t>
             </a:fld>
             <a:endParaRPr lang="en-US"/>
           </a:p>
@@ -4752,7 +4965,7 @@
           <a:p>
             <a:fld id="{E80C50CD-E178-4744-9B35-B2F624D6C5E9}" type="datetimeFigureOut">
               <a:rPr lang="en-US" smtClean="0"/>
-              <a:t>6/19/2026</a:t>
+              <a:t>6/22/2026</a:t>
             </a:fld>
             <a:endParaRPr lang="en-US"/>
           </a:p>
@@ -5069,7 +5282,7 @@
           <a:p>
             <a:fld id="{E80C50CD-E178-4744-9B35-B2F624D6C5E9}" type="datetimeFigureOut">
               <a:rPr lang="en-US" smtClean="0"/>
-              <a:t>6/19/2026</a:t>
+              <a:t>6/22/2026</a:t>
             </a:fld>
             <a:endParaRPr lang="en-US"/>
           </a:p>
@@ -5361,7 +5574,7 @@
           <a:p>
             <a:fld id="{E80C50CD-E178-4744-9B35-B2F624D6C5E9}" type="datetimeFigureOut">
               <a:rPr lang="en-US" smtClean="0"/>
-              <a:t>6/19/2026</a:t>
+              <a:t>6/22/2026</a:t>
             </a:fld>
             <a:endParaRPr lang="en-US"/>
           </a:p>
@@ -5601,7 +5814,7 @@
             <a:fld id="{E80C50CD-E178-4744-9B35-B2F624D6C5E9}" type="datetimeFigureOut">
               <a:rPr lang="en-US" smtClean="0"/>
               <a:pPr/>
-              <a:t>6/19/2026</a:t>
+              <a:t>6/22/2026</a:t>
             </a:fld>
             <a:endParaRPr lang="en-US"/>
           </a:p>
@@ -6607,14 +6820,6 @@
 <file path=ppt/slides/slide10.xml><?xml version="1.0" encoding="utf-8"?>
 <p:sld xmlns:a="http://schemas.openxmlformats.org/drawingml/2006/main" xmlns:r="http://schemas.openxmlformats.org/officeDocument/2006/relationships" xmlns:p="http://schemas.openxmlformats.org/presentationml/2006/main">
   <p:cSld>
-    <p:bg>
-      <p:bgPr>
-        <a:solidFill>
-          <a:schemeClr val="bg1"/>
-        </a:solidFill>
-        <a:effectLst/>
-      </p:bgPr>
-    </p:bg>
     <p:spTree>
       <p:nvGrpSpPr>
         <p:cNvPr id="1" name=""/>
@@ -6631,385 +6836,10 @@
       </p:grpSpPr>
       <p:sp>
         <p:nvSpPr>
-          <p:cNvPr id="9" name="Freeform: Shape 8">
-            <a:extLst>
-              <a:ext uri="{FF2B5EF4-FFF2-40B4-BE49-F238E27FC236}">
-                <a16:creationId xmlns:a16="http://schemas.microsoft.com/office/drawing/2014/main" id="{774A975B-A886-5202-0489-6965514A0D14}"/>
-              </a:ext>
-              <a:ext uri="{C183D7F6-B498-43B3-948B-1728B52AA6E4}">
-                <adec:decorative xmlns:adec="http://schemas.microsoft.com/office/drawing/2017/decorative" val="1"/>
-              </a:ext>
-            </a:extLst>
-          </p:cNvPr>
-          <p:cNvSpPr>
-            <a:spLocks noGrp="1" noRot="1" noChangeAspect="1" noMove="1" noResize="1" noEditPoints="1" noAdjustHandles="1" noChangeArrowheads="1" noChangeShapeType="1" noTextEdit="1"/>
-          </p:cNvSpPr>
-          <p:nvPr>
-            <p:extLst>
-              <p:ext uri="{386F3935-93C4-4BCD-93E2-E3B085C9AB24}">
-                <p16:designElem xmlns:p16="http://schemas.microsoft.com/office/powerpoint/2015/main" val="1"/>
-              </p:ext>
-            </p:extLst>
-          </p:nvPr>
-        </p:nvSpPr>
-        <p:spPr>
-          <a:xfrm>
-            <a:off x="517869" y="508090"/>
-            <a:ext cx="11153214" cy="149279"/>
-          </a:xfrm>
-          <a:custGeom>
-            <a:avLst/>
-            <a:gdLst>
-              <a:gd name="connsiteX0" fmla="*/ 0 w 8085002"/>
-              <a:gd name="connsiteY0" fmla="*/ 0 h 149279"/>
-              <a:gd name="connsiteX1" fmla="*/ 8085002 w 8085002"/>
-              <a:gd name="connsiteY1" fmla="*/ 0 h 149279"/>
-              <a:gd name="connsiteX2" fmla="*/ 8085002 w 8085002"/>
-              <a:gd name="connsiteY2" fmla="*/ 149279 h 149279"/>
-              <a:gd name="connsiteX3" fmla="*/ 0 w 8085002"/>
-              <a:gd name="connsiteY3" fmla="*/ 149279 h 149279"/>
-            </a:gdLst>
-            <a:ahLst/>
-            <a:cxnLst>
-              <a:cxn ang="0">
-                <a:pos x="connsiteX0" y="connsiteY0"/>
-              </a:cxn>
-              <a:cxn ang="0">
-                <a:pos x="connsiteX1" y="connsiteY1"/>
-              </a:cxn>
-              <a:cxn ang="0">
-                <a:pos x="connsiteX2" y="connsiteY2"/>
-              </a:cxn>
-              <a:cxn ang="0">
-                <a:pos x="connsiteX3" y="connsiteY3"/>
-              </a:cxn>
-            </a:cxnLst>
-            <a:rect l="l" t="t" r="r" b="b"/>
-            <a:pathLst>
-              <a:path w="8085002" h="149279">
-                <a:moveTo>
-                  <a:pt x="0" y="0"/>
-                </a:moveTo>
-                <a:lnTo>
-                  <a:pt x="8085002" y="0"/>
-                </a:lnTo>
-                <a:lnTo>
-                  <a:pt x="8085002" y="149279"/>
-                </a:lnTo>
-                <a:lnTo>
-                  <a:pt x="0" y="149279"/>
-                </a:lnTo>
-                <a:close/>
-              </a:path>
-            </a:pathLst>
-          </a:custGeom>
-          <a:solidFill>
-            <a:schemeClr val="tx1"/>
-          </a:solidFill>
-          <a:ln>
-            <a:noFill/>
-          </a:ln>
-        </p:spPr>
-        <p:style>
-          <a:lnRef idx="2">
-            <a:schemeClr val="accent1">
-              <a:shade val="50000"/>
-            </a:schemeClr>
-          </a:lnRef>
-          <a:fillRef idx="1">
-            <a:schemeClr val="accent1"/>
-          </a:fillRef>
-          <a:effectRef idx="0">
-            <a:schemeClr val="accent1"/>
-          </a:effectRef>
-          <a:fontRef idx="minor">
-            <a:schemeClr val="lt1"/>
-          </a:fontRef>
-        </p:style>
-        <p:txBody>
-          <a:bodyPr wrap="square" rtlCol="0" anchor="ctr">
-            <a:noAutofit/>
-          </a:bodyPr>
-          <a:lstStyle/>
-          <a:p>
-            <a:pPr algn="ctr"/>
-            <a:endParaRPr lang="en-US"/>
-          </a:p>
-        </p:txBody>
-      </p:sp>
-      <p:sp>
-        <p:nvSpPr>
-          <p:cNvPr id="11" name="Freeform: Shape 10">
-            <a:extLst>
-              <a:ext uri="{FF2B5EF4-FFF2-40B4-BE49-F238E27FC236}">
-                <a16:creationId xmlns:a16="http://schemas.microsoft.com/office/drawing/2014/main" id="{EA67E988-5919-57BB-C7DE-D3EAD38A3045}"/>
-              </a:ext>
-              <a:ext uri="{C183D7F6-B498-43B3-948B-1728B52AA6E4}">
-                <adec:decorative xmlns:adec="http://schemas.microsoft.com/office/drawing/2017/decorative" val="1"/>
-              </a:ext>
-            </a:extLst>
-          </p:cNvPr>
-          <p:cNvSpPr>
-            <a:spLocks noGrp="1" noRot="1" noChangeAspect="1" noMove="1" noResize="1" noEditPoints="1" noAdjustHandles="1" noChangeArrowheads="1" noChangeShapeType="1" noTextEdit="1"/>
-          </p:cNvSpPr>
-          <p:nvPr>
-            <p:extLst>
-              <p:ext uri="{386F3935-93C4-4BCD-93E2-E3B085C9AB24}">
-                <p16:designElem xmlns:p16="http://schemas.microsoft.com/office/powerpoint/2015/main" val="1"/>
-              </p:ext>
-            </p:extLst>
-          </p:nvPr>
-        </p:nvSpPr>
-        <p:spPr>
-          <a:xfrm>
-            <a:off x="517870" y="6209925"/>
-            <a:ext cx="11155680" cy="45719"/>
-          </a:xfrm>
-          <a:custGeom>
-            <a:avLst/>
-            <a:gdLst/>
-            <a:ahLst/>
-            <a:cxnLst/>
-            <a:rect l="l" t="t" r="r" b="b"/>
-            <a:pathLst>
-              <a:path w="8715708" h="45719">
-                <a:moveTo>
-                  <a:pt x="0" y="0"/>
-                </a:moveTo>
-                <a:lnTo>
-                  <a:pt x="3694525" y="0"/>
-                </a:lnTo>
-                <a:lnTo>
-                  <a:pt x="5021183" y="0"/>
-                </a:lnTo>
-                <a:lnTo>
-                  <a:pt x="8715708" y="0"/>
-                </a:lnTo>
-                <a:lnTo>
-                  <a:pt x="8715708" y="45719"/>
-                </a:lnTo>
-                <a:lnTo>
-                  <a:pt x="5021183" y="45719"/>
-                </a:lnTo>
-                <a:lnTo>
-                  <a:pt x="3694525" y="45719"/>
-                </a:lnTo>
-                <a:lnTo>
-                  <a:pt x="0" y="45719"/>
-                </a:lnTo>
-                <a:close/>
-              </a:path>
-            </a:pathLst>
-          </a:custGeom>
-          <a:solidFill>
-            <a:schemeClr val="tx1"/>
-          </a:solidFill>
-          <a:ln>
-            <a:noFill/>
-          </a:ln>
-        </p:spPr>
-        <p:style>
-          <a:lnRef idx="2">
-            <a:schemeClr val="accent1">
-              <a:shade val="50000"/>
-            </a:schemeClr>
-          </a:lnRef>
-          <a:fillRef idx="1">
-            <a:schemeClr val="accent1"/>
-          </a:fillRef>
-          <a:effectRef idx="0">
-            <a:schemeClr val="accent1"/>
-          </a:effectRef>
-          <a:fontRef idx="minor">
-            <a:schemeClr val="lt1"/>
-          </a:fontRef>
-        </p:style>
-        <p:txBody>
-          <a:bodyPr wrap="square" rtlCol="0" anchor="ctr">
-            <a:noAutofit/>
-          </a:bodyPr>
-          <a:lstStyle/>
-          <a:p>
-            <a:pPr algn="ctr"/>
-            <a:endParaRPr lang="en-US"/>
-          </a:p>
-        </p:txBody>
-      </p:sp>
-      <p:sp useBgFill="1">
-        <p:nvSpPr>
-          <p:cNvPr id="13" name="Rectangle 12">
-            <a:extLst>
-              <a:ext uri="{FF2B5EF4-FFF2-40B4-BE49-F238E27FC236}">
-                <a16:creationId xmlns:a16="http://schemas.microsoft.com/office/drawing/2014/main" id="{E20BB609-EF92-42DB-836C-0699A590B5CF}"/>
-              </a:ext>
-              <a:ext uri="{C183D7F6-B498-43B3-948B-1728B52AA6E4}">
-                <adec:decorative xmlns:adec="http://schemas.microsoft.com/office/drawing/2017/decorative" val="1"/>
-              </a:ext>
-            </a:extLst>
-          </p:cNvPr>
-          <p:cNvSpPr>
-            <a:spLocks noGrp="1" noRot="1" noChangeAspect="1" noMove="1" noResize="1" noEditPoints="1" noAdjustHandles="1" noChangeArrowheads="1" noChangeShapeType="1" noTextEdit="1"/>
-          </p:cNvSpPr>
-          <p:nvPr>
-            <p:extLst>
-              <p:ext uri="{386F3935-93C4-4BCD-93E2-E3B085C9AB24}">
-                <p16:designElem xmlns:p16="http://schemas.microsoft.com/office/powerpoint/2015/main" val="1"/>
-              </p:ext>
-            </p:extLst>
-          </p:nvPr>
-        </p:nvSpPr>
-        <p:spPr>
-          <a:xfrm>
-            <a:off x="0" y="0"/>
-            <a:ext cx="12192000" cy="6858001"/>
-          </a:xfrm>
-          <a:prstGeom prst="rect">
-            <a:avLst/>
-          </a:prstGeom>
-          <a:ln>
-            <a:noFill/>
-          </a:ln>
-        </p:spPr>
-        <p:style>
-          <a:lnRef idx="2">
-            <a:schemeClr val="accent1">
-              <a:shade val="50000"/>
-            </a:schemeClr>
-          </a:lnRef>
-          <a:fillRef idx="1">
-            <a:schemeClr val="accent1"/>
-          </a:fillRef>
-          <a:effectRef idx="0">
-            <a:schemeClr val="accent1"/>
-          </a:effectRef>
-          <a:fontRef idx="minor">
-            <a:schemeClr val="lt1"/>
-          </a:fontRef>
-        </p:style>
-        <p:txBody>
-          <a:bodyPr rtlCol="0" anchor="ctr"/>
-          <a:lstStyle/>
-          <a:p>
-            <a:pPr algn="ctr"/>
-            <a:endParaRPr lang="en-US" dirty="0"/>
-          </a:p>
-        </p:txBody>
-      </p:sp>
-      <p:pic>
-        <p:nvPicPr>
-          <p:cNvPr id="5" name="Picture 4">
-            <a:extLst>
-              <a:ext uri="{FF2B5EF4-FFF2-40B4-BE49-F238E27FC236}">
-                <a16:creationId xmlns:a16="http://schemas.microsoft.com/office/drawing/2014/main" id="{827C1362-236A-6BAD-A329-94810AF9A7F0}"/>
-              </a:ext>
-            </a:extLst>
-          </p:cNvPr>
-          <p:cNvPicPr>
-            <a:picLocks noChangeAspect="1"/>
-          </p:cNvPicPr>
-          <p:nvPr/>
-        </p:nvPicPr>
-        <p:blipFill>
-          <a:blip r:embed="rId2"/>
-          <a:srcRect l="25"/>
-          <a:stretch>
-            <a:fillRect/>
-          </a:stretch>
-        </p:blipFill>
-        <p:spPr>
-          <a:xfrm>
-            <a:off x="20" y="10"/>
-            <a:ext cx="12188932" cy="6857990"/>
-          </a:xfrm>
-          <a:prstGeom prst="rect">
-            <a:avLst/>
-          </a:prstGeom>
-        </p:spPr>
-      </p:pic>
-      <p:sp>
-        <p:nvSpPr>
-          <p:cNvPr id="15" name="Rectangle 14">
-            <a:extLst>
-              <a:ext uri="{FF2B5EF4-FFF2-40B4-BE49-F238E27FC236}">
-                <a16:creationId xmlns:a16="http://schemas.microsoft.com/office/drawing/2014/main" id="{637992A9-1E8C-4E57-B4F4-EE2D38E504A2}"/>
-              </a:ext>
-              <a:ext uri="{C183D7F6-B498-43B3-948B-1728B52AA6E4}">
-                <adec:decorative xmlns:adec="http://schemas.microsoft.com/office/drawing/2017/decorative" val="1"/>
-              </a:ext>
-            </a:extLst>
-          </p:cNvPr>
-          <p:cNvSpPr>
-            <a:spLocks noGrp="1" noRot="1" noChangeAspect="1" noMove="1" noResize="1" noEditPoints="1" noAdjustHandles="1" noChangeArrowheads="1" noChangeShapeType="1" noTextEdit="1"/>
-          </p:cNvSpPr>
-          <p:nvPr>
-            <p:extLst>
-              <p:ext uri="{386F3935-93C4-4BCD-93E2-E3B085C9AB24}">
-                <p16:designElem xmlns:p16="http://schemas.microsoft.com/office/powerpoint/2015/main" val="1"/>
-              </p:ext>
-            </p:extLst>
-          </p:nvPr>
-        </p:nvSpPr>
-        <p:spPr>
-          <a:xfrm rot="16200000">
-            <a:off x="389239" y="-389238"/>
-            <a:ext cx="6858000" cy="7636476"/>
-          </a:xfrm>
-          <a:prstGeom prst="rect">
-            <a:avLst/>
-          </a:prstGeom>
-          <a:gradFill>
-            <a:gsLst>
-              <a:gs pos="100000">
-                <a:srgbClr val="000000">
-                  <a:alpha val="0"/>
-                </a:srgbClr>
-              </a:gs>
-              <a:gs pos="0">
-                <a:schemeClr val="tx1"/>
-              </a:gs>
-              <a:gs pos="0">
-                <a:srgbClr val="000000">
-                  <a:alpha val="70000"/>
-                </a:srgbClr>
-              </a:gs>
-            </a:gsLst>
-            <a:lin ang="5400000" scaled="1"/>
-          </a:gradFill>
-          <a:ln>
-            <a:noFill/>
-          </a:ln>
-        </p:spPr>
-        <p:style>
-          <a:lnRef idx="2">
-            <a:schemeClr val="accent1">
-              <a:shade val="50000"/>
-            </a:schemeClr>
-          </a:lnRef>
-          <a:fillRef idx="1">
-            <a:schemeClr val="accent1"/>
-          </a:fillRef>
-          <a:effectRef idx="0">
-            <a:schemeClr val="accent1"/>
-          </a:effectRef>
-          <a:fontRef idx="minor">
-            <a:schemeClr val="lt1"/>
-          </a:fontRef>
-        </p:style>
-        <p:txBody>
-          <a:bodyPr rtlCol="0" anchor="ctr"/>
-          <a:lstStyle/>
-          <a:p>
-            <a:pPr algn="ctr"/>
-            <a:endParaRPr lang="en-US"/>
-          </a:p>
-        </p:txBody>
-      </p:sp>
-      <p:sp>
-        <p:nvSpPr>
           <p:cNvPr id="2" name="Titre 1">
             <a:extLst>
               <a:ext uri="{FF2B5EF4-FFF2-40B4-BE49-F238E27FC236}">
-                <a16:creationId xmlns:a16="http://schemas.microsoft.com/office/drawing/2014/main" id="{E34E0744-9D9A-00B0-9E8E-D0320984E3F4}"/>
+                <a16:creationId xmlns:a16="http://schemas.microsoft.com/office/drawing/2014/main" id="{28431003-C42D-2839-0352-9DFB793D0672}"/>
               </a:ext>
             </a:extLst>
           </p:cNvPr>
@@ -7020,25 +6850,14 @@
             <p:ph type="title"/>
           </p:nvPr>
         </p:nvSpPr>
-        <p:spPr>
-          <a:xfrm>
-            <a:off x="517870" y="978407"/>
-            <a:ext cx="5021182" cy="3309511"/>
-          </a:xfrm>
-        </p:spPr>
-        <p:txBody>
-          <a:bodyPr vert="horz" lIns="91440" tIns="45720" rIns="91440" bIns="45720" rtlCol="0" anchor="t">
-            <a:normAutofit/>
-          </a:bodyPr>
+        <p:spPr/>
+        <p:txBody>
+          <a:bodyPr/>
           <a:lstStyle/>
           <a:p>
             <a:r>
-              <a:rPr lang="en-US" sz="6000">
-                <a:solidFill>
-                  <a:srgbClr val="FFFFFF"/>
-                </a:solidFill>
-              </a:rPr>
-              <a:t>AstroLab</a:t>
+              <a:rPr lang="fr-CH" dirty="0"/>
+              <a:t>Annexes</a:t>
             </a:r>
           </a:p>
         </p:txBody>
@@ -7048,7 +6867,7 @@
           <p:cNvPr id="3" name="Espace réservé du contenu 2">
             <a:extLst>
               <a:ext uri="{FF2B5EF4-FFF2-40B4-BE49-F238E27FC236}">
-                <a16:creationId xmlns:a16="http://schemas.microsoft.com/office/drawing/2014/main" id="{0C44115A-CC4B-00F3-04DA-D24F28C4E5EA}"/>
+                <a16:creationId xmlns:a16="http://schemas.microsoft.com/office/drawing/2014/main" id="{6CCCDBFD-5663-D214-57DC-83E4A11B564D}"/>
               </a:ext>
             </a:extLst>
           </p:cNvPr>
@@ -7059,194 +6878,71 @@
             <p:ph idx="1"/>
           </p:nvPr>
         </p:nvSpPr>
-        <p:spPr>
-          <a:xfrm>
-            <a:off x="517870" y="4482450"/>
-            <a:ext cx="5040785" cy="1724029"/>
-          </a:xfrm>
-        </p:spPr>
-        <p:txBody>
-          <a:bodyPr vert="horz" lIns="91440" tIns="45720" rIns="91440" bIns="45720" rtlCol="0" anchor="t">
-            <a:normAutofit/>
-          </a:bodyPr>
+        <p:spPr/>
+        <p:txBody>
+          <a:bodyPr/>
           <a:lstStyle/>
           <a:p>
-            <a:pPr marL="0" indent="0">
-              <a:buNone/>
-            </a:pPr>
-            <a:r>
-              <a:rPr lang="en-US" sz="2200" i="1" kern="1200">
-                <a:solidFill>
-                  <a:srgbClr val="FFFFFF"/>
-                </a:solidFill>
-                <a:latin typeface="+mn-lt"/>
-                <a:ea typeface="+mn-ea"/>
-                <a:cs typeface="+mn-cs"/>
+            <a:r>
+              <a:rPr lang="fr-CH" dirty="0"/>
+              <a:t>Lien vers projets Teams : </a:t>
+            </a:r>
+            <a:r>
+              <a:rPr lang="fr-CH" dirty="0">
+                <a:hlinkClick r:id="rId2"/>
               </a:rPr>
-              <a:t>Projet en python</a:t>
-            </a:r>
-          </a:p>
-        </p:txBody>
-      </p:sp>
-      <p:sp>
-        <p:nvSpPr>
-          <p:cNvPr id="17" name="Rectangle 16">
-            <a:extLst>
-              <a:ext uri="{FF2B5EF4-FFF2-40B4-BE49-F238E27FC236}">
-                <a16:creationId xmlns:a16="http://schemas.microsoft.com/office/drawing/2014/main" id="{B2C335F7-F61C-4EB4-80F2-4B1438FE66BB}"/>
-              </a:ext>
-              <a:ext uri="{C183D7F6-B498-43B3-948B-1728B52AA6E4}">
-                <adec:decorative xmlns:adec="http://schemas.microsoft.com/office/drawing/2017/decorative" val="1"/>
-              </a:ext>
-            </a:extLst>
-          </p:cNvPr>
-          <p:cNvSpPr>
-            <a:spLocks noGrp="1" noRot="1" noChangeAspect="1" noMove="1" noResize="1" noEditPoints="1" noAdjustHandles="1" noChangeArrowheads="1" noChangeShapeType="1" noTextEdit="1"/>
-          </p:cNvSpPr>
-          <p:nvPr>
-            <p:extLst>
-              <p:ext uri="{386F3935-93C4-4BCD-93E2-E3B085C9AB24}">
-                <p16:designElem xmlns:p16="http://schemas.microsoft.com/office/powerpoint/2015/main" val="1"/>
-              </p:ext>
-            </p:extLst>
-          </p:nvPr>
-        </p:nvSpPr>
-        <p:spPr>
-          <a:xfrm>
-            <a:off x="517870" y="508090"/>
-            <a:ext cx="5021183" cy="149279"/>
-          </a:xfrm>
-          <a:prstGeom prst="rect">
-            <a:avLst/>
-          </a:prstGeom>
-          <a:solidFill>
-            <a:srgbClr val="FFFFFF"/>
-          </a:solidFill>
-          <a:ln>
-            <a:noFill/>
-          </a:ln>
-        </p:spPr>
-        <p:style>
-          <a:lnRef idx="2">
-            <a:schemeClr val="accent1">
-              <a:shade val="50000"/>
-            </a:schemeClr>
-          </a:lnRef>
-          <a:fillRef idx="1">
-            <a:schemeClr val="accent1"/>
-          </a:fillRef>
-          <a:effectRef idx="0">
-            <a:schemeClr val="accent1"/>
-          </a:effectRef>
-          <a:fontRef idx="minor">
-            <a:schemeClr val="lt1"/>
-          </a:fontRef>
-        </p:style>
-        <p:txBody>
-          <a:bodyPr rtlCol="0" anchor="ctr"/>
-          <a:lstStyle/>
-          <a:p>
-            <a:pPr algn="ctr"/>
-            <a:endParaRPr lang="en-US"/>
+              <a:t>Agashae - Nathan - Liam – Noah</a:t>
+            </a:r>
+            <a:endParaRPr lang="fr-CH" dirty="0"/>
+          </a:p>
+          <a:p>
+            <a:r>
+              <a:rPr lang="fr-CH" dirty="0"/>
+              <a:t>Mon JDT : </a:t>
+            </a:r>
+            <a:r>
+              <a:rPr lang="fr-CH" dirty="0">
+                <a:hlinkClick r:id="rId3"/>
+              </a:rPr>
+              <a:t>https://github.com/Agashae/MoonWebsite</a:t>
+            </a:r>
+            <a:endParaRPr lang="fr-CH" dirty="0"/>
+          </a:p>
+          <a:p>
+            <a:r>
+              <a:rPr lang="fr-CH" dirty="0"/>
+              <a:t>Lien vers mon site : </a:t>
+            </a:r>
+            <a:r>
+              <a:rPr lang="fr-CH" dirty="0">
+                <a:hlinkClick r:id="rId4"/>
+              </a:rPr>
+              <a:t>https://agashae.space/</a:t>
+            </a:r>
+            <a:endParaRPr lang="fr-CH" dirty="0"/>
+          </a:p>
+          <a:p>
+            <a:r>
+              <a:rPr lang="fr-CH" dirty="0"/>
+              <a:t>Lien vers mon code Python : </a:t>
+            </a:r>
+            <a:r>
+              <a:rPr lang="fr-CH" dirty="0">
+                <a:hlinkClick r:id="rId5"/>
+              </a:rPr>
+              <a:t>https://github.com/Agashae/AstroLab</a:t>
+            </a:r>
+            <a:endParaRPr lang="fr-CH" dirty="0"/>
+          </a:p>
+          <a:p>
+            <a:endParaRPr lang="fr-CH" dirty="0"/>
           </a:p>
         </p:txBody>
       </p:sp>
     </p:spTree>
     <p:extLst>
       <p:ext uri="{BB962C8B-B14F-4D97-AF65-F5344CB8AC3E}">
-        <p14:creationId xmlns:p14="http://schemas.microsoft.com/office/powerpoint/2010/main" val="832870440"/>
-      </p:ext>
-    </p:extLst>
-  </p:cSld>
-  <p:clrMapOvr>
-    <a:overrideClrMapping bg1="dk1" tx1="lt1" bg2="dk2" tx2="lt2" accent1="accent1" accent2="accent2" accent3="accent3" accent4="accent4" accent5="accent5" accent6="accent6" hlink="hlink" folHlink="folHlink"/>
-  </p:clrMapOvr>
-</p:sld>
-</file>
-
-<file path=ppt/slides/slide11.xml><?xml version="1.0" encoding="utf-8"?>
-<p:sld xmlns:a="http://schemas.openxmlformats.org/drawingml/2006/main" xmlns:r="http://schemas.openxmlformats.org/officeDocument/2006/relationships" xmlns:p="http://schemas.openxmlformats.org/presentationml/2006/main">
-  <p:cSld>
-    <p:spTree>
-      <p:nvGrpSpPr>
-        <p:cNvPr id="1" name=""/>
-        <p:cNvGrpSpPr/>
-        <p:nvPr/>
-      </p:nvGrpSpPr>
-      <p:grpSpPr>
-        <a:xfrm>
-          <a:off x="0" y="0"/>
-          <a:ext cx="0" cy="0"/>
-          <a:chOff x="0" y="0"/>
-          <a:chExt cx="0" cy="0"/>
-        </a:xfrm>
-      </p:grpSpPr>
-      <p:sp>
-        <p:nvSpPr>
-          <p:cNvPr id="2" name="Titre 1">
-            <a:extLst>
-              <a:ext uri="{FF2B5EF4-FFF2-40B4-BE49-F238E27FC236}">
-                <a16:creationId xmlns:a16="http://schemas.microsoft.com/office/drawing/2014/main" id="{0CD193FF-2B7B-BC23-F6D7-D46536517DE1}"/>
-              </a:ext>
-            </a:extLst>
-          </p:cNvPr>
-          <p:cNvSpPr>
-            <a:spLocks noGrp="1"/>
-          </p:cNvSpPr>
-          <p:nvPr>
-            <p:ph type="title"/>
-          </p:nvPr>
-        </p:nvSpPr>
-        <p:spPr/>
-        <p:txBody>
-          <a:bodyPr/>
-          <a:lstStyle/>
-          <a:p>
-            <a:r>
-              <a:rPr lang="fr-CH" dirty="0"/>
-              <a:t>Pourquoi ce projet ?</a:t>
-            </a:r>
-          </a:p>
-        </p:txBody>
-      </p:sp>
-      <p:sp>
-        <p:nvSpPr>
-          <p:cNvPr id="3" name="Espace réservé du contenu 2">
-            <a:extLst>
-              <a:ext uri="{FF2B5EF4-FFF2-40B4-BE49-F238E27FC236}">
-                <a16:creationId xmlns:a16="http://schemas.microsoft.com/office/drawing/2014/main" id="{E1121C98-EC16-3C52-8342-E449BCD3F200}"/>
-              </a:ext>
-            </a:extLst>
-          </p:cNvPr>
-          <p:cNvSpPr>
-            <a:spLocks noGrp="1"/>
-          </p:cNvSpPr>
-          <p:nvPr>
-            <p:ph idx="1"/>
-          </p:nvPr>
-        </p:nvSpPr>
-        <p:spPr/>
-        <p:txBody>
-          <a:bodyPr/>
-          <a:lstStyle/>
-          <a:p>
-            <a:r>
-              <a:rPr lang="fr-CH" dirty="0"/>
-              <a:t>Apprendre un nouveau langage : Python</a:t>
-            </a:r>
-          </a:p>
-          <a:p>
-            <a:r>
-              <a:rPr lang="fr-CH" dirty="0"/>
-              <a:t>Faire un projet avec des calculs</a:t>
-            </a:r>
-          </a:p>
-        </p:txBody>
-      </p:sp>
-    </p:spTree>
-    <p:extLst>
-      <p:ext uri="{BB962C8B-B14F-4D97-AF65-F5344CB8AC3E}">
-        <p14:creationId xmlns:p14="http://schemas.microsoft.com/office/powerpoint/2010/main" val="3658721233"/>
+        <p14:creationId xmlns:p14="http://schemas.microsoft.com/office/powerpoint/2010/main" val="1875545670"/>
       </p:ext>
     </p:extLst>
   </p:cSld>
@@ -7517,7 +7213,7 @@
         <p:spPr>
           <a:xfrm>
             <a:off x="521208" y="2578608"/>
-            <a:ext cx="4672584" cy="3767328"/>
+            <a:ext cx="5574792" cy="2898648"/>
           </a:xfrm>
         </p:spPr>
         <p:txBody>
@@ -7574,8 +7270,38 @@
         </p:blipFill>
         <p:spPr>
           <a:xfrm>
-            <a:off x="5958018" y="508090"/>
-            <a:ext cx="5709726" cy="5846989"/>
+            <a:off x="1599478" y="4342665"/>
+            <a:ext cx="2024438" cy="2073106"/>
+          </a:xfrm>
+          <a:prstGeom prst="rect">
+            <a:avLst/>
+          </a:prstGeom>
+        </p:spPr>
+      </p:pic>
+      <p:pic>
+        <p:nvPicPr>
+          <p:cNvPr id="6" name="Image 5">
+            <a:extLst>
+              <a:ext uri="{FF2B5EF4-FFF2-40B4-BE49-F238E27FC236}">
+                <a16:creationId xmlns:a16="http://schemas.microsoft.com/office/drawing/2014/main" id="{E0D106A1-996B-11A1-E2B4-4097136F1AFA}"/>
+              </a:ext>
+            </a:extLst>
+          </p:cNvPr>
+          <p:cNvPicPr>
+            <a:picLocks noChangeAspect="1"/>
+          </p:cNvPicPr>
+          <p:nvPr/>
+        </p:nvPicPr>
+        <p:blipFill>
+          <a:blip r:embed="rId4"/>
+          <a:stretch>
+            <a:fillRect/>
+          </a:stretch>
+        </p:blipFill>
+        <p:spPr>
+          <a:xfrm>
+            <a:off x="6290005" y="1539796"/>
+            <a:ext cx="5705821" cy="3778408"/>
           </a:xfrm>
           <a:prstGeom prst="rect">
             <a:avLst/>
@@ -7738,9 +7464,10 @@
           <a:lstStyle/>
           <a:p>
             <a:r>
-              <a:rPr lang="fr-CH" dirty="0"/>
+              <a:rPr lang="fr-CH"/>
               <a:t>Cadavre Exquis</a:t>
             </a:r>
+            <a:endParaRPr lang="fr-CH" dirty="0"/>
           </a:p>
         </p:txBody>
       </p:sp>
@@ -7865,9 +7592,10 @@
           <a:lstStyle/>
           <a:p>
             <a:r>
-              <a:rPr lang="fr-CH" dirty="0"/>
+              <a:rPr lang="fr-CH"/>
               <a:t>Aider à la création du fichier Word d’aide au code avec Noah</a:t>
             </a:r>
+            <a:endParaRPr lang="fr-CH" dirty="0"/>
           </a:p>
         </p:txBody>
       </p:sp>
@@ -7894,8 +7622,39 @@
         </p:blipFill>
         <p:spPr>
           <a:xfrm>
-            <a:off x="5958018" y="508090"/>
-            <a:ext cx="5709726" cy="5846989"/>
+            <a:off x="1371542" y="3761906"/>
+            <a:ext cx="2342348" cy="2398659"/>
+          </a:xfrm>
+          <a:prstGeom prst="rect">
+            <a:avLst/>
+          </a:prstGeom>
+        </p:spPr>
+      </p:pic>
+      <p:pic>
+        <p:nvPicPr>
+          <p:cNvPr id="6" name="Image 5">
+            <a:extLst>
+              <a:ext uri="{FF2B5EF4-FFF2-40B4-BE49-F238E27FC236}">
+                <a16:creationId xmlns:a16="http://schemas.microsoft.com/office/drawing/2014/main" id="{600E900D-A1D3-EFA2-1C96-569EEF31A65F}"/>
+              </a:ext>
+            </a:extLst>
+          </p:cNvPr>
+          <p:cNvPicPr>
+            <a:picLocks noChangeAspect="1"/>
+          </p:cNvPicPr>
+          <p:nvPr/>
+        </p:nvPicPr>
+        <p:blipFill>
+          <a:blip r:embed="rId3"/>
+          <a:srcRect l="10139" t="11396" r="3969"/>
+          <a:stretch>
+            <a:fillRect/>
+          </a:stretch>
+        </p:blipFill>
+        <p:spPr>
+          <a:xfrm>
+            <a:off x="5593205" y="582729"/>
+            <a:ext cx="6276515" cy="5972075"/>
           </a:xfrm>
           <a:prstGeom prst="rect">
             <a:avLst/>
@@ -8258,8 +8017,8 @@
         </p:blipFill>
         <p:spPr>
           <a:xfrm>
-            <a:off x="517868" y="2749818"/>
-            <a:ext cx="5639091" cy="3171988"/>
+            <a:off x="6000935" y="1635777"/>
+            <a:ext cx="5114759" cy="2877051"/>
           </a:xfrm>
           <a:prstGeom prst="rect">
             <a:avLst/>
@@ -8284,8 +8043,8 @@
         </p:nvSpPr>
         <p:spPr>
           <a:xfrm>
-            <a:off x="6547104" y="2304288"/>
-            <a:ext cx="5129784" cy="4050792"/>
+            <a:off x="621792" y="1813629"/>
+            <a:ext cx="4242816" cy="976371"/>
           </a:xfrm>
         </p:spPr>
         <p:txBody>
@@ -8307,6 +8066,37 @@
           </a:p>
         </p:txBody>
       </p:sp>
+      <p:pic>
+        <p:nvPicPr>
+          <p:cNvPr id="8" name="Image 7">
+            <a:extLst>
+              <a:ext uri="{FF2B5EF4-FFF2-40B4-BE49-F238E27FC236}">
+                <a16:creationId xmlns:a16="http://schemas.microsoft.com/office/drawing/2014/main" id="{B7040E9E-A10A-A1CE-80BC-1260B853207E}"/>
+              </a:ext>
+            </a:extLst>
+          </p:cNvPr>
+          <p:cNvPicPr>
+            <a:picLocks noChangeAspect="1"/>
+          </p:cNvPicPr>
+          <p:nvPr/>
+        </p:nvPicPr>
+        <p:blipFill>
+          <a:blip r:embed="rId3"/>
+          <a:srcRect l="5287" t="12165" r="24737"/>
+          <a:stretch>
+            <a:fillRect/>
+          </a:stretch>
+        </p:blipFill>
+        <p:spPr>
+          <a:xfrm>
+            <a:off x="1076306" y="2735174"/>
+            <a:ext cx="3593672" cy="3896522"/>
+          </a:xfrm>
+          <a:prstGeom prst="rect">
+            <a:avLst/>
+          </a:prstGeom>
+        </p:spPr>
+      </p:pic>
     </p:spTree>
     <p:extLst>
       <p:ext uri="{BB962C8B-B14F-4D97-AF65-F5344CB8AC3E}">
@@ -8519,7 +8309,7 @@
             <p:ph idx="1"/>
             <p:extLst>
               <p:ext uri="{D42A27DB-BD31-4B8C-83A1-F6EECF244321}">
-                <p14:modId xmlns:p14="http://schemas.microsoft.com/office/powerpoint/2010/main" val="1826076837"/>
+                <p14:modId xmlns:p14="http://schemas.microsoft.com/office/powerpoint/2010/main" val="2156283680"/>
               </p:ext>
             </p:extLst>
           </p:nvPr>
@@ -9131,9 +8921,16 @@
             <p:ph idx="1"/>
           </p:nvPr>
         </p:nvSpPr>
-        <p:spPr/>
-        <p:txBody>
-          <a:bodyPr/>
+        <p:spPr>
+          <a:xfrm>
+            <a:off x="588585" y="1943341"/>
+            <a:ext cx="11155680" cy="3767328"/>
+          </a:xfrm>
+        </p:spPr>
+        <p:txBody>
+          <a:bodyPr>
+            <a:normAutofit lnSpcReduction="10000"/>
+          </a:bodyPr>
           <a:lstStyle/>
           <a:p>
             <a:r>
@@ -9164,23 +8961,13 @@
           <a:p>
             <a:r>
               <a:rPr lang="fr-CH" dirty="0"/>
-              <a:t>Développement pur en </a:t>
-            </a:r>
-            <a:r>
-              <a:rPr lang="fr-CH" b="1" dirty="0"/>
               <a:t>HTML5</a:t>
             </a:r>
+          </a:p>
+          <a:p>
             <a:r>
               <a:rPr lang="fr-CH" dirty="0"/>
-              <a:t> et </a:t>
-            </a:r>
-            <a:r>
-              <a:rPr lang="fr-CH" b="1" dirty="0"/>
               <a:t>CSS3</a:t>
-            </a:r>
-            <a:r>
-              <a:rPr lang="fr-CH" dirty="0"/>
-              <a:t> pour garantir une structure sémantique et un design moderne et responsive.</a:t>
             </a:r>
           </a:p>
           <a:p>
@@ -9192,15 +8979,13 @@
           <a:p>
             <a:r>
               <a:rPr lang="fr-CH" dirty="0"/>
-              <a:t>Utilisation de </a:t>
-            </a:r>
-            <a:r>
-              <a:rPr lang="fr-CH" b="1" dirty="0"/>
               <a:t>Visual Studio Code</a:t>
             </a:r>
+          </a:p>
+          <a:p>
             <a:r>
               <a:rPr lang="fr-CH" dirty="0"/>
-              <a:t> comme IDE principal, optimisé pour un workflow fluide entre le code et le rendu navigateur.</a:t>
+              <a:t>GitHub Desktop</a:t>
             </a:r>
           </a:p>
         </p:txBody>
@@ -9221,6 +9006,14 @@
 <file path=ppt/slides/slide8.xml><?xml version="1.0" encoding="utf-8"?>
 <p:sld xmlns:a="http://schemas.openxmlformats.org/drawingml/2006/main" xmlns:r="http://schemas.openxmlformats.org/officeDocument/2006/relationships" xmlns:p="http://schemas.openxmlformats.org/presentationml/2006/main">
   <p:cSld>
+    <p:bg>
+      <p:bgPr>
+        <a:solidFill>
+          <a:schemeClr val="bg1"/>
+        </a:solidFill>
+        <a:effectLst/>
+      </p:bgPr>
+    </p:bg>
     <p:spTree>
       <p:nvGrpSpPr>
         <p:cNvPr id="1" name=""/>
@@ -9237,10 +9030,385 @@
       </p:grpSpPr>
       <p:sp>
         <p:nvSpPr>
+          <p:cNvPr id="9" name="Freeform: Shape 8">
+            <a:extLst>
+              <a:ext uri="{FF2B5EF4-FFF2-40B4-BE49-F238E27FC236}">
+                <a16:creationId xmlns:a16="http://schemas.microsoft.com/office/drawing/2014/main" id="{774A975B-A886-5202-0489-6965514A0D14}"/>
+              </a:ext>
+              <a:ext uri="{C183D7F6-B498-43B3-948B-1728B52AA6E4}">
+                <adec:decorative xmlns:adec="http://schemas.microsoft.com/office/drawing/2017/decorative" val="1"/>
+              </a:ext>
+            </a:extLst>
+          </p:cNvPr>
+          <p:cNvSpPr>
+            <a:spLocks noGrp="1" noRot="1" noChangeAspect="1" noMove="1" noResize="1" noEditPoints="1" noAdjustHandles="1" noChangeArrowheads="1" noChangeShapeType="1" noTextEdit="1"/>
+          </p:cNvSpPr>
+          <p:nvPr>
+            <p:extLst>
+              <p:ext uri="{386F3935-93C4-4BCD-93E2-E3B085C9AB24}">
+                <p16:designElem xmlns:p16="http://schemas.microsoft.com/office/powerpoint/2015/main" val="1"/>
+              </p:ext>
+            </p:extLst>
+          </p:nvPr>
+        </p:nvSpPr>
+        <p:spPr>
+          <a:xfrm>
+            <a:off x="517869" y="508090"/>
+            <a:ext cx="11153214" cy="149279"/>
+          </a:xfrm>
+          <a:custGeom>
+            <a:avLst/>
+            <a:gdLst>
+              <a:gd name="connsiteX0" fmla="*/ 0 w 8085002"/>
+              <a:gd name="connsiteY0" fmla="*/ 0 h 149279"/>
+              <a:gd name="connsiteX1" fmla="*/ 8085002 w 8085002"/>
+              <a:gd name="connsiteY1" fmla="*/ 0 h 149279"/>
+              <a:gd name="connsiteX2" fmla="*/ 8085002 w 8085002"/>
+              <a:gd name="connsiteY2" fmla="*/ 149279 h 149279"/>
+              <a:gd name="connsiteX3" fmla="*/ 0 w 8085002"/>
+              <a:gd name="connsiteY3" fmla="*/ 149279 h 149279"/>
+            </a:gdLst>
+            <a:ahLst/>
+            <a:cxnLst>
+              <a:cxn ang="0">
+                <a:pos x="connsiteX0" y="connsiteY0"/>
+              </a:cxn>
+              <a:cxn ang="0">
+                <a:pos x="connsiteX1" y="connsiteY1"/>
+              </a:cxn>
+              <a:cxn ang="0">
+                <a:pos x="connsiteX2" y="connsiteY2"/>
+              </a:cxn>
+              <a:cxn ang="0">
+                <a:pos x="connsiteX3" y="connsiteY3"/>
+              </a:cxn>
+            </a:cxnLst>
+            <a:rect l="l" t="t" r="r" b="b"/>
+            <a:pathLst>
+              <a:path w="8085002" h="149279">
+                <a:moveTo>
+                  <a:pt x="0" y="0"/>
+                </a:moveTo>
+                <a:lnTo>
+                  <a:pt x="8085002" y="0"/>
+                </a:lnTo>
+                <a:lnTo>
+                  <a:pt x="8085002" y="149279"/>
+                </a:lnTo>
+                <a:lnTo>
+                  <a:pt x="0" y="149279"/>
+                </a:lnTo>
+                <a:close/>
+              </a:path>
+            </a:pathLst>
+          </a:custGeom>
+          <a:solidFill>
+            <a:schemeClr val="tx1"/>
+          </a:solidFill>
+          <a:ln>
+            <a:noFill/>
+          </a:ln>
+        </p:spPr>
+        <p:style>
+          <a:lnRef idx="2">
+            <a:schemeClr val="accent1">
+              <a:shade val="50000"/>
+            </a:schemeClr>
+          </a:lnRef>
+          <a:fillRef idx="1">
+            <a:schemeClr val="accent1"/>
+          </a:fillRef>
+          <a:effectRef idx="0">
+            <a:schemeClr val="accent1"/>
+          </a:effectRef>
+          <a:fontRef idx="minor">
+            <a:schemeClr val="lt1"/>
+          </a:fontRef>
+        </p:style>
+        <p:txBody>
+          <a:bodyPr wrap="square" rtlCol="0" anchor="ctr">
+            <a:noAutofit/>
+          </a:bodyPr>
+          <a:lstStyle/>
+          <a:p>
+            <a:pPr algn="ctr"/>
+            <a:endParaRPr lang="en-US"/>
+          </a:p>
+        </p:txBody>
+      </p:sp>
+      <p:sp>
+        <p:nvSpPr>
+          <p:cNvPr id="11" name="Freeform: Shape 10">
+            <a:extLst>
+              <a:ext uri="{FF2B5EF4-FFF2-40B4-BE49-F238E27FC236}">
+                <a16:creationId xmlns:a16="http://schemas.microsoft.com/office/drawing/2014/main" id="{EA67E988-5919-57BB-C7DE-D3EAD38A3045}"/>
+              </a:ext>
+              <a:ext uri="{C183D7F6-B498-43B3-948B-1728B52AA6E4}">
+                <adec:decorative xmlns:adec="http://schemas.microsoft.com/office/drawing/2017/decorative" val="1"/>
+              </a:ext>
+            </a:extLst>
+          </p:cNvPr>
+          <p:cNvSpPr>
+            <a:spLocks noGrp="1" noRot="1" noChangeAspect="1" noMove="1" noResize="1" noEditPoints="1" noAdjustHandles="1" noChangeArrowheads="1" noChangeShapeType="1" noTextEdit="1"/>
+          </p:cNvSpPr>
+          <p:nvPr>
+            <p:extLst>
+              <p:ext uri="{386F3935-93C4-4BCD-93E2-E3B085C9AB24}">
+                <p16:designElem xmlns:p16="http://schemas.microsoft.com/office/powerpoint/2015/main" val="1"/>
+              </p:ext>
+            </p:extLst>
+          </p:nvPr>
+        </p:nvSpPr>
+        <p:spPr>
+          <a:xfrm>
+            <a:off x="517870" y="6209925"/>
+            <a:ext cx="11155680" cy="45719"/>
+          </a:xfrm>
+          <a:custGeom>
+            <a:avLst/>
+            <a:gdLst/>
+            <a:ahLst/>
+            <a:cxnLst/>
+            <a:rect l="l" t="t" r="r" b="b"/>
+            <a:pathLst>
+              <a:path w="8715708" h="45719">
+                <a:moveTo>
+                  <a:pt x="0" y="0"/>
+                </a:moveTo>
+                <a:lnTo>
+                  <a:pt x="3694525" y="0"/>
+                </a:lnTo>
+                <a:lnTo>
+                  <a:pt x="5021183" y="0"/>
+                </a:lnTo>
+                <a:lnTo>
+                  <a:pt x="8715708" y="0"/>
+                </a:lnTo>
+                <a:lnTo>
+                  <a:pt x="8715708" y="45719"/>
+                </a:lnTo>
+                <a:lnTo>
+                  <a:pt x="5021183" y="45719"/>
+                </a:lnTo>
+                <a:lnTo>
+                  <a:pt x="3694525" y="45719"/>
+                </a:lnTo>
+                <a:lnTo>
+                  <a:pt x="0" y="45719"/>
+                </a:lnTo>
+                <a:close/>
+              </a:path>
+            </a:pathLst>
+          </a:custGeom>
+          <a:solidFill>
+            <a:schemeClr val="tx1"/>
+          </a:solidFill>
+          <a:ln>
+            <a:noFill/>
+          </a:ln>
+        </p:spPr>
+        <p:style>
+          <a:lnRef idx="2">
+            <a:schemeClr val="accent1">
+              <a:shade val="50000"/>
+            </a:schemeClr>
+          </a:lnRef>
+          <a:fillRef idx="1">
+            <a:schemeClr val="accent1"/>
+          </a:fillRef>
+          <a:effectRef idx="0">
+            <a:schemeClr val="accent1"/>
+          </a:effectRef>
+          <a:fontRef idx="minor">
+            <a:schemeClr val="lt1"/>
+          </a:fontRef>
+        </p:style>
+        <p:txBody>
+          <a:bodyPr wrap="square" rtlCol="0" anchor="ctr">
+            <a:noAutofit/>
+          </a:bodyPr>
+          <a:lstStyle/>
+          <a:p>
+            <a:pPr algn="ctr"/>
+            <a:endParaRPr lang="en-US"/>
+          </a:p>
+        </p:txBody>
+      </p:sp>
+      <p:sp useBgFill="1">
+        <p:nvSpPr>
+          <p:cNvPr id="13" name="Rectangle 12">
+            <a:extLst>
+              <a:ext uri="{FF2B5EF4-FFF2-40B4-BE49-F238E27FC236}">
+                <a16:creationId xmlns:a16="http://schemas.microsoft.com/office/drawing/2014/main" id="{E20BB609-EF92-42DB-836C-0699A590B5CF}"/>
+              </a:ext>
+              <a:ext uri="{C183D7F6-B498-43B3-948B-1728B52AA6E4}">
+                <adec:decorative xmlns:adec="http://schemas.microsoft.com/office/drawing/2017/decorative" val="1"/>
+              </a:ext>
+            </a:extLst>
+          </p:cNvPr>
+          <p:cNvSpPr>
+            <a:spLocks noGrp="1" noRot="1" noChangeAspect="1" noMove="1" noResize="1" noEditPoints="1" noAdjustHandles="1" noChangeArrowheads="1" noChangeShapeType="1" noTextEdit="1"/>
+          </p:cNvSpPr>
+          <p:nvPr>
+            <p:extLst>
+              <p:ext uri="{386F3935-93C4-4BCD-93E2-E3B085C9AB24}">
+                <p16:designElem xmlns:p16="http://schemas.microsoft.com/office/powerpoint/2015/main" val="1"/>
+              </p:ext>
+            </p:extLst>
+          </p:nvPr>
+        </p:nvSpPr>
+        <p:spPr>
+          <a:xfrm>
+            <a:off x="0" y="0"/>
+            <a:ext cx="12192000" cy="6858001"/>
+          </a:xfrm>
+          <a:prstGeom prst="rect">
+            <a:avLst/>
+          </a:prstGeom>
+          <a:ln>
+            <a:noFill/>
+          </a:ln>
+        </p:spPr>
+        <p:style>
+          <a:lnRef idx="2">
+            <a:schemeClr val="accent1">
+              <a:shade val="50000"/>
+            </a:schemeClr>
+          </a:lnRef>
+          <a:fillRef idx="1">
+            <a:schemeClr val="accent1"/>
+          </a:fillRef>
+          <a:effectRef idx="0">
+            <a:schemeClr val="accent1"/>
+          </a:effectRef>
+          <a:fontRef idx="minor">
+            <a:schemeClr val="lt1"/>
+          </a:fontRef>
+        </p:style>
+        <p:txBody>
+          <a:bodyPr rtlCol="0" anchor="ctr"/>
+          <a:lstStyle/>
+          <a:p>
+            <a:pPr algn="ctr"/>
+            <a:endParaRPr lang="en-US" dirty="0"/>
+          </a:p>
+        </p:txBody>
+      </p:sp>
+      <p:pic>
+        <p:nvPicPr>
+          <p:cNvPr id="5" name="Picture 4">
+            <a:extLst>
+              <a:ext uri="{FF2B5EF4-FFF2-40B4-BE49-F238E27FC236}">
+                <a16:creationId xmlns:a16="http://schemas.microsoft.com/office/drawing/2014/main" id="{827C1362-236A-6BAD-A329-94810AF9A7F0}"/>
+              </a:ext>
+            </a:extLst>
+          </p:cNvPr>
+          <p:cNvPicPr>
+            <a:picLocks noChangeAspect="1"/>
+          </p:cNvPicPr>
+          <p:nvPr/>
+        </p:nvPicPr>
+        <p:blipFill>
+          <a:blip r:embed="rId2"/>
+          <a:srcRect l="25"/>
+          <a:stretch>
+            <a:fillRect/>
+          </a:stretch>
+        </p:blipFill>
+        <p:spPr>
+          <a:xfrm>
+            <a:off x="20" y="10"/>
+            <a:ext cx="12188932" cy="6857990"/>
+          </a:xfrm>
+          <a:prstGeom prst="rect">
+            <a:avLst/>
+          </a:prstGeom>
+        </p:spPr>
+      </p:pic>
+      <p:sp>
+        <p:nvSpPr>
+          <p:cNvPr id="15" name="Rectangle 14">
+            <a:extLst>
+              <a:ext uri="{FF2B5EF4-FFF2-40B4-BE49-F238E27FC236}">
+                <a16:creationId xmlns:a16="http://schemas.microsoft.com/office/drawing/2014/main" id="{637992A9-1E8C-4E57-B4F4-EE2D38E504A2}"/>
+              </a:ext>
+              <a:ext uri="{C183D7F6-B498-43B3-948B-1728B52AA6E4}">
+                <adec:decorative xmlns:adec="http://schemas.microsoft.com/office/drawing/2017/decorative" val="1"/>
+              </a:ext>
+            </a:extLst>
+          </p:cNvPr>
+          <p:cNvSpPr>
+            <a:spLocks noGrp="1" noRot="1" noChangeAspect="1" noMove="1" noResize="1" noEditPoints="1" noAdjustHandles="1" noChangeArrowheads="1" noChangeShapeType="1" noTextEdit="1"/>
+          </p:cNvSpPr>
+          <p:nvPr>
+            <p:extLst>
+              <p:ext uri="{386F3935-93C4-4BCD-93E2-E3B085C9AB24}">
+                <p16:designElem xmlns:p16="http://schemas.microsoft.com/office/powerpoint/2015/main" val="1"/>
+              </p:ext>
+            </p:extLst>
+          </p:nvPr>
+        </p:nvSpPr>
+        <p:spPr>
+          <a:xfrm rot="16200000">
+            <a:off x="389239" y="-389238"/>
+            <a:ext cx="6858000" cy="7636476"/>
+          </a:xfrm>
+          <a:prstGeom prst="rect">
+            <a:avLst/>
+          </a:prstGeom>
+          <a:gradFill>
+            <a:gsLst>
+              <a:gs pos="100000">
+                <a:srgbClr val="000000">
+                  <a:alpha val="0"/>
+                </a:srgbClr>
+              </a:gs>
+              <a:gs pos="0">
+                <a:schemeClr val="tx1"/>
+              </a:gs>
+              <a:gs pos="0">
+                <a:srgbClr val="000000">
+                  <a:alpha val="70000"/>
+                </a:srgbClr>
+              </a:gs>
+            </a:gsLst>
+            <a:lin ang="5400000" scaled="1"/>
+          </a:gradFill>
+          <a:ln>
+            <a:noFill/>
+          </a:ln>
+        </p:spPr>
+        <p:style>
+          <a:lnRef idx="2">
+            <a:schemeClr val="accent1">
+              <a:shade val="50000"/>
+            </a:schemeClr>
+          </a:lnRef>
+          <a:fillRef idx="1">
+            <a:schemeClr val="accent1"/>
+          </a:fillRef>
+          <a:effectRef idx="0">
+            <a:schemeClr val="accent1"/>
+          </a:effectRef>
+          <a:fontRef idx="minor">
+            <a:schemeClr val="lt1"/>
+          </a:fontRef>
+        </p:style>
+        <p:txBody>
+          <a:bodyPr rtlCol="0" anchor="ctr"/>
+          <a:lstStyle/>
+          <a:p>
+            <a:pPr algn="ctr"/>
+            <a:endParaRPr lang="en-US"/>
+          </a:p>
+        </p:txBody>
+      </p:sp>
+      <p:sp>
+        <p:nvSpPr>
           <p:cNvPr id="2" name="Titre 1">
             <a:extLst>
               <a:ext uri="{FF2B5EF4-FFF2-40B4-BE49-F238E27FC236}">
-                <a16:creationId xmlns:a16="http://schemas.microsoft.com/office/drawing/2014/main" id="{39CDB58D-7818-6269-97FE-DB12D816E353}"/>
+                <a16:creationId xmlns:a16="http://schemas.microsoft.com/office/drawing/2014/main" id="{E34E0744-9D9A-00B0-9E8E-D0320984E3F4}"/>
               </a:ext>
             </a:extLst>
           </p:cNvPr>
@@ -9251,14 +9419,25 @@
             <p:ph type="title"/>
           </p:nvPr>
         </p:nvSpPr>
-        <p:spPr/>
-        <p:txBody>
-          <a:bodyPr/>
+        <p:spPr>
+          <a:xfrm>
+            <a:off x="517870" y="978407"/>
+            <a:ext cx="5021182" cy="3309511"/>
+          </a:xfrm>
+        </p:spPr>
+        <p:txBody>
+          <a:bodyPr vert="horz" lIns="91440" tIns="45720" rIns="91440" bIns="45720" rtlCol="0" anchor="t">
+            <a:normAutofit/>
+          </a:bodyPr>
           <a:lstStyle/>
           <a:p>
             <a:r>
-              <a:rPr lang="fr-CH" dirty="0"/>
-              <a:t>Cahier des charges</a:t>
+              <a:rPr lang="en-US" sz="6000">
+                <a:solidFill>
+                  <a:srgbClr val="FFFFFF"/>
+                </a:solidFill>
+              </a:rPr>
+              <a:t>AstroLab</a:t>
             </a:r>
           </a:p>
         </p:txBody>
@@ -9268,7 +9447,7 @@
           <p:cNvPr id="3" name="Espace réservé du contenu 2">
             <a:extLst>
               <a:ext uri="{FF2B5EF4-FFF2-40B4-BE49-F238E27FC236}">
-                <a16:creationId xmlns:a16="http://schemas.microsoft.com/office/drawing/2014/main" id="{1173D744-E38A-8D6D-6C85-1B94E33E8328}"/>
+                <a16:creationId xmlns:a16="http://schemas.microsoft.com/office/drawing/2014/main" id="{0C44115A-CC4B-00F3-04DA-D24F28C4E5EA}"/>
               </a:ext>
             </a:extLst>
           </p:cNvPr>
@@ -9279,74 +9458,107 @@
             <p:ph idx="1"/>
           </p:nvPr>
         </p:nvSpPr>
-        <p:spPr/>
-        <p:txBody>
-          <a:bodyPr/>
+        <p:spPr>
+          <a:xfrm>
+            <a:off x="517870" y="4482450"/>
+            <a:ext cx="5040785" cy="1724029"/>
+          </a:xfrm>
+        </p:spPr>
+        <p:txBody>
+          <a:bodyPr vert="horz" lIns="91440" tIns="45720" rIns="91440" bIns="45720" rtlCol="0" anchor="t">
+            <a:normAutofit/>
+          </a:bodyPr>
           <a:lstStyle/>
           <a:p>
-            <a:r>
-              <a:rPr lang="fr-CH" b="1" dirty="0"/>
-              <a:t>Données Scientifiques :</a:t>
-            </a:r>
-            <a:r>
-              <a:rPr lang="fr-CH" dirty="0"/>
-              <a:t> Affichage d'informations générales précises sur la Lune.</a:t>
-            </a:r>
-          </a:p>
-          <a:p>
-            <a:r>
-              <a:rPr lang="fr-CH" b="1" dirty="0"/>
-              <a:t>Cycle Lunaire :</a:t>
-            </a:r>
-            <a:r>
-              <a:rPr lang="fr-CH" dirty="0"/>
-              <a:t> Présentation des huit phases avec illustrations dédiées.</a:t>
-            </a:r>
-          </a:p>
-          <a:p>
-            <a:r>
-              <a:rPr lang="fr-CH" b="1" dirty="0"/>
-              <a:t>Galerie Visuelle :</a:t>
-            </a:r>
-            <a:r>
-              <a:rPr lang="fr-CH" dirty="0"/>
-              <a:t> Mise à disposition d'une banque d'images astronomiques.</a:t>
-            </a:r>
-          </a:p>
-          <a:p>
-            <a:r>
-              <a:rPr lang="fr-CH" b="1" dirty="0"/>
-              <a:t>UX Intuitive :</a:t>
-            </a:r>
-            <a:r>
-              <a:rPr lang="fr-CH" dirty="0"/>
-              <a:t> Navigation simple et fluide sur une seule page (Single Page).</a:t>
-            </a:r>
-          </a:p>
-          <a:p>
-            <a:r>
-              <a:rPr lang="fr-CH" b="1" dirty="0"/>
-              <a:t>Adaptabilité :</a:t>
-            </a:r>
-            <a:r>
-              <a:rPr lang="fr-CH" dirty="0"/>
-              <a:t> Design 100% responsive pour tous types d'écrans.</a:t>
-            </a:r>
-          </a:p>
-          <a:p>
-            <a:endParaRPr lang="fr-CH" dirty="0"/>
+            <a:pPr marL="0" indent="0">
+              <a:buNone/>
+            </a:pPr>
+            <a:r>
+              <a:rPr lang="en-US" sz="2200" i="1" kern="1200">
+                <a:solidFill>
+                  <a:srgbClr val="FFFFFF"/>
+                </a:solidFill>
+                <a:latin typeface="+mn-lt"/>
+                <a:ea typeface="+mn-ea"/>
+                <a:cs typeface="+mn-cs"/>
+              </a:rPr>
+              <a:t>Projet en python</a:t>
+            </a:r>
+          </a:p>
+        </p:txBody>
+      </p:sp>
+      <p:sp>
+        <p:nvSpPr>
+          <p:cNvPr id="17" name="Rectangle 16">
+            <a:extLst>
+              <a:ext uri="{FF2B5EF4-FFF2-40B4-BE49-F238E27FC236}">
+                <a16:creationId xmlns:a16="http://schemas.microsoft.com/office/drawing/2014/main" id="{B2C335F7-F61C-4EB4-80F2-4B1438FE66BB}"/>
+              </a:ext>
+              <a:ext uri="{C183D7F6-B498-43B3-948B-1728B52AA6E4}">
+                <adec:decorative xmlns:adec="http://schemas.microsoft.com/office/drawing/2017/decorative" val="1"/>
+              </a:ext>
+            </a:extLst>
+          </p:cNvPr>
+          <p:cNvSpPr>
+            <a:spLocks noGrp="1" noRot="1" noChangeAspect="1" noMove="1" noResize="1" noEditPoints="1" noAdjustHandles="1" noChangeArrowheads="1" noChangeShapeType="1" noTextEdit="1"/>
+          </p:cNvSpPr>
+          <p:nvPr>
+            <p:extLst>
+              <p:ext uri="{386F3935-93C4-4BCD-93E2-E3B085C9AB24}">
+                <p16:designElem xmlns:p16="http://schemas.microsoft.com/office/powerpoint/2015/main" val="1"/>
+              </p:ext>
+            </p:extLst>
+          </p:nvPr>
+        </p:nvSpPr>
+        <p:spPr>
+          <a:xfrm>
+            <a:off x="517870" y="508090"/>
+            <a:ext cx="5021183" cy="149279"/>
+          </a:xfrm>
+          <a:prstGeom prst="rect">
+            <a:avLst/>
+          </a:prstGeom>
+          <a:solidFill>
+            <a:srgbClr val="FFFFFF"/>
+          </a:solidFill>
+          <a:ln>
+            <a:noFill/>
+          </a:ln>
+        </p:spPr>
+        <p:style>
+          <a:lnRef idx="2">
+            <a:schemeClr val="accent1">
+              <a:shade val="50000"/>
+            </a:schemeClr>
+          </a:lnRef>
+          <a:fillRef idx="1">
+            <a:schemeClr val="accent1"/>
+          </a:fillRef>
+          <a:effectRef idx="0">
+            <a:schemeClr val="accent1"/>
+          </a:effectRef>
+          <a:fontRef idx="minor">
+            <a:schemeClr val="lt1"/>
+          </a:fontRef>
+        </p:style>
+        <p:txBody>
+          <a:bodyPr rtlCol="0" anchor="ctr"/>
+          <a:lstStyle/>
+          <a:p>
+            <a:pPr algn="ctr"/>
+            <a:endParaRPr lang="en-US"/>
           </a:p>
         </p:txBody>
       </p:sp>
     </p:spTree>
     <p:extLst>
       <p:ext uri="{BB962C8B-B14F-4D97-AF65-F5344CB8AC3E}">
-        <p14:creationId xmlns:p14="http://schemas.microsoft.com/office/powerpoint/2010/main" val="102074461"/>
+        <p14:creationId xmlns:p14="http://schemas.microsoft.com/office/powerpoint/2010/main" val="832870440"/>
       </p:ext>
     </p:extLst>
   </p:cSld>
   <p:clrMapOvr>
-    <a:masterClrMapping/>
+    <a:overrideClrMapping bg1="dk1" tx1="lt1" bg2="dk2" tx2="lt2" accent1="accent1" accent2="accent2" accent3="accent3" accent4="accent4" accent5="accent5" accent6="accent6" hlink="hlink" folHlink="folHlink"/>
   </p:clrMapOvr>
 </p:sld>
 </file>
@@ -9354,6 +9566,14 @@
 <file path=ppt/slides/slide9.xml><?xml version="1.0" encoding="utf-8"?>
 <p:sld xmlns:a="http://schemas.openxmlformats.org/drawingml/2006/main" xmlns:r="http://schemas.openxmlformats.org/officeDocument/2006/relationships" xmlns:p="http://schemas.openxmlformats.org/presentationml/2006/main">
   <p:cSld>
+    <p:bg>
+      <p:bgPr>
+        <a:solidFill>
+          <a:schemeClr val="bg1"/>
+        </a:solidFill>
+        <a:effectLst/>
+      </p:bgPr>
+    </p:bg>
     <p:spTree>
       <p:nvGrpSpPr>
         <p:cNvPr id="1" name=""/>
@@ -9368,12 +9588,101 @@
           <a:chExt cx="0" cy="0"/>
         </a:xfrm>
       </p:grpSpPr>
+      <p:sp useBgFill="1">
+        <p:nvSpPr>
+          <p:cNvPr id="10" name="Rectangle 9">
+            <a:extLst>
+              <a:ext uri="{FF2B5EF4-FFF2-40B4-BE49-F238E27FC236}">
+                <a16:creationId xmlns:a16="http://schemas.microsoft.com/office/drawing/2014/main" id="{34C0330F-1D4F-4552-B799-615DD237B6DE}"/>
+              </a:ext>
+              <a:ext uri="{C183D7F6-B498-43B3-948B-1728B52AA6E4}">
+                <adec:decorative xmlns:adec="http://schemas.microsoft.com/office/drawing/2017/decorative" val="1"/>
+              </a:ext>
+            </a:extLst>
+          </p:cNvPr>
+          <p:cNvSpPr>
+            <a:spLocks noGrp="1" noRot="1" noChangeAspect="1" noMove="1" noResize="1" noEditPoints="1" noAdjustHandles="1" noChangeArrowheads="1" noChangeShapeType="1" noTextEdit="1"/>
+          </p:cNvSpPr>
+          <p:nvPr>
+            <p:extLst>
+              <p:ext uri="{386F3935-93C4-4BCD-93E2-E3B085C9AB24}">
+                <p16:designElem xmlns:p16="http://schemas.microsoft.com/office/powerpoint/2015/main" val="1"/>
+              </p:ext>
+            </p:extLst>
+          </p:nvPr>
+        </p:nvSpPr>
+        <p:spPr>
+          <a:xfrm>
+            <a:off x="0" y="0"/>
+            <a:ext cx="12188952" cy="6857995"/>
+          </a:xfrm>
+          <a:prstGeom prst="rect">
+            <a:avLst/>
+          </a:prstGeom>
+          <a:ln>
+            <a:noFill/>
+          </a:ln>
+        </p:spPr>
+        <p:style>
+          <a:lnRef idx="2">
+            <a:schemeClr val="accent1">
+              <a:shade val="50000"/>
+            </a:schemeClr>
+          </a:lnRef>
+          <a:fillRef idx="1">
+            <a:schemeClr val="accent1"/>
+          </a:fillRef>
+          <a:effectRef idx="0">
+            <a:schemeClr val="accent1"/>
+          </a:effectRef>
+          <a:fontRef idx="minor">
+            <a:schemeClr val="lt1"/>
+          </a:fontRef>
+        </p:style>
+        <p:txBody>
+          <a:bodyPr rtlCol="0" anchor="ctr"/>
+          <a:lstStyle/>
+          <a:p>
+            <a:pPr marL="0" marR="0" lvl="0" indent="0" algn="ctr" defTabSz="914400" rtl="0" eaLnBrk="1" fontAlgn="auto" latinLnBrk="0" hangingPunct="1">
+              <a:lnSpc>
+                <a:spcPct val="100000"/>
+              </a:lnSpc>
+              <a:spcBef>
+                <a:spcPts val="0"/>
+              </a:spcBef>
+              <a:spcAft>
+                <a:spcPts val="0"/>
+              </a:spcAft>
+              <a:buClrTx/>
+              <a:buSzTx/>
+              <a:buFontTx/>
+              <a:buNone/>
+              <a:tabLst/>
+              <a:defRPr/>
+            </a:pPr>
+            <a:endParaRPr kumimoji="0" lang="en-US" sz="1800" b="0" i="0" u="none" strike="noStrike" kern="1200" cap="none" spc="0" normalizeH="0" baseline="0" noProof="0" dirty="0">
+              <a:ln>
+                <a:noFill/>
+              </a:ln>
+              <a:solidFill>
+                <a:prstClr val="white"/>
+              </a:solidFill>
+              <a:effectLst/>
+              <a:uLnTx/>
+              <a:uFillTx/>
+              <a:latin typeface="Bierstadt"/>
+              <a:ea typeface="+mn-ea"/>
+              <a:cs typeface="+mn-cs"/>
+            </a:endParaRPr>
+          </a:p>
+        </p:txBody>
+      </p:sp>
       <p:sp>
         <p:nvSpPr>
           <p:cNvPr id="2" name="Titre 1">
             <a:extLst>
               <a:ext uri="{FF2B5EF4-FFF2-40B4-BE49-F238E27FC236}">
-                <a16:creationId xmlns:a16="http://schemas.microsoft.com/office/drawing/2014/main" id="{D0AE247B-784E-CA2F-2D02-4273E444927D}"/>
+                <a16:creationId xmlns:a16="http://schemas.microsoft.com/office/drawing/2014/main" id="{0CD193FF-2B7B-BC23-F6D7-D46536517DE1}"/>
               </a:ext>
             </a:extLst>
           </p:cNvPr>
@@ -9384,31 +9693,193 @@
             <p:ph type="title"/>
           </p:nvPr>
         </p:nvSpPr>
-        <p:spPr/>
+        <p:spPr>
+          <a:xfrm>
+            <a:off x="521208" y="978408"/>
+            <a:ext cx="4754880" cy="1463040"/>
+          </a:xfrm>
+        </p:spPr>
         <p:txBody>
           <a:bodyPr>
-            <a:normAutofit fontScale="90000"/>
+            <a:normAutofit/>
           </a:bodyPr>
           <a:lstStyle/>
           <a:p>
             <a:r>
-              <a:rPr lang="fr-CH" b="0" dirty="0"/>
-              <a:t>Extrait du Journal de Travail</a:t>
-            </a:r>
-            <a:br>
-              <a:rPr lang="fr-CH" b="0" dirty="0"/>
-            </a:br>
-            <a:br>
               <a:rPr lang="fr-CH" dirty="0"/>
-            </a:br>
-            <a:endParaRPr lang="fr-CH" dirty="0"/>
-          </a:p>
-        </p:txBody>
-      </p:sp>
+              <a:t>Pourquoi ce projet ?</a:t>
+            </a:r>
+          </a:p>
+        </p:txBody>
+      </p:sp>
+      <p:sp>
+        <p:nvSpPr>
+          <p:cNvPr id="12" name="Rectangle 11">
+            <a:extLst>
+              <a:ext uri="{FF2B5EF4-FFF2-40B4-BE49-F238E27FC236}">
+                <a16:creationId xmlns:a16="http://schemas.microsoft.com/office/drawing/2014/main" id="{92BE0106-0C20-465B-A1BE-0BAC2737B1AD}"/>
+              </a:ext>
+              <a:ext uri="{C183D7F6-B498-43B3-948B-1728B52AA6E4}">
+                <adec:decorative xmlns:adec="http://schemas.microsoft.com/office/drawing/2017/decorative" val="1"/>
+              </a:ext>
+            </a:extLst>
+          </p:cNvPr>
+          <p:cNvSpPr>
+            <a:spLocks noGrp="1" noRot="1" noChangeAspect="1" noMove="1" noResize="1" noEditPoints="1" noAdjustHandles="1" noChangeArrowheads="1" noChangeShapeType="1" noTextEdit="1"/>
+          </p:cNvSpPr>
+          <p:nvPr>
+            <p:extLst>
+              <p:ext uri="{386F3935-93C4-4BCD-93E2-E3B085C9AB24}">
+                <p16:designElem xmlns:p16="http://schemas.microsoft.com/office/powerpoint/2015/main" val="1"/>
+              </p:ext>
+            </p:extLst>
+          </p:nvPr>
+        </p:nvSpPr>
+        <p:spPr>
+          <a:xfrm>
+            <a:off x="517871" y="508090"/>
+            <a:ext cx="4672966" cy="149279"/>
+          </a:xfrm>
+          <a:prstGeom prst="rect">
+            <a:avLst/>
+          </a:prstGeom>
+          <a:solidFill>
+            <a:schemeClr val="tx1"/>
+          </a:solidFill>
+          <a:ln>
+            <a:noFill/>
+          </a:ln>
+        </p:spPr>
+        <p:style>
+          <a:lnRef idx="2">
+            <a:schemeClr val="accent1">
+              <a:shade val="50000"/>
+            </a:schemeClr>
+          </a:lnRef>
+          <a:fillRef idx="1">
+            <a:schemeClr val="accent1"/>
+          </a:fillRef>
+          <a:effectRef idx="0">
+            <a:schemeClr val="accent1"/>
+          </a:effectRef>
+          <a:fontRef idx="minor">
+            <a:schemeClr val="lt1"/>
+          </a:fontRef>
+        </p:style>
+        <p:txBody>
+          <a:bodyPr rtlCol="0" anchor="ctr"/>
+          <a:lstStyle/>
+          <a:p>
+            <a:pPr marL="0" marR="0" lvl="0" indent="0" algn="ctr" defTabSz="914400" rtl="0" eaLnBrk="1" fontAlgn="auto" latinLnBrk="0" hangingPunct="1">
+              <a:lnSpc>
+                <a:spcPct val="100000"/>
+              </a:lnSpc>
+              <a:spcBef>
+                <a:spcPts val="0"/>
+              </a:spcBef>
+              <a:spcAft>
+                <a:spcPts val="0"/>
+              </a:spcAft>
+              <a:buClrTx/>
+              <a:buSzTx/>
+              <a:buFontTx/>
+              <a:buNone/>
+              <a:tabLst/>
+              <a:defRPr/>
+            </a:pPr>
+            <a:endParaRPr kumimoji="0" lang="en-US" sz="1800" b="0" i="0" u="none" strike="noStrike" kern="1200" cap="none" spc="0" normalizeH="0" baseline="0" noProof="0">
+              <a:ln>
+                <a:noFill/>
+              </a:ln>
+              <a:solidFill>
+                <a:prstClr val="white"/>
+              </a:solidFill>
+              <a:effectLst/>
+              <a:uLnTx/>
+              <a:uFillTx/>
+              <a:latin typeface="Bierstadt"/>
+              <a:ea typeface="+mn-ea"/>
+              <a:cs typeface="+mn-cs"/>
+            </a:endParaRPr>
+          </a:p>
+        </p:txBody>
+      </p:sp>
+      <p:sp>
+        <p:nvSpPr>
+          <p:cNvPr id="3" name="Espace réservé du contenu 2">
+            <a:extLst>
+              <a:ext uri="{FF2B5EF4-FFF2-40B4-BE49-F238E27FC236}">
+                <a16:creationId xmlns:a16="http://schemas.microsoft.com/office/drawing/2014/main" id="{E1121C98-EC16-3C52-8342-E449BCD3F200}"/>
+              </a:ext>
+            </a:extLst>
+          </p:cNvPr>
+          <p:cNvSpPr>
+            <a:spLocks noGrp="1"/>
+          </p:cNvSpPr>
+          <p:nvPr>
+            <p:ph idx="1"/>
+          </p:nvPr>
+        </p:nvSpPr>
+        <p:spPr>
+          <a:xfrm>
+            <a:off x="521208" y="2578608"/>
+            <a:ext cx="4672584" cy="3767328"/>
+          </a:xfrm>
+        </p:spPr>
+        <p:txBody>
+          <a:bodyPr>
+            <a:normAutofit/>
+          </a:bodyPr>
+          <a:lstStyle/>
+          <a:p>
+            <a:r>
+              <a:rPr lang="fr-CH" dirty="0"/>
+              <a:t>Apprendre un nouveau langage : Python</a:t>
+            </a:r>
+          </a:p>
+          <a:p>
+            <a:r>
+              <a:rPr lang="fr-CH" dirty="0"/>
+              <a:t>Faire un projet avec des calculs</a:t>
+            </a:r>
+          </a:p>
+        </p:txBody>
+      </p:sp>
+      <p:pic>
+        <p:nvPicPr>
+          <p:cNvPr id="5" name="Image 4">
+            <a:extLst>
+              <a:ext uri="{FF2B5EF4-FFF2-40B4-BE49-F238E27FC236}">
+                <a16:creationId xmlns:a16="http://schemas.microsoft.com/office/drawing/2014/main" id="{54D9DB48-7DD3-279F-53A0-D17677026E50}"/>
+              </a:ext>
+            </a:extLst>
+          </p:cNvPr>
+          <p:cNvPicPr>
+            <a:picLocks noChangeAspect="1"/>
+          </p:cNvPicPr>
+          <p:nvPr/>
+        </p:nvPicPr>
+        <p:blipFill>
+          <a:blip r:embed="rId2"/>
+          <a:srcRect r="15776" b="1"/>
+          <a:stretch>
+            <a:fillRect/>
+          </a:stretch>
+        </p:blipFill>
+        <p:spPr>
+          <a:xfrm>
+            <a:off x="5958018" y="508090"/>
+            <a:ext cx="5709726" cy="5846989"/>
+          </a:xfrm>
+          <a:prstGeom prst="rect">
+            <a:avLst/>
+          </a:prstGeom>
+        </p:spPr>
+      </p:pic>
     </p:spTree>
     <p:extLst>
       <p:ext uri="{BB962C8B-B14F-4D97-AF65-F5344CB8AC3E}">
-        <p14:creationId xmlns:p14="http://schemas.microsoft.com/office/powerpoint/2010/main" val="684144989"/>
+        <p14:creationId xmlns:p14="http://schemas.microsoft.com/office/powerpoint/2010/main" val="3658721233"/>
       </p:ext>
     </p:extLst>
   </p:cSld>

</xml_diff>

<commit_message>
add : ajout Rencontre Célestes Le croissant de Lune + Vénus + Jupiter
</commit_message>
<xml_diff>
--- a/annexe/Presentation.pptx
+++ b/annexe/Presentation.pptx
@@ -3043,7 +3043,7 @@
           <a:p>
             <a:fld id="{E80C50CD-E178-4744-9B35-B2F624D6C5E9}" type="datetimeFigureOut">
               <a:rPr lang="en-US" smtClean="0"/>
-              <a:t>6/22/2026</a:t>
+              <a:t>6/23/2026</a:t>
             </a:fld>
             <a:endParaRPr lang="en-US"/>
           </a:p>
@@ -3241,7 +3241,7 @@
           <a:p>
             <a:fld id="{E80C50CD-E178-4744-9B35-B2F624D6C5E9}" type="datetimeFigureOut">
               <a:rPr lang="en-US" smtClean="0"/>
-              <a:t>6/22/2026</a:t>
+              <a:t>6/23/2026</a:t>
             </a:fld>
             <a:endParaRPr lang="en-US"/>
           </a:p>
@@ -3449,7 +3449,7 @@
           <a:p>
             <a:fld id="{E80C50CD-E178-4744-9B35-B2F624D6C5E9}" type="datetimeFigureOut">
               <a:rPr lang="en-US" smtClean="0"/>
-              <a:t>6/22/2026</a:t>
+              <a:t>6/23/2026</a:t>
             </a:fld>
             <a:endParaRPr lang="en-US"/>
           </a:p>
@@ -3699,7 +3699,7 @@
           <a:p>
             <a:fld id="{E80C50CD-E178-4744-9B35-B2F624D6C5E9}" type="datetimeFigureOut">
               <a:rPr lang="en-US" smtClean="0"/>
-              <a:t>6/22/2026</a:t>
+              <a:t>6/23/2026</a:t>
             </a:fld>
             <a:endParaRPr lang="en-US"/>
           </a:p>
@@ -3978,7 +3978,7 @@
           <a:p>
             <a:fld id="{E80C50CD-E178-4744-9B35-B2F624D6C5E9}" type="datetimeFigureOut">
               <a:rPr lang="en-US" smtClean="0"/>
-              <a:t>6/22/2026</a:t>
+              <a:t>6/23/2026</a:t>
             </a:fld>
             <a:endParaRPr lang="en-US"/>
           </a:p>
@@ -4295,7 +4295,7 @@
           <a:p>
             <a:fld id="{E80C50CD-E178-4744-9B35-B2F624D6C5E9}" type="datetimeFigureOut">
               <a:rPr lang="en-US" smtClean="0"/>
-              <a:t>6/22/2026</a:t>
+              <a:t>6/23/2026</a:t>
             </a:fld>
             <a:endParaRPr lang="en-US"/>
           </a:p>
@@ -4711,7 +4711,7 @@
           <a:p>
             <a:fld id="{E80C50CD-E178-4744-9B35-B2F624D6C5E9}" type="datetimeFigureOut">
               <a:rPr lang="en-US" smtClean="0"/>
-              <a:t>6/22/2026</a:t>
+              <a:t>6/23/2026</a:t>
             </a:fld>
             <a:endParaRPr lang="en-US"/>
           </a:p>
@@ -4852,7 +4852,7 @@
           <a:p>
             <a:fld id="{E80C50CD-E178-4744-9B35-B2F624D6C5E9}" type="datetimeFigureOut">
               <a:rPr lang="en-US" smtClean="0"/>
-              <a:t>6/22/2026</a:t>
+              <a:t>6/23/2026</a:t>
             </a:fld>
             <a:endParaRPr lang="en-US"/>
           </a:p>
@@ -4965,7 +4965,7 @@
           <a:p>
             <a:fld id="{E80C50CD-E178-4744-9B35-B2F624D6C5E9}" type="datetimeFigureOut">
               <a:rPr lang="en-US" smtClean="0"/>
-              <a:t>6/22/2026</a:t>
+              <a:t>6/23/2026</a:t>
             </a:fld>
             <a:endParaRPr lang="en-US"/>
           </a:p>
@@ -5282,7 +5282,7 @@
           <a:p>
             <a:fld id="{E80C50CD-E178-4744-9B35-B2F624D6C5E9}" type="datetimeFigureOut">
               <a:rPr lang="en-US" smtClean="0"/>
-              <a:t>6/22/2026</a:t>
+              <a:t>6/23/2026</a:t>
             </a:fld>
             <a:endParaRPr lang="en-US"/>
           </a:p>
@@ -5574,7 +5574,7 @@
           <a:p>
             <a:fld id="{E80C50CD-E178-4744-9B35-B2F624D6C5E9}" type="datetimeFigureOut">
               <a:rPr lang="en-US" smtClean="0"/>
-              <a:t>6/22/2026</a:t>
+              <a:t>6/23/2026</a:t>
             </a:fld>
             <a:endParaRPr lang="en-US"/>
           </a:p>
@@ -5814,7 +5814,7 @@
             <a:fld id="{E80C50CD-E178-4744-9B35-B2F624D6C5E9}" type="datetimeFigureOut">
               <a:rPr lang="en-US" smtClean="0"/>
               <a:pPr/>
-              <a:t>6/22/2026</a:t>
+              <a:t>6/23/2026</a:t>
             </a:fld>
             <a:endParaRPr lang="en-US"/>
           </a:p>
@@ -8899,9 +8899,10 @@
           <a:lstStyle/>
           <a:p>
             <a:r>
-              <a:rPr lang="fr-CH" dirty="0"/>
+              <a:rPr lang="fr-CH"/>
               <a:t>Pourquoi ce projet ?</a:t>
             </a:r>
+            <a:endParaRPr lang="fr-CH" dirty="0"/>
           </a:p>
         </p:txBody>
       </p:sp>
@@ -8990,6 +8991,36 @@
           </a:p>
         </p:txBody>
       </p:sp>
+      <p:pic>
+        <p:nvPicPr>
+          <p:cNvPr id="5" name="Image 4">
+            <a:extLst>
+              <a:ext uri="{FF2B5EF4-FFF2-40B4-BE49-F238E27FC236}">
+                <a16:creationId xmlns:a16="http://schemas.microsoft.com/office/drawing/2014/main" id="{4774EA8B-0F41-A1AA-4CA2-DC15A7D723CC}"/>
+              </a:ext>
+            </a:extLst>
+          </p:cNvPr>
+          <p:cNvPicPr>
+            <a:picLocks noChangeAspect="1"/>
+          </p:cNvPicPr>
+          <p:nvPr/>
+        </p:nvPicPr>
+        <p:blipFill>
+          <a:blip r:embed="rId2"/>
+          <a:stretch>
+            <a:fillRect/>
+          </a:stretch>
+        </p:blipFill>
+        <p:spPr>
+          <a:xfrm>
+            <a:off x="4198222" y="3012505"/>
+            <a:ext cx="7194880" cy="3513423"/>
+          </a:xfrm>
+          <a:prstGeom prst="rect">
+            <a:avLst/>
+          </a:prstGeom>
+        </p:spPr>
+      </p:pic>
     </p:spTree>
     <p:extLst>
       <p:ext uri="{BB962C8B-B14F-4D97-AF65-F5344CB8AC3E}">

</xml_diff>